<commit_message>
docs: add Atlantis ecosystem and 2024 survey evidence
Signed-off-by: Rui Chen <rui@chenrui.dev>
</commit_message>
<xml_diff>
--- a/talks/kubecon-china-2026-atlantis-lightning/slides.pptx
+++ b/talks/kubecon-china-2026-atlantis-lightning/slides.pptx
@@ -789,17 +789,13 @@
           <a:p>
             <a:r>
               <a:rPr lang="en-US" dirty="0"/>
-              <a:t>Target: 2:40–4:05 (85 seconds)
-Spoken words: 179
-Cue: Visible → controlled → collaborative. Last 25 seconds: current project signals.
-First, visibility: the plan and execution results sit beside the code review. Second, control: the platform team configures credentials, approval requirements, and optional policy checks. Atlantis project locks help coordinate competing pull requests. Third, collaboration: developers can propose changes through a familiar workflow, without each person needing a privileged workstation. You could build this in generic CI. Atlantis packages the PR interaction, planning, applying, and locking into a purpose-built service. The core workflow needs no separate Atlantis SaaS control plane. Your Git host, state backend, and cloud services remain part of the system. This still runs powerful code: even planning can execute code. Trusted repositories, restricted permissions, and a maintained deployment remain essential. The project continues to evolve for Terraform and OpenTofu users. Recent work includes alpha APIs for drift workflows; version zero point forty-seven added richer drift plan output. The latest release, zero point forty-seven point one, fixes a command-injection vulnerability. These are useful updates for existing operators. For a new team, the starting point is still the pull request.
-Transition: And that is the idea to take away.
+              <a:t>Target: 2:40–3:40 (60 seconds)
+Spoken words: 107
+Cue: Left: current integrations. Right: 2024 survey, not market share.
+Atlantis fits a broader infrastructure stack. Today, it connects to several Git hosts, runs Terraform or OpenTofu, and supports Terragrunt through custom workflows. The project's 2024 survey received three hundred fifty-four responses. GitHub led, with a sizeable GitLab group, followed by Bitbucket and others. Terraform dominated; about half also used Terragrunt, and OpenTofu was gaining ground. Kubernetes and AWS were common deployment environments. These are survey responses, not a measure of market share. Atlantis gives those tools a shared pull-request workflow. Terragrunt is an optional workflow integration, not an infrastructure target.
+Transition: Whatever combination you run underneath, the idea stays the same: infrastructure changes belong in code review.
 Emergency cuts:
-You could build this in generic CI.
-Atlantis packages the PR interaction, planning, applying, and locking into a purpose-built service.
-Your Git host, state backend, and cloud services remain part of the system.
-Recent work includes alpha APIs for drift workflows; version zero point forty-seven added richer drift plan output.
-These are useful updates for existing operators.</a:t>
+Terragrunt is an optional workflow integration, not an infrastructure target.</a:t>
             </a:r>
             <a:endParaRPr lang="en-US" dirty="0"/>
           </a:p>
@@ -887,7 +883,7 @@
           <a:p>
             <a:r>
               <a:rPr lang="en-US" dirty="0"/>
-              <a:t>Target: 4:05–4:35 (30 seconds)
+              <a:t>Target: 3:40–4:10 (30 seconds)
 Spoken words: 52
 Cue: Point to the URL, then land the final four phrases.
 Atlantis is a CNCF Sandbox project. Visit runatlantis dot io for the getting-started guide, or find the code and contribution guide on GitHub. Start with one repository and one infrastructure change. Bring your team's review rules into that workflow. Infrastructure is code. Plan it. Review it. Apply it. From the pull request.
@@ -9519,7 +9515,7 @@
                 <a:ea typeface="Arial" pitchFamily="34" charset="-122"/>
                 <a:cs typeface="Arial" pitchFamily="34" charset="-120"/>
               </a:rPr>
-              <a:t>WHY PLATFORM TEAMS CHOOSE IT</a:t>
+              <a:t>ECOSYSTEM + COMMUNITY</a:t>
             </a:r>
             <a:endParaRPr lang="en-US" sz="1600" dirty="0"/>
           </a:p>
@@ -9558,7 +9554,7 @@
                 <a:ea typeface="Arial" pitchFamily="34" charset="-122"/>
                 <a:cs typeface="Arial" pitchFamily="34" charset="-120"/>
               </a:rPr>
-              <a:t>A shared workflow. A platform you control.</a:t>
+              <a:t>Atlantis in the IaC ecosystem</a:t>
             </a:r>
             <a:endParaRPr lang="en-US" sz="3600" dirty="0"/>
           </a:p>
@@ -9605,14 +9601,53 @@
       </p:sp>
       <p:sp>
         <p:nvSpPr>
-          <p:cNvPr id="5" name="Shape 3"/>
+          <p:cNvPr id="5" name="Text 3"/>
           <p:cNvSpPr/>
           <p:nvPr/>
         </p:nvSpPr>
         <p:spPr>
           <a:xfrm>
-            <a:off x="640080" y="2395728"/>
-            <a:ext cx="3493008" cy="2267712"/>
+            <a:off x="640080" y="1956816"/>
+            <a:ext cx="6400800" cy="274320"/>
+          </a:xfrm>
+          <a:prstGeom prst="rect">
+            <a:avLst/>
+          </a:prstGeom>
+          <a:noFill/>
+          <a:ln/>
+        </p:spPr>
+        <p:txBody>
+          <a:bodyPr wrap="square" lIns="0" tIns="0" rIns="0" bIns="0" rtlCol="0" anchor="ctr"/>
+          <a:lstStyle/>
+          <a:p>
+            <a:pPr indent="0" marL="0">
+              <a:buNone/>
+            </a:pPr>
+            <a:r>
+              <a:rPr lang="en-US" sz="1700" b="1" dirty="0">
+                <a:solidFill>
+                  <a:srgbClr val="086679"/>
+                </a:solidFill>
+                <a:latin typeface="Arial" pitchFamily="34" charset="0"/>
+                <a:ea typeface="Arial" pitchFamily="34" charset="-122"/>
+                <a:cs typeface="Arial" pitchFamily="34" charset="-120"/>
+              </a:rPr>
+              <a:t>CURRENT INTEGRATIONS</a:t>
+            </a:r>
+            <a:endParaRPr lang="en-US" sz="1700" dirty="0"/>
+          </a:p>
+        </p:txBody>
+      </p:sp>
+      <p:sp>
+        <p:nvSpPr>
+          <p:cNvPr id="6" name="Shape 4"/>
+          <p:cNvSpPr/>
+          <p:nvPr/>
+        </p:nvSpPr>
+        <p:spPr>
+          <a:xfrm>
+            <a:off x="640080" y="2212848"/>
+            <a:ext cx="6446520" cy="914400"/>
           </a:xfrm>
           <a:prstGeom prst="rect">
             <a:avLst/>
@@ -9630,14 +9665,14 @@
       </p:sp>
       <p:sp>
         <p:nvSpPr>
-          <p:cNvPr id="6" name="Text 4"/>
+          <p:cNvPr id="7" name="Text 5"/>
           <p:cNvSpPr/>
           <p:nvPr/>
         </p:nvSpPr>
         <p:spPr>
           <a:xfrm>
-            <a:off x="850392" y="2606040"/>
-            <a:ext cx="2743200" cy="347472"/>
+            <a:off x="822960" y="2295144"/>
+            <a:ext cx="6080760" cy="292608"/>
           </a:xfrm>
           <a:prstGeom prst="rect">
             <a:avLst/>
@@ -9653,30 +9688,30 @@
               <a:buNone/>
             </a:pPr>
             <a:r>
-              <a:rPr lang="en-US" sz="2000" dirty="0">
-                <a:solidFill>
-                  <a:srgbClr val="086679"/>
+              <a:rPr lang="en-US" sz="2300" b="1" dirty="0">
+                <a:solidFill>
+                  <a:srgbClr val="083E4F"/>
                 </a:solidFill>
                 <a:latin typeface="Arial" pitchFamily="34" charset="0"/>
                 <a:ea typeface="Arial" pitchFamily="34" charset="-122"/>
                 <a:cs typeface="Arial" pitchFamily="34" charset="-120"/>
               </a:rPr>
-              <a:t>01</a:t>
+              <a:t>Git providers</a:t>
             </a:r>
-            <a:endParaRPr lang="en-US" sz="2000" dirty="0"/>
+            <a:endParaRPr lang="en-US" sz="2300" dirty="0"/>
           </a:p>
         </p:txBody>
       </p:sp>
       <p:sp>
         <p:nvSpPr>
-          <p:cNvPr id="7" name="Text 5"/>
+          <p:cNvPr id="8" name="Text 6"/>
           <p:cNvSpPr/>
           <p:nvPr/>
         </p:nvSpPr>
         <p:spPr>
           <a:xfrm>
-            <a:off x="850392" y="3182112"/>
-            <a:ext cx="3108960" cy="411480"/>
+            <a:off x="822960" y="2651760"/>
+            <a:ext cx="6080760" cy="402336"/>
           </a:xfrm>
           <a:prstGeom prst="rect">
             <a:avLst/>
@@ -9692,46 +9727,24 @@
               <a:buNone/>
             </a:pPr>
             <a:r>
-              <a:rPr lang="en-US" sz="2900" b="1" dirty="0">
-                <a:solidFill>
-                  <a:srgbClr val="083E4F"/>
+              <a:rPr lang="en-US" sz="1800" dirty="0">
+                <a:solidFill>
+                  <a:srgbClr val="405965"/>
                 </a:solidFill>
                 <a:latin typeface="Arial" pitchFamily="34" charset="0"/>
                 <a:ea typeface="Arial" pitchFamily="34" charset="-122"/>
                 <a:cs typeface="Arial" pitchFamily="34" charset="-120"/>
               </a:rPr>
-              <a:t>Visible</a:t>
+              <a:t>GitHub · GitLab · Gitea / Forgejo</a:t>
             </a:r>
-            <a:endParaRPr lang="en-US" sz="2900" dirty="0"/>
+            <a:endParaRPr lang="en-US" sz="1800" dirty="0"/>
           </a:p>
-        </p:txBody>
-      </p:sp>
-      <p:sp>
-        <p:nvSpPr>
-          <p:cNvPr id="8" name="Text 6"/>
-          <p:cNvSpPr/>
-          <p:nvPr/>
-        </p:nvSpPr>
-        <p:spPr>
-          <a:xfrm>
-            <a:off x="850392" y="3886200"/>
-            <a:ext cx="3108960" cy="658368"/>
-          </a:xfrm>
-          <a:prstGeom prst="rect">
-            <a:avLst/>
-          </a:prstGeom>
-          <a:noFill/>
-          <a:ln/>
-        </p:spPr>
-        <p:txBody>
-          <a:bodyPr wrap="square" lIns="0" tIns="0" rIns="0" bIns="0" rtlCol="0" anchor="ctr"/>
-          <a:lstStyle/>
           <a:p>
             <a:pPr indent="0" marL="0">
               <a:buNone/>
             </a:pPr>
             <a:r>
-              <a:rPr lang="en-US" sz="2200" dirty="0">
+              <a:rPr lang="en-US" sz="1800" dirty="0">
                 <a:solidFill>
                   <a:srgbClr val="405965"/>
                 </a:solidFill>
@@ -9739,26 +9752,9 @@
                 <a:ea typeface="Arial" pitchFamily="34" charset="-122"/>
                 <a:cs typeface="Arial" pitchFamily="34" charset="-120"/>
               </a:rPr>
-              <a:t>Plan + execution results</a:t>
+              <a:t>Bitbucket Cloud / Server · Azure DevOps</a:t>
             </a:r>
-            <a:endParaRPr lang="en-US" sz="2200" dirty="0"/>
-          </a:p>
-          <a:p>
-            <a:pPr indent="0" marL="0">
-              <a:buNone/>
-            </a:pPr>
-            <a:r>
-              <a:rPr lang="en-US" sz="2200" dirty="0">
-                <a:solidFill>
-                  <a:srgbClr val="405965"/>
-                </a:solidFill>
-                <a:latin typeface="Arial" pitchFamily="34" charset="0"/>
-                <a:ea typeface="Arial" pitchFamily="34" charset="-122"/>
-                <a:cs typeface="Arial" pitchFamily="34" charset="-120"/>
-              </a:rPr>
-              <a:t>beside the code review.</a:t>
-            </a:r>
-            <a:endParaRPr lang="en-US" sz="2200" dirty="0"/>
+            <a:endParaRPr lang="en-US" sz="1800" dirty="0"/>
           </a:p>
         </p:txBody>
       </p:sp>
@@ -9770,8 +9766,33 @@
         </p:nvSpPr>
         <p:spPr>
           <a:xfrm>
-            <a:off x="4352544" y="2395728"/>
-            <a:ext cx="3493008" cy="2267712"/>
+            <a:off x="3858768" y="3163824"/>
+            <a:ext cx="0" cy="228600"/>
+          </a:xfrm>
+          <a:prstGeom prst="line">
+            <a:avLst/>
+          </a:prstGeom>
+          <a:noFill/>
+          <a:ln w="25400">
+            <a:solidFill>
+              <a:srgbClr val="086679"/>
+            </a:solidFill>
+            <a:prstDash val="solid"/>
+            <a:headEnd type="none"/>
+            <a:tailEnd type="triangle"/>
+          </a:ln>
+        </p:spPr>
+      </p:sp>
+      <p:sp>
+        <p:nvSpPr>
+          <p:cNvPr id="10" name="Shape 8"/>
+          <p:cNvSpPr/>
+          <p:nvPr/>
+        </p:nvSpPr>
+        <p:spPr>
+          <a:xfrm>
+            <a:off x="640080" y="3456432"/>
+            <a:ext cx="6446520" cy="658368"/>
           </a:xfrm>
           <a:prstGeom prst="rect">
             <a:avLst/>
@@ -9789,14 +9810,14 @@
       </p:sp>
       <p:sp>
         <p:nvSpPr>
-          <p:cNvPr id="10" name="Text 8"/>
+          <p:cNvPr id="11" name="Text 9"/>
           <p:cNvSpPr/>
           <p:nvPr/>
         </p:nvSpPr>
         <p:spPr>
           <a:xfrm>
-            <a:off x="4562856" y="2606040"/>
-            <a:ext cx="2743200" cy="347472"/>
+            <a:off x="822960" y="3602736"/>
+            <a:ext cx="1920240" cy="329184"/>
           </a:xfrm>
           <a:prstGeom prst="rect">
             <a:avLst/>
@@ -9812,30 +9833,30 @@
               <a:buNone/>
             </a:pPr>
             <a:r>
-              <a:rPr lang="en-US" sz="2000" dirty="0">
-                <a:solidFill>
-                  <a:srgbClr val="086679"/>
+              <a:rPr lang="en-US" sz="2700" b="1" dirty="0">
+                <a:solidFill>
+                  <a:srgbClr val="083E4F"/>
                 </a:solidFill>
                 <a:latin typeface="Arial" pitchFamily="34" charset="0"/>
                 <a:ea typeface="Arial" pitchFamily="34" charset="-122"/>
                 <a:cs typeface="Arial" pitchFamily="34" charset="-120"/>
               </a:rPr>
-              <a:t>02</a:t>
+              <a:t>Atlantis</a:t>
             </a:r>
-            <a:endParaRPr lang="en-US" sz="2000" dirty="0"/>
+            <a:endParaRPr lang="en-US" sz="2700" dirty="0"/>
           </a:p>
         </p:txBody>
       </p:sp>
       <p:sp>
         <p:nvSpPr>
-          <p:cNvPr id="11" name="Text 9"/>
+          <p:cNvPr id="12" name="Text 10"/>
           <p:cNvSpPr/>
           <p:nvPr/>
         </p:nvSpPr>
         <p:spPr>
           <a:xfrm>
-            <a:off x="4562856" y="3182112"/>
-            <a:ext cx="3108960" cy="411480"/>
+            <a:off x="2825496" y="3630168"/>
+            <a:ext cx="4023360" cy="292608"/>
           </a:xfrm>
           <a:prstGeom prst="rect">
             <a:avLst/>
@@ -9851,73 +9872,17 @@
               <a:buNone/>
             </a:pPr>
             <a:r>
-              <a:rPr lang="en-US" sz="2900" b="1" dirty="0">
-                <a:solidFill>
-                  <a:srgbClr val="083E4F"/>
+              <a:rPr lang="en-US" sz="2300" b="1" dirty="0">
+                <a:solidFill>
+                  <a:srgbClr val="086679"/>
                 </a:solidFill>
                 <a:latin typeface="Arial" pitchFamily="34" charset="0"/>
                 <a:ea typeface="Arial" pitchFamily="34" charset="-122"/>
                 <a:cs typeface="Arial" pitchFamily="34" charset="-120"/>
               </a:rPr>
-              <a:t>Controlled</a:t>
+              <a:t>Plan → review → apply</a:t>
             </a:r>
-            <a:endParaRPr lang="en-US" sz="2900" dirty="0"/>
-          </a:p>
-        </p:txBody>
-      </p:sp>
-      <p:sp>
-        <p:nvSpPr>
-          <p:cNvPr id="12" name="Text 10"/>
-          <p:cNvSpPr/>
-          <p:nvPr/>
-        </p:nvSpPr>
-        <p:spPr>
-          <a:xfrm>
-            <a:off x="4562856" y="3886200"/>
-            <a:ext cx="3108960" cy="658368"/>
-          </a:xfrm>
-          <a:prstGeom prst="rect">
-            <a:avLst/>
-          </a:prstGeom>
-          <a:noFill/>
-          <a:ln/>
-        </p:spPr>
-        <p:txBody>
-          <a:bodyPr wrap="square" lIns="0" tIns="0" rIns="0" bIns="0" rtlCol="0" anchor="ctr"/>
-          <a:lstStyle/>
-          <a:p>
-            <a:pPr indent="0" marL="0">
-              <a:buNone/>
-            </a:pPr>
-            <a:r>
-              <a:rPr lang="en-US" sz="2200" dirty="0">
-                <a:solidFill>
-                  <a:srgbClr val="405965"/>
-                </a:solidFill>
-                <a:latin typeface="Arial" pitchFamily="34" charset="0"/>
-                <a:ea typeface="Arial" pitchFamily="34" charset="-122"/>
-                <a:cs typeface="Arial" pitchFamily="34" charset="-120"/>
-              </a:rPr>
-              <a:t>Configured approvals,</a:t>
-            </a:r>
-            <a:endParaRPr lang="en-US" sz="2200" dirty="0"/>
-          </a:p>
-          <a:p>
-            <a:pPr indent="0" marL="0">
-              <a:buNone/>
-            </a:pPr>
-            <a:r>
-              <a:rPr lang="en-US" sz="2200" dirty="0">
-                <a:solidFill>
-                  <a:srgbClr val="405965"/>
-                </a:solidFill>
-                <a:latin typeface="Arial" pitchFamily="34" charset="0"/>
-                <a:ea typeface="Arial" pitchFamily="34" charset="-122"/>
-                <a:cs typeface="Arial" pitchFamily="34" charset="-120"/>
-              </a:rPr>
-              <a:t>policies + project locks.</a:t>
-            </a:r>
-            <a:endParaRPr lang="en-US" sz="2200" dirty="0"/>
+            <a:endParaRPr lang="en-US" sz="2300" dirty="0"/>
           </a:p>
         </p:txBody>
       </p:sp>
@@ -9929,8 +9894,33 @@
         </p:nvSpPr>
         <p:spPr>
           <a:xfrm>
-            <a:off x="8065008" y="2395728"/>
-            <a:ext cx="3493008" cy="2267712"/>
+            <a:off x="3858768" y="4160520"/>
+            <a:ext cx="0" cy="228600"/>
+          </a:xfrm>
+          <a:prstGeom prst="line">
+            <a:avLst/>
+          </a:prstGeom>
+          <a:noFill/>
+          <a:ln w="25400">
+            <a:solidFill>
+              <a:srgbClr val="086679"/>
+            </a:solidFill>
+            <a:prstDash val="solid"/>
+            <a:headEnd type="none"/>
+            <a:tailEnd type="triangle"/>
+          </a:ln>
+        </p:spPr>
+      </p:sp>
+      <p:sp>
+        <p:nvSpPr>
+          <p:cNvPr id="14" name="Shape 12"/>
+          <p:cNvSpPr/>
+          <p:nvPr/>
+        </p:nvSpPr>
+        <p:spPr>
+          <a:xfrm>
+            <a:off x="640080" y="4443984"/>
+            <a:ext cx="6446520" cy="905256"/>
           </a:xfrm>
           <a:prstGeom prst="rect">
             <a:avLst/>
@@ -9948,14 +9938,14 @@
       </p:sp>
       <p:sp>
         <p:nvSpPr>
-          <p:cNvPr id="14" name="Text 12"/>
+          <p:cNvPr id="15" name="Text 13"/>
           <p:cNvSpPr/>
           <p:nvPr/>
         </p:nvSpPr>
         <p:spPr>
           <a:xfrm>
-            <a:off x="8275320" y="2606040"/>
-            <a:ext cx="2743200" cy="347472"/>
+            <a:off x="822960" y="4562856"/>
+            <a:ext cx="6080760" cy="338328"/>
           </a:xfrm>
           <a:prstGeom prst="rect">
             <a:avLst/>
@@ -9971,30 +9961,30 @@
               <a:buNone/>
             </a:pPr>
             <a:r>
-              <a:rPr lang="en-US" sz="2000" dirty="0">
-                <a:solidFill>
-                  <a:srgbClr val="086679"/>
+              <a:rPr lang="en-US" sz="2400" b="1" dirty="0">
+                <a:solidFill>
+                  <a:srgbClr val="083E4F"/>
                 </a:solidFill>
                 <a:latin typeface="Arial" pitchFamily="34" charset="0"/>
                 <a:ea typeface="Arial" pitchFamily="34" charset="-122"/>
                 <a:cs typeface="Arial" pitchFamily="34" charset="-120"/>
               </a:rPr>
-              <a:t>03</a:t>
+              <a:t>IaC execution: Terraform / OpenTofu</a:t>
             </a:r>
-            <a:endParaRPr lang="en-US" sz="2000" dirty="0"/>
+            <a:endParaRPr lang="en-US" sz="2400" dirty="0"/>
           </a:p>
         </p:txBody>
       </p:sp>
       <p:sp>
         <p:nvSpPr>
-          <p:cNvPr id="15" name="Text 13"/>
+          <p:cNvPr id="16" name="Text 14"/>
           <p:cNvSpPr/>
           <p:nvPr/>
         </p:nvSpPr>
         <p:spPr>
           <a:xfrm>
-            <a:off x="8275320" y="3182112"/>
-            <a:ext cx="3108960" cy="411480"/>
+            <a:off x="822960" y="5020056"/>
+            <a:ext cx="6080760" cy="265176"/>
           </a:xfrm>
           <a:prstGeom prst="rect">
             <a:avLst/>
@@ -10010,30 +10000,119 @@
               <a:buNone/>
             </a:pPr>
             <a:r>
-              <a:rPr lang="en-US" sz="2900" b="1" dirty="0">
-                <a:solidFill>
-                  <a:srgbClr val="083E4F"/>
+              <a:rPr lang="en-US" sz="1900" dirty="0">
+                <a:solidFill>
+                  <a:srgbClr val="405965"/>
                 </a:solidFill>
                 <a:latin typeface="Arial" pitchFamily="34" charset="0"/>
                 <a:ea typeface="Arial" pitchFamily="34" charset="-122"/>
                 <a:cs typeface="Arial" pitchFamily="34" charset="-120"/>
               </a:rPr>
-              <a:t>Collaborative</a:t>
+              <a:t>Optional: Terragrunt via custom workflows</a:t>
             </a:r>
-            <a:endParaRPr lang="en-US" sz="2900" dirty="0"/>
+            <a:endParaRPr lang="en-US" sz="1900" dirty="0"/>
           </a:p>
         </p:txBody>
       </p:sp>
       <p:sp>
         <p:nvSpPr>
-          <p:cNvPr id="16" name="Text 14"/>
+          <p:cNvPr id="17" name="Shape 15"/>
           <p:cNvSpPr/>
           <p:nvPr/>
         </p:nvSpPr>
         <p:spPr>
           <a:xfrm>
-            <a:off x="8275320" y="3886200"/>
-            <a:ext cx="3108960" cy="658368"/>
+            <a:off x="3858768" y="5385816"/>
+            <a:ext cx="0" cy="219456"/>
+          </a:xfrm>
+          <a:prstGeom prst="line">
+            <a:avLst/>
+          </a:prstGeom>
+          <a:noFill/>
+          <a:ln w="25400">
+            <a:solidFill>
+              <a:srgbClr val="086679"/>
+            </a:solidFill>
+            <a:prstDash val="solid"/>
+            <a:headEnd type="none"/>
+            <a:tailEnd type="triangle"/>
+          </a:ln>
+        </p:spPr>
+      </p:sp>
+      <p:sp>
+        <p:nvSpPr>
+          <p:cNvPr id="18" name="Text 16"/>
+          <p:cNvSpPr/>
+          <p:nvPr/>
+        </p:nvSpPr>
+        <p:spPr>
+          <a:xfrm>
+            <a:off x="822960" y="5660136"/>
+            <a:ext cx="6080760" cy="329184"/>
+          </a:xfrm>
+          <a:prstGeom prst="rect">
+            <a:avLst/>
+          </a:prstGeom>
+          <a:noFill/>
+          <a:ln/>
+        </p:spPr>
+        <p:txBody>
+          <a:bodyPr wrap="square" lIns="0" tIns="0" rIns="0" bIns="0" rtlCol="0" anchor="ctr"/>
+          <a:lstStyle/>
+          <a:p>
+            <a:pPr algn="ctr" indent="0" marL="0">
+              <a:buNone/>
+            </a:pPr>
+            <a:r>
+              <a:rPr lang="en-US" sz="2400" b="1" dirty="0">
+                <a:solidFill>
+                  <a:srgbClr val="083E4F"/>
+                </a:solidFill>
+                <a:latin typeface="Arial" pitchFamily="34" charset="0"/>
+                <a:ea typeface="Arial" pitchFamily="34" charset="-122"/>
+                <a:cs typeface="Arial" pitchFamily="34" charset="-120"/>
+              </a:rPr>
+              <a:t>Infrastructure · via provider APIs</a:t>
+            </a:r>
+            <a:endParaRPr lang="en-US" sz="2400" dirty="0"/>
+          </a:p>
+        </p:txBody>
+      </p:sp>
+      <p:sp>
+        <p:nvSpPr>
+          <p:cNvPr id="19" name="Shape 17"/>
+          <p:cNvSpPr/>
+          <p:nvPr/>
+        </p:nvSpPr>
+        <p:spPr>
+          <a:xfrm>
+            <a:off x="7424928" y="1947672"/>
+            <a:ext cx="4114800" cy="4169664"/>
+          </a:xfrm>
+          <a:prstGeom prst="rect">
+            <a:avLst/>
+          </a:prstGeom>
+          <a:solidFill>
+            <a:srgbClr val="EAF1F3"/>
+          </a:solidFill>
+          <a:ln w="12700">
+            <a:solidFill>
+              <a:srgbClr val="EAF1F3"/>
+            </a:solidFill>
+            <a:prstDash val="solid"/>
+          </a:ln>
+        </p:spPr>
+      </p:sp>
+      <p:sp>
+        <p:nvSpPr>
+          <p:cNvPr id="20" name="Text 18"/>
+          <p:cNvSpPr/>
+          <p:nvPr/>
+        </p:nvSpPr>
+        <p:spPr>
+          <a:xfrm>
+            <a:off x="7589520" y="2057400"/>
+            <a:ext cx="3785616" cy="274320"/>
           </a:xfrm>
           <a:prstGeom prst="rect">
             <a:avLst/>
@@ -10049,47 +10128,30 @@
               <a:buNone/>
             </a:pPr>
             <a:r>
-              <a:rPr lang="en-US" sz="2200" dirty="0">
-                <a:solidFill>
-                  <a:srgbClr val="405965"/>
+              <a:rPr lang="en-US" sz="1700" b="1" dirty="0">
+                <a:solidFill>
+                  <a:srgbClr val="086679"/>
                 </a:solidFill>
                 <a:latin typeface="Arial" pitchFamily="34" charset="0"/>
                 <a:ea typeface="Arial" pitchFamily="34" charset="-122"/>
                 <a:cs typeface="Arial" pitchFamily="34" charset="-120"/>
               </a:rPr>
-              <a:t>Developers propose.</a:t>
+              <a:t>Atlantis User Survey · 2024 · n=354</a:t>
             </a:r>
-            <a:endParaRPr lang="en-US" sz="2200" dirty="0"/>
-          </a:p>
-          <a:p>
-            <a:pPr indent="0" marL="0">
-              <a:buNone/>
-            </a:pPr>
-            <a:r>
-              <a:rPr lang="en-US" sz="2200" dirty="0">
-                <a:solidFill>
-                  <a:srgbClr val="405965"/>
-                </a:solidFill>
-                <a:latin typeface="Arial" pitchFamily="34" charset="0"/>
-                <a:ea typeface="Arial" pitchFamily="34" charset="-122"/>
-                <a:cs typeface="Arial" pitchFamily="34" charset="-120"/>
-              </a:rPr>
-              <a:t>The platform runs it.</a:t>
-            </a:r>
-            <a:endParaRPr lang="en-US" sz="2200" dirty="0"/>
+            <a:endParaRPr lang="en-US" sz="1700" dirty="0"/>
           </a:p>
         </p:txBody>
       </p:sp>
       <p:sp>
         <p:nvSpPr>
-          <p:cNvPr id="17" name="Text 15"/>
+          <p:cNvPr id="21" name="Text 19"/>
           <p:cNvSpPr/>
           <p:nvPr/>
         </p:nvSpPr>
         <p:spPr>
           <a:xfrm>
-            <a:off x="640080" y="4992624"/>
-            <a:ext cx="10972800" cy="411480"/>
+            <a:off x="7589520" y="2459736"/>
+            <a:ext cx="3749040" cy="594360"/>
           </a:xfrm>
           <a:prstGeom prst="rect">
             <a:avLst/>
@@ -10105,30 +10167,30 @@
               <a:buNone/>
             </a:pPr>
             <a:r>
-              <a:rPr lang="en-US" sz="2600" b="1" dirty="0">
-                <a:solidFill>
-                  <a:srgbClr val="086679"/>
+              <a:rPr lang="en-US" sz="5400" b="1" dirty="0">
+                <a:solidFill>
+                  <a:srgbClr val="083E4F"/>
                 </a:solidFill>
                 <a:latin typeface="Arial" pitchFamily="34" charset="0"/>
                 <a:ea typeface="Arial" pitchFamily="34" charset="-122"/>
                 <a:cs typeface="Arial" pitchFamily="34" charset="-120"/>
               </a:rPr>
-              <a:t>Self-hosted · Kubernetes / Helm, or a server</a:t>
+              <a:t>354</a:t>
             </a:r>
-            <a:endParaRPr lang="en-US" sz="2600" dirty="0"/>
+            <a:endParaRPr lang="en-US" sz="5400" dirty="0"/>
           </a:p>
         </p:txBody>
       </p:sp>
       <p:sp>
         <p:nvSpPr>
-          <p:cNvPr id="18" name="Text 16"/>
+          <p:cNvPr id="22" name="Text 20"/>
           <p:cNvSpPr/>
           <p:nvPr/>
         </p:nvSpPr>
         <p:spPr>
           <a:xfrm>
-            <a:off x="640080" y="5504688"/>
-            <a:ext cx="10972800" cy="320040"/>
+            <a:off x="7589520" y="3072384"/>
+            <a:ext cx="3749040" cy="292608"/>
           </a:xfrm>
           <a:prstGeom prst="rect">
             <a:avLst/>
@@ -10144,7 +10206,7 @@
               <a:buNone/>
             </a:pPr>
             <a:r>
-              <a:rPr lang="en-US" sz="1900" dirty="0">
+              <a:rPr lang="en-US" sz="2300" dirty="0">
                 <a:solidFill>
                   <a:srgbClr val="405965"/>
                 </a:solidFill>
@@ -10152,7 +10214,292 @@
                 <a:ea typeface="Arial" pitchFamily="34" charset="-122"/>
                 <a:cs typeface="Arial" pitchFamily="34" charset="-120"/>
               </a:rPr>
-              <a:t>Today: alpha drift APIs · v0.47.1 command-injection fix</a:t>
+              <a:t>survey responses</a:t>
+            </a:r>
+            <a:endParaRPr lang="en-US" sz="2300" dirty="0"/>
+          </a:p>
+        </p:txBody>
+      </p:sp>
+      <p:sp>
+        <p:nvSpPr>
+          <p:cNvPr id="23" name="Text 21"/>
+          <p:cNvSpPr/>
+          <p:nvPr/>
+        </p:nvSpPr>
+        <p:spPr>
+          <a:xfrm>
+            <a:off x="7589520" y="3474720"/>
+            <a:ext cx="3749040" cy="228600"/>
+          </a:xfrm>
+          <a:prstGeom prst="rect">
+            <a:avLst/>
+          </a:prstGeom>
+          <a:noFill/>
+          <a:ln/>
+        </p:spPr>
+        <p:txBody>
+          <a:bodyPr wrap="square" lIns="0" tIns="0" rIns="0" bIns="0" rtlCol="0" anchor="ctr"/>
+          <a:lstStyle/>
+          <a:p>
+            <a:pPr indent="0" marL="0">
+              <a:buNone/>
+            </a:pPr>
+            <a:r>
+              <a:rPr lang="en-US" sz="1800" b="1" dirty="0">
+                <a:solidFill>
+                  <a:srgbClr val="086679"/>
+                </a:solidFill>
+                <a:latin typeface="Arial" pitchFamily="34" charset="0"/>
+                <a:ea typeface="Arial" pitchFamily="34" charset="-122"/>
+                <a:cs typeface="Arial" pitchFamily="34" charset="-120"/>
+              </a:rPr>
+              <a:t>GIT</a:t>
+            </a:r>
+            <a:endParaRPr lang="en-US" sz="1800" dirty="0"/>
+          </a:p>
+        </p:txBody>
+      </p:sp>
+      <p:sp>
+        <p:nvSpPr>
+          <p:cNvPr id="24" name="Text 22"/>
+          <p:cNvSpPr/>
+          <p:nvPr/>
+        </p:nvSpPr>
+        <p:spPr>
+          <a:xfrm>
+            <a:off x="7589520" y="3749040"/>
+            <a:ext cx="3749040" cy="502920"/>
+          </a:xfrm>
+          <a:prstGeom prst="rect">
+            <a:avLst/>
+          </a:prstGeom>
+          <a:noFill/>
+          <a:ln/>
+        </p:spPr>
+        <p:txBody>
+          <a:bodyPr wrap="square" lIns="0" tIns="0" rIns="0" bIns="0" rtlCol="0" anchor="ctr"/>
+          <a:lstStyle/>
+          <a:p>
+            <a:pPr indent="0" marL="0">
+              <a:buNone/>
+            </a:pPr>
+            <a:r>
+              <a:rPr lang="en-US" sz="1900" dirty="0">
+                <a:solidFill>
+                  <a:srgbClr val="083E4F"/>
+                </a:solidFill>
+                <a:latin typeface="Arial" pitchFamily="34" charset="0"/>
+                <a:ea typeface="Arial" pitchFamily="34" charset="-122"/>
+                <a:cs typeface="Arial" pitchFamily="34" charset="-120"/>
+              </a:rPr>
+              <a:t>GitHub leads · GitLab sizeable</a:t>
+            </a:r>
+            <a:endParaRPr lang="en-US" sz="1900" dirty="0"/>
+          </a:p>
+          <a:p>
+            <a:pPr indent="0" marL="0">
+              <a:buNone/>
+            </a:pPr>
+            <a:r>
+              <a:rPr lang="en-US" sz="1900" dirty="0">
+                <a:solidFill>
+                  <a:srgbClr val="083E4F"/>
+                </a:solidFill>
+                <a:latin typeface="Arial" pitchFamily="34" charset="0"/>
+                <a:ea typeface="Arial" pitchFamily="34" charset="-122"/>
+                <a:cs typeface="Arial" pitchFamily="34" charset="-120"/>
+              </a:rPr>
+              <a:t>Bitbucket + others</a:t>
+            </a:r>
+            <a:endParaRPr lang="en-US" sz="1900" dirty="0"/>
+          </a:p>
+        </p:txBody>
+      </p:sp>
+      <p:sp>
+        <p:nvSpPr>
+          <p:cNvPr id="25" name="Text 23"/>
+          <p:cNvSpPr/>
+          <p:nvPr/>
+        </p:nvSpPr>
+        <p:spPr>
+          <a:xfrm>
+            <a:off x="7589520" y="4325112"/>
+            <a:ext cx="3749040" cy="228600"/>
+          </a:xfrm>
+          <a:prstGeom prst="rect">
+            <a:avLst/>
+          </a:prstGeom>
+          <a:noFill/>
+          <a:ln/>
+        </p:spPr>
+        <p:txBody>
+          <a:bodyPr wrap="square" lIns="0" tIns="0" rIns="0" bIns="0" rtlCol="0" anchor="ctr"/>
+          <a:lstStyle/>
+          <a:p>
+            <a:pPr indent="0" marL="0">
+              <a:buNone/>
+            </a:pPr>
+            <a:r>
+              <a:rPr lang="en-US" sz="1800" b="1" dirty="0">
+                <a:solidFill>
+                  <a:srgbClr val="086679"/>
+                </a:solidFill>
+                <a:latin typeface="Arial" pitchFamily="34" charset="0"/>
+                <a:ea typeface="Arial" pitchFamily="34" charset="-122"/>
+                <a:cs typeface="Arial" pitchFamily="34" charset="-120"/>
+              </a:rPr>
+              <a:t>IaC</a:t>
+            </a:r>
+            <a:endParaRPr lang="en-US" sz="1800" dirty="0"/>
+          </a:p>
+        </p:txBody>
+      </p:sp>
+      <p:sp>
+        <p:nvSpPr>
+          <p:cNvPr id="26" name="Text 24"/>
+          <p:cNvSpPr/>
+          <p:nvPr/>
+        </p:nvSpPr>
+        <p:spPr>
+          <a:xfrm>
+            <a:off x="7589520" y="4626864"/>
+            <a:ext cx="3749040" cy="713232"/>
+          </a:xfrm>
+          <a:prstGeom prst="rect">
+            <a:avLst/>
+          </a:prstGeom>
+          <a:noFill/>
+          <a:ln/>
+        </p:spPr>
+        <p:txBody>
+          <a:bodyPr wrap="square" lIns="0" tIns="0" rIns="0" bIns="0" rtlCol="0" anchor="ctr"/>
+          <a:lstStyle/>
+          <a:p>
+            <a:pPr indent="0" marL="0">
+              <a:buNone/>
+            </a:pPr>
+            <a:r>
+              <a:rPr lang="en-US" sz="1900" dirty="0">
+                <a:solidFill>
+                  <a:srgbClr val="083E4F"/>
+                </a:solidFill>
+                <a:latin typeface="Arial" pitchFamily="34" charset="0"/>
+                <a:ea typeface="Arial" pitchFamily="34" charset="-122"/>
+                <a:cs typeface="Arial" pitchFamily="34" charset="-120"/>
+              </a:rPr>
+              <a:t>Terraform dominant</a:t>
+            </a:r>
+            <a:endParaRPr lang="en-US" sz="1900" dirty="0"/>
+          </a:p>
+          <a:p>
+            <a:pPr indent="0" marL="0">
+              <a:buNone/>
+            </a:pPr>
+            <a:r>
+              <a:rPr lang="en-US" sz="1900" dirty="0">
+                <a:solidFill>
+                  <a:srgbClr val="083E4F"/>
+                </a:solidFill>
+                <a:latin typeface="Arial" pitchFamily="34" charset="0"/>
+                <a:ea typeface="Arial" pitchFamily="34" charset="-122"/>
+                <a:cs typeface="Arial" pitchFamily="34" charset="-120"/>
+              </a:rPr>
+              <a:t>About half also use Terragrunt</a:t>
+            </a:r>
+            <a:endParaRPr lang="en-US" sz="1900" dirty="0"/>
+          </a:p>
+          <a:p>
+            <a:pPr indent="0" marL="0">
+              <a:buNone/>
+            </a:pPr>
+            <a:r>
+              <a:rPr lang="en-US" sz="1900" dirty="0">
+                <a:solidFill>
+                  <a:srgbClr val="083E4F"/>
+                </a:solidFill>
+                <a:latin typeface="Arial" pitchFamily="34" charset="0"/>
+                <a:ea typeface="Arial" pitchFamily="34" charset="-122"/>
+                <a:cs typeface="Arial" pitchFamily="34" charset="-120"/>
+              </a:rPr>
+              <a:t>OpenTofu gaining ground</a:t>
+            </a:r>
+            <a:endParaRPr lang="en-US" sz="1900" dirty="0"/>
+          </a:p>
+        </p:txBody>
+      </p:sp>
+      <p:sp>
+        <p:nvSpPr>
+          <p:cNvPr id="27" name="Text 25"/>
+          <p:cNvSpPr/>
+          <p:nvPr/>
+        </p:nvSpPr>
+        <p:spPr>
+          <a:xfrm>
+            <a:off x="7589520" y="5431536"/>
+            <a:ext cx="3749040" cy="228600"/>
+          </a:xfrm>
+          <a:prstGeom prst="rect">
+            <a:avLst/>
+          </a:prstGeom>
+          <a:noFill/>
+          <a:ln/>
+        </p:spPr>
+        <p:txBody>
+          <a:bodyPr wrap="square" lIns="0" tIns="0" rIns="0" bIns="0" rtlCol="0" anchor="ctr"/>
+          <a:lstStyle/>
+          <a:p>
+            <a:pPr indent="0" marL="0">
+              <a:buNone/>
+            </a:pPr>
+            <a:r>
+              <a:rPr lang="en-US" sz="1800" b="1" dirty="0">
+                <a:solidFill>
+                  <a:srgbClr val="086679"/>
+                </a:solidFill>
+                <a:latin typeface="Arial" pitchFamily="34" charset="0"/>
+                <a:ea typeface="Arial" pitchFamily="34" charset="-122"/>
+                <a:cs typeface="Arial" pitchFamily="34" charset="-120"/>
+              </a:rPr>
+              <a:t>RUNTIME</a:t>
+            </a:r>
+            <a:endParaRPr lang="en-US" sz="1800" dirty="0"/>
+          </a:p>
+        </p:txBody>
+      </p:sp>
+      <p:sp>
+        <p:nvSpPr>
+          <p:cNvPr id="28" name="Text 26"/>
+          <p:cNvSpPr/>
+          <p:nvPr/>
+        </p:nvSpPr>
+        <p:spPr>
+          <a:xfrm>
+            <a:off x="7589520" y="5715000"/>
+            <a:ext cx="3749040" cy="237744"/>
+          </a:xfrm>
+          <a:prstGeom prst="rect">
+            <a:avLst/>
+          </a:prstGeom>
+          <a:noFill/>
+          <a:ln/>
+        </p:spPr>
+        <p:txBody>
+          <a:bodyPr wrap="square" lIns="0" tIns="0" rIns="0" bIns="0" rtlCol="0" anchor="ctr"/>
+          <a:lstStyle/>
+          <a:p>
+            <a:pPr indent="0" marL="0">
+              <a:buNone/>
+            </a:pPr>
+            <a:r>
+              <a:rPr lang="en-US" sz="1900" dirty="0">
+                <a:solidFill>
+                  <a:srgbClr val="083E4F"/>
+                </a:solidFill>
+                <a:latin typeface="Arial" pitchFamily="34" charset="0"/>
+                <a:ea typeface="Arial" pitchFamily="34" charset="-122"/>
+                <a:cs typeface="Arial" pitchFamily="34" charset="-120"/>
+              </a:rPr>
+              <a:t>Kubernetes / AWS common</a:t>
             </a:r>
             <a:endParaRPr lang="en-US" sz="1900" dirty="0"/>
           </a:p>

</xml_diff>

<commit_message>
docs: distribute Atlantis talk content and preserve reference deck
Signed-off-by: Rui Chen <rui@chenrui.dev>
</commit_message>
<xml_diff>
--- a/talks/kubecon-china-2026-atlantis-lightning/slides.pptx
+++ b/talks/kubecon-china-2026-atlantis-lightning/slides.pptx
@@ -511,13 +511,13 @@
           <a:p>
             <a:r>
               <a:rPr lang="en-US" dirty="0"/>
-              <a:t>Target: 0:00–0:15 (15 seconds)
-Spoken words: 22
-Cue: Start with the definition.
-Hi, I'm Rui, an Atlantis maintainer. Atlantis is an open-source service that runs Terraform and OpenTofu plans and applies from pull requests.
+              <a:t>Target: 0:00–0:20 (20 seconds)
+Spoken words: 34
+Cue: Define Atlantis before introducing the workflow.
+Hi, I'm Rui, an Atlantis maintainer. Atlantis is an open-source service that runs Terraform and OpenTofu plans and applies from pull requests. The idea is simple: code review should include the infrastructure execution result.
 Transition: Advance after the final sentence.
 Emergency cuts:
-</a:t>
+None; retain this slide’s narration.</a:t>
             </a:r>
             <a:endParaRPr lang="en-US" dirty="0"/>
           </a:p>
@@ -605,14 +605,13 @@
           <a:p>
             <a:r>
               <a:rPr lang="en-US" dirty="0"/>
-              <a:t>Target: 4:05–4:35 (30 seconds)
-Spoken words: 52
-Cue: Point to the URL, then land the final four phrases.
-Atlantis is a CNCF Sandbox project. Visit runatlantis dot io for the getting-started guide, or find the code and contribution guide on GitHub. Start with one repository and one infrastructure change. Bring your team's review rules into that workflow. Infrastructure is code. Plan it. Review it. Apply it. From the pull request.
+              <a:t>Target: 4:05–4:30 (25 seconds)
+Spoken words: 43
+Cue: Point to discovery links, then hold the final slide.
+Learn more at runatlantis dot io, explore the code on GitHub, and join the CNCF community. Find Atlantis at Project Pavilion, table T-ten, in Grand Ballroom One on Tuesday morning. Infrastructure is code. Plan it. Review it. Apply it. From the pull request.
 Transition: Hold the closing slide.
 Emergency cuts:
-Start with one repository and one infrastructure change.
-Bring your team's review rules into that workflow.</a:t>
+None; retain this slide’s narration.</a:t>
             </a:r>
             <a:endParaRPr lang="en-US" dirty="0"/>
           </a:p>
@@ -700,13 +699,13 @@
           <a:p>
             <a:r>
               <a:rPr lang="en-US" dirty="0"/>
-              <a:t>Target: 0:15–0:35 (20 seconds)
-Spoken words: 39
-Cue: Point to the missing plan and result.
-Many teams already automate infrastructure. But if your workflow ends with someone running a command from a laptop, the reviewer may see the code without seeing the plan or the result. Atlantis brings those parts into the same conversation.
+              <a:t>Target: 0:20–1:10 (50 seconds)
+Spoken words: 76
+Cue: Trace the numbered loop once; pause at review.
+Many teams already automate infrastructure. Atlantis brings planning, review, execution, and results into one workflow. A developer opens a pull request. The Git host sends a webhook; Atlantis runs Terraform or OpenTofu and posts the plan back. The team reviews the code and plan together. An authorized engineer requests atlantis apply. Atlantis checks configured requirements, executes the change, and reports the result in the pull request. The infrastructure tooling still uses your providers and state backend.
 Transition: Advance after the final sentence.
 Emergency cuts:
-</a:t>
+None; retain this slide’s narration.</a:t>
             </a:r>
             <a:endParaRPr lang="en-US" dirty="0"/>
           </a:p>
@@ -794,13 +793,13 @@
           <a:p>
             <a:r>
               <a:rPr lang="en-US" dirty="0"/>
-              <a:t>Target: 0:35–1:10 (35 seconds)
-Spoken words: 57
-Cue: Trace the webhook and return arrow.
-A developer opens a pull request. The Git host sends a webhook to Atlantis, a service your team hosts. Atlantis detects affected projects and runs a plan using Terraform or OpenTofu. The plan describes the proposed infrastructure changes. Atlantis posts the result back to the pull request, so reviewers can read the code and the plan together.
+              <a:t>Target: 1:10–1:50 (40 seconds)
+Spoken words: 61
+Cue: Explain the engineer experience; do not repeat the architecture.
+Here is one database capacity change. The summary says zero to add, one to change, zero to destroy. Small does not mean safe: the reviewer reads the full plan and considers operational impact. Approval and the apply request stay in the conversation. If execution fails, the team can correct the change in the same pull request. This example applies before merging.
 Transition: Advance after the final sentence.
 Emergency cuts:
-</a:t>
+If execution fails, the team can correct the change in the same pull request.</a:t>
             </a:r>
             <a:endParaRPr lang="en-US" dirty="0"/>
           </a:p>
@@ -888,13 +887,13 @@
           <a:p>
             <a:r>
               <a:rPr lang="en-US" dirty="0"/>
-              <a:t>Target: 1:10–1:40 (30 seconds)
-Spoken words: 44
-Cue: Review stays in Git; execution runs on Atlantis.
-After review, an authorized engineer comments atlantis apply. Atlantis checks the requirements your platform team configured, then runs the apply and reports the result. Terraform or OpenTofu still talks to provider APIs and uses your state backend. Atlantis coordinates the workflow around those tools.
+              <a:t>Target: 1:50–2:15 (25 seconds)
+Spoken words: 46
+Cue: Three outcomes; centralized execution is not a security guarantee.
+For a platform team, the benefit is visibility, control, and collaboration. Plans and results sit beside the code review. Execution and credentials live in a managed service, with requirements your team configures. Developers propose changes through Git. The service still needs careful permissions and trusted repositories.
 Transition: Advance after the final sentence.
 Emergency cuts:
-</a:t>
+None; retain this slide’s narration.</a:t>
             </a:r>
             <a:endParaRPr lang="en-US" dirty="0"/>
           </a:p>
@@ -982,13 +981,13 @@
           <a:p>
             <a:r>
               <a:rPr lang="en-US" dirty="0"/>
-              <a:t>Target: 1:40–2:30 (50 seconds)
-Spoken words: 104
-Cue: Walk the PR rows. A small plan still needs review.
-Here is a simplified example: increase a database's capacity. Atlantis posts a plan: zero resources to add, one to change, zero to destroy. That one change still deserves attention. For a database, that could include downtime, connection limits, and the cost change. The reviewer reads the full plan and checks the operational impact, then approves the pull request. I comment atlantis apply, and the bot reports completion. In this workflow, we apply before merging. If the apply fails, we can fix the change in the same pull request and try again. That is the experience to remember: review infrastructure where you already review code.
+              <a:t>Target: 2:15–2:40 (25 seconds)
+Spoken words: 39
+Cue: Point to the flow; do not read the host list.
+Atlantis fits several Git hosts and supports both Terraform and OpenTofu. Terragrunt can run through custom workflows. You could build this in generic CI; Atlantis packages the infrastructure-specific PR interaction, project planning, applying, and locking into a purpose-built service.
 Transition: Advance after the final sentence.
 Emergency cuts:
-If the apply fails, we can fix the change in the same pull request and try again.</a:t>
+You could build this in generic CI; Atlantis packages the infrastructure-specific PR interaction, project planning, applying, and locking into a purpose-built service.</a:t>
             </a:r>
             <a:endParaRPr lang="en-US" dirty="0"/>
           </a:p>
@@ -1076,13 +1075,13 @@
           <a:p>
             <a:r>
               <a:rPr lang="en-US" dirty="0"/>
-              <a:t>Target: 2:30–2:55 (25 seconds)
-Spoken words: 39
-Cue: Git → execution → optional policy and cost context.
-Atlantis connects your Git host to Terraform or OpenTofu. Terragrunt can run through custom workflows. Optional Conftest checks evaluate policy against the plan. Infracost can add cost estimates through a workflow integration. These give reviewers more context before execution.
+              <a:t>Target: 2:40–3:00 (20 seconds)
+Spoken words: 31
+Cue: Policy and cost are separate, optional review inputs.
+Optional integrations add context. Conftest evaluates policy against the plan. Infracost can add cost estimates through workflow integration. Your platform team configures these checks; installing Atlantis does not automatically enable them.
 Transition: Advance after the final sentence.
 Emergency cuts:
-</a:t>
+None; retain this slide’s narration.</a:t>
             </a:r>
             <a:endParaRPr lang="en-US" dirty="0"/>
           </a:p>
@@ -1170,13 +1169,13 @@
           <a:p>
             <a:r>
               <a:rPr lang="en-US" dirty="0"/>
-              <a:t>Target: 2:55–3:15 (20 seconds)
+              <a:t>Target: 3:00–3:20 (20 seconds)
 Spoken words: 34
-Cue: Hosting choices differ from managed infrastructure.
-For deployment, choose Kubernetes with Helm, containers, or a server. The docs include AWS Fargate, Google Cloud, and Azure options. This is where Atlantis runs; Terraform and OpenTofu providers determine what infrastructure it manages.
+Cue: Hosting choice does not determine provider support.
+Deploy Atlantis on Kubernetes with the official Helm chart, as a container, or as a server binary. Kubernetes is optional. Where Atlantis runs is separate from the infrastructure your Terraform or OpenTofu providers manage.
 Transition: Advance after the final sentence.
 Emergency cuts:
-</a:t>
+None; retain this slide’s narration.</a:t>
             </a:r>
             <a:endParaRPr lang="en-US" dirty="0"/>
           </a:p>
@@ -1264,13 +1263,13 @@
           <a:p>
             <a:r>
               <a:rPr lang="en-US" dirty="0"/>
-              <a:t>Target: 3:15–3:45 (30 seconds)
-Spoken words: 56
-Cue: One historical survey; point to the three findings.
-The project's twenty twenty-four survey received three hundred fifty-four responses. GitHub led, with a sizeable GitLab group, followed by Bitbucket and others. Terraform dominated; about half also used Terragrunt, and OpenTofu was gaining ground. Kubernetes and AWS were common deployment environments. These are community responses, not market share. The full results are in the project's blog.
+              <a:t>Target: 3:20–3:50 (30 seconds)
+Spoken words: 43
+Cue: Say the year; point to the official survey blog.
+The project's twenty twenty-four survey received three hundred fifty-four responses. GitHub led, with sizeable GitLab usage. Terraform dominated; about half also used Terragrunt, and OpenTofu was gaining ground. Kubernetes and AWS were common deployment environments. These are historical community responses, not market share.
 Transition: Advance after the final sentence.
 Emergency cuts:
-</a:t>
+None; retain this slide’s narration.</a:t>
             </a:r>
             <a:endParaRPr lang="en-US" dirty="0"/>
           </a:p>
@@ -1358,13 +1357,13 @@
           <a:p>
             <a:r>
               <a:rPr lang="en-US" dirty="0"/>
-              <a:t>Target: 3:45–4:05 (20 seconds)
-Spoken words: 42
-Cue: Draft direction, not a release announcement.
-The team is also planning for one point zero. The draft proposal emphasizes stability, backwards compatibility, and clearer versioning for breaking changes. This is a planning discussion, not a released version or a promised date. The pull-request workflow remains the starting point.
+              <a:t>Target: 3:50–4:05 (15 seconds)
+Spoken words: 26
+Cue: Keep project direction brief and explicitly provisional.
+The draft one point zero proposal emphasizes stability, backwards compatibility, and clearer versioning. It is a planning discussion, not a release announcement or a promised date.
 Transition: Advance after the final sentence.
 Emergency cuts:
-</a:t>
+None; retain this slide’s narration.</a:t>
             </a:r>
             <a:endParaRPr lang="en-US" dirty="0"/>
           </a:p>
@@ -8759,8 +8758,8 @@
         </p:nvSpPr>
         <p:spPr>
           <a:xfrm>
-            <a:off x="566928" y="4864608"/>
-            <a:ext cx="7589520" cy="594360"/>
+            <a:off x="566928" y="4800600"/>
+            <a:ext cx="7589520" cy="457200"/>
           </a:xfrm>
           <a:prstGeom prst="rect">
             <a:avLst/>
@@ -8874,8 +8873,8 @@
         </p:nvSpPr>
         <p:spPr>
           <a:xfrm>
-            <a:off x="566928" y="5559552"/>
-            <a:ext cx="7772400" cy="347472"/>
+            <a:off x="566928" y="5385816"/>
+            <a:ext cx="7772400" cy="301752"/>
           </a:xfrm>
           <a:prstGeom prst="rect">
             <a:avLst/>
@@ -8906,9 +8905,57 @@
                   </a:extLst>
                 </a:hlinkClick>
               </a:rPr>
-              <a:t>github.com/runatlantis/atlantis</a:t>
+              <a:t>GitHub: runatlantis/atlantis</a:t>
             </a:r>
             <a:endParaRPr lang="en-US" sz="2200" dirty="0"/>
+          </a:p>
+        </p:txBody>
+      </p:sp>
+      <p:sp>
+        <p:nvSpPr>
+          <p:cNvPr id="10" name="Text 7">
+            <a:hlinkClick r:id="rId5" tooltip=""/>
+          </p:cNvPr>
+          <p:cNvSpPr/>
+          <p:nvPr/>
+        </p:nvSpPr>
+        <p:spPr>
+          <a:xfrm>
+            <a:off x="566928" y="5806440"/>
+            <a:ext cx="10789920" cy="274320"/>
+          </a:xfrm>
+          <a:prstGeom prst="rect">
+            <a:avLst/>
+          </a:prstGeom>
+          <a:noFill/>
+          <a:ln/>
+        </p:spPr>
+        <p:txBody>
+          <a:bodyPr wrap="square" lIns="0" tIns="0" rIns="0" bIns="0" rtlCol="0" anchor="ctr"/>
+          <a:lstStyle/>
+          <a:p>
+            <a:pPr indent="0" marL="0">
+              <a:buNone/>
+            </a:pPr>
+            <a:r>
+              <a:rPr lang="en-US" sz="1800" u="sng" dirty="0">
+                <a:solidFill>
+                  <a:srgbClr val="405965"/>
+                </a:solidFill>
+                <a:latin typeface="Arial" pitchFamily="34" charset="0"/>
+                <a:ea typeface="Arial" pitchFamily="34" charset="-122"/>
+                <a:cs typeface="Arial" pitchFamily="34" charset="-120"/>
+                <a:hlinkClick r:id="rId5" invalidUrl="" action="" tgtFrame="" tooltip="" history="1" highlightClick="0" endSnd="0">
+                  <a:extLst>
+                    <a:ext uri="{A12FA001-AC4F-418D-AE19-62706E023703}">
+                      <ahyp:hlinkClr xmlns:ahyp="http://schemas.microsoft.com/office/drawing/2018/hyperlinkcolor" val="tx"/>
+                    </a:ext>
+                  </a:extLst>
+                </a:hlinkClick>
+              </a:rPr>
+              <a:t>Find Atlantis: Project Pavilion · T-10 · Tue 10:30–14:30</a:t>
+            </a:r>
+            <a:endParaRPr lang="en-US" sz="1800" dirty="0"/>
           </a:p>
         </p:txBody>
       </p:sp>
@@ -8970,7 +9017,7 @@
                 <a:ea typeface="Arial" pitchFamily="34" charset="-122"/>
                 <a:cs typeface="Arial" pitchFamily="34" charset="-120"/>
               </a:rPr>
-              <a:t>THE WORKFLOW GAP</a:t>
+              <a:t>PLAN → REVIEW → APPLY</a:t>
             </a:r>
             <a:endParaRPr lang="en-US" sz="1600" dirty="0"/>
           </a:p>
@@ -9009,7 +9056,7 @@
                 <a:ea typeface="Arial" pitchFamily="34" charset="-122"/>
                 <a:cs typeface="Arial" pitchFamily="34" charset="-120"/>
               </a:rPr>
-              <a:t>Code review needs the execution result.</a:t>
+              <a:t>The pull request becomes the workflow.</a:t>
             </a:r>
             <a:endParaRPr lang="en-US" sz="3600" dirty="0"/>
           </a:p>
@@ -9062,8 +9109,8 @@
         </p:nvSpPr>
         <p:spPr>
           <a:xfrm>
-            <a:off x="731520" y="2560320"/>
-            <a:ext cx="4206240" cy="1371600"/>
+            <a:off x="731520" y="2468880"/>
+            <a:ext cx="3749040" cy="1234440"/>
           </a:xfrm>
           <a:prstGeom prst="rect">
             <a:avLst/>
@@ -9087,8 +9134,8 @@
         </p:nvSpPr>
         <p:spPr>
           <a:xfrm>
-            <a:off x="932688" y="2697480"/>
-            <a:ext cx="3803904" cy="393192"/>
+            <a:off x="932688" y="2606040"/>
+            <a:ext cx="3346704" cy="393192"/>
           </a:xfrm>
           <a:prstGeom prst="rect">
             <a:avLst/>
@@ -9126,8 +9173,8 @@
         </p:nvSpPr>
         <p:spPr>
           <a:xfrm>
-            <a:off x="932688" y="3182112"/>
-            <a:ext cx="3803904" cy="329184"/>
+            <a:off x="932688" y="3090672"/>
+            <a:ext cx="3346704" cy="329184"/>
           </a:xfrm>
           <a:prstGeom prst="rect">
             <a:avLst/>
@@ -9151,7 +9198,7 @@
                 <a:ea typeface="Arial" pitchFamily="34" charset="-122"/>
                 <a:cs typeface="Arial" pitchFamily="34" charset="-120"/>
               </a:rPr>
-              <a:t>Code is reviewed</a:t>
+              <a:t>Developer opens a change</a:t>
             </a:r>
             <a:endParaRPr lang="en-US" sz="1900" dirty="0"/>
           </a:p>
@@ -9165,8 +9212,189 @@
         </p:nvSpPr>
         <p:spPr>
           <a:xfrm>
-            <a:off x="5212080" y="3246120"/>
-            <a:ext cx="1645920" cy="0"/>
+            <a:off x="7589520" y="2468880"/>
+            <a:ext cx="3749040" cy="1234440"/>
+          </a:xfrm>
+          <a:prstGeom prst="rect">
+            <a:avLst/>
+          </a:prstGeom>
+          <a:solidFill>
+            <a:srgbClr val="EAF1F3"/>
+          </a:solidFill>
+          <a:ln w="12700">
+            <a:solidFill>
+              <a:srgbClr val="EAF1F3"/>
+            </a:solidFill>
+            <a:prstDash val="solid"/>
+          </a:ln>
+        </p:spPr>
+      </p:sp>
+      <p:sp>
+        <p:nvSpPr>
+          <p:cNvPr id="9" name="Text 7"/>
+          <p:cNvSpPr/>
+          <p:nvPr/>
+        </p:nvSpPr>
+        <p:spPr>
+          <a:xfrm>
+            <a:off x="7790688" y="2606040"/>
+            <a:ext cx="3346704" cy="393192"/>
+          </a:xfrm>
+          <a:prstGeom prst="rect">
+            <a:avLst/>
+          </a:prstGeom>
+          <a:noFill/>
+          <a:ln/>
+        </p:spPr>
+        <p:txBody>
+          <a:bodyPr wrap="square" lIns="0" tIns="0" rIns="0" bIns="0" rtlCol="0" anchor="ctr"/>
+          <a:lstStyle/>
+          <a:p>
+            <a:pPr indent="0" marL="0">
+              <a:buNone/>
+            </a:pPr>
+            <a:r>
+              <a:rPr lang="en-US" sz="2700" b="1" dirty="0">
+                <a:solidFill>
+                  <a:srgbClr val="083E4F"/>
+                </a:solidFill>
+                <a:latin typeface="Arial" pitchFamily="34" charset="0"/>
+                <a:ea typeface="Arial" pitchFamily="34" charset="-122"/>
+                <a:cs typeface="Arial" pitchFamily="34" charset="-120"/>
+              </a:rPr>
+              <a:t>Atlantis</a:t>
+            </a:r>
+            <a:endParaRPr lang="en-US" sz="2700" dirty="0"/>
+          </a:p>
+        </p:txBody>
+      </p:sp>
+      <p:sp>
+        <p:nvSpPr>
+          <p:cNvPr id="10" name="Text 8"/>
+          <p:cNvSpPr/>
+          <p:nvPr/>
+        </p:nvSpPr>
+        <p:spPr>
+          <a:xfrm>
+            <a:off x="7790688" y="3090672"/>
+            <a:ext cx="3346704" cy="329184"/>
+          </a:xfrm>
+          <a:prstGeom prst="rect">
+            <a:avLst/>
+          </a:prstGeom>
+          <a:noFill/>
+          <a:ln/>
+        </p:spPr>
+        <p:txBody>
+          <a:bodyPr wrap="square" lIns="0" tIns="0" rIns="0" bIns="0" rtlCol="0" anchor="ctr"/>
+          <a:lstStyle/>
+          <a:p>
+            <a:pPr indent="0" marL="0">
+              <a:buNone/>
+            </a:pPr>
+            <a:r>
+              <a:rPr lang="en-US" sz="1900" dirty="0">
+                <a:solidFill>
+                  <a:srgbClr val="405965"/>
+                </a:solidFill>
+                <a:latin typeface="Arial" pitchFamily="34" charset="0"/>
+                <a:ea typeface="Arial" pitchFamily="34" charset="-122"/>
+                <a:cs typeface="Arial" pitchFamily="34" charset="-120"/>
+              </a:rPr>
+              <a:t>Terraform / OpenTofu</a:t>
+            </a:r>
+            <a:endParaRPr lang="en-US" sz="1900" dirty="0"/>
+          </a:p>
+        </p:txBody>
+      </p:sp>
+      <p:sp>
+        <p:nvSpPr>
+          <p:cNvPr id="11" name="Text 9"/>
+          <p:cNvSpPr/>
+          <p:nvPr/>
+        </p:nvSpPr>
+        <p:spPr>
+          <a:xfrm>
+            <a:off x="932688" y="3977640"/>
+            <a:ext cx="3657600" cy="457200"/>
+          </a:xfrm>
+          <a:prstGeom prst="rect">
+            <a:avLst/>
+          </a:prstGeom>
+          <a:noFill/>
+          <a:ln/>
+        </p:spPr>
+        <p:txBody>
+          <a:bodyPr wrap="square" lIns="0" tIns="0" rIns="0" bIns="0" rtlCol="0" anchor="ctr"/>
+          <a:lstStyle/>
+          <a:p>
+            <a:pPr indent="0" marL="0">
+              <a:buNone/>
+            </a:pPr>
+            <a:r>
+              <a:rPr lang="en-US" sz="2600" b="1" dirty="0">
+                <a:solidFill>
+                  <a:srgbClr val="086679"/>
+                </a:solidFill>
+                <a:latin typeface="Arial" pitchFamily="34" charset="0"/>
+                <a:ea typeface="Arial" pitchFamily="34" charset="-122"/>
+                <a:cs typeface="Arial" pitchFamily="34" charset="-120"/>
+              </a:rPr>
+              <a:t>Code + plan review</a:t>
+            </a:r>
+            <a:endParaRPr lang="en-US" sz="2600" dirty="0"/>
+          </a:p>
+        </p:txBody>
+      </p:sp>
+      <p:sp>
+        <p:nvSpPr>
+          <p:cNvPr id="12" name="Text 10"/>
+          <p:cNvSpPr/>
+          <p:nvPr/>
+        </p:nvSpPr>
+        <p:spPr>
+          <a:xfrm>
+            <a:off x="7589520" y="3977640"/>
+            <a:ext cx="3749040" cy="457200"/>
+          </a:xfrm>
+          <a:prstGeom prst="rect">
+            <a:avLst/>
+          </a:prstGeom>
+          <a:noFill/>
+          <a:ln/>
+        </p:spPr>
+        <p:txBody>
+          <a:bodyPr wrap="square" lIns="0" tIns="0" rIns="0" bIns="0" rtlCol="0" anchor="ctr"/>
+          <a:lstStyle/>
+          <a:p>
+            <a:pPr indent="0" marL="0">
+              <a:buNone/>
+            </a:pPr>
+            <a:r>
+              <a:rPr lang="en-US" sz="2300" b="1" dirty="0">
+                <a:solidFill>
+                  <a:srgbClr val="086679"/>
+                </a:solidFill>
+                <a:latin typeface="Arial" pitchFamily="34" charset="0"/>
+                <a:ea typeface="Arial" pitchFamily="34" charset="-122"/>
+                <a:cs typeface="Arial" pitchFamily="34" charset="-120"/>
+              </a:rPr>
+              <a:t>Configured requirements</a:t>
+            </a:r>
+            <a:endParaRPr lang="en-US" sz="2300" dirty="0"/>
+          </a:p>
+        </p:txBody>
+      </p:sp>
+      <p:sp>
+        <p:nvSpPr>
+          <p:cNvPr id="13" name="Shape 11"/>
+          <p:cNvSpPr/>
+          <p:nvPr/>
+        </p:nvSpPr>
+        <p:spPr>
+          <a:xfrm>
+            <a:off x="4663440" y="2606040"/>
+            <a:ext cx="2697480" cy="0"/>
           </a:xfrm>
           <a:prstGeom prst="line">
             <a:avLst/>
@@ -9184,14 +9412,206 @@
       </p:sp>
       <p:sp>
         <p:nvSpPr>
-          <p:cNvPr id="9" name="Shape 7"/>
+          <p:cNvPr id="14" name="Text 12"/>
           <p:cNvSpPr/>
           <p:nvPr/>
         </p:nvSpPr>
         <p:spPr>
           <a:xfrm>
-            <a:off x="7178040" y="2560320"/>
-            <a:ext cx="4206240" cy="1371600"/>
+            <a:off x="4617720" y="2176272"/>
+            <a:ext cx="2788920" cy="320040"/>
+          </a:xfrm>
+          <a:prstGeom prst="rect">
+            <a:avLst/>
+          </a:prstGeom>
+          <a:noFill/>
+          <a:ln/>
+        </p:spPr>
+        <p:txBody>
+          <a:bodyPr wrap="square" lIns="0" tIns="0" rIns="0" bIns="0" rtlCol="0" anchor="ctr"/>
+          <a:lstStyle/>
+          <a:p>
+            <a:pPr algn="ctr" indent="0" marL="0">
+              <a:buNone/>
+            </a:pPr>
+            <a:r>
+              <a:rPr lang="en-US" sz="2100" dirty="0">
+                <a:solidFill>
+                  <a:srgbClr val="086679"/>
+                </a:solidFill>
+                <a:latin typeface="Arial" pitchFamily="34" charset="0"/>
+                <a:ea typeface="Arial" pitchFamily="34" charset="-122"/>
+                <a:cs typeface="Arial" pitchFamily="34" charset="-120"/>
+              </a:rPr>
+              <a:t>Webhook</a:t>
+            </a:r>
+            <a:endParaRPr lang="en-US" sz="2100" dirty="0"/>
+          </a:p>
+        </p:txBody>
+      </p:sp>
+      <p:sp>
+        <p:nvSpPr>
+          <p:cNvPr id="15" name="Shape 13"/>
+          <p:cNvSpPr/>
+          <p:nvPr/>
+        </p:nvSpPr>
+        <p:spPr>
+          <a:xfrm>
+            <a:off x="7360920" y="3474720"/>
+            <a:ext cx="-2697480" cy="0"/>
+          </a:xfrm>
+          <a:prstGeom prst="line">
+            <a:avLst/>
+          </a:prstGeom>
+          <a:noFill/>
+          <a:ln w="25400">
+            <a:solidFill>
+              <a:srgbClr val="086679"/>
+            </a:solidFill>
+            <a:prstDash val="solid"/>
+            <a:headEnd type="none"/>
+            <a:tailEnd type="triangle"/>
+          </a:ln>
+        </p:spPr>
+      </p:sp>
+      <p:sp>
+        <p:nvSpPr>
+          <p:cNvPr id="16" name="Text 14"/>
+          <p:cNvSpPr/>
+          <p:nvPr/>
+        </p:nvSpPr>
+        <p:spPr>
+          <a:xfrm>
+            <a:off x="4526280" y="3008376"/>
+            <a:ext cx="2971800" cy="365760"/>
+          </a:xfrm>
+          <a:prstGeom prst="rect">
+            <a:avLst/>
+          </a:prstGeom>
+          <a:noFill/>
+          <a:ln/>
+        </p:spPr>
+        <p:txBody>
+          <a:bodyPr wrap="square" lIns="0" tIns="0" rIns="0" bIns="0" rtlCol="0" anchor="ctr"/>
+          <a:lstStyle/>
+          <a:p>
+            <a:pPr algn="ctr" indent="0" marL="0">
+              <a:buNone/>
+            </a:pPr>
+            <a:r>
+              <a:rPr lang="en-US" sz="2100" dirty="0">
+                <a:solidFill>
+                  <a:srgbClr val="086679"/>
+                </a:solidFill>
+                <a:latin typeface="Arial" pitchFamily="34" charset="0"/>
+                <a:ea typeface="Arial" pitchFamily="34" charset="-122"/>
+                <a:cs typeface="Arial" pitchFamily="34" charset="-120"/>
+              </a:rPr>
+              <a:t>Plan + apply results</a:t>
+            </a:r>
+            <a:endParaRPr lang="en-US" sz="2100" dirty="0"/>
+          </a:p>
+        </p:txBody>
+      </p:sp>
+      <p:sp>
+        <p:nvSpPr>
+          <p:cNvPr id="17" name="Shape 15"/>
+          <p:cNvSpPr/>
+          <p:nvPr/>
+        </p:nvSpPr>
+        <p:spPr>
+          <a:xfrm>
+            <a:off x="4663440" y="4434840"/>
+            <a:ext cx="2697480" cy="0"/>
+          </a:xfrm>
+          <a:prstGeom prst="line">
+            <a:avLst/>
+          </a:prstGeom>
+          <a:noFill/>
+          <a:ln w="25400">
+            <a:solidFill>
+              <a:srgbClr val="086679"/>
+            </a:solidFill>
+            <a:prstDash val="solid"/>
+            <a:headEnd type="none"/>
+            <a:tailEnd type="triangle"/>
+          </a:ln>
+        </p:spPr>
+      </p:sp>
+      <p:sp>
+        <p:nvSpPr>
+          <p:cNvPr id="18" name="Text 16"/>
+          <p:cNvSpPr/>
+          <p:nvPr/>
+        </p:nvSpPr>
+        <p:spPr>
+          <a:xfrm>
+            <a:off x="4572000" y="3977640"/>
+            <a:ext cx="2926080" cy="320040"/>
+          </a:xfrm>
+          <a:prstGeom prst="rect">
+            <a:avLst/>
+          </a:prstGeom>
+          <a:noFill/>
+          <a:ln/>
+        </p:spPr>
+        <p:txBody>
+          <a:bodyPr wrap="square" lIns="0" tIns="0" rIns="0" bIns="0" rtlCol="0" anchor="ctr"/>
+          <a:lstStyle/>
+          <a:p>
+            <a:pPr algn="ctr" indent="0" marL="0">
+              <a:buNone/>
+            </a:pPr>
+            <a:r>
+              <a:rPr lang="en-US" sz="2100" dirty="0">
+                <a:solidFill>
+                  <a:srgbClr val="086679"/>
+                </a:solidFill>
+                <a:latin typeface="Arial" pitchFamily="34" charset="0"/>
+                <a:ea typeface="Arial" pitchFamily="34" charset="-122"/>
+                <a:cs typeface="Arial" pitchFamily="34" charset="-120"/>
+              </a:rPr>
+              <a:t>atlantis apply</a:t>
+            </a:r>
+            <a:endParaRPr lang="en-US" sz="2100" dirty="0"/>
+          </a:p>
+        </p:txBody>
+      </p:sp>
+      <p:sp>
+        <p:nvSpPr>
+          <p:cNvPr id="19" name="Shape 17"/>
+          <p:cNvSpPr/>
+          <p:nvPr/>
+        </p:nvSpPr>
+        <p:spPr>
+          <a:xfrm>
+            <a:off x="9464040" y="4480560"/>
+            <a:ext cx="0" cy="411480"/>
+          </a:xfrm>
+          <a:prstGeom prst="line">
+            <a:avLst/>
+          </a:prstGeom>
+          <a:noFill/>
+          <a:ln w="25400">
+            <a:solidFill>
+              <a:srgbClr val="086679"/>
+            </a:solidFill>
+            <a:prstDash val="solid"/>
+            <a:headEnd type="none"/>
+            <a:tailEnd type="triangle"/>
+          </a:ln>
+        </p:spPr>
+      </p:sp>
+      <p:sp>
+        <p:nvSpPr>
+          <p:cNvPr id="20" name="Shape 18"/>
+          <p:cNvSpPr/>
+          <p:nvPr/>
+        </p:nvSpPr>
+        <p:spPr>
+          <a:xfrm>
+            <a:off x="7589520" y="5010912"/>
+            <a:ext cx="3749040" cy="868680"/>
           </a:xfrm>
           <a:prstGeom prst="rect">
             <a:avLst/>
@@ -9209,14 +9629,14 @@
       </p:sp>
       <p:sp>
         <p:nvSpPr>
-          <p:cNvPr id="10" name="Text 8"/>
+          <p:cNvPr id="21" name="Text 19"/>
           <p:cNvSpPr/>
           <p:nvPr/>
         </p:nvSpPr>
         <p:spPr>
           <a:xfrm>
-            <a:off x="7379208" y="2697480"/>
-            <a:ext cx="3803904" cy="393192"/>
+            <a:off x="7790688" y="5148072"/>
+            <a:ext cx="3346704" cy="393192"/>
           </a:xfrm>
           <a:prstGeom prst="rect">
             <a:avLst/>
@@ -9240,7 +9660,7 @@
                 <a:ea typeface="Arial" pitchFamily="34" charset="-122"/>
                 <a:cs typeface="Arial" pitchFamily="34" charset="-120"/>
               </a:rPr>
-              <a:t>Laptop</a:t>
+              <a:t>Infrastructure</a:t>
             </a:r>
             <a:endParaRPr lang="en-US" sz="2700" dirty="0"/>
           </a:p>
@@ -9248,14 +9668,14 @@
       </p:sp>
       <p:sp>
         <p:nvSpPr>
-          <p:cNvPr id="11" name="Text 9"/>
+          <p:cNvPr id="22" name="Text 20"/>
           <p:cNvSpPr/>
           <p:nvPr/>
         </p:nvSpPr>
         <p:spPr>
           <a:xfrm>
-            <a:off x="7379208" y="3182112"/>
-            <a:ext cx="3803904" cy="329184"/>
+            <a:off x="7790688" y="5532120"/>
+            <a:ext cx="3346704" cy="228600"/>
           </a:xfrm>
           <a:prstGeom prst="rect">
             <a:avLst/>
@@ -9271,7 +9691,7 @@
               <a:buNone/>
             </a:pPr>
             <a:r>
-              <a:rPr lang="en-US" sz="1900" dirty="0">
+              <a:rPr lang="en-US" sz="1800" dirty="0">
                 <a:solidFill>
                   <a:srgbClr val="405965"/>
                 </a:solidFill>
@@ -9279,22 +9699,22 @@
                 <a:ea typeface="Arial" pitchFamily="34" charset="-122"/>
                 <a:cs typeface="Arial" pitchFamily="34" charset="-120"/>
               </a:rPr>
-              <a:t>Someone runs the change</a:t>
+              <a:t>Via provider APIs</a:t>
             </a:r>
-            <a:endParaRPr lang="en-US" sz="1900" dirty="0"/>
-          </a:p>
-        </p:txBody>
-      </p:sp>
-      <p:sp>
-        <p:nvSpPr>
-          <p:cNvPr id="12" name="Text 10"/>
+            <a:endParaRPr lang="en-US" sz="1800" dirty="0"/>
+          </a:p>
+        </p:txBody>
+      </p:sp>
+      <p:sp>
+        <p:nvSpPr>
+          <p:cNvPr id="23" name="Text 21"/>
           <p:cNvSpPr/>
           <p:nvPr/>
         </p:nvSpPr>
         <p:spPr>
           <a:xfrm>
-            <a:off x="731520" y="4754880"/>
-            <a:ext cx="10698480" cy="731520"/>
+            <a:off x="932688" y="4983480"/>
+            <a:ext cx="3520440" cy="868680"/>
           </a:xfrm>
           <a:prstGeom prst="rect">
             <a:avLst/>
@@ -9310,17 +9730,34 @@
               <a:buNone/>
             </a:pPr>
             <a:r>
-              <a:rPr lang="en-US" sz="3000" b="1" dirty="0">
-                <a:solidFill>
-                  <a:srgbClr val="086679"/>
+              <a:rPr lang="en-US" sz="2600" b="1" dirty="0">
+                <a:solidFill>
+                  <a:srgbClr val="083E4F"/>
                 </a:solidFill>
                 <a:latin typeface="Arial" pitchFamily="34" charset="0"/>
                 <a:ea typeface="Arial" pitchFamily="34" charset="-122"/>
                 <a:cs typeface="Arial" pitchFamily="34" charset="-120"/>
               </a:rPr>
-              <a:t>Which plan?     Who applied it?     What happened?</a:t>
+              <a:t>Results stay with</a:t>
             </a:r>
-            <a:endParaRPr lang="en-US" sz="3000" dirty="0"/>
+            <a:endParaRPr lang="en-US" sz="2600" dirty="0"/>
+          </a:p>
+          <a:p>
+            <a:pPr indent="0" marL="0">
+              <a:buNone/>
+            </a:pPr>
+            <a:r>
+              <a:rPr lang="en-US" sz="2600" b="1" dirty="0">
+                <a:solidFill>
+                  <a:srgbClr val="083E4F"/>
+                </a:solidFill>
+                <a:latin typeface="Arial" pitchFamily="34" charset="0"/>
+                <a:ea typeface="Arial" pitchFamily="34" charset="-122"/>
+                <a:cs typeface="Arial" pitchFamily="34" charset="-120"/>
+              </a:rPr>
+              <a:t>the pull request.</a:t>
+            </a:r>
+            <a:endParaRPr lang="en-US" sz="2600" dirty="0"/>
           </a:p>
         </p:txBody>
       </p:sp>
@@ -9382,7 +9819,7 @@
                 <a:ea typeface="Arial" pitchFamily="34" charset="-122"/>
                 <a:cs typeface="Arial" pitchFamily="34" charset="-120"/>
               </a:rPr>
-              <a:t>PLAN</a:t>
+              <a:t>ENGINEER EXPERIENCE</a:t>
             </a:r>
             <a:endParaRPr lang="en-US" sz="1600" dirty="0"/>
           </a:p>
@@ -9421,7 +9858,7 @@
                 <a:ea typeface="Arial" pitchFamily="34" charset="-122"/>
                 <a:cs typeface="Arial" pitchFamily="34" charset="-120"/>
               </a:rPr>
-              <a:t>Open a PR. See the plan.</a:t>
+              <a:t>One change. One PR conversation.</a:t>
             </a:r>
             <a:endParaRPr lang="en-US" sz="3600" dirty="0"/>
           </a:p>
@@ -9474,8 +9911,8 @@
         </p:nvSpPr>
         <p:spPr>
           <a:xfrm>
-            <a:off x="731520" y="2560320"/>
-            <a:ext cx="4114800" cy="1463040"/>
+            <a:off x="658368" y="2148840"/>
+            <a:ext cx="10881360" cy="3657600"/>
           </a:xfrm>
           <a:prstGeom prst="rect">
             <a:avLst/>
@@ -9499,8 +9936,8 @@
         </p:nvSpPr>
         <p:spPr>
           <a:xfrm>
-            <a:off x="932688" y="2697480"/>
-            <a:ext cx="3712464" cy="393192"/>
+            <a:off x="932688" y="2377440"/>
+            <a:ext cx="9966960" cy="384048"/>
           </a:xfrm>
           <a:prstGeom prst="rect">
             <a:avLst/>
@@ -9524,7 +9961,7 @@
                 <a:ea typeface="Arial" pitchFamily="34" charset="-122"/>
                 <a:cs typeface="Arial" pitchFamily="34" charset="-120"/>
               </a:rPr>
-              <a:t>Git pull request</a:t>
+              <a:t>infra: resize production database</a:t>
             </a:r>
             <a:endParaRPr lang="en-US" sz="2700" dirty="0"/>
           </a:p>
@@ -9532,14 +9969,39 @@
       </p:sp>
       <p:sp>
         <p:nvSpPr>
-          <p:cNvPr id="7" name="Text 5"/>
+          <p:cNvPr id="7" name="Shape 5"/>
           <p:cNvSpPr/>
           <p:nvPr/>
         </p:nvSpPr>
         <p:spPr>
           <a:xfrm>
-            <a:off x="932688" y="3182112"/>
-            <a:ext cx="3712464" cy="329184"/>
+            <a:off x="932688" y="2971800"/>
+            <a:ext cx="10287000" cy="0"/>
+          </a:xfrm>
+          <a:prstGeom prst="line">
+            <a:avLst/>
+          </a:prstGeom>
+          <a:noFill/>
+          <a:ln w="25400">
+            <a:solidFill>
+              <a:srgbClr val="A6BAC1"/>
+            </a:solidFill>
+            <a:prstDash val="solid"/>
+            <a:headEnd type="none"/>
+            <a:tailEnd type="none"/>
+          </a:ln>
+        </p:spPr>
+      </p:sp>
+      <p:sp>
+        <p:nvSpPr>
+          <p:cNvPr id="8" name="Text 6"/>
+          <p:cNvSpPr/>
+          <p:nvPr/>
+        </p:nvSpPr>
+        <p:spPr>
+          <a:xfrm>
+            <a:off x="950976" y="3218688"/>
+            <a:ext cx="1508760" cy="365760"/>
           </a:xfrm>
           <a:prstGeom prst="rect">
             <a:avLst/>
@@ -9555,73 +10017,9 @@
               <a:buNone/>
             </a:pPr>
             <a:r>
-              <a:rPr lang="en-US" sz="1900" dirty="0">
+              <a:rPr lang="en-US" sz="2100" dirty="0">
                 <a:solidFill>
                   <a:srgbClr val="405965"/>
-                </a:solidFill>
-                <a:latin typeface="Arial" pitchFamily="34" charset="0"/>
-                <a:ea typeface="Arial" pitchFamily="34" charset="-122"/>
-                <a:cs typeface="Arial" pitchFamily="34" charset="-120"/>
-              </a:rPr>
-              <a:t>Developer opens a change</a:t>
-            </a:r>
-            <a:endParaRPr lang="en-US" sz="1900" dirty="0"/>
-          </a:p>
-        </p:txBody>
-      </p:sp>
-      <p:sp>
-        <p:nvSpPr>
-          <p:cNvPr id="8" name="Shape 6"/>
-          <p:cNvSpPr/>
-          <p:nvPr/>
-        </p:nvSpPr>
-        <p:spPr>
-          <a:xfrm>
-            <a:off x="7315200" y="2560320"/>
-            <a:ext cx="4114800" cy="1463040"/>
-          </a:xfrm>
-          <a:prstGeom prst="rect">
-            <a:avLst/>
-          </a:prstGeom>
-          <a:solidFill>
-            <a:srgbClr val="EAF1F3"/>
-          </a:solidFill>
-          <a:ln w="12700">
-            <a:solidFill>
-              <a:srgbClr val="EAF1F3"/>
-            </a:solidFill>
-            <a:prstDash val="solid"/>
-          </a:ln>
-        </p:spPr>
-      </p:sp>
-      <p:sp>
-        <p:nvSpPr>
-          <p:cNvPr id="9" name="Text 7"/>
-          <p:cNvSpPr/>
-          <p:nvPr/>
-        </p:nvSpPr>
-        <p:spPr>
-          <a:xfrm>
-            <a:off x="7516368" y="2697480"/>
-            <a:ext cx="3712464" cy="393192"/>
-          </a:xfrm>
-          <a:prstGeom prst="rect">
-            <a:avLst/>
-          </a:prstGeom>
-          <a:noFill/>
-          <a:ln/>
-        </p:spPr>
-        <p:txBody>
-          <a:bodyPr wrap="square" lIns="0" tIns="0" rIns="0" bIns="0" rtlCol="0" anchor="ctr"/>
-          <a:lstStyle/>
-          <a:p>
-            <a:pPr indent="0" marL="0">
-              <a:buNone/>
-            </a:pPr>
-            <a:r>
-              <a:rPr lang="en-US" sz="2700" b="1" dirty="0">
-                <a:solidFill>
-                  <a:srgbClr val="083E4F"/>
                 </a:solidFill>
                 <a:latin typeface="Arial" pitchFamily="34" charset="0"/>
                 <a:ea typeface="Arial" pitchFamily="34" charset="-122"/>
@@ -9629,20 +10027,20 @@
               </a:rPr>
               <a:t>Atlantis</a:t>
             </a:r>
-            <a:endParaRPr lang="en-US" sz="2700" dirty="0"/>
-          </a:p>
-        </p:txBody>
-      </p:sp>
-      <p:sp>
-        <p:nvSpPr>
-          <p:cNvPr id="10" name="Text 8"/>
+            <a:endParaRPr lang="en-US" sz="2100" dirty="0"/>
+          </a:p>
+        </p:txBody>
+      </p:sp>
+      <p:sp>
+        <p:nvSpPr>
+          <p:cNvPr id="9" name="Text 7"/>
           <p:cNvSpPr/>
           <p:nvPr/>
         </p:nvSpPr>
         <p:spPr>
           <a:xfrm>
-            <a:off x="7516368" y="3182112"/>
-            <a:ext cx="3712464" cy="329184"/>
+            <a:off x="2743200" y="3218688"/>
+            <a:ext cx="8412480" cy="365760"/>
           </a:xfrm>
           <a:prstGeom prst="rect">
             <a:avLst/>
@@ -9658,55 +10056,30 @@
               <a:buNone/>
             </a:pPr>
             <a:r>
-              <a:rPr lang="en-US" sz="1900" dirty="0">
-                <a:solidFill>
-                  <a:srgbClr val="405965"/>
+              <a:rPr lang="en-US" sz="2500" b="1" dirty="0">
+                <a:solidFill>
+                  <a:srgbClr val="086679"/>
                 </a:solidFill>
                 <a:latin typeface="Arial" pitchFamily="34" charset="0"/>
                 <a:ea typeface="Arial" pitchFamily="34" charset="-122"/>
                 <a:cs typeface="Arial" pitchFamily="34" charset="-120"/>
               </a:rPr>
-              <a:t>Runs Terraform / OpenTofu</a:t>
+              <a:t>Plan: 0 to add, 1 to change, 0 to destroy</a:t>
             </a:r>
-            <a:endParaRPr lang="en-US" sz="1900" dirty="0"/>
-          </a:p>
-        </p:txBody>
-      </p:sp>
-      <p:sp>
-        <p:nvSpPr>
-          <p:cNvPr id="11" name="Shape 9"/>
+            <a:endParaRPr lang="en-US" sz="2500" dirty="0"/>
+          </a:p>
+        </p:txBody>
+      </p:sp>
+      <p:sp>
+        <p:nvSpPr>
+          <p:cNvPr id="10" name="Text 8"/>
           <p:cNvSpPr/>
           <p:nvPr/>
         </p:nvSpPr>
         <p:spPr>
           <a:xfrm>
-            <a:off x="5029200" y="2880360"/>
-            <a:ext cx="2103120" cy="0"/>
-          </a:xfrm>
-          <a:prstGeom prst="line">
-            <a:avLst/>
-          </a:prstGeom>
-          <a:noFill/>
-          <a:ln w="25400">
-            <a:solidFill>
-              <a:srgbClr val="086679"/>
-            </a:solidFill>
-            <a:prstDash val="solid"/>
-            <a:headEnd type="none"/>
-            <a:tailEnd type="triangle"/>
-          </a:ln>
-        </p:spPr>
-      </p:sp>
-      <p:sp>
-        <p:nvSpPr>
-          <p:cNvPr id="12" name="Text 10"/>
-          <p:cNvSpPr/>
-          <p:nvPr/>
-        </p:nvSpPr>
-        <p:spPr>
-          <a:xfrm>
-            <a:off x="4937760" y="2377440"/>
-            <a:ext cx="2240280" cy="365760"/>
+            <a:off x="950976" y="3813048"/>
+            <a:ext cx="1508760" cy="365760"/>
           </a:xfrm>
           <a:prstGeom prst="rect">
             <a:avLst/>
@@ -9718,59 +10091,34 @@
           <a:bodyPr wrap="square" lIns="0" tIns="0" rIns="0" bIns="0" rtlCol="0" anchor="ctr"/>
           <a:lstStyle/>
           <a:p>
-            <a:pPr algn="ctr" indent="0" marL="0">
+            <a:pPr indent="0" marL="0">
               <a:buNone/>
             </a:pPr>
             <a:r>
-              <a:rPr lang="en-US" sz="2300" dirty="0">
-                <a:solidFill>
-                  <a:srgbClr val="086679"/>
+              <a:rPr lang="en-US" sz="2100" dirty="0">
+                <a:solidFill>
+                  <a:srgbClr val="405965"/>
                 </a:solidFill>
                 <a:latin typeface="Arial" pitchFamily="34" charset="0"/>
                 <a:ea typeface="Arial" pitchFamily="34" charset="-122"/>
                 <a:cs typeface="Arial" pitchFamily="34" charset="-120"/>
               </a:rPr>
-              <a:t>Webhook</a:t>
+              <a:t>Reviewer</a:t>
             </a:r>
-            <a:endParaRPr lang="en-US" sz="2300" dirty="0"/>
-          </a:p>
-        </p:txBody>
-      </p:sp>
-      <p:sp>
-        <p:nvSpPr>
-          <p:cNvPr id="13" name="Shape 11"/>
+            <a:endParaRPr lang="en-US" sz="2100" dirty="0"/>
+          </a:p>
+        </p:txBody>
+      </p:sp>
+      <p:sp>
+        <p:nvSpPr>
+          <p:cNvPr id="11" name="Text 9"/>
           <p:cNvSpPr/>
           <p:nvPr/>
         </p:nvSpPr>
         <p:spPr>
           <a:xfrm>
-            <a:off x="7132320" y="3657600"/>
-            <a:ext cx="-2103120" cy="0"/>
-          </a:xfrm>
-          <a:prstGeom prst="line">
-            <a:avLst/>
-          </a:prstGeom>
-          <a:noFill/>
-          <a:ln w="25400">
-            <a:solidFill>
-              <a:srgbClr val="086679"/>
-            </a:solidFill>
-            <a:prstDash val="solid"/>
-            <a:headEnd type="none"/>
-            <a:tailEnd type="triangle"/>
-          </a:ln>
-        </p:spPr>
-      </p:sp>
-      <p:sp>
-        <p:nvSpPr>
-          <p:cNvPr id="14" name="Text 12"/>
-          <p:cNvSpPr/>
-          <p:nvPr/>
-        </p:nvSpPr>
-        <p:spPr>
-          <a:xfrm>
-            <a:off x="4937760" y="3886200"/>
-            <a:ext cx="2240280" cy="365760"/>
+            <a:off x="2743200" y="3813048"/>
+            <a:ext cx="8412480" cy="365760"/>
           </a:xfrm>
           <a:prstGeom prst="rect">
             <a:avLst/>
@@ -9782,34 +10130,34 @@
           <a:bodyPr wrap="square" lIns="0" tIns="0" rIns="0" bIns="0" rtlCol="0" anchor="ctr"/>
           <a:lstStyle/>
           <a:p>
-            <a:pPr algn="ctr" indent="0" marL="0">
+            <a:pPr indent="0" marL="0">
               <a:buNone/>
             </a:pPr>
             <a:r>
-              <a:rPr lang="en-US" sz="2300" dirty="0">
-                <a:solidFill>
-                  <a:srgbClr val="086679"/>
+              <a:rPr lang="en-US" sz="2500" dirty="0">
+                <a:solidFill>
+                  <a:srgbClr val="083E4F"/>
                 </a:solidFill>
                 <a:latin typeface="Arial" pitchFamily="34" charset="0"/>
                 <a:ea typeface="Arial" pitchFamily="34" charset="-122"/>
                 <a:cs typeface="Arial" pitchFamily="34" charset="-120"/>
               </a:rPr>
-              <a:t>Plan result</a:t>
+              <a:t>Approved</a:t>
             </a:r>
-            <a:endParaRPr lang="en-US" sz="2300" dirty="0"/>
-          </a:p>
-        </p:txBody>
-      </p:sp>
-      <p:sp>
-        <p:nvSpPr>
-          <p:cNvPr id="15" name="Text 13"/>
+            <a:endParaRPr lang="en-US" sz="2500" dirty="0"/>
+          </a:p>
+        </p:txBody>
+      </p:sp>
+      <p:sp>
+        <p:nvSpPr>
+          <p:cNvPr id="12" name="Text 10"/>
           <p:cNvSpPr/>
           <p:nvPr/>
         </p:nvSpPr>
         <p:spPr>
           <a:xfrm>
-            <a:off x="731520" y="5029200"/>
-            <a:ext cx="10698480" cy="594360"/>
+            <a:off x="950976" y="4407408"/>
+            <a:ext cx="1508760" cy="365760"/>
           </a:xfrm>
           <a:prstGeom prst="rect">
             <a:avLst/>
@@ -9825,17 +10173,173 @@
               <a:buNone/>
             </a:pPr>
             <a:r>
-              <a:rPr lang="en-US" sz="3400" b="1" dirty="0">
-                <a:solidFill>
-                  <a:srgbClr val="083E4F"/>
+              <a:rPr lang="en-US" sz="2100" dirty="0">
+                <a:solidFill>
+                  <a:srgbClr val="405965"/>
                 </a:solidFill>
                 <a:latin typeface="Arial" pitchFamily="34" charset="0"/>
                 <a:ea typeface="Arial" pitchFamily="34" charset="-122"/>
                 <a:cs typeface="Arial" pitchFamily="34" charset="-120"/>
               </a:rPr>
-              <a:t>Review the code and the plan together.</a:t>
+              <a:t>Rui</a:t>
             </a:r>
-            <a:endParaRPr lang="en-US" sz="3400" dirty="0"/>
+            <a:endParaRPr lang="en-US" sz="2100" dirty="0"/>
+          </a:p>
+        </p:txBody>
+      </p:sp>
+      <p:sp>
+        <p:nvSpPr>
+          <p:cNvPr id="13" name="Text 11"/>
+          <p:cNvSpPr/>
+          <p:nvPr/>
+        </p:nvSpPr>
+        <p:spPr>
+          <a:xfrm>
+            <a:off x="2743200" y="4407408"/>
+            <a:ext cx="8412480" cy="365760"/>
+          </a:xfrm>
+          <a:prstGeom prst="rect">
+            <a:avLst/>
+          </a:prstGeom>
+          <a:noFill/>
+          <a:ln/>
+        </p:spPr>
+        <p:txBody>
+          <a:bodyPr wrap="square" lIns="0" tIns="0" rIns="0" bIns="0" rtlCol="0" anchor="ctr"/>
+          <a:lstStyle/>
+          <a:p>
+            <a:pPr indent="0" marL="0">
+              <a:buNone/>
+            </a:pPr>
+            <a:r>
+              <a:rPr lang="en-US" sz="2500" b="1" dirty="0">
+                <a:solidFill>
+                  <a:srgbClr val="086679"/>
+                </a:solidFill>
+                <a:latin typeface="Arial" pitchFamily="34" charset="0"/>
+                <a:ea typeface="Arial" pitchFamily="34" charset="-122"/>
+                <a:cs typeface="Arial" pitchFamily="34" charset="-120"/>
+              </a:rPr>
+              <a:t>atlantis apply</a:t>
+            </a:r>
+            <a:endParaRPr lang="en-US" sz="2500" dirty="0"/>
+          </a:p>
+        </p:txBody>
+      </p:sp>
+      <p:sp>
+        <p:nvSpPr>
+          <p:cNvPr id="14" name="Text 12"/>
+          <p:cNvSpPr/>
+          <p:nvPr/>
+        </p:nvSpPr>
+        <p:spPr>
+          <a:xfrm>
+            <a:off x="950976" y="5001768"/>
+            <a:ext cx="1508760" cy="365760"/>
+          </a:xfrm>
+          <a:prstGeom prst="rect">
+            <a:avLst/>
+          </a:prstGeom>
+          <a:noFill/>
+          <a:ln/>
+        </p:spPr>
+        <p:txBody>
+          <a:bodyPr wrap="square" lIns="0" tIns="0" rIns="0" bIns="0" rtlCol="0" anchor="ctr"/>
+          <a:lstStyle/>
+          <a:p>
+            <a:pPr indent="0" marL="0">
+              <a:buNone/>
+            </a:pPr>
+            <a:r>
+              <a:rPr lang="en-US" sz="2100" dirty="0">
+                <a:solidFill>
+                  <a:srgbClr val="405965"/>
+                </a:solidFill>
+                <a:latin typeface="Arial" pitchFamily="34" charset="0"/>
+                <a:ea typeface="Arial" pitchFamily="34" charset="-122"/>
+                <a:cs typeface="Arial" pitchFamily="34" charset="-120"/>
+              </a:rPr>
+              <a:t>Atlantis</a:t>
+            </a:r>
+            <a:endParaRPr lang="en-US" sz="2100" dirty="0"/>
+          </a:p>
+        </p:txBody>
+      </p:sp>
+      <p:sp>
+        <p:nvSpPr>
+          <p:cNvPr id="15" name="Text 13"/>
+          <p:cNvSpPr/>
+          <p:nvPr/>
+        </p:nvSpPr>
+        <p:spPr>
+          <a:xfrm>
+            <a:off x="2743200" y="5001768"/>
+            <a:ext cx="8412480" cy="365760"/>
+          </a:xfrm>
+          <a:prstGeom prst="rect">
+            <a:avLst/>
+          </a:prstGeom>
+          <a:noFill/>
+          <a:ln/>
+        </p:spPr>
+        <p:txBody>
+          <a:bodyPr wrap="square" lIns="0" tIns="0" rIns="0" bIns="0" rtlCol="0" anchor="ctr"/>
+          <a:lstStyle/>
+          <a:p>
+            <a:pPr indent="0" marL="0">
+              <a:buNone/>
+            </a:pPr>
+            <a:r>
+              <a:rPr lang="en-US" sz="2500" dirty="0">
+                <a:solidFill>
+                  <a:srgbClr val="083E4F"/>
+                </a:solidFill>
+                <a:latin typeface="Arial" pitchFamily="34" charset="0"/>
+                <a:ea typeface="Arial" pitchFamily="34" charset="-122"/>
+                <a:cs typeface="Arial" pitchFamily="34" charset="-120"/>
+              </a:rPr>
+              <a:t>Apply complete.</a:t>
+            </a:r>
+            <a:endParaRPr lang="en-US" sz="2500" dirty="0"/>
+          </a:p>
+        </p:txBody>
+      </p:sp>
+      <p:sp>
+        <p:nvSpPr>
+          <p:cNvPr id="16" name="Text 14"/>
+          <p:cNvSpPr/>
+          <p:nvPr/>
+        </p:nvSpPr>
+        <p:spPr>
+          <a:xfrm>
+            <a:off x="932688" y="5504688"/>
+            <a:ext cx="10332720" cy="274320"/>
+          </a:xfrm>
+          <a:prstGeom prst="rect">
+            <a:avLst/>
+          </a:prstGeom>
+          <a:noFill/>
+          <a:ln/>
+        </p:spPr>
+        <p:txBody>
+          <a:bodyPr wrap="square" lIns="0" tIns="0" rIns="0" bIns="0" rtlCol="0" anchor="ctr"/>
+          <a:lstStyle/>
+          <a:p>
+            <a:pPr indent="0" marL="0">
+              <a:buNone/>
+            </a:pPr>
+            <a:r>
+              <a:rPr lang="en-US" sz="1800" dirty="0">
+                <a:solidFill>
+                  <a:srgbClr val="405965"/>
+                </a:solidFill>
+                <a:latin typeface="Arial" pitchFamily="34" charset="0"/>
+                <a:ea typeface="Arial" pitchFamily="34" charset="-122"/>
+                <a:cs typeface="Arial" pitchFamily="34" charset="-120"/>
+              </a:rPr>
+              <a:t>Illustrative PR · approval requirement configured · apply before merge</a:t>
+            </a:r>
+            <a:endParaRPr lang="en-US" sz="1800" dirty="0"/>
           </a:p>
         </p:txBody>
       </p:sp>
@@ -9897,7 +10401,7 @@
                 <a:ea typeface="Arial" pitchFamily="34" charset="-122"/>
                 <a:cs typeface="Arial" pitchFamily="34" charset="-120"/>
               </a:rPr>
-              <a:t>REVIEW → APPLY</a:t>
+              <a:t>PLATFORM TEAMS</a:t>
             </a:r>
             <a:endParaRPr lang="en-US" sz="1600" dirty="0"/>
           </a:p>
@@ -9936,7 +10440,7 @@
                 <a:ea typeface="Arial" pitchFamily="34" charset="-122"/>
                 <a:cs typeface="Arial" pitchFamily="34" charset="-120"/>
               </a:rPr>
-              <a:t>Review it. Request the apply.</a:t>
+              <a:t>Shared review. Controlled execution.</a:t>
             </a:r>
             <a:endParaRPr lang="en-US" sz="3600" dirty="0"/>
           </a:p>
@@ -9989,18 +10493,18 @@
         </p:nvSpPr>
         <p:spPr>
           <a:xfrm>
-            <a:off x="731520" y="2377440"/>
-            <a:ext cx="4937760" cy="1280160"/>
-          </a:xfrm>
-          <a:prstGeom prst="rect">
+            <a:off x="777240" y="2487168"/>
+            <a:ext cx="365760" cy="365760"/>
+          </a:xfrm>
+          <a:prstGeom prst="ellipse">
             <a:avLst/>
           </a:prstGeom>
           <a:solidFill>
-            <a:srgbClr val="EAF1F3"/>
+            <a:srgbClr val="086679"/>
           </a:solidFill>
           <a:ln w="12700">
             <a:solidFill>
-              <a:srgbClr val="EAF1F3"/>
+              <a:srgbClr val="086679"/>
             </a:solidFill>
             <a:prstDash val="solid"/>
           </a:ln>
@@ -10014,8 +10518,8 @@
         </p:nvSpPr>
         <p:spPr>
           <a:xfrm>
-            <a:off x="932688" y="2514600"/>
-            <a:ext cx="4535424" cy="393192"/>
+            <a:off x="1417320" y="2423160"/>
+            <a:ext cx="2834640" cy="530352"/>
           </a:xfrm>
           <a:prstGeom prst="rect">
             <a:avLst/>
@@ -10031,17 +10535,17 @@
               <a:buNone/>
             </a:pPr>
             <a:r>
-              <a:rPr lang="en-US" sz="2700" b="1" dirty="0">
-                <a:solidFill>
-                  <a:srgbClr val="083E4F"/>
+              <a:rPr lang="en-US" sz="3100" b="1" dirty="0">
+                <a:solidFill>
+                  <a:srgbClr val="086679"/>
                 </a:solidFill>
                 <a:latin typeface="Arial" pitchFamily="34" charset="0"/>
                 <a:ea typeface="Arial" pitchFamily="34" charset="-122"/>
                 <a:cs typeface="Arial" pitchFamily="34" charset="-120"/>
               </a:rPr>
-              <a:t>Pull request</a:t>
+              <a:t>Visible</a:t>
             </a:r>
-            <a:endParaRPr lang="en-US" sz="2700" dirty="0"/>
+            <a:endParaRPr lang="en-US" sz="3100" dirty="0"/>
           </a:p>
         </p:txBody>
       </p:sp>
@@ -10053,8 +10557,8 @@
         </p:nvSpPr>
         <p:spPr>
           <a:xfrm>
-            <a:off x="932688" y="2999232"/>
-            <a:ext cx="4535424" cy="329184"/>
+            <a:off x="4572000" y="2423160"/>
+            <a:ext cx="6492240" cy="594360"/>
           </a:xfrm>
           <a:prstGeom prst="rect">
             <a:avLst/>
@@ -10070,30 +10574,55 @@
               <a:buNone/>
             </a:pPr>
             <a:r>
-              <a:rPr lang="en-US" sz="1900" dirty="0">
-                <a:solidFill>
-                  <a:srgbClr val="405965"/>
+              <a:rPr lang="en-US" sz="2600" dirty="0">
+                <a:solidFill>
+                  <a:srgbClr val="083E4F"/>
                 </a:solidFill>
                 <a:latin typeface="Arial" pitchFamily="34" charset="0"/>
                 <a:ea typeface="Arial" pitchFamily="34" charset="-122"/>
                 <a:cs typeface="Arial" pitchFamily="34" charset="-120"/>
               </a:rPr>
-              <a:t>Review + configured approval</a:t>
+              <a:t>Plan and result beside the code</a:t>
             </a:r>
-            <a:endParaRPr lang="en-US" sz="1900" dirty="0"/>
-          </a:p>
-        </p:txBody>
-      </p:sp>
-      <p:sp>
-        <p:nvSpPr>
-          <p:cNvPr id="8" name="Text 6"/>
+            <a:endParaRPr lang="en-US" sz="2600" dirty="0"/>
+          </a:p>
+        </p:txBody>
+      </p:sp>
+      <p:sp>
+        <p:nvSpPr>
+          <p:cNvPr id="8" name="Shape 6"/>
           <p:cNvSpPr/>
           <p:nvPr/>
         </p:nvSpPr>
         <p:spPr>
           <a:xfrm>
-            <a:off x="731520" y="4069080"/>
-            <a:ext cx="4937760" cy="548640"/>
+            <a:off x="777240" y="3566160"/>
+            <a:ext cx="365760" cy="365760"/>
+          </a:xfrm>
+          <a:prstGeom prst="ellipse">
+            <a:avLst/>
+          </a:prstGeom>
+          <a:solidFill>
+            <a:srgbClr val="086679"/>
+          </a:solidFill>
+          <a:ln w="12700">
+            <a:solidFill>
+              <a:srgbClr val="086679"/>
+            </a:solidFill>
+            <a:prstDash val="solid"/>
+          </a:ln>
+        </p:spPr>
+      </p:sp>
+      <p:sp>
+        <p:nvSpPr>
+          <p:cNvPr id="9" name="Text 7"/>
+          <p:cNvSpPr/>
+          <p:nvPr/>
+        </p:nvSpPr>
+        <p:spPr>
+          <a:xfrm>
+            <a:off x="1417320" y="3502152"/>
+            <a:ext cx="2834640" cy="530352"/>
           </a:xfrm>
           <a:prstGeom prst="rect">
             <a:avLst/>
@@ -10109,7 +10638,7 @@
               <a:buNone/>
             </a:pPr>
             <a:r>
-              <a:rPr lang="en-US" sz="3400" b="1" dirty="0">
+              <a:rPr lang="en-US" sz="3100" b="1" dirty="0">
                 <a:solidFill>
                   <a:srgbClr val="086679"/>
                 </a:solidFill>
@@ -10117,72 +10646,86 @@
                 <a:ea typeface="Arial" pitchFamily="34" charset="-122"/>
                 <a:cs typeface="Arial" pitchFamily="34" charset="-120"/>
               </a:rPr>
-              <a:t>atlantis apply</a:t>
+              <a:t>Controlled</a:t>
             </a:r>
-            <a:endParaRPr lang="en-US" sz="3400" dirty="0"/>
-          </a:p>
-        </p:txBody>
-      </p:sp>
-      <p:sp>
-        <p:nvSpPr>
-          <p:cNvPr id="9" name="Shape 7"/>
+            <a:endParaRPr lang="en-US" sz="3100" dirty="0"/>
+          </a:p>
+        </p:txBody>
+      </p:sp>
+      <p:sp>
+        <p:nvSpPr>
+          <p:cNvPr id="10" name="Text 8"/>
           <p:cNvSpPr/>
           <p:nvPr/>
         </p:nvSpPr>
         <p:spPr>
           <a:xfrm>
-            <a:off x="5852160" y="3017520"/>
-            <a:ext cx="1188720" cy="0"/>
-          </a:xfrm>
-          <a:prstGeom prst="line">
+            <a:off x="4572000" y="3502152"/>
+            <a:ext cx="6492240" cy="594360"/>
+          </a:xfrm>
+          <a:prstGeom prst="rect">
             <a:avLst/>
           </a:prstGeom>
           <a:noFill/>
-          <a:ln w="25400">
+          <a:ln/>
+        </p:spPr>
+        <p:txBody>
+          <a:bodyPr wrap="square" lIns="0" tIns="0" rIns="0" bIns="0" rtlCol="0" anchor="ctr"/>
+          <a:lstStyle/>
+          <a:p>
+            <a:pPr indent="0" marL="0">
+              <a:buNone/>
+            </a:pPr>
+            <a:r>
+              <a:rPr lang="en-US" sz="2600" dirty="0">
+                <a:solidFill>
+                  <a:srgbClr val="083E4F"/>
+                </a:solidFill>
+                <a:latin typeface="Arial" pitchFamily="34" charset="0"/>
+                <a:ea typeface="Arial" pitchFamily="34" charset="-122"/>
+                <a:cs typeface="Arial" pitchFamily="34" charset="-120"/>
+              </a:rPr>
+              <a:t>Managed execution · configured requirements</a:t>
+            </a:r>
+            <a:endParaRPr lang="en-US" sz="2600" dirty="0"/>
+          </a:p>
+        </p:txBody>
+      </p:sp>
+      <p:sp>
+        <p:nvSpPr>
+          <p:cNvPr id="11" name="Shape 9"/>
+          <p:cNvSpPr/>
+          <p:nvPr/>
+        </p:nvSpPr>
+        <p:spPr>
+          <a:xfrm>
+            <a:off x="777240" y="4645152"/>
+            <a:ext cx="365760" cy="365760"/>
+          </a:xfrm>
+          <a:prstGeom prst="ellipse">
+            <a:avLst/>
+          </a:prstGeom>
+          <a:solidFill>
+            <a:srgbClr val="086679"/>
+          </a:solidFill>
+          <a:ln w="12700">
             <a:solidFill>
               <a:srgbClr val="086679"/>
             </a:solidFill>
             <a:prstDash val="solid"/>
-            <a:headEnd type="none"/>
-            <a:tailEnd type="triangle"/>
           </a:ln>
         </p:spPr>
       </p:sp>
       <p:sp>
         <p:nvSpPr>
-          <p:cNvPr id="10" name="Shape 8"/>
+          <p:cNvPr id="12" name="Text 10"/>
           <p:cNvSpPr/>
           <p:nvPr/>
         </p:nvSpPr>
         <p:spPr>
           <a:xfrm>
-            <a:off x="7223760" y="2377440"/>
-            <a:ext cx="4206240" cy="1280160"/>
-          </a:xfrm>
-          <a:prstGeom prst="rect">
-            <a:avLst/>
-          </a:prstGeom>
-          <a:solidFill>
-            <a:srgbClr val="EAF1F3"/>
-          </a:solidFill>
-          <a:ln w="12700">
-            <a:solidFill>
-              <a:srgbClr val="EAF1F3"/>
-            </a:solidFill>
-            <a:prstDash val="solid"/>
-          </a:ln>
-        </p:spPr>
-      </p:sp>
-      <p:sp>
-        <p:nvSpPr>
-          <p:cNvPr id="11" name="Text 9"/>
-          <p:cNvSpPr/>
-          <p:nvPr/>
-        </p:nvSpPr>
-        <p:spPr>
-          <a:xfrm>
-            <a:off x="7424928" y="2514600"/>
-            <a:ext cx="3803904" cy="393192"/>
+            <a:off x="1417320" y="4581144"/>
+            <a:ext cx="2834640" cy="530352"/>
           </a:xfrm>
           <a:prstGeom prst="rect">
             <a:avLst/>
@@ -10198,30 +10741,30 @@
               <a:buNone/>
             </a:pPr>
             <a:r>
-              <a:rPr lang="en-US" sz="2700" b="1" dirty="0">
-                <a:solidFill>
-                  <a:srgbClr val="083E4F"/>
+              <a:rPr lang="en-US" sz="3100" b="1" dirty="0">
+                <a:solidFill>
+                  <a:srgbClr val="086679"/>
                 </a:solidFill>
                 <a:latin typeface="Arial" pitchFamily="34" charset="0"/>
                 <a:ea typeface="Arial" pitchFamily="34" charset="-122"/>
                 <a:cs typeface="Arial" pitchFamily="34" charset="-120"/>
               </a:rPr>
-              <a:t>Atlantis</a:t>
+              <a:t>Collaborative</a:t>
             </a:r>
-            <a:endParaRPr lang="en-US" sz="2700" dirty="0"/>
-          </a:p>
-        </p:txBody>
-      </p:sp>
-      <p:sp>
-        <p:nvSpPr>
-          <p:cNvPr id="12" name="Text 10"/>
+            <a:endParaRPr lang="en-US" sz="3100" dirty="0"/>
+          </a:p>
+        </p:txBody>
+      </p:sp>
+      <p:sp>
+        <p:nvSpPr>
+          <p:cNvPr id="13" name="Text 11"/>
           <p:cNvSpPr/>
           <p:nvPr/>
         </p:nvSpPr>
         <p:spPr>
           <a:xfrm>
-            <a:off x="7424928" y="2999232"/>
-            <a:ext cx="3803904" cy="329184"/>
+            <a:off x="4572000" y="4581144"/>
+            <a:ext cx="6492240" cy="594360"/>
           </a:xfrm>
           <a:prstGeom prst="rect">
             <a:avLst/>
@@ -10237,184 +10780,17 @@
               <a:buNone/>
             </a:pPr>
             <a:r>
-              <a:rPr lang="en-US" sz="1900" dirty="0">
-                <a:solidFill>
-                  <a:srgbClr val="405965"/>
+              <a:rPr lang="en-US" sz="2600" dirty="0">
+                <a:solidFill>
+                  <a:srgbClr val="083E4F"/>
                 </a:solidFill>
                 <a:latin typeface="Arial" pitchFamily="34" charset="0"/>
                 <a:ea typeface="Arial" pitchFamily="34" charset="-122"/>
                 <a:cs typeface="Arial" pitchFamily="34" charset="-120"/>
               </a:rPr>
-              <a:t>Checks requirements; executes</a:t>
+              <a:t>Developers propose changes through Git</a:t>
             </a:r>
-            <a:endParaRPr lang="en-US" sz="1900" dirty="0"/>
-          </a:p>
-        </p:txBody>
-      </p:sp>
-      <p:sp>
-        <p:nvSpPr>
-          <p:cNvPr id="13" name="Shape 11"/>
-          <p:cNvSpPr/>
-          <p:nvPr/>
-        </p:nvSpPr>
-        <p:spPr>
-          <a:xfrm>
-            <a:off x="9326880" y="3840480"/>
-            <a:ext cx="0" cy="548640"/>
-          </a:xfrm>
-          <a:prstGeom prst="line">
-            <a:avLst/>
-          </a:prstGeom>
-          <a:noFill/>
-          <a:ln w="25400">
-            <a:solidFill>
-              <a:srgbClr val="086679"/>
-            </a:solidFill>
-            <a:prstDash val="solid"/>
-            <a:headEnd type="none"/>
-            <a:tailEnd type="triangle"/>
-          </a:ln>
-        </p:spPr>
-      </p:sp>
-      <p:sp>
-        <p:nvSpPr>
-          <p:cNvPr id="14" name="Shape 12"/>
-          <p:cNvSpPr/>
-          <p:nvPr/>
-        </p:nvSpPr>
-        <p:spPr>
-          <a:xfrm>
-            <a:off x="7223760" y="4572000"/>
-            <a:ext cx="4206240" cy="1143000"/>
-          </a:xfrm>
-          <a:prstGeom prst="rect">
-            <a:avLst/>
-          </a:prstGeom>
-          <a:solidFill>
-            <a:srgbClr val="EAF1F3"/>
-          </a:solidFill>
-          <a:ln w="12700">
-            <a:solidFill>
-              <a:srgbClr val="EAF1F3"/>
-            </a:solidFill>
-            <a:prstDash val="solid"/>
-          </a:ln>
-        </p:spPr>
-      </p:sp>
-      <p:sp>
-        <p:nvSpPr>
-          <p:cNvPr id="15" name="Text 13"/>
-          <p:cNvSpPr/>
-          <p:nvPr/>
-        </p:nvSpPr>
-        <p:spPr>
-          <a:xfrm>
-            <a:off x="7424928" y="4709160"/>
-            <a:ext cx="3803904" cy="393192"/>
-          </a:xfrm>
-          <a:prstGeom prst="rect">
-            <a:avLst/>
-          </a:prstGeom>
-          <a:noFill/>
-          <a:ln/>
-        </p:spPr>
-        <p:txBody>
-          <a:bodyPr wrap="square" lIns="0" tIns="0" rIns="0" bIns="0" rtlCol="0" anchor="ctr"/>
-          <a:lstStyle/>
-          <a:p>
-            <a:pPr indent="0" marL="0">
-              <a:buNone/>
-            </a:pPr>
-            <a:r>
-              <a:rPr lang="en-US" sz="2700" b="1" dirty="0">
-                <a:solidFill>
-                  <a:srgbClr val="083E4F"/>
-                </a:solidFill>
-                <a:latin typeface="Arial" pitchFamily="34" charset="0"/>
-                <a:ea typeface="Arial" pitchFamily="34" charset="-122"/>
-                <a:cs typeface="Arial" pitchFamily="34" charset="-120"/>
-              </a:rPr>
-              <a:t>Infrastructure</a:t>
-            </a:r>
-            <a:endParaRPr lang="en-US" sz="2700" dirty="0"/>
-          </a:p>
-        </p:txBody>
-      </p:sp>
-      <p:sp>
-        <p:nvSpPr>
-          <p:cNvPr id="16" name="Text 14"/>
-          <p:cNvSpPr/>
-          <p:nvPr/>
-        </p:nvSpPr>
-        <p:spPr>
-          <a:xfrm>
-            <a:off x="7424928" y="5193792"/>
-            <a:ext cx="3803904" cy="329184"/>
-          </a:xfrm>
-          <a:prstGeom prst="rect">
-            <a:avLst/>
-          </a:prstGeom>
-          <a:noFill/>
-          <a:ln/>
-        </p:spPr>
-        <p:txBody>
-          <a:bodyPr wrap="square" lIns="0" tIns="0" rIns="0" bIns="0" rtlCol="0" anchor="ctr"/>
-          <a:lstStyle/>
-          <a:p>
-            <a:pPr indent="0" marL="0">
-              <a:buNone/>
-            </a:pPr>
-            <a:r>
-              <a:rPr lang="en-US" sz="1900" dirty="0">
-                <a:solidFill>
-                  <a:srgbClr val="405965"/>
-                </a:solidFill>
-                <a:latin typeface="Arial" pitchFamily="34" charset="0"/>
-                <a:ea typeface="Arial" pitchFamily="34" charset="-122"/>
-                <a:cs typeface="Arial" pitchFamily="34" charset="-120"/>
-              </a:rPr>
-              <a:t>Via provider APIs</a:t>
-            </a:r>
-            <a:endParaRPr lang="en-US" sz="1900" dirty="0"/>
-          </a:p>
-        </p:txBody>
-      </p:sp>
-      <p:sp>
-        <p:nvSpPr>
-          <p:cNvPr id="17" name="Text 15"/>
-          <p:cNvSpPr/>
-          <p:nvPr/>
-        </p:nvSpPr>
-        <p:spPr>
-          <a:xfrm>
-            <a:off x="731520" y="5212080"/>
-            <a:ext cx="6035040" cy="457200"/>
-          </a:xfrm>
-          <a:prstGeom prst="rect">
-            <a:avLst/>
-          </a:prstGeom>
-          <a:noFill/>
-          <a:ln/>
-        </p:spPr>
-        <p:txBody>
-          <a:bodyPr wrap="square" lIns="0" tIns="0" rIns="0" bIns="0" rtlCol="0" anchor="ctr"/>
-          <a:lstStyle/>
-          <a:p>
-            <a:pPr indent="0" marL="0">
-              <a:buNone/>
-            </a:pPr>
-            <a:r>
-              <a:rPr lang="en-US" sz="2700" dirty="0">
-                <a:solidFill>
-                  <a:srgbClr val="405965"/>
-                </a:solidFill>
-                <a:latin typeface="Arial" pitchFamily="34" charset="0"/>
-                <a:ea typeface="Arial" pitchFamily="34" charset="-122"/>
-                <a:cs typeface="Arial" pitchFamily="34" charset="-120"/>
-              </a:rPr>
-              <a:t>Execution result returns to the PR.</a:t>
-            </a:r>
-            <a:endParaRPr lang="en-US" sz="2700" dirty="0"/>
+            <a:endParaRPr lang="en-US" sz="2600" dirty="0"/>
           </a:p>
         </p:txBody>
       </p:sp>
@@ -10476,7 +10852,7 @@
                 <a:ea typeface="Arial" pitchFamily="34" charset="-122"/>
                 <a:cs typeface="Arial" pitchFamily="34" charset="-120"/>
               </a:rPr>
-              <a:t>ENGINEER EXPERIENCE</a:t>
+              <a:t>CORE INTEGRATIONS</a:t>
             </a:r>
             <a:endParaRPr lang="en-US" sz="1600" dirty="0"/>
           </a:p>
@@ -10515,7 +10891,7 @@
                 <a:ea typeface="Arial" pitchFamily="34" charset="-122"/>
                 <a:cs typeface="Arial" pitchFamily="34" charset="-120"/>
               </a:rPr>
-              <a:t>One change. One PR conversation.</a:t>
+              <a:t>Connect Git to your infrastructure tools.</a:t>
             </a:r>
             <a:endParaRPr lang="en-US" sz="3600" dirty="0"/>
           </a:p>
@@ -10568,8 +10944,8 @@
         </p:nvSpPr>
         <p:spPr>
           <a:xfrm>
-            <a:off x="658368" y="2148840"/>
-            <a:ext cx="10881360" cy="3657600"/>
+            <a:off x="731520" y="2377440"/>
+            <a:ext cx="3703320" cy="2286000"/>
           </a:xfrm>
           <a:prstGeom prst="rect">
             <a:avLst/>
@@ -10593,8 +10969,8 @@
         </p:nvSpPr>
         <p:spPr>
           <a:xfrm>
-            <a:off x="932688" y="2377440"/>
-            <a:ext cx="9966960" cy="384048"/>
+            <a:off x="932688" y="2514600"/>
+            <a:ext cx="3300984" cy="393192"/>
           </a:xfrm>
           <a:prstGeom prst="rect">
             <a:avLst/>
@@ -10618,7 +10994,7 @@
                 <a:ea typeface="Arial" pitchFamily="34" charset="-122"/>
                 <a:cs typeface="Arial" pitchFamily="34" charset="-120"/>
               </a:rPr>
-              <a:t>infra: resize production database</a:t>
+              <a:t>Git hosts</a:t>
             </a:r>
             <a:endParaRPr lang="en-US" sz="2700" dirty="0"/>
           </a:p>
@@ -10626,39 +11002,129 @@
       </p:sp>
       <p:sp>
         <p:nvSpPr>
-          <p:cNvPr id="7" name="Shape 5"/>
+          <p:cNvPr id="7" name="Text 5"/>
           <p:cNvSpPr/>
           <p:nvPr/>
         </p:nvSpPr>
         <p:spPr>
           <a:xfrm>
             <a:off x="932688" y="2971800"/>
-            <a:ext cx="10287000" cy="0"/>
-          </a:xfrm>
-          <a:prstGeom prst="line">
+            <a:ext cx="3300984" cy="1417320"/>
+          </a:xfrm>
+          <a:prstGeom prst="rect">
             <a:avLst/>
           </a:prstGeom>
           <a:noFill/>
-          <a:ln w="25400">
+          <a:ln/>
+        </p:spPr>
+        <p:txBody>
+          <a:bodyPr wrap="square" lIns="0" tIns="0" rIns="0" bIns="0" rtlCol="0" anchor="ctr"/>
+          <a:lstStyle/>
+          <a:p>
+            <a:pPr indent="0" marL="0">
+              <a:buNone/>
+            </a:pPr>
+            <a:r>
+              <a:rPr lang="en-US" sz="2200" dirty="0">
+                <a:solidFill>
+                  <a:srgbClr val="405965"/>
+                </a:solidFill>
+                <a:latin typeface="Arial" pitchFamily="34" charset="0"/>
+                <a:ea typeface="Arial" pitchFamily="34" charset="-122"/>
+                <a:cs typeface="Arial" pitchFamily="34" charset="-120"/>
+              </a:rPr>
+              <a:t>GitHub · GitLab</a:t>
+            </a:r>
+            <a:endParaRPr lang="en-US" sz="2200" dirty="0"/>
+          </a:p>
+          <a:p>
+            <a:pPr indent="0" marL="0">
+              <a:buNone/>
+            </a:pPr>
+            <a:r>
+              <a:rPr lang="en-US" sz="2200" dirty="0">
+                <a:solidFill>
+                  <a:srgbClr val="405965"/>
+                </a:solidFill>
+                <a:latin typeface="Arial" pitchFamily="34" charset="0"/>
+                <a:ea typeface="Arial" pitchFamily="34" charset="-122"/>
+                <a:cs typeface="Arial" pitchFamily="34" charset="-120"/>
+              </a:rPr>
+              <a:t>Bitbucket Cloud / Server</a:t>
+            </a:r>
+            <a:endParaRPr lang="en-US" sz="2200" dirty="0"/>
+          </a:p>
+          <a:p>
+            <a:pPr indent="0" marL="0">
+              <a:buNone/>
+            </a:pPr>
+            <a:r>
+              <a:rPr lang="en-US" sz="2200" dirty="0">
+                <a:solidFill>
+                  <a:srgbClr val="405965"/>
+                </a:solidFill>
+                <a:latin typeface="Arial" pitchFamily="34" charset="0"/>
+                <a:ea typeface="Arial" pitchFamily="34" charset="-122"/>
+                <a:cs typeface="Arial" pitchFamily="34" charset="-120"/>
+              </a:rPr>
+              <a:t>Gitea / Forgejo</a:t>
+            </a:r>
+            <a:endParaRPr lang="en-US" sz="2200" dirty="0"/>
+          </a:p>
+          <a:p>
+            <a:pPr indent="0" marL="0">
+              <a:buNone/>
+            </a:pPr>
+            <a:r>
+              <a:rPr lang="en-US" sz="2200" dirty="0">
+                <a:solidFill>
+                  <a:srgbClr val="405965"/>
+                </a:solidFill>
+                <a:latin typeface="Arial" pitchFamily="34" charset="0"/>
+                <a:ea typeface="Arial" pitchFamily="34" charset="-122"/>
+                <a:cs typeface="Arial" pitchFamily="34" charset="-120"/>
+              </a:rPr>
+              <a:t>Azure DevOps</a:t>
+            </a:r>
+            <a:endParaRPr lang="en-US" sz="2200" dirty="0"/>
+          </a:p>
+        </p:txBody>
+      </p:sp>
+      <p:sp>
+        <p:nvSpPr>
+          <p:cNvPr id="8" name="Shape 6"/>
+          <p:cNvSpPr/>
+          <p:nvPr/>
+        </p:nvSpPr>
+        <p:spPr>
+          <a:xfrm>
+            <a:off x="5074920" y="2788920"/>
+            <a:ext cx="2377440" cy="1234440"/>
+          </a:xfrm>
+          <a:prstGeom prst="rect">
+            <a:avLst/>
+          </a:prstGeom>
+          <a:solidFill>
+            <a:srgbClr val="EAF1F3"/>
+          </a:solidFill>
+          <a:ln w="12700">
             <a:solidFill>
-              <a:srgbClr val="A6BAC1"/>
+              <a:srgbClr val="EAF1F3"/>
             </a:solidFill>
             <a:prstDash val="solid"/>
-            <a:headEnd type="none"/>
-            <a:tailEnd type="none"/>
           </a:ln>
         </p:spPr>
       </p:sp>
       <p:sp>
         <p:nvSpPr>
-          <p:cNvPr id="8" name="Text 6"/>
+          <p:cNvPr id="9" name="Text 7"/>
           <p:cNvSpPr/>
           <p:nvPr/>
         </p:nvSpPr>
         <p:spPr>
           <a:xfrm>
-            <a:off x="950976" y="3218688"/>
-            <a:ext cx="1508760" cy="365760"/>
+            <a:off x="5276088" y="2926080"/>
+            <a:ext cx="1975104" cy="393192"/>
           </a:xfrm>
           <a:prstGeom prst="rect">
             <a:avLst/>
@@ -10674,9 +11140,9 @@
               <a:buNone/>
             </a:pPr>
             <a:r>
-              <a:rPr lang="en-US" sz="2100" dirty="0">
-                <a:solidFill>
-                  <a:srgbClr val="405965"/>
+              <a:rPr lang="en-US" sz="2700" b="1" dirty="0">
+                <a:solidFill>
+                  <a:srgbClr val="083E4F"/>
                 </a:solidFill>
                 <a:latin typeface="Arial" pitchFamily="34" charset="0"/>
                 <a:ea typeface="Arial" pitchFamily="34" charset="-122"/>
@@ -10684,20 +11150,20 @@
               </a:rPr>
               <a:t>Atlantis</a:t>
             </a:r>
-            <a:endParaRPr lang="en-US" sz="2100" dirty="0"/>
-          </a:p>
-        </p:txBody>
-      </p:sp>
-      <p:sp>
-        <p:nvSpPr>
-          <p:cNvPr id="9" name="Text 7"/>
+            <a:endParaRPr lang="en-US" sz="2700" dirty="0"/>
+          </a:p>
+        </p:txBody>
+      </p:sp>
+      <p:sp>
+        <p:nvSpPr>
+          <p:cNvPr id="10" name="Text 8"/>
           <p:cNvSpPr/>
           <p:nvPr/>
         </p:nvSpPr>
         <p:spPr>
           <a:xfrm>
-            <a:off x="2743200" y="3218688"/>
-            <a:ext cx="8412480" cy="365760"/>
+            <a:off x="5276088" y="3410712"/>
+            <a:ext cx="1975104" cy="329184"/>
           </a:xfrm>
           <a:prstGeom prst="rect">
             <a:avLst/>
@@ -10713,30 +11179,55 @@
               <a:buNone/>
             </a:pPr>
             <a:r>
-              <a:rPr lang="en-US" sz="2500" b="1" dirty="0">
-                <a:solidFill>
-                  <a:srgbClr val="086679"/>
+              <a:rPr lang="en-US" sz="1900" dirty="0">
+                <a:solidFill>
+                  <a:srgbClr val="405965"/>
                 </a:solidFill>
                 <a:latin typeface="Arial" pitchFamily="34" charset="0"/>
                 <a:ea typeface="Arial" pitchFamily="34" charset="-122"/>
                 <a:cs typeface="Arial" pitchFamily="34" charset="-120"/>
               </a:rPr>
-              <a:t>Plan: 0 to add, 1 to change, 0 to destroy</a:t>
+              <a:t>PR automation</a:t>
             </a:r>
-            <a:endParaRPr lang="en-US" sz="2500" dirty="0"/>
-          </a:p>
-        </p:txBody>
-      </p:sp>
-      <p:sp>
-        <p:nvSpPr>
-          <p:cNvPr id="10" name="Text 8"/>
+            <a:endParaRPr lang="en-US" sz="1900" dirty="0"/>
+          </a:p>
+        </p:txBody>
+      </p:sp>
+      <p:sp>
+        <p:nvSpPr>
+          <p:cNvPr id="11" name="Shape 9"/>
           <p:cNvSpPr/>
           <p:nvPr/>
         </p:nvSpPr>
         <p:spPr>
           <a:xfrm>
-            <a:off x="950976" y="3813048"/>
-            <a:ext cx="1508760" cy="365760"/>
+            <a:off x="8092440" y="2377440"/>
+            <a:ext cx="3337560" cy="2286000"/>
+          </a:xfrm>
+          <a:prstGeom prst="rect">
+            <a:avLst/>
+          </a:prstGeom>
+          <a:solidFill>
+            <a:srgbClr val="EAF1F3"/>
+          </a:solidFill>
+          <a:ln w="12700">
+            <a:solidFill>
+              <a:srgbClr val="EAF1F3"/>
+            </a:solidFill>
+            <a:prstDash val="solid"/>
+          </a:ln>
+        </p:spPr>
+      </p:sp>
+      <p:sp>
+        <p:nvSpPr>
+          <p:cNvPr id="12" name="Text 10"/>
+          <p:cNvSpPr/>
+          <p:nvPr/>
+        </p:nvSpPr>
+        <p:spPr>
+          <a:xfrm>
+            <a:off x="8293608" y="2514600"/>
+            <a:ext cx="2935224" cy="393192"/>
           </a:xfrm>
           <a:prstGeom prst="rect">
             <a:avLst/>
@@ -10752,30 +11243,30 @@
               <a:buNone/>
             </a:pPr>
             <a:r>
-              <a:rPr lang="en-US" sz="2100" dirty="0">
-                <a:solidFill>
-                  <a:srgbClr val="405965"/>
+              <a:rPr lang="en-US" sz="2700" b="1" dirty="0">
+                <a:solidFill>
+                  <a:srgbClr val="083E4F"/>
                 </a:solidFill>
                 <a:latin typeface="Arial" pitchFamily="34" charset="0"/>
                 <a:ea typeface="Arial" pitchFamily="34" charset="-122"/>
                 <a:cs typeface="Arial" pitchFamily="34" charset="-120"/>
               </a:rPr>
-              <a:t>Reviewer</a:t>
+              <a:t>IaC execution</a:t>
             </a:r>
-            <a:endParaRPr lang="en-US" sz="2100" dirty="0"/>
-          </a:p>
-        </p:txBody>
-      </p:sp>
-      <p:sp>
-        <p:nvSpPr>
-          <p:cNvPr id="11" name="Text 9"/>
+            <a:endParaRPr lang="en-US" sz="2700" dirty="0"/>
+          </a:p>
+        </p:txBody>
+      </p:sp>
+      <p:sp>
+        <p:nvSpPr>
+          <p:cNvPr id="13" name="Text 11"/>
           <p:cNvSpPr/>
           <p:nvPr/>
         </p:nvSpPr>
         <p:spPr>
           <a:xfrm>
-            <a:off x="2743200" y="3813048"/>
-            <a:ext cx="8412480" cy="365760"/>
+            <a:off x="8293608" y="3017520"/>
+            <a:ext cx="2935224" cy="685800"/>
           </a:xfrm>
           <a:prstGeom prst="rect">
             <a:avLst/>
@@ -10791,7 +11282,7 @@
               <a:buNone/>
             </a:pPr>
             <a:r>
-              <a:rPr lang="en-US" sz="2500" dirty="0">
+              <a:rPr lang="en-US" sz="2500" b="1" dirty="0">
                 <a:solidFill>
                   <a:srgbClr val="083E4F"/>
                 </a:solidFill>
@@ -10799,7 +11290,7 @@
                 <a:ea typeface="Arial" pitchFamily="34" charset="-122"/>
                 <a:cs typeface="Arial" pitchFamily="34" charset="-120"/>
               </a:rPr>
-              <a:t>Approved</a:t>
+              <a:t>Terraform / OpenTofu</a:t>
             </a:r>
             <a:endParaRPr lang="en-US" sz="2500" dirty="0"/>
           </a:p>
@@ -10807,14 +11298,14 @@
       </p:sp>
       <p:sp>
         <p:nvSpPr>
-          <p:cNvPr id="12" name="Text 10"/>
+          <p:cNvPr id="14" name="Text 12"/>
           <p:cNvSpPr/>
           <p:nvPr/>
         </p:nvSpPr>
         <p:spPr>
           <a:xfrm>
-            <a:off x="950976" y="4407408"/>
-            <a:ext cx="1508760" cy="365760"/>
+            <a:off x="8293608" y="3794760"/>
+            <a:ext cx="2935224" cy="685800"/>
           </a:xfrm>
           <a:prstGeom prst="rect">
             <a:avLst/>
@@ -10830,7 +11321,7 @@
               <a:buNone/>
             </a:pPr>
             <a:r>
-              <a:rPr lang="en-US" sz="2100" dirty="0">
+              <a:rPr lang="en-US" sz="2200" dirty="0">
                 <a:solidFill>
                   <a:srgbClr val="405965"/>
                 </a:solidFill>
@@ -10838,61 +11329,89 @@
                 <a:ea typeface="Arial" pitchFamily="34" charset="-122"/>
                 <a:cs typeface="Arial" pitchFamily="34" charset="-120"/>
               </a:rPr>
-              <a:t>Rui</a:t>
+              <a:t>Terragrunt via</a:t>
             </a:r>
-            <a:endParaRPr lang="en-US" sz="2100" dirty="0"/>
-          </a:p>
-        </p:txBody>
-      </p:sp>
-      <p:sp>
-        <p:nvSpPr>
-          <p:cNvPr id="13" name="Text 11"/>
-          <p:cNvSpPr/>
-          <p:nvPr/>
-        </p:nvSpPr>
-        <p:spPr>
-          <a:xfrm>
-            <a:off x="2743200" y="4407408"/>
-            <a:ext cx="8412480" cy="365760"/>
-          </a:xfrm>
-          <a:prstGeom prst="rect">
-            <a:avLst/>
-          </a:prstGeom>
-          <a:noFill/>
-          <a:ln/>
-        </p:spPr>
-        <p:txBody>
-          <a:bodyPr wrap="square" lIns="0" tIns="0" rIns="0" bIns="0" rtlCol="0" anchor="ctr"/>
-          <a:lstStyle/>
+            <a:endParaRPr lang="en-US" sz="2200" dirty="0"/>
+          </a:p>
           <a:p>
             <a:pPr indent="0" marL="0">
               <a:buNone/>
             </a:pPr>
             <a:r>
-              <a:rPr lang="en-US" sz="2500" b="1" dirty="0">
-                <a:solidFill>
-                  <a:srgbClr val="086679"/>
+              <a:rPr lang="en-US" sz="2200" dirty="0">
+                <a:solidFill>
+                  <a:srgbClr val="405965"/>
                 </a:solidFill>
                 <a:latin typeface="Arial" pitchFamily="34" charset="0"/>
                 <a:ea typeface="Arial" pitchFamily="34" charset="-122"/>
                 <a:cs typeface="Arial" pitchFamily="34" charset="-120"/>
               </a:rPr>
-              <a:t>atlantis apply</a:t>
+              <a:t>custom workflows</a:t>
             </a:r>
-            <a:endParaRPr lang="en-US" sz="2500" dirty="0"/>
-          </a:p>
-        </p:txBody>
-      </p:sp>
-      <p:sp>
-        <p:nvSpPr>
-          <p:cNvPr id="14" name="Text 12"/>
+            <a:endParaRPr lang="en-US" sz="2200" dirty="0"/>
+          </a:p>
+        </p:txBody>
+      </p:sp>
+      <p:sp>
+        <p:nvSpPr>
+          <p:cNvPr id="15" name="Shape 13"/>
           <p:cNvSpPr/>
           <p:nvPr/>
         </p:nvSpPr>
         <p:spPr>
           <a:xfrm>
-            <a:off x="950976" y="5001768"/>
-            <a:ext cx="1508760" cy="365760"/>
+            <a:off x="4572000" y="3383280"/>
+            <a:ext cx="365760" cy="0"/>
+          </a:xfrm>
+          <a:prstGeom prst="line">
+            <a:avLst/>
+          </a:prstGeom>
+          <a:noFill/>
+          <a:ln w="25400">
+            <a:solidFill>
+              <a:srgbClr val="086679"/>
+            </a:solidFill>
+            <a:prstDash val="solid"/>
+            <a:headEnd type="none"/>
+            <a:tailEnd type="triangle"/>
+          </a:ln>
+        </p:spPr>
+      </p:sp>
+      <p:sp>
+        <p:nvSpPr>
+          <p:cNvPr id="16" name="Shape 14"/>
+          <p:cNvSpPr/>
+          <p:nvPr/>
+        </p:nvSpPr>
+        <p:spPr>
+          <a:xfrm>
+            <a:off x="7589520" y="3383280"/>
+            <a:ext cx="365760" cy="0"/>
+          </a:xfrm>
+          <a:prstGeom prst="line">
+            <a:avLst/>
+          </a:prstGeom>
+          <a:noFill/>
+          <a:ln w="25400">
+            <a:solidFill>
+              <a:srgbClr val="086679"/>
+            </a:solidFill>
+            <a:prstDash val="solid"/>
+            <a:headEnd type="none"/>
+            <a:tailEnd type="triangle"/>
+          </a:ln>
+        </p:spPr>
+      </p:sp>
+      <p:sp>
+        <p:nvSpPr>
+          <p:cNvPr id="17" name="Text 15"/>
+          <p:cNvSpPr/>
+          <p:nvPr/>
+        </p:nvSpPr>
+        <p:spPr>
+          <a:xfrm>
+            <a:off x="731520" y="5303520"/>
+            <a:ext cx="10789920" cy="594360"/>
           </a:xfrm>
           <a:prstGeom prst="rect">
             <a:avLst/>
@@ -10908,95 +11427,17 @@
               <a:buNone/>
             </a:pPr>
             <a:r>
-              <a:rPr lang="en-US" sz="2100" dirty="0">
-                <a:solidFill>
-                  <a:srgbClr val="405965"/>
+              <a:rPr lang="en-US" sz="3000" b="1" dirty="0">
+                <a:solidFill>
+                  <a:srgbClr val="086679"/>
                 </a:solidFill>
                 <a:latin typeface="Arial" pitchFamily="34" charset="0"/>
                 <a:ea typeface="Arial" pitchFamily="34" charset="-122"/>
                 <a:cs typeface="Arial" pitchFamily="34" charset="-120"/>
               </a:rPr>
-              <a:t>Atlantis</a:t>
+              <a:t>Purpose-built infrastructure PR automation</a:t>
             </a:r>
-            <a:endParaRPr lang="en-US" sz="2100" dirty="0"/>
-          </a:p>
-        </p:txBody>
-      </p:sp>
-      <p:sp>
-        <p:nvSpPr>
-          <p:cNvPr id="15" name="Text 13"/>
-          <p:cNvSpPr/>
-          <p:nvPr/>
-        </p:nvSpPr>
-        <p:spPr>
-          <a:xfrm>
-            <a:off x="2743200" y="5001768"/>
-            <a:ext cx="8412480" cy="365760"/>
-          </a:xfrm>
-          <a:prstGeom prst="rect">
-            <a:avLst/>
-          </a:prstGeom>
-          <a:noFill/>
-          <a:ln/>
-        </p:spPr>
-        <p:txBody>
-          <a:bodyPr wrap="square" lIns="0" tIns="0" rIns="0" bIns="0" rtlCol="0" anchor="ctr"/>
-          <a:lstStyle/>
-          <a:p>
-            <a:pPr indent="0" marL="0">
-              <a:buNone/>
-            </a:pPr>
-            <a:r>
-              <a:rPr lang="en-US" sz="2500" dirty="0">
-                <a:solidFill>
-                  <a:srgbClr val="083E4F"/>
-                </a:solidFill>
-                <a:latin typeface="Arial" pitchFamily="34" charset="0"/>
-                <a:ea typeface="Arial" pitchFamily="34" charset="-122"/>
-                <a:cs typeface="Arial" pitchFamily="34" charset="-120"/>
-              </a:rPr>
-              <a:t>Apply complete.</a:t>
-            </a:r>
-            <a:endParaRPr lang="en-US" sz="2500" dirty="0"/>
-          </a:p>
-        </p:txBody>
-      </p:sp>
-      <p:sp>
-        <p:nvSpPr>
-          <p:cNvPr id="16" name="Text 14"/>
-          <p:cNvSpPr/>
-          <p:nvPr/>
-        </p:nvSpPr>
-        <p:spPr>
-          <a:xfrm>
-            <a:off x="932688" y="5504688"/>
-            <a:ext cx="10332720" cy="274320"/>
-          </a:xfrm>
-          <a:prstGeom prst="rect">
-            <a:avLst/>
-          </a:prstGeom>
-          <a:noFill/>
-          <a:ln/>
-        </p:spPr>
-        <p:txBody>
-          <a:bodyPr wrap="square" lIns="0" tIns="0" rIns="0" bIns="0" rtlCol="0" anchor="ctr"/>
-          <a:lstStyle/>
-          <a:p>
-            <a:pPr indent="0" marL="0">
-              <a:buNone/>
-            </a:pPr>
-            <a:r>
-              <a:rPr lang="en-US" sz="1800" dirty="0">
-                <a:solidFill>
-                  <a:srgbClr val="405965"/>
-                </a:solidFill>
-                <a:latin typeface="Arial" pitchFamily="34" charset="0"/>
-                <a:ea typeface="Arial" pitchFamily="34" charset="-122"/>
-                <a:cs typeface="Arial" pitchFamily="34" charset="-120"/>
-              </a:rPr>
-              <a:t>Illustrative PR · approval requirement configured · apply before merge</a:t>
-            </a:r>
-            <a:endParaRPr lang="en-US" sz="1800" dirty="0"/>
+            <a:endParaRPr lang="en-US" sz="3000" dirty="0"/>
           </a:p>
         </p:txBody>
       </p:sp>
@@ -11058,7 +11499,7 @@
                 <a:ea typeface="Arial" pitchFamily="34" charset="-122"/>
                 <a:cs typeface="Arial" pitchFamily="34" charset="-120"/>
               </a:rPr>
-              <a:t>ECOSYSTEM INTEGRATIONS</a:t>
+              <a:t>OPTIONAL INTEGRATIONS</a:t>
             </a:r>
             <a:endParaRPr lang="en-US" sz="1600" dirty="0"/>
           </a:p>
@@ -11097,7 +11538,7 @@
                 <a:ea typeface="Arial" pitchFamily="34" charset="-122"/>
                 <a:cs typeface="Arial" pitchFamily="34" charset="-120"/>
               </a:rPr>
-              <a:t>Connect your platform tools.</a:t>
+              <a:t>Give reviewers policy and cost context.</a:t>
             </a:r>
             <a:endParaRPr lang="en-US" sz="3600" dirty="0"/>
           </a:p>
@@ -11150,8 +11591,8 @@
         </p:nvSpPr>
         <p:spPr>
           <a:xfrm>
-            <a:off x="640080" y="2423160"/>
-            <a:ext cx="3493008" cy="2971800"/>
+            <a:off x="731520" y="2514600"/>
+            <a:ext cx="3566160" cy="1280160"/>
           </a:xfrm>
           <a:prstGeom prst="rect">
             <a:avLst/>
@@ -11175,8 +11616,8 @@
         </p:nvSpPr>
         <p:spPr>
           <a:xfrm>
-            <a:off x="841248" y="2697480"/>
-            <a:ext cx="3090672" cy="457200"/>
+            <a:off x="932688" y="2651760"/>
+            <a:ext cx="3163824" cy="393192"/>
           </a:xfrm>
           <a:prstGeom prst="rect">
             <a:avLst/>
@@ -11192,7 +11633,7 @@
               <a:buNone/>
             </a:pPr>
             <a:r>
-              <a:rPr lang="en-US" sz="2900" b="1" dirty="0">
+              <a:rPr lang="en-US" sz="2700" b="1" dirty="0">
                 <a:solidFill>
                   <a:srgbClr val="083E4F"/>
                 </a:solidFill>
@@ -11200,9 +11641,9 @@
                 <a:ea typeface="Arial" pitchFamily="34" charset="-122"/>
                 <a:cs typeface="Arial" pitchFamily="34" charset="-120"/>
               </a:rPr>
-              <a:t>Git hosts</a:t>
+              <a:t>Conftest</a:t>
             </a:r>
-            <a:endParaRPr lang="en-US" sz="2900" dirty="0"/>
+            <a:endParaRPr lang="en-US" sz="2700" dirty="0"/>
           </a:p>
         </p:txBody>
       </p:sp>
@@ -11214,8 +11655,8 @@
         </p:nvSpPr>
         <p:spPr>
           <a:xfrm>
-            <a:off x="841248" y="3474720"/>
-            <a:ext cx="3090672" cy="1600200"/>
+            <a:off x="932688" y="3136392"/>
+            <a:ext cx="3163824" cy="329184"/>
           </a:xfrm>
           <a:prstGeom prst="rect">
             <a:avLst/>
@@ -11231,7 +11672,7 @@
               <a:buNone/>
             </a:pPr>
             <a:r>
-              <a:rPr lang="en-US" sz="2200" dirty="0">
+              <a:rPr lang="en-US" sz="1900" dirty="0">
                 <a:solidFill>
                   <a:srgbClr val="405965"/>
                 </a:solidFill>
@@ -11239,60 +11680,9 @@
                 <a:ea typeface="Arial" pitchFamily="34" charset="-122"/>
                 <a:cs typeface="Arial" pitchFamily="34" charset="-120"/>
               </a:rPr>
-              <a:t>GitHub · GitLab</a:t>
+              <a:t>Policy checks</a:t>
             </a:r>
-            <a:endParaRPr lang="en-US" sz="2200" dirty="0"/>
-          </a:p>
-          <a:p>
-            <a:pPr indent="0" marL="0">
-              <a:buNone/>
-            </a:pPr>
-            <a:r>
-              <a:rPr lang="en-US" sz="2200" dirty="0">
-                <a:solidFill>
-                  <a:srgbClr val="405965"/>
-                </a:solidFill>
-                <a:latin typeface="Arial" pitchFamily="34" charset="0"/>
-                <a:ea typeface="Arial" pitchFamily="34" charset="-122"/>
-                <a:cs typeface="Arial" pitchFamily="34" charset="-120"/>
-              </a:rPr>
-              <a:t>Gitea / Forgejo</a:t>
-            </a:r>
-            <a:endParaRPr lang="en-US" sz="2200" dirty="0"/>
-          </a:p>
-          <a:p>
-            <a:pPr indent="0" marL="0">
-              <a:buNone/>
-            </a:pPr>
-            <a:r>
-              <a:rPr lang="en-US" sz="2200" dirty="0">
-                <a:solidFill>
-                  <a:srgbClr val="405965"/>
-                </a:solidFill>
-                <a:latin typeface="Arial" pitchFamily="34" charset="0"/>
-                <a:ea typeface="Arial" pitchFamily="34" charset="-122"/>
-                <a:cs typeface="Arial" pitchFamily="34" charset="-120"/>
-              </a:rPr>
-              <a:t>Bitbucket</a:t>
-            </a:r>
-            <a:endParaRPr lang="en-US" sz="2200" dirty="0"/>
-          </a:p>
-          <a:p>
-            <a:pPr indent="0" marL="0">
-              <a:buNone/>
-            </a:pPr>
-            <a:r>
-              <a:rPr lang="en-US" sz="2200" dirty="0">
-                <a:solidFill>
-                  <a:srgbClr val="405965"/>
-                </a:solidFill>
-                <a:latin typeface="Arial" pitchFamily="34" charset="0"/>
-                <a:ea typeface="Arial" pitchFamily="34" charset="-122"/>
-                <a:cs typeface="Arial" pitchFamily="34" charset="-120"/>
-              </a:rPr>
-              <a:t>Azure DevOps</a:t>
-            </a:r>
-            <a:endParaRPr lang="en-US" sz="2200" dirty="0"/>
+            <a:endParaRPr lang="en-US" sz="1900" dirty="0"/>
           </a:p>
         </p:txBody>
       </p:sp>
@@ -11304,8 +11694,8 @@
         </p:nvSpPr>
         <p:spPr>
           <a:xfrm>
-            <a:off x="4352544" y="2423160"/>
-            <a:ext cx="3493008" cy="2971800"/>
+            <a:off x="731520" y="4251960"/>
+            <a:ext cx="3566160" cy="1280160"/>
           </a:xfrm>
           <a:prstGeom prst="rect">
             <a:avLst/>
@@ -11329,8 +11719,8 @@
         </p:nvSpPr>
         <p:spPr>
           <a:xfrm>
-            <a:off x="4553712" y="2697480"/>
-            <a:ext cx="3090672" cy="457200"/>
+            <a:off x="932688" y="4389120"/>
+            <a:ext cx="3163824" cy="393192"/>
           </a:xfrm>
           <a:prstGeom prst="rect">
             <a:avLst/>
@@ -11346,7 +11736,7 @@
               <a:buNone/>
             </a:pPr>
             <a:r>
-              <a:rPr lang="en-US" sz="2900" b="1" dirty="0">
+              <a:rPr lang="en-US" sz="2700" b="1" dirty="0">
                 <a:solidFill>
                   <a:srgbClr val="083E4F"/>
                 </a:solidFill>
@@ -11354,9 +11744,9 @@
                 <a:ea typeface="Arial" pitchFamily="34" charset="-122"/>
                 <a:cs typeface="Arial" pitchFamily="34" charset="-120"/>
               </a:rPr>
-              <a:t>IaC execution</a:t>
+              <a:t>Infracost</a:t>
             </a:r>
-            <a:endParaRPr lang="en-US" sz="2900" dirty="0"/>
+            <a:endParaRPr lang="en-US" sz="2700" dirty="0"/>
           </a:p>
         </p:txBody>
       </p:sp>
@@ -11368,8 +11758,8 @@
         </p:nvSpPr>
         <p:spPr>
           <a:xfrm>
-            <a:off x="4553712" y="3474720"/>
-            <a:ext cx="3090672" cy="1600200"/>
+            <a:off x="932688" y="4873752"/>
+            <a:ext cx="3163824" cy="329184"/>
           </a:xfrm>
           <a:prstGeom prst="rect">
             <a:avLst/>
@@ -11385,7 +11775,7 @@
               <a:buNone/>
             </a:pPr>
             <a:r>
-              <a:rPr lang="en-US" sz="2200" dirty="0">
+              <a:rPr lang="en-US" sz="1900" dirty="0">
                 <a:solidFill>
                   <a:srgbClr val="405965"/>
                 </a:solidFill>
@@ -11393,49 +11783,9 @@
                 <a:ea typeface="Arial" pitchFamily="34" charset="-122"/>
                 <a:cs typeface="Arial" pitchFamily="34" charset="-120"/>
               </a:rPr>
-              <a:t>Terraform / OpenTofu</a:t>
+              <a:t>Cost estimates</a:t>
             </a:r>
-            <a:endParaRPr lang="en-US" sz="2200" dirty="0"/>
-          </a:p>
-          <a:p>
-            <a:pPr indent="0" marL="0">
-              <a:buNone/>
-            </a:pPr>
-            <a:endParaRPr lang="en-US" sz="2200" dirty="0"/>
-          </a:p>
-          <a:p>
-            <a:pPr indent="0" marL="0">
-              <a:buNone/>
-            </a:pPr>
-            <a:r>
-              <a:rPr lang="en-US" sz="2200" dirty="0">
-                <a:solidFill>
-                  <a:srgbClr val="405965"/>
-                </a:solidFill>
-                <a:latin typeface="Arial" pitchFamily="34" charset="0"/>
-                <a:ea typeface="Arial" pitchFamily="34" charset="-122"/>
-                <a:cs typeface="Arial" pitchFamily="34" charset="-120"/>
-              </a:rPr>
-              <a:t>Terragrunt via</a:t>
-            </a:r>
-            <a:endParaRPr lang="en-US" sz="2200" dirty="0"/>
-          </a:p>
-          <a:p>
-            <a:pPr indent="0" marL="0">
-              <a:buNone/>
-            </a:pPr>
-            <a:r>
-              <a:rPr lang="en-US" sz="2200" dirty="0">
-                <a:solidFill>
-                  <a:srgbClr val="405965"/>
-                </a:solidFill>
-                <a:latin typeface="Arial" pitchFamily="34" charset="0"/>
-                <a:ea typeface="Arial" pitchFamily="34" charset="-122"/>
-                <a:cs typeface="Arial" pitchFamily="34" charset="-120"/>
-              </a:rPr>
-              <a:t>custom workflows</a:t>
-            </a:r>
-            <a:endParaRPr lang="en-US" sz="2200" dirty="0"/>
+            <a:endParaRPr lang="en-US" sz="1900" dirty="0"/>
           </a:p>
         </p:txBody>
       </p:sp>
@@ -11447,8 +11797,8 @@
         </p:nvSpPr>
         <p:spPr>
           <a:xfrm>
-            <a:off x="8065008" y="2423160"/>
-            <a:ext cx="3493008" cy="2971800"/>
+            <a:off x="7315200" y="3383280"/>
+            <a:ext cx="4114800" cy="1417320"/>
           </a:xfrm>
           <a:prstGeom prst="rect">
             <a:avLst/>
@@ -11472,8 +11822,8 @@
         </p:nvSpPr>
         <p:spPr>
           <a:xfrm>
-            <a:off x="8266176" y="2697480"/>
-            <a:ext cx="3090672" cy="457200"/>
+            <a:off x="7516368" y="3520440"/>
+            <a:ext cx="3712464" cy="393192"/>
           </a:xfrm>
           <a:prstGeom prst="rect">
             <a:avLst/>
@@ -11489,7 +11839,7 @@
               <a:buNone/>
             </a:pPr>
             <a:r>
-              <a:rPr lang="en-US" sz="2900" b="1" dirty="0">
+              <a:rPr lang="en-US" sz="2700" b="1" dirty="0">
                 <a:solidFill>
                   <a:srgbClr val="083E4F"/>
                 </a:solidFill>
@@ -11497,9 +11847,9 @@
                 <a:ea typeface="Arial" pitchFamily="34" charset="-122"/>
                 <a:cs typeface="Arial" pitchFamily="34" charset="-120"/>
               </a:rPr>
-              <a:t>Review context</a:t>
+              <a:t>Pull request review</a:t>
             </a:r>
-            <a:endParaRPr lang="en-US" sz="2900" dirty="0"/>
+            <a:endParaRPr lang="en-US" sz="2700" dirty="0"/>
           </a:p>
         </p:txBody>
       </p:sp>
@@ -11511,8 +11861,8 @@
         </p:nvSpPr>
         <p:spPr>
           <a:xfrm>
-            <a:off x="8266176" y="3474720"/>
-            <a:ext cx="3090672" cy="1600200"/>
+            <a:off x="7516368" y="4005072"/>
+            <a:ext cx="3712464" cy="329184"/>
           </a:xfrm>
           <a:prstGeom prst="rect">
             <a:avLst/>
@@ -11528,7 +11878,7 @@
               <a:buNone/>
             </a:pPr>
             <a:r>
-              <a:rPr lang="en-US" sz="2200" dirty="0">
+              <a:rPr lang="en-US" sz="1900" dirty="0">
                 <a:solidFill>
                   <a:srgbClr val="405965"/>
                 </a:solidFill>
@@ -11536,16 +11886,138 @@
                 <a:ea typeface="Arial" pitchFamily="34" charset="-122"/>
                 <a:cs typeface="Arial" pitchFamily="34" charset="-120"/>
               </a:rPr>
-              <a:t>Conftest → policy</a:t>
+              <a:t>Code + plan + added context</a:t>
             </a:r>
-            <a:endParaRPr lang="en-US" sz="2200" dirty="0"/>
-          </a:p>
+            <a:endParaRPr lang="en-US" sz="1900" dirty="0"/>
+          </a:p>
+        </p:txBody>
+      </p:sp>
+      <p:sp>
+        <p:nvSpPr>
+          <p:cNvPr id="14" name="Shape 12"/>
+          <p:cNvSpPr/>
+          <p:nvPr/>
+        </p:nvSpPr>
+        <p:spPr>
+          <a:xfrm>
+            <a:off x="4526280" y="3154680"/>
+            <a:ext cx="1188720" cy="0"/>
+          </a:xfrm>
+          <a:prstGeom prst="line">
+            <a:avLst/>
+          </a:prstGeom>
+          <a:noFill/>
+          <a:ln w="25400">
+            <a:solidFill>
+              <a:srgbClr val="086679"/>
+            </a:solidFill>
+            <a:prstDash val="solid"/>
+            <a:headEnd type="none"/>
+            <a:tailEnd type="none"/>
+          </a:ln>
+        </p:spPr>
+      </p:sp>
+      <p:sp>
+        <p:nvSpPr>
+          <p:cNvPr id="15" name="Shape 13"/>
+          <p:cNvSpPr/>
+          <p:nvPr/>
+        </p:nvSpPr>
+        <p:spPr>
+          <a:xfrm>
+            <a:off x="4526280" y="4892040"/>
+            <a:ext cx="1188720" cy="0"/>
+          </a:xfrm>
+          <a:prstGeom prst="line">
+            <a:avLst/>
+          </a:prstGeom>
+          <a:noFill/>
+          <a:ln w="25400">
+            <a:solidFill>
+              <a:srgbClr val="086679"/>
+            </a:solidFill>
+            <a:prstDash val="solid"/>
+            <a:headEnd type="none"/>
+            <a:tailEnd type="none"/>
+          </a:ln>
+        </p:spPr>
+      </p:sp>
+      <p:sp>
+        <p:nvSpPr>
+          <p:cNvPr id="16" name="Shape 14"/>
+          <p:cNvSpPr/>
+          <p:nvPr/>
+        </p:nvSpPr>
+        <p:spPr>
+          <a:xfrm>
+            <a:off x="5715000" y="3154680"/>
+            <a:ext cx="0" cy="1737360"/>
+          </a:xfrm>
+          <a:prstGeom prst="line">
+            <a:avLst/>
+          </a:prstGeom>
+          <a:noFill/>
+          <a:ln w="25400">
+            <a:solidFill>
+              <a:srgbClr val="086679"/>
+            </a:solidFill>
+            <a:prstDash val="solid"/>
+            <a:headEnd type="none"/>
+            <a:tailEnd type="none"/>
+          </a:ln>
+        </p:spPr>
+      </p:sp>
+      <p:sp>
+        <p:nvSpPr>
+          <p:cNvPr id="17" name="Shape 15"/>
+          <p:cNvSpPr/>
+          <p:nvPr/>
+        </p:nvSpPr>
+        <p:spPr>
+          <a:xfrm>
+            <a:off x="5715000" y="4114800"/>
+            <a:ext cx="1371600" cy="0"/>
+          </a:xfrm>
+          <a:prstGeom prst="line">
+            <a:avLst/>
+          </a:prstGeom>
+          <a:noFill/>
+          <a:ln w="25400">
+            <a:solidFill>
+              <a:srgbClr val="086679"/>
+            </a:solidFill>
+            <a:prstDash val="solid"/>
+            <a:headEnd type="none"/>
+            <a:tailEnd type="triangle"/>
+          </a:ln>
+        </p:spPr>
+      </p:sp>
+      <p:sp>
+        <p:nvSpPr>
+          <p:cNvPr id="18" name="Text 16"/>
+          <p:cNvSpPr/>
+          <p:nvPr/>
+        </p:nvSpPr>
+        <p:spPr>
+          <a:xfrm>
+            <a:off x="7223760" y="5166360"/>
+            <a:ext cx="4297680" cy="594360"/>
+          </a:xfrm>
+          <a:prstGeom prst="rect">
+            <a:avLst/>
+          </a:prstGeom>
+          <a:noFill/>
+          <a:ln/>
+        </p:spPr>
+        <p:txBody>
+          <a:bodyPr wrap="square" lIns="0" tIns="0" rIns="0" bIns="0" rtlCol="0" anchor="ctr"/>
+          <a:lstStyle/>
           <a:p>
             <a:pPr indent="0" marL="0">
               <a:buNone/>
             </a:pPr>
             <a:r>
-              <a:rPr lang="en-US" sz="2200" dirty="0">
+              <a:rPr lang="en-US" sz="2300" dirty="0">
                 <a:solidFill>
                   <a:srgbClr val="405965"/>
                 </a:solidFill>
@@ -11553,71 +12025,9 @@
                 <a:ea typeface="Arial" pitchFamily="34" charset="-122"/>
                 <a:cs typeface="Arial" pitchFamily="34" charset="-120"/>
               </a:rPr>
-              <a:t>Infracost → costs</a:t>
+              <a:t>Configured by your platform team</a:t>
             </a:r>
-            <a:endParaRPr lang="en-US" sz="2200" dirty="0"/>
-          </a:p>
-          <a:p>
-            <a:pPr indent="0" marL="0">
-              <a:buNone/>
-            </a:pPr>
-            <a:endParaRPr lang="en-US" sz="2200" dirty="0"/>
-          </a:p>
-          <a:p>
-            <a:pPr indent="0" marL="0">
-              <a:buNone/>
-            </a:pPr>
-            <a:r>
-              <a:rPr lang="en-US" sz="2200" dirty="0">
-                <a:solidFill>
-                  <a:srgbClr val="405965"/>
-                </a:solidFill>
-                <a:latin typeface="Arial" pitchFamily="34" charset="0"/>
-                <a:ea typeface="Arial" pitchFamily="34" charset="-122"/>
-                <a:cs typeface="Arial" pitchFamily="34" charset="-120"/>
-              </a:rPr>
-              <a:t>Optional integrations</a:t>
-            </a:r>
-            <a:endParaRPr lang="en-US" sz="2200" dirty="0"/>
-          </a:p>
-        </p:txBody>
-      </p:sp>
-      <p:sp>
-        <p:nvSpPr>
-          <p:cNvPr id="14" name="Text 12"/>
-          <p:cNvSpPr/>
-          <p:nvPr/>
-        </p:nvSpPr>
-        <p:spPr>
-          <a:xfrm>
-            <a:off x="640080" y="5650992"/>
-            <a:ext cx="10881360" cy="411480"/>
-          </a:xfrm>
-          <a:prstGeom prst="rect">
-            <a:avLst/>
-          </a:prstGeom>
-          <a:noFill/>
-          <a:ln/>
-        </p:spPr>
-        <p:txBody>
-          <a:bodyPr wrap="square" lIns="0" tIns="0" rIns="0" bIns="0" rtlCol="0" anchor="ctr"/>
-          <a:lstStyle/>
-          <a:p>
-            <a:pPr indent="0" marL="0">
-              <a:buNone/>
-            </a:pPr>
-            <a:r>
-              <a:rPr lang="en-US" sz="2500" b="1" dirty="0">
-                <a:solidFill>
-                  <a:srgbClr val="086679"/>
-                </a:solidFill>
-                <a:latin typeface="Arial" pitchFamily="34" charset="0"/>
-                <a:ea typeface="Arial" pitchFamily="34" charset="-122"/>
-                <a:cs typeface="Arial" pitchFamily="34" charset="-120"/>
-              </a:rPr>
-              <a:t>Shared PR workflow · configurable execution</a:t>
-            </a:r>
-            <a:endParaRPr lang="en-US" sz="2500" dirty="0"/>
+            <a:endParaRPr lang="en-US" sz="2300" dirty="0"/>
           </a:p>
         </p:txBody>
       </p:sp>
@@ -12080,8 +12490,8 @@
         </p:nvSpPr>
         <p:spPr>
           <a:xfrm>
-            <a:off x="640080" y="4663440"/>
-            <a:ext cx="10789920" cy="365760"/>
+            <a:off x="640080" y="5074920"/>
+            <a:ext cx="10789920" cy="640080"/>
           </a:xfrm>
           <a:prstGeom prst="rect">
             <a:avLst/>
@@ -12097,56 +12507,17 @@
               <a:buNone/>
             </a:pPr>
             <a:r>
-              <a:rPr lang="en-US" sz="2200" dirty="0">
-                <a:solidFill>
-                  <a:srgbClr val="405965"/>
+              <a:rPr lang="en-US" sz="3100" b="1" dirty="0">
+                <a:solidFill>
+                  <a:srgbClr val="086679"/>
                 </a:solidFill>
                 <a:latin typeface="Arial" pitchFamily="34" charset="0"/>
                 <a:ea typeface="Arial" pitchFamily="34" charset="-122"/>
                 <a:cs typeface="Arial" pitchFamily="34" charset="-120"/>
               </a:rPr>
-              <a:t>Cloud examples in the docs</a:t>
+              <a:t>Your hosting choice. Your infrastructure workflow.</a:t>
             </a:r>
-            <a:endParaRPr lang="en-US" sz="2200" dirty="0"/>
-          </a:p>
-        </p:txBody>
-      </p:sp>
-      <p:sp>
-        <p:nvSpPr>
-          <p:cNvPr id="15" name="Text 13"/>
-          <p:cNvSpPr/>
-          <p:nvPr/>
-        </p:nvSpPr>
-        <p:spPr>
-          <a:xfrm>
-            <a:off x="640080" y="5212080"/>
-            <a:ext cx="10789920" cy="548640"/>
-          </a:xfrm>
-          <a:prstGeom prst="rect">
-            <a:avLst/>
-          </a:prstGeom>
-          <a:noFill/>
-          <a:ln/>
-        </p:spPr>
-        <p:txBody>
-          <a:bodyPr wrap="square" lIns="0" tIns="0" rIns="0" bIns="0" rtlCol="0" anchor="ctr"/>
-          <a:lstStyle/>
-          <a:p>
-            <a:pPr indent="0" marL="0">
-              <a:buNone/>
-            </a:pPr>
-            <a:r>
-              <a:rPr lang="en-US" sz="3200" b="1" dirty="0">
-                <a:solidFill>
-                  <a:srgbClr val="086679"/>
-                </a:solidFill>
-                <a:latin typeface="Arial" pitchFamily="34" charset="0"/>
-                <a:ea typeface="Arial" pitchFamily="34" charset="-122"/>
-                <a:cs typeface="Arial" pitchFamily="34" charset="-120"/>
-              </a:rPr>
-              <a:t>AWS Fargate · Google Cloud · Azure</a:t>
-            </a:r>
-            <a:endParaRPr lang="en-US" sz="3200" dirty="0"/>
+            <a:endParaRPr lang="en-US" sz="3100" dirty="0"/>
           </a:p>
         </p:txBody>
       </p:sp>

</xml_diff>

<commit_message>
docs: clarify Atlantis responsibilities and extension model
Signed-off-by: Rui Chen <rui@chenrui.dev>
</commit_message>
<xml_diff>
--- a/talks/kubecon-china-2026-atlantis-lightning/slides.pptx
+++ b/talks/kubecon-china-2026-atlantis-lightning/slides.pptx
@@ -517,7 +517,9 @@
 Hi, I'm Rui, an Atlantis maintainer. Atlantis is an open-source service that runs Terraform and OpenTofu plans and applies from pull requests. The idea is simple: code review should include the infrastructure execution result.
 Transition: Advance after the final sentence.
 Emergency cuts:
-None; retain this slide’s narration.</a:t>
+None; retain this slide’s narration.
+Reference notes (not spoken):
+See sources.md for factual references.</a:t>
             </a:r>
             <a:endParaRPr lang="en-US" dirty="0"/>
           </a:p>
@@ -606,12 +608,14 @@
             <a:r>
               <a:rPr lang="en-US" dirty="0"/>
               <a:t>Target: 4:05–4:30 (25 seconds)
-Spoken words: 43
+Spoken words: 42
 Cue: Point to discovery links, then hold the final slide.
-Learn more at runatlantis dot io, explore the code on GitHub, and join the CNCF community. Find Atlantis at Project Pavilion, table T-ten, in Grand Ballroom One on Tuesday morning. Infrastructure is code. Plan it. Review it. Apply it. From the pull request.
+Learn more at runatlantis dot io, explore the code on GitHub, and join the CNCF community. Find Atlantis at Project Pavilion, table T-ten, in Grand Ballroom One on Tuesday. Infrastructure is code. Plan it. Review it. Apply it. From the pull request.
 Transition: Hold the closing slide.
 Emergency cuts:
-None; retain this slide’s narration.</a:t>
+None; retain this slide’s narration.
+Reference notes (not spoken):
+E03: Project Pavilion T-10, Tuesday September 8, 10:30–14:30, Grand Ballroom I. The slot extends into afternoon. This does not promise Rui is continuously present during the whole pavilion slot.</a:t>
             </a:r>
             <a:endParaRPr lang="en-US" dirty="0"/>
           </a:p>
@@ -701,11 +705,13 @@
               <a:rPr lang="en-US" dirty="0"/>
               <a:t>Target: 0:20–1:10 (50 seconds)
 Spoken words: 76
-Cue: Trace the numbered loop once; pause at review.
+Cue: Trace the loop once; distinguish orchestration from provider/state execution.
 Many teams already automate infrastructure. Atlantis brings planning, review, execution, and results into one workflow. A developer opens a pull request. The Git host sends a webhook; Atlantis runs Terraform or OpenTofu and posts the plan back. The team reviews the code and plan together. An authorized engineer requests atlantis apply. Atlantis checks configured requirements, executes the change, and reports the result in the pull request. The infrastructure tooling still uses your providers and state backend.
 Transition: Advance after the final sentence.
 Emergency cuts:
-None; retain this slide’s narration.</a:t>
+None; retain this slide’s narration.
+Reference notes (not spoken):
+C01/C05/C06: Atlantis orchestrates VCS interaction, affected-project workflows, command requirements and reporting. Terraform/OpenTofu handles provider APIs and remote state/backend operations. The diagram combines plan and apply result arrows; they are separate events.</a:t>
             </a:r>
             <a:endParaRPr lang="en-US" dirty="0"/>
           </a:p>
@@ -794,12 +800,14 @@
             <a:r>
               <a:rPr lang="en-US" dirty="0"/>
               <a:t>Target: 1:10–1:50 (40 seconds)
-Spoken words: 61
+Spoken words: 62
 Cue: Explain the engineer experience; do not repeat the architecture.
-Here is one database capacity change. The summary says zero to add, one to change, zero to destroy. Small does not mean safe: the reviewer reads the full plan and considers operational impact. Approval and the apply request stay in the conversation. If execution fails, the team can correct the change in the same pull request. This example applies before merging.
+Here is one database capacity change. The summary says zero to add, one to change, zero to destroy. Small does not mean safe: the reviewer reads the full plan and considers operational impact. The plan becomes review context attached to the code change. If execution fails, the team can correct the change in the same pull request. This example applies before merging.
 Transition: Advance after the final sentence.
 Emergency cuts:
-If execution fails, the team can correct the change in the same pull request.</a:t>
+If execution fails, the team can correct the change in the same pull request.
+Reference notes (not spoken):
+See sources.md for factual references.</a:t>
             </a:r>
             <a:endParaRPr lang="en-US" dirty="0"/>
           </a:p>
@@ -888,12 +896,14 @@
             <a:r>
               <a:rPr lang="en-US" dirty="0"/>
               <a:t>Target: 1:50–2:15 (25 seconds)
-Spoken words: 46
+Spoken words: 38
 Cue: Three outcomes; centralized execution is not a security guarantee.
-For a platform team, the benefit is visibility, control, and collaboration. Plans and results sit beside the code review. Execution and credentials live in a managed service, with requirements your team configures. Developers propose changes through Git. The service still needs careful permissions and trusted repositories.
+Platform teams get visibility, control, and collaboration. Plans and results sit beside code. Credentials and execution are centralized; configured requirements and locking coordinate changes. Developers propose; platform rules govern execution. Centralization still needs careful permissions and trusted repositories.
 Transition: Advance after the final sentence.
 Emergency cuts:
-None; retain this slide’s narration.</a:t>
+None; retain this slide’s narration.
+Reference notes (not spoken):
+C18: Provider credentials are supplied to the Atlantis execution environment; this does not assert that all developer credentials disappear. Repo/server configuration controls requirements. Atlantis locks a directory/workspace across PRs; this is separate from Terraform state locking. Plan execution also needs trusted repositories and restricted permissions.</a:t>
             </a:r>
             <a:endParaRPr lang="en-US" dirty="0"/>
           </a:p>
@@ -982,12 +992,14 @@
             <a:r>
               <a:rPr lang="en-US" dirty="0"/>
               <a:t>Target: 2:15–2:40 (25 seconds)
-Spoken words: 39
+Spoken words: 36
 Cue: Point to the flow; do not read the host list.
-Atlantis fits several Git hosts and supports both Terraform and OpenTofu. Terragrunt can run through custom workflows. You could build this in generic CI; Atlantis packages the infrastructure-specific PR interaction, project planning, applying, and locking into a purpose-built service.
+Atlantis connects your Git provider to IaC execution. You can build pieces in generic CI; Atlantis packages projects, plans, applies, locking, and VCS interaction into one service. Custom workflows extend execution, including tools such as Terragrunt.
 Transition: Advance after the final sentence.
 Emergency cuts:
-You could build this in generic CI; Atlantis packages the infrastructure-specific PR interaction, project planning, applying, and locking into a purpose-built service.</a:t>
+Custom workflows extend execution, including tools such as Terragrunt.
+Reference notes (not spoken):
+P01–P03/C04/C18: Current hosts: GitHub, GitLab, Bitbucket Cloud and Server, Azure DevOps, Gitea and compatible forks such as Forgejo. Examples on screen are not exhaustive. Terraform and OpenTofu are selectable distributions. Terragrunt requires its binary and custom workflow commands; it is not a peer provider. Project discovery/planning, apply coordination, locking and VCS comments are purpose-built behaviors, not capabilities exclusive to Atlantis.</a:t>
             </a:r>
             <a:endParaRPr lang="en-US" dirty="0"/>
           </a:p>
@@ -1076,12 +1088,14 @@
             <a:r>
               <a:rPr lang="en-US" dirty="0"/>
               <a:t>Target: 2:40–3:00 (20 seconds)
-Spoken words: 31
+Spoken words: 32
 Cue: Policy and cost are separate, optional review inputs.
-Optional integrations add context. Conftest evaluates policy against the plan. Infracost can add cost estimates through workflow integration. Your platform team configures these checks; installing Atlantis does not automatically enable them.
+Platform teams compose tooling through custom workflows. Policy and cost are examples: Conftest checks the plan; Infracost adds cost context. These are configured extensions, not checks that every Atlantis installation automatically runs.
 Transition: Advance after the final sentence.
 Emergency cuts:
-None; retain this slide’s narration.</a:t>
+None; retain this slide’s narration.
+Reference notes (not spoken):
+P04/P05/P07: Examples, not an exhaustive ecosystem: Conftest policy evaluation and Infracost cost estimation. Custom workflow run steps invoke external tools. Server-side pre/post workflow hooks support surrounding scripts; unlike workflow output, hooks do not automatically post their output as PR comments. Pre-hook errors do not block workflows by default; fail-on-pre-workflow-hook-error changes that behavior. Infracost integration requires configured tooling/hooks or workflow steps; it is not enabled by installing Atlantis. Custom validation or notification scripts are possible mechanisms, not bundled products.</a:t>
             </a:r>
             <a:endParaRPr lang="en-US" dirty="0"/>
           </a:p>
@@ -1172,10 +1186,12 @@
               <a:t>Target: 3:00–3:20 (20 seconds)
 Spoken words: 34
 Cue: Hosting choice does not determine provider support.
-Deploy Atlantis on Kubernetes with the official Helm chart, as a container, or as a server binary. Kubernetes is optional. Where Atlantis runs is separate from the infrastructure your Terraform or OpenTofu providers manage.
+Atlantis is self-hosted: use Helm, a container, or a server binary. Kubernetes is optional. Running Atlantis on Kubernetes does not limit it to managing Kubernetes; Terraform and OpenTofu providers determine the infrastructure being managed.
 Transition: Advance after the final sentence.
 Emergency cuts:
-None; retain this slide’s narration.</a:t>
+None; retain this slide’s narration.
+Reference notes (not spoken):
+P06: Official Helm chart, official container image and Go binary deployment. Hosting is distinct from Terraform/OpenTofu provider targets. No cloud-provider compatibility list is implied.</a:t>
             </a:r>
             <a:endParaRPr lang="en-US" dirty="0"/>
           </a:p>
@@ -1269,7 +1285,9 @@
 The project's twenty twenty-four survey received three hundred fifty-four responses. GitHub led, with sizeable GitLab usage. Terraform dominated; about half also used Terragrunt, and OpenTofu was gaining ground. Kubernetes and AWS were common deployment environments. These are historical community responses, not market share.
 Transition: Advance after the final sentence.
 Emergency cuts:
-None; retain this slide’s narration.</a:t>
+None; retain this slide’s narration.
+Reference notes (not spoken):
+S01–S05: Official 2024 survey: 354 responses, not organizations or market share. GitHub most common; sizeable GitLab, then Bitbucket/others. Terraform dominant; about half additionally use Terragrunt; OpenTofu gaining ground. Kubernetes and/or AWS common. Published Markdown links WebP chart images, with no raw numeric table or downloadable dataset; no chart estimates used. Visible examples summarize breadth; complete qualitative findings remain here.</a:t>
             </a:r>
             <a:endParaRPr lang="en-US" dirty="0"/>
           </a:p>
@@ -1358,12 +1376,14 @@
             <a:r>
               <a:rPr lang="en-US" dirty="0"/>
               <a:t>Target: 3:50–4:05 (15 seconds)
-Spoken words: 26
+Spoken words: 29
 Cue: Keep project direction brief and explicitly provisional.
-The draft one point zero proposal emphasizes stability, backwards compatibility, and clearer versioning. It is a planning discussion, not a release announcement or a promised date.
+The draft one point zero proposal clarifies the compatibility contract: breaking changes would require major versions. It signals stability and backwards compatibility. This is planning, not a release announcement.
 Transition: Advance after the final sentence.
 Emergency cuts:
-None; retain this slide’s narration.</a:t>
+None; retain this slide’s narration.
+Reference notes (not spoken):
+R01: Draft PR #5296 says 1.0 is not expected to differ from a usual 0.x feature release; it signals stability/backwards compatibility. Proposed semantics: bug fixes patch, features minor, backwards-incompatible changes major. Server settings, repo config, API and core execution behavior are examples of compatibility boundaries. Draft and unmerged; no release date promised.</a:t>
             </a:r>
             <a:endParaRPr lang="en-US" dirty="0"/>
           </a:p>
@@ -9301,7 +9321,7 @@
                 <a:ea typeface="Arial" pitchFamily="34" charset="-122"/>
                 <a:cs typeface="Arial" pitchFamily="34" charset="-120"/>
               </a:rPr>
-              <a:t>Terraform / OpenTofu</a:t>
+              <a:t>Workflow orchestration</a:t>
             </a:r>
             <a:endParaRPr lang="en-US" sz="1900" dirty="0"/>
           </a:p>
@@ -9730,7 +9750,7 @@
               <a:buNone/>
             </a:pPr>
             <a:r>
-              <a:rPr lang="en-US" sz="2600" b="1" dirty="0">
+              <a:rPr lang="en-US" sz="2300" b="1" dirty="0">
                 <a:solidFill>
                   <a:srgbClr val="083E4F"/>
                 </a:solidFill>
@@ -9738,16 +9758,16 @@
                 <a:ea typeface="Arial" pitchFamily="34" charset="-122"/>
                 <a:cs typeface="Arial" pitchFamily="34" charset="-120"/>
               </a:rPr>
-              <a:t>Results stay with</a:t>
+              <a:t>Terraform / OpenTofu:</a:t>
             </a:r>
-            <a:endParaRPr lang="en-US" sz="2600" dirty="0"/>
+            <a:endParaRPr lang="en-US" sz="2300" dirty="0"/>
           </a:p>
           <a:p>
             <a:pPr indent="0" marL="0">
               <a:buNone/>
             </a:pPr>
             <a:r>
-              <a:rPr lang="en-US" sz="2600" b="1" dirty="0">
+              <a:rPr lang="en-US" sz="2300" b="1" dirty="0">
                 <a:solidFill>
                   <a:srgbClr val="083E4F"/>
                 </a:solidFill>
@@ -9755,9 +9775,9 @@
                 <a:ea typeface="Arial" pitchFamily="34" charset="-122"/>
                 <a:cs typeface="Arial" pitchFamily="34" charset="-120"/>
               </a:rPr>
-              <a:t>the pull request.</a:t>
+              <a:t>providers + state</a:t>
             </a:r>
-            <a:endParaRPr lang="en-US" sz="2600" dirty="0"/>
+            <a:endParaRPr lang="en-US" sz="2300" dirty="0"/>
           </a:p>
         </p:txBody>
       </p:sp>
@@ -10582,7 +10602,7 @@
                 <a:ea typeface="Arial" pitchFamily="34" charset="-122"/>
                 <a:cs typeface="Arial" pitchFamily="34" charset="-120"/>
               </a:rPr>
-              <a:t>Plan and result beside the code</a:t>
+              <a:t>Plan + result beside the code</a:t>
             </a:r>
             <a:endParaRPr lang="en-US" sz="2600" dirty="0"/>
           </a:p>
@@ -10685,7 +10705,7 @@
                 <a:ea typeface="Arial" pitchFamily="34" charset="-122"/>
                 <a:cs typeface="Arial" pitchFamily="34" charset="-120"/>
               </a:rPr>
-              <a:t>Managed execution · configured requirements</a:t>
+              <a:t>Centralized execution + requirements</a:t>
             </a:r>
             <a:endParaRPr lang="en-US" sz="2600" dirty="0"/>
           </a:p>
@@ -10788,7 +10808,7 @@
                 <a:ea typeface="Arial" pitchFamily="34" charset="-122"/>
                 <a:cs typeface="Arial" pitchFamily="34" charset="-120"/>
               </a:rPr>
-              <a:t>Developers propose changes through Git</a:t>
+              <a:t>Developers propose; platform rules govern</a:t>
             </a:r>
             <a:endParaRPr lang="en-US" sz="2600" dirty="0"/>
           </a:p>
@@ -10944,8 +10964,8 @@
         </p:nvSpPr>
         <p:spPr>
           <a:xfrm>
-            <a:off x="731520" y="2377440"/>
-            <a:ext cx="3703320" cy="2286000"/>
+            <a:off x="731520" y="2606040"/>
+            <a:ext cx="3703320" cy="1920240"/>
           </a:xfrm>
           <a:prstGeom prst="rect">
             <a:avLst/>
@@ -10969,7 +10989,7 @@
         </p:nvSpPr>
         <p:spPr>
           <a:xfrm>
-            <a:off x="932688" y="2514600"/>
+            <a:off x="932688" y="2743200"/>
             <a:ext cx="3300984" cy="393192"/>
           </a:xfrm>
           <a:prstGeom prst="rect">
@@ -10994,7 +11014,7 @@
                 <a:ea typeface="Arial" pitchFamily="34" charset="-122"/>
                 <a:cs typeface="Arial" pitchFamily="34" charset="-120"/>
               </a:rPr>
-              <a:t>Git hosts</a:t>
+              <a:t>Git provider</a:t>
             </a:r>
             <a:endParaRPr lang="en-US" sz="2700" dirty="0"/>
           </a:p>
@@ -11008,8 +11028,8 @@
         </p:nvSpPr>
         <p:spPr>
           <a:xfrm>
-            <a:off x="932688" y="2971800"/>
-            <a:ext cx="3300984" cy="1417320"/>
+            <a:off x="932688" y="3291840"/>
+            <a:ext cx="3300984" cy="822960"/>
           </a:xfrm>
           <a:prstGeom prst="rect">
             <a:avLst/>
@@ -11025,7 +11045,24 @@
               <a:buNone/>
             </a:pPr>
             <a:r>
-              <a:rPr lang="en-US" sz="2200" dirty="0">
+              <a:rPr lang="en-US" sz="2400" dirty="0">
+                <a:solidFill>
+                  <a:srgbClr val="405965"/>
+                </a:solidFill>
+                <a:latin typeface="Arial" pitchFamily="34" charset="0"/>
+                <a:ea typeface="Arial" pitchFamily="34" charset="-122"/>
+                <a:cs typeface="Arial" pitchFamily="34" charset="-120"/>
+              </a:rPr>
+              <a:t>Examples:</a:t>
+            </a:r>
+            <a:endParaRPr lang="en-US" sz="2400" dirty="0"/>
+          </a:p>
+          <a:p>
+            <a:pPr indent="0" marL="0">
+              <a:buNone/>
+            </a:pPr>
+            <a:r>
+              <a:rPr lang="en-US" sz="2400" dirty="0">
                 <a:solidFill>
                   <a:srgbClr val="405965"/>
                 </a:solidFill>
@@ -11035,58 +11072,7 @@
               </a:rPr>
               <a:t>GitHub · GitLab</a:t>
             </a:r>
-            <a:endParaRPr lang="en-US" sz="2200" dirty="0"/>
-          </a:p>
-          <a:p>
-            <a:pPr indent="0" marL="0">
-              <a:buNone/>
-            </a:pPr>
-            <a:r>
-              <a:rPr lang="en-US" sz="2200" dirty="0">
-                <a:solidFill>
-                  <a:srgbClr val="405965"/>
-                </a:solidFill>
-                <a:latin typeface="Arial" pitchFamily="34" charset="0"/>
-                <a:ea typeface="Arial" pitchFamily="34" charset="-122"/>
-                <a:cs typeface="Arial" pitchFamily="34" charset="-120"/>
-              </a:rPr>
-              <a:t>Bitbucket Cloud / Server</a:t>
-            </a:r>
-            <a:endParaRPr lang="en-US" sz="2200" dirty="0"/>
-          </a:p>
-          <a:p>
-            <a:pPr indent="0" marL="0">
-              <a:buNone/>
-            </a:pPr>
-            <a:r>
-              <a:rPr lang="en-US" sz="2200" dirty="0">
-                <a:solidFill>
-                  <a:srgbClr val="405965"/>
-                </a:solidFill>
-                <a:latin typeface="Arial" pitchFamily="34" charset="0"/>
-                <a:ea typeface="Arial" pitchFamily="34" charset="-122"/>
-                <a:cs typeface="Arial" pitchFamily="34" charset="-120"/>
-              </a:rPr>
-              <a:t>Gitea / Forgejo</a:t>
-            </a:r>
-            <a:endParaRPr lang="en-US" sz="2200" dirty="0"/>
-          </a:p>
-          <a:p>
-            <a:pPr indent="0" marL="0">
-              <a:buNone/>
-            </a:pPr>
-            <a:r>
-              <a:rPr lang="en-US" sz="2200" dirty="0">
-                <a:solidFill>
-                  <a:srgbClr val="405965"/>
-                </a:solidFill>
-                <a:latin typeface="Arial" pitchFamily="34" charset="0"/>
-                <a:ea typeface="Arial" pitchFamily="34" charset="-122"/>
-                <a:cs typeface="Arial" pitchFamily="34" charset="-120"/>
-              </a:rPr>
-              <a:t>Azure DevOps</a:t>
-            </a:r>
-            <a:endParaRPr lang="en-US" sz="2200" dirty="0"/>
+            <a:endParaRPr lang="en-US" sz="2400" dirty="0"/>
           </a:p>
         </p:txBody>
       </p:sp>
@@ -11098,7 +11084,7 @@
         </p:nvSpPr>
         <p:spPr>
           <a:xfrm>
-            <a:off x="5074920" y="2788920"/>
+            <a:off x="5074920" y="2971800"/>
             <a:ext cx="2377440" cy="1234440"/>
           </a:xfrm>
           <a:prstGeom prst="rect">
@@ -11123,7 +11109,7 @@
         </p:nvSpPr>
         <p:spPr>
           <a:xfrm>
-            <a:off x="5276088" y="2926080"/>
+            <a:off x="5276088" y="3108960"/>
             <a:ext cx="1975104" cy="393192"/>
           </a:xfrm>
           <a:prstGeom prst="rect">
@@ -11162,7 +11148,7 @@
         </p:nvSpPr>
         <p:spPr>
           <a:xfrm>
-            <a:off x="5276088" y="3410712"/>
+            <a:off x="5276088" y="3593592"/>
             <a:ext cx="1975104" cy="329184"/>
           </a:xfrm>
           <a:prstGeom prst="rect">
@@ -11187,7 +11173,7 @@
                 <a:ea typeface="Arial" pitchFamily="34" charset="-122"/>
                 <a:cs typeface="Arial" pitchFamily="34" charset="-120"/>
               </a:rPr>
-              <a:t>PR automation</a:t>
+              <a:t>Orchestration</a:t>
             </a:r>
             <a:endParaRPr lang="en-US" sz="1900" dirty="0"/>
           </a:p>
@@ -11201,8 +11187,8 @@
         </p:nvSpPr>
         <p:spPr>
           <a:xfrm>
-            <a:off x="8092440" y="2377440"/>
-            <a:ext cx="3337560" cy="2286000"/>
+            <a:off x="8092440" y="2606040"/>
+            <a:ext cx="3337560" cy="1920240"/>
           </a:xfrm>
           <a:prstGeom prst="rect">
             <a:avLst/>
@@ -11226,7 +11212,7 @@
         </p:nvSpPr>
         <p:spPr>
           <a:xfrm>
-            <a:off x="8293608" y="2514600"/>
+            <a:off x="8293608" y="2743200"/>
             <a:ext cx="2935224" cy="393192"/>
           </a:xfrm>
           <a:prstGeom prst="rect">
@@ -11265,8 +11251,8 @@
         </p:nvSpPr>
         <p:spPr>
           <a:xfrm>
-            <a:off x="8293608" y="3017520"/>
-            <a:ext cx="2935224" cy="685800"/>
+            <a:off x="8293608" y="3291840"/>
+            <a:ext cx="2935224" cy="822960"/>
           </a:xfrm>
           <a:prstGeom prst="rect">
             <a:avLst/>
@@ -11298,69 +11284,13 @@
       </p:sp>
       <p:sp>
         <p:nvSpPr>
-          <p:cNvPr id="14" name="Text 12"/>
+          <p:cNvPr id="14" name="Shape 12"/>
           <p:cNvSpPr/>
           <p:nvPr/>
         </p:nvSpPr>
         <p:spPr>
           <a:xfrm>
-            <a:off x="8293608" y="3794760"/>
-            <a:ext cx="2935224" cy="685800"/>
-          </a:xfrm>
-          <a:prstGeom prst="rect">
-            <a:avLst/>
-          </a:prstGeom>
-          <a:noFill/>
-          <a:ln/>
-        </p:spPr>
-        <p:txBody>
-          <a:bodyPr wrap="square" lIns="0" tIns="0" rIns="0" bIns="0" rtlCol="0" anchor="ctr"/>
-          <a:lstStyle/>
-          <a:p>
-            <a:pPr indent="0" marL="0">
-              <a:buNone/>
-            </a:pPr>
-            <a:r>
-              <a:rPr lang="en-US" sz="2200" dirty="0">
-                <a:solidFill>
-                  <a:srgbClr val="405965"/>
-                </a:solidFill>
-                <a:latin typeface="Arial" pitchFamily="34" charset="0"/>
-                <a:ea typeface="Arial" pitchFamily="34" charset="-122"/>
-                <a:cs typeface="Arial" pitchFamily="34" charset="-120"/>
-              </a:rPr>
-              <a:t>Terragrunt via</a:t>
-            </a:r>
-            <a:endParaRPr lang="en-US" sz="2200" dirty="0"/>
-          </a:p>
-          <a:p>
-            <a:pPr indent="0" marL="0">
-              <a:buNone/>
-            </a:pPr>
-            <a:r>
-              <a:rPr lang="en-US" sz="2200" dirty="0">
-                <a:solidFill>
-                  <a:srgbClr val="405965"/>
-                </a:solidFill>
-                <a:latin typeface="Arial" pitchFamily="34" charset="0"/>
-                <a:ea typeface="Arial" pitchFamily="34" charset="-122"/>
-                <a:cs typeface="Arial" pitchFamily="34" charset="-120"/>
-              </a:rPr>
-              <a:t>custom workflows</a:t>
-            </a:r>
-            <a:endParaRPr lang="en-US" sz="2200" dirty="0"/>
-          </a:p>
-        </p:txBody>
-      </p:sp>
-      <p:sp>
-        <p:nvSpPr>
-          <p:cNvPr id="15" name="Shape 13"/>
-          <p:cNvSpPr/>
-          <p:nvPr/>
-        </p:nvSpPr>
-        <p:spPr>
-          <a:xfrm>
-            <a:off x="4572000" y="3383280"/>
+            <a:off x="4572000" y="3611880"/>
             <a:ext cx="365760" cy="0"/>
           </a:xfrm>
           <a:prstGeom prst="line">
@@ -11379,13 +11309,13 @@
       </p:sp>
       <p:sp>
         <p:nvSpPr>
-          <p:cNvPr id="16" name="Shape 14"/>
+          <p:cNvPr id="15" name="Shape 13"/>
           <p:cNvSpPr/>
           <p:nvPr/>
         </p:nvSpPr>
         <p:spPr>
           <a:xfrm>
-            <a:off x="7589520" y="3383280"/>
+            <a:off x="7589520" y="3611880"/>
             <a:ext cx="365760" cy="0"/>
           </a:xfrm>
           <a:prstGeom prst="line">
@@ -11404,7 +11334,7 @@
       </p:sp>
       <p:sp>
         <p:nvSpPr>
-          <p:cNvPr id="17" name="Text 15"/>
+          <p:cNvPr id="16" name="Text 14"/>
           <p:cNvSpPr/>
           <p:nvPr/>
         </p:nvSpPr>
@@ -11499,7 +11429,7 @@
                 <a:ea typeface="Arial" pitchFamily="34" charset="-122"/>
                 <a:cs typeface="Arial" pitchFamily="34" charset="-120"/>
               </a:rPr>
-              <a:t>OPTIONAL INTEGRATIONS</a:t>
+              <a:t>WORKFLOW EXTENSIONS</a:t>
             </a:r>
             <a:endParaRPr lang="en-US" sz="1600" dirty="0"/>
           </a:p>
@@ -11538,7 +11468,7 @@
                 <a:ea typeface="Arial" pitchFamily="34" charset="-122"/>
                 <a:cs typeface="Arial" pitchFamily="34" charset="-120"/>
               </a:rPr>
-              <a:t>Give reviewers policy and cost context.</a:t>
+              <a:t>Extend the pull-request review.</a:t>
             </a:r>
             <a:endParaRPr lang="en-US" sz="3600" dirty="0"/>
           </a:p>
@@ -11591,8 +11521,8 @@
         </p:nvSpPr>
         <p:spPr>
           <a:xfrm>
-            <a:off x="731520" y="2514600"/>
-            <a:ext cx="3566160" cy="1280160"/>
+            <a:off x="731520" y="3154680"/>
+            <a:ext cx="2423160" cy="1234440"/>
           </a:xfrm>
           <a:prstGeom prst="rect">
             <a:avLst/>
@@ -11616,8 +11546,8 @@
         </p:nvSpPr>
         <p:spPr>
           <a:xfrm>
-            <a:off x="932688" y="2651760"/>
-            <a:ext cx="3163824" cy="393192"/>
+            <a:off x="932688" y="3291840"/>
+            <a:ext cx="2020824" cy="393192"/>
           </a:xfrm>
           <a:prstGeom prst="rect">
             <a:avLst/>
@@ -11641,7 +11571,7 @@
                 <a:ea typeface="Arial" pitchFamily="34" charset="-122"/>
                 <a:cs typeface="Arial" pitchFamily="34" charset="-120"/>
               </a:rPr>
-              <a:t>Conftest</a:t>
+              <a:t>Plan</a:t>
             </a:r>
             <a:endParaRPr lang="en-US" sz="2700" dirty="0"/>
           </a:p>
@@ -11655,8 +11585,8 @@
         </p:nvSpPr>
         <p:spPr>
           <a:xfrm>
-            <a:off x="932688" y="3136392"/>
-            <a:ext cx="3163824" cy="329184"/>
+            <a:off x="932688" y="3776472"/>
+            <a:ext cx="2020824" cy="329184"/>
           </a:xfrm>
           <a:prstGeom prst="rect">
             <a:avLst/>
@@ -11680,7 +11610,7 @@
                 <a:ea typeface="Arial" pitchFamily="34" charset="-122"/>
                 <a:cs typeface="Arial" pitchFamily="34" charset="-120"/>
               </a:rPr>
-              <a:t>Policy checks</a:t>
+              <a:t>Review input</a:t>
             </a:r>
             <a:endParaRPr lang="en-US" sz="1900" dirty="0"/>
           </a:p>
@@ -11694,8 +11624,8 @@
         </p:nvSpPr>
         <p:spPr>
           <a:xfrm>
-            <a:off x="731520" y="4251960"/>
-            <a:ext cx="3566160" cy="1280160"/>
+            <a:off x="4572000" y="2331720"/>
+            <a:ext cx="2880360" cy="1143000"/>
           </a:xfrm>
           <a:prstGeom prst="rect">
             <a:avLst/>
@@ -11719,8 +11649,8 @@
         </p:nvSpPr>
         <p:spPr>
           <a:xfrm>
-            <a:off x="932688" y="4389120"/>
-            <a:ext cx="3163824" cy="393192"/>
+            <a:off x="4773168" y="2468880"/>
+            <a:ext cx="2478024" cy="393192"/>
           </a:xfrm>
           <a:prstGeom prst="rect">
             <a:avLst/>
@@ -11744,7 +11674,7 @@
                 <a:ea typeface="Arial" pitchFamily="34" charset="-122"/>
                 <a:cs typeface="Arial" pitchFamily="34" charset="-120"/>
               </a:rPr>
-              <a:t>Infracost</a:t>
+              <a:t>Policy</a:t>
             </a:r>
             <a:endParaRPr lang="en-US" sz="2700" dirty="0"/>
           </a:p>
@@ -11758,8 +11688,8 @@
         </p:nvSpPr>
         <p:spPr>
           <a:xfrm>
-            <a:off x="932688" y="4873752"/>
-            <a:ext cx="3163824" cy="329184"/>
+            <a:off x="4773168" y="2953512"/>
+            <a:ext cx="2478024" cy="329184"/>
           </a:xfrm>
           <a:prstGeom prst="rect">
             <a:avLst/>
@@ -11783,7 +11713,7 @@
                 <a:ea typeface="Arial" pitchFamily="34" charset="-122"/>
                 <a:cs typeface="Arial" pitchFamily="34" charset="-120"/>
               </a:rPr>
-              <a:t>Cost estimates</a:t>
+              <a:t>e.g. Conftest</a:t>
             </a:r>
             <a:endParaRPr lang="en-US" sz="1900" dirty="0"/>
           </a:p>
@@ -11797,8 +11727,8 @@
         </p:nvSpPr>
         <p:spPr>
           <a:xfrm>
-            <a:off x="7315200" y="3383280"/>
-            <a:ext cx="4114800" cy="1417320"/>
+            <a:off x="4572000" y="4069080"/>
+            <a:ext cx="2880360" cy="1143000"/>
           </a:xfrm>
           <a:prstGeom prst="rect">
             <a:avLst/>
@@ -11822,8 +11752,8 @@
         </p:nvSpPr>
         <p:spPr>
           <a:xfrm>
-            <a:off x="7516368" y="3520440"/>
-            <a:ext cx="3712464" cy="393192"/>
+            <a:off x="4773168" y="4206240"/>
+            <a:ext cx="2478024" cy="393192"/>
           </a:xfrm>
           <a:prstGeom prst="rect">
             <a:avLst/>
@@ -11847,7 +11777,7 @@
                 <a:ea typeface="Arial" pitchFamily="34" charset="-122"/>
                 <a:cs typeface="Arial" pitchFamily="34" charset="-120"/>
               </a:rPr>
-              <a:t>Pull request review</a:t>
+              <a:t>Cost</a:t>
             </a:r>
             <a:endParaRPr lang="en-US" sz="2700" dirty="0"/>
           </a:p>
@@ -11861,8 +11791,8 @@
         </p:nvSpPr>
         <p:spPr>
           <a:xfrm>
-            <a:off x="7516368" y="4005072"/>
-            <a:ext cx="3712464" cy="329184"/>
+            <a:off x="4773168" y="4690872"/>
+            <a:ext cx="2478024" cy="329184"/>
           </a:xfrm>
           <a:prstGeom prst="rect">
             <a:avLst/>
@@ -11886,7 +11816,7 @@
                 <a:ea typeface="Arial" pitchFamily="34" charset="-122"/>
                 <a:cs typeface="Arial" pitchFamily="34" charset="-120"/>
               </a:rPr>
-              <a:t>Code + plan + added context</a:t>
+              <a:t>e.g. Infracost</a:t>
             </a:r>
             <a:endParaRPr lang="en-US" sz="1900" dirty="0"/>
           </a:p>
@@ -11900,8 +11830,111 @@
         </p:nvSpPr>
         <p:spPr>
           <a:xfrm>
-            <a:off x="4526280" y="3154680"/>
-            <a:ext cx="1188720" cy="0"/>
+            <a:off x="8869680" y="3154680"/>
+            <a:ext cx="2560320" cy="1234440"/>
+          </a:xfrm>
+          <a:prstGeom prst="rect">
+            <a:avLst/>
+          </a:prstGeom>
+          <a:solidFill>
+            <a:srgbClr val="EAF1F3"/>
+          </a:solidFill>
+          <a:ln w="12700">
+            <a:solidFill>
+              <a:srgbClr val="EAF1F3"/>
+            </a:solidFill>
+            <a:prstDash val="solid"/>
+          </a:ln>
+        </p:spPr>
+      </p:sp>
+      <p:sp>
+        <p:nvSpPr>
+          <p:cNvPr id="15" name="Text 13"/>
+          <p:cNvSpPr/>
+          <p:nvPr/>
+        </p:nvSpPr>
+        <p:spPr>
+          <a:xfrm>
+            <a:off x="9070848" y="3291840"/>
+            <a:ext cx="2157984" cy="393192"/>
+          </a:xfrm>
+          <a:prstGeom prst="rect">
+            <a:avLst/>
+          </a:prstGeom>
+          <a:noFill/>
+          <a:ln/>
+        </p:spPr>
+        <p:txBody>
+          <a:bodyPr wrap="square" lIns="0" tIns="0" rIns="0" bIns="0" rtlCol="0" anchor="ctr"/>
+          <a:lstStyle/>
+          <a:p>
+            <a:pPr indent="0" marL="0">
+              <a:buNone/>
+            </a:pPr>
+            <a:r>
+              <a:rPr lang="en-US" sz="2700" b="1" dirty="0">
+                <a:solidFill>
+                  <a:srgbClr val="083E4F"/>
+                </a:solidFill>
+                <a:latin typeface="Arial" pitchFamily="34" charset="0"/>
+                <a:ea typeface="Arial" pitchFamily="34" charset="-122"/>
+                <a:cs typeface="Arial" pitchFamily="34" charset="-120"/>
+              </a:rPr>
+              <a:t>Review</a:t>
+            </a:r>
+            <a:endParaRPr lang="en-US" sz="2700" dirty="0"/>
+          </a:p>
+        </p:txBody>
+      </p:sp>
+      <p:sp>
+        <p:nvSpPr>
+          <p:cNvPr id="16" name="Text 14"/>
+          <p:cNvSpPr/>
+          <p:nvPr/>
+        </p:nvSpPr>
+        <p:spPr>
+          <a:xfrm>
+            <a:off x="9070848" y="3776472"/>
+            <a:ext cx="2157984" cy="329184"/>
+          </a:xfrm>
+          <a:prstGeom prst="rect">
+            <a:avLst/>
+          </a:prstGeom>
+          <a:noFill/>
+          <a:ln/>
+        </p:spPr>
+        <p:txBody>
+          <a:bodyPr wrap="square" lIns="0" tIns="0" rIns="0" bIns="0" rtlCol="0" anchor="ctr"/>
+          <a:lstStyle/>
+          <a:p>
+            <a:pPr indent="0" marL="0">
+              <a:buNone/>
+            </a:pPr>
+            <a:r>
+              <a:rPr lang="en-US" sz="1900" dirty="0">
+                <a:solidFill>
+                  <a:srgbClr val="405965"/>
+                </a:solidFill>
+                <a:latin typeface="Arial" pitchFamily="34" charset="0"/>
+                <a:ea typeface="Arial" pitchFamily="34" charset="-122"/>
+                <a:cs typeface="Arial" pitchFamily="34" charset="-120"/>
+              </a:rPr>
+              <a:t>Added context</a:t>
+            </a:r>
+            <a:endParaRPr lang="en-US" sz="1900" dirty="0"/>
+          </a:p>
+        </p:txBody>
+      </p:sp>
+      <p:sp>
+        <p:nvSpPr>
+          <p:cNvPr id="17" name="Shape 15"/>
+          <p:cNvSpPr/>
+          <p:nvPr/>
+        </p:nvSpPr>
+        <p:spPr>
+          <a:xfrm>
+            <a:off x="3291840" y="3749040"/>
+            <a:ext cx="548640" cy="0"/>
           </a:xfrm>
           <a:prstGeom prst="line">
             <a:avLst/>
@@ -11919,14 +11952,14 @@
       </p:sp>
       <p:sp>
         <p:nvSpPr>
-          <p:cNvPr id="15" name="Shape 13"/>
+          <p:cNvPr id="18" name="Shape 16"/>
           <p:cNvSpPr/>
           <p:nvPr/>
         </p:nvSpPr>
         <p:spPr>
           <a:xfrm>
-            <a:off x="4526280" y="4892040"/>
-            <a:ext cx="1188720" cy="0"/>
+            <a:off x="3840480" y="2926080"/>
+            <a:ext cx="0" cy="1737360"/>
           </a:xfrm>
           <a:prstGeom prst="line">
             <a:avLst/>
@@ -11944,14 +11977,64 @@
       </p:sp>
       <p:sp>
         <p:nvSpPr>
-          <p:cNvPr id="16" name="Shape 14"/>
+          <p:cNvPr id="19" name="Shape 17"/>
           <p:cNvSpPr/>
           <p:nvPr/>
         </p:nvSpPr>
         <p:spPr>
           <a:xfrm>
-            <a:off x="5715000" y="3154680"/>
-            <a:ext cx="0" cy="1737360"/>
+            <a:off x="3840480" y="2926080"/>
+            <a:ext cx="548640" cy="0"/>
+          </a:xfrm>
+          <a:prstGeom prst="line">
+            <a:avLst/>
+          </a:prstGeom>
+          <a:noFill/>
+          <a:ln w="25400">
+            <a:solidFill>
+              <a:srgbClr val="086679"/>
+            </a:solidFill>
+            <a:prstDash val="solid"/>
+            <a:headEnd type="none"/>
+            <a:tailEnd type="triangle"/>
+          </a:ln>
+        </p:spPr>
+      </p:sp>
+      <p:sp>
+        <p:nvSpPr>
+          <p:cNvPr id="20" name="Shape 18"/>
+          <p:cNvSpPr/>
+          <p:nvPr/>
+        </p:nvSpPr>
+        <p:spPr>
+          <a:xfrm>
+            <a:off x="3840480" y="4663440"/>
+            <a:ext cx="548640" cy="0"/>
+          </a:xfrm>
+          <a:prstGeom prst="line">
+            <a:avLst/>
+          </a:prstGeom>
+          <a:noFill/>
+          <a:ln w="25400">
+            <a:solidFill>
+              <a:srgbClr val="086679"/>
+            </a:solidFill>
+            <a:prstDash val="solid"/>
+            <a:headEnd type="none"/>
+            <a:tailEnd type="triangle"/>
+          </a:ln>
+        </p:spPr>
+      </p:sp>
+      <p:sp>
+        <p:nvSpPr>
+          <p:cNvPr id="21" name="Shape 19"/>
+          <p:cNvSpPr/>
+          <p:nvPr/>
+        </p:nvSpPr>
+        <p:spPr>
+          <a:xfrm>
+            <a:off x="7589520" y="2926080"/>
+            <a:ext cx="548640" cy="0"/>
           </a:xfrm>
           <a:prstGeom prst="line">
             <a:avLst/>
@@ -11969,14 +12052,64 @@
       </p:sp>
       <p:sp>
         <p:nvSpPr>
-          <p:cNvPr id="17" name="Shape 15"/>
+          <p:cNvPr id="22" name="Shape 20"/>
           <p:cNvSpPr/>
           <p:nvPr/>
         </p:nvSpPr>
         <p:spPr>
           <a:xfrm>
-            <a:off x="5715000" y="4114800"/>
-            <a:ext cx="1371600" cy="0"/>
+            <a:off x="7589520" y="4663440"/>
+            <a:ext cx="548640" cy="0"/>
+          </a:xfrm>
+          <a:prstGeom prst="line">
+            <a:avLst/>
+          </a:prstGeom>
+          <a:noFill/>
+          <a:ln w="25400">
+            <a:solidFill>
+              <a:srgbClr val="086679"/>
+            </a:solidFill>
+            <a:prstDash val="solid"/>
+            <a:headEnd type="none"/>
+            <a:tailEnd type="none"/>
+          </a:ln>
+        </p:spPr>
+      </p:sp>
+      <p:sp>
+        <p:nvSpPr>
+          <p:cNvPr id="23" name="Shape 21"/>
+          <p:cNvSpPr/>
+          <p:nvPr/>
+        </p:nvSpPr>
+        <p:spPr>
+          <a:xfrm>
+            <a:off x="8138160" y="2926080"/>
+            <a:ext cx="0" cy="1737360"/>
+          </a:xfrm>
+          <a:prstGeom prst="line">
+            <a:avLst/>
+          </a:prstGeom>
+          <a:noFill/>
+          <a:ln w="25400">
+            <a:solidFill>
+              <a:srgbClr val="086679"/>
+            </a:solidFill>
+            <a:prstDash val="solid"/>
+            <a:headEnd type="none"/>
+            <a:tailEnd type="none"/>
+          </a:ln>
+        </p:spPr>
+      </p:sp>
+      <p:sp>
+        <p:nvSpPr>
+          <p:cNvPr id="24" name="Shape 22"/>
+          <p:cNvSpPr/>
+          <p:nvPr/>
+        </p:nvSpPr>
+        <p:spPr>
+          <a:xfrm>
+            <a:off x="8138160" y="3749040"/>
+            <a:ext cx="548640" cy="0"/>
           </a:xfrm>
           <a:prstGeom prst="line">
             <a:avLst/>
@@ -11994,14 +12127,14 @@
       </p:sp>
       <p:sp>
         <p:nvSpPr>
-          <p:cNvPr id="18" name="Text 16"/>
+          <p:cNvPr id="25" name="Text 23"/>
           <p:cNvSpPr/>
           <p:nvPr/>
         </p:nvSpPr>
         <p:spPr>
           <a:xfrm>
-            <a:off x="7223760" y="5166360"/>
-            <a:ext cx="4297680" cy="594360"/>
+            <a:off x="731520" y="5577840"/>
+            <a:ext cx="10789920" cy="411480"/>
           </a:xfrm>
           <a:prstGeom prst="rect">
             <a:avLst/>
@@ -12017,17 +12150,17 @@
               <a:buNone/>
             </a:pPr>
             <a:r>
-              <a:rPr lang="en-US" sz="2300" dirty="0">
-                <a:solidFill>
-                  <a:srgbClr val="405965"/>
+              <a:rPr lang="en-US" sz="2700" b="1" dirty="0">
+                <a:solidFill>
+                  <a:srgbClr val="086679"/>
                 </a:solidFill>
                 <a:latin typeface="Arial" pitchFamily="34" charset="0"/>
                 <a:ea typeface="Arial" pitchFamily="34" charset="-122"/>
                 <a:cs typeface="Arial" pitchFamily="34" charset="-120"/>
               </a:rPr>
-              <a:t>Configured by your platform team</a:t>
+              <a:t>Custom workflows compose your own tooling.</a:t>
             </a:r>
-            <a:endParaRPr lang="en-US" sz="2300" dirty="0"/>
+            <a:endParaRPr lang="en-US" sz="2700" dirty="0"/>
           </a:p>
         </p:txBody>
       </p:sp>
@@ -12515,7 +12648,7 @@
                 <a:ea typeface="Arial" pitchFamily="34" charset="-122"/>
                 <a:cs typeface="Arial" pitchFamily="34" charset="-120"/>
               </a:rPr>
-              <a:t>Your hosting choice. Your infrastructure workflow.</a:t>
+              <a:t>Self-hosted. Kubernetes is optional.</a:t>
             </a:r>
             <a:endParaRPr lang="en-US" sz="3100" dirty="0"/>
           </a:p>
@@ -12618,7 +12751,7 @@
                 <a:ea typeface="Arial" pitchFamily="34" charset="-122"/>
                 <a:cs typeface="Arial" pitchFamily="34" charset="-120"/>
               </a:rPr>
-              <a:t>What the Atlantis community uses</a:t>
+              <a:t>Multiple stacks. One PR workflow.</a:t>
             </a:r>
             <a:endParaRPr lang="en-US" sz="3600" dirty="0"/>
           </a:p>
@@ -12749,8 +12882,8 @@
         </p:nvSpPr>
         <p:spPr>
           <a:xfrm>
-            <a:off x="4480560" y="2240280"/>
-            <a:ext cx="6766560" cy="274320"/>
+            <a:off x="4480560" y="2606040"/>
+            <a:ext cx="6766560" cy="320040"/>
           </a:xfrm>
           <a:prstGeom prst="rect">
             <a:avLst/>
@@ -12766,7 +12899,7 @@
               <a:buNone/>
             </a:pPr>
             <a:r>
-              <a:rPr lang="en-US" sz="1900" b="1" dirty="0">
+              <a:rPr lang="en-US" sz="2200" b="1" dirty="0">
                 <a:solidFill>
                   <a:srgbClr val="086679"/>
                 </a:solidFill>
@@ -12776,7 +12909,7 @@
               </a:rPr>
               <a:t>GIT</a:t>
             </a:r>
-            <a:endParaRPr lang="en-US" sz="1900" dirty="0"/>
+            <a:endParaRPr lang="en-US" sz="2200" dirty="0"/>
           </a:p>
         </p:txBody>
       </p:sp>
@@ -12788,8 +12921,8 @@
         </p:nvSpPr>
         <p:spPr>
           <a:xfrm>
-            <a:off x="4480560" y="2569464"/>
-            <a:ext cx="6812280" cy="694944"/>
+            <a:off x="4480560" y="3044952"/>
+            <a:ext cx="6812280" cy="822960"/>
           </a:xfrm>
           <a:prstGeom prst="rect">
             <a:avLst/>
@@ -12805,7 +12938,7 @@
               <a:buNone/>
             </a:pPr>
             <a:r>
-              <a:rPr lang="en-US" sz="2400" dirty="0">
+              <a:rPr lang="en-US" sz="2700" dirty="0">
                 <a:solidFill>
                   <a:srgbClr val="083E4F"/>
                 </a:solidFill>
@@ -12815,53 +12948,36 @@
               </a:rPr>
               <a:t>GitHub leads · GitLab sizeable</a:t>
             </a:r>
-            <a:endParaRPr lang="en-US" sz="2400" dirty="0"/>
-          </a:p>
+            <a:endParaRPr lang="en-US" sz="2700" dirty="0"/>
+          </a:p>
+        </p:txBody>
+      </p:sp>
+      <p:sp>
+        <p:nvSpPr>
+          <p:cNvPr id="9" name="Text 7"/>
+          <p:cNvSpPr/>
+          <p:nvPr/>
+        </p:nvSpPr>
+        <p:spPr>
+          <a:xfrm>
+            <a:off x="4480560" y="3977640"/>
+            <a:ext cx="6766560" cy="320040"/>
+          </a:xfrm>
+          <a:prstGeom prst="rect">
+            <a:avLst/>
+          </a:prstGeom>
+          <a:noFill/>
+          <a:ln/>
+        </p:spPr>
+        <p:txBody>
+          <a:bodyPr wrap="square" lIns="0" tIns="0" rIns="0" bIns="0" rtlCol="0" anchor="ctr"/>
+          <a:lstStyle/>
           <a:p>
             <a:pPr indent="0" marL="0">
               <a:buNone/>
             </a:pPr>
             <a:r>
-              <a:rPr lang="en-US" sz="2400" dirty="0">
-                <a:solidFill>
-                  <a:srgbClr val="083E4F"/>
-                </a:solidFill>
-                <a:latin typeface="Arial" pitchFamily="34" charset="0"/>
-                <a:ea typeface="Arial" pitchFamily="34" charset="-122"/>
-                <a:cs typeface="Arial" pitchFamily="34" charset="-120"/>
-              </a:rPr>
-              <a:t>Bitbucket + others</a:t>
-            </a:r>
-            <a:endParaRPr lang="en-US" sz="2400" dirty="0"/>
-          </a:p>
-        </p:txBody>
-      </p:sp>
-      <p:sp>
-        <p:nvSpPr>
-          <p:cNvPr id="9" name="Text 7"/>
-          <p:cNvSpPr/>
-          <p:nvPr/>
-        </p:nvSpPr>
-        <p:spPr>
-          <a:xfrm>
-            <a:off x="4480560" y="3383280"/>
-            <a:ext cx="6766560" cy="274320"/>
-          </a:xfrm>
-          <a:prstGeom prst="rect">
-            <a:avLst/>
-          </a:prstGeom>
-          <a:noFill/>
-          <a:ln/>
-        </p:spPr>
-        <p:txBody>
-          <a:bodyPr wrap="square" lIns="0" tIns="0" rIns="0" bIns="0" rtlCol="0" anchor="ctr"/>
-          <a:lstStyle/>
-          <a:p>
-            <a:pPr indent="0" marL="0">
-              <a:buNone/>
-            </a:pPr>
-            <a:r>
-              <a:rPr lang="en-US" sz="1900" b="1" dirty="0">
+              <a:rPr lang="en-US" sz="2200" b="1" dirty="0">
                 <a:solidFill>
                   <a:srgbClr val="086679"/>
                 </a:solidFill>
@@ -12871,7 +12987,7 @@
               </a:rPr>
               <a:t>IaC</a:t>
             </a:r>
-            <a:endParaRPr lang="en-US" sz="1900" dirty="0"/>
+            <a:endParaRPr lang="en-US" sz="2200" dirty="0"/>
           </a:p>
         </p:txBody>
       </p:sp>
@@ -12883,8 +12999,8 @@
         </p:nvSpPr>
         <p:spPr>
           <a:xfrm>
-            <a:off x="4480560" y="3712464"/>
-            <a:ext cx="6812280" cy="1097280"/>
+            <a:off x="4480560" y="4416552"/>
+            <a:ext cx="6812280" cy="822960"/>
           </a:xfrm>
           <a:prstGeom prst="rect">
             <a:avLst/>
@@ -12900,7 +13016,7 @@
               <a:buNone/>
             </a:pPr>
             <a:r>
-              <a:rPr lang="en-US" sz="2400" dirty="0">
+              <a:rPr lang="en-US" sz="2700" dirty="0">
                 <a:solidFill>
                   <a:srgbClr val="083E4F"/>
                 </a:solidFill>
@@ -12910,14 +13026,14 @@
               </a:rPr>
               <a:t>Terraform dominant</a:t>
             </a:r>
-            <a:endParaRPr lang="en-US" sz="2400" dirty="0"/>
+            <a:endParaRPr lang="en-US" sz="2700" dirty="0"/>
           </a:p>
           <a:p>
             <a:pPr indent="0" marL="0">
               <a:buNone/>
             </a:pPr>
             <a:r>
-              <a:rPr lang="en-US" sz="2400" dirty="0">
+              <a:rPr lang="en-US" sz="2700" dirty="0">
                 <a:solidFill>
                   <a:srgbClr val="083E4F"/>
                 </a:solidFill>
@@ -12927,108 +13043,13 @@
               </a:rPr>
               <a:t>About half also use Terragrunt</a:t>
             </a:r>
-            <a:endParaRPr lang="en-US" sz="2400" dirty="0"/>
-          </a:p>
-          <a:p>
-            <a:pPr indent="0" marL="0">
-              <a:buNone/>
-            </a:pPr>
-            <a:r>
-              <a:rPr lang="en-US" sz="2400" dirty="0">
-                <a:solidFill>
-                  <a:srgbClr val="083E4F"/>
-                </a:solidFill>
-                <a:latin typeface="Arial" pitchFamily="34" charset="0"/>
-                <a:ea typeface="Arial" pitchFamily="34" charset="-122"/>
-                <a:cs typeface="Arial" pitchFamily="34" charset="-120"/>
-              </a:rPr>
-              <a:t>OpenTofu gaining ground</a:t>
-            </a:r>
-            <a:endParaRPr lang="en-US" sz="2400" dirty="0"/>
-          </a:p>
-        </p:txBody>
-      </p:sp>
-      <p:sp>
-        <p:nvSpPr>
-          <p:cNvPr id="11" name="Text 9"/>
-          <p:cNvSpPr/>
-          <p:nvPr/>
-        </p:nvSpPr>
-        <p:spPr>
-          <a:xfrm>
-            <a:off x="4480560" y="4892040"/>
-            <a:ext cx="6766560" cy="274320"/>
-          </a:xfrm>
-          <a:prstGeom prst="rect">
-            <a:avLst/>
-          </a:prstGeom>
-          <a:noFill/>
-          <a:ln/>
-        </p:spPr>
-        <p:txBody>
-          <a:bodyPr wrap="square" lIns="0" tIns="0" rIns="0" bIns="0" rtlCol="0" anchor="ctr"/>
-          <a:lstStyle/>
-          <a:p>
-            <a:pPr indent="0" marL="0">
-              <a:buNone/>
-            </a:pPr>
-            <a:r>
-              <a:rPr lang="en-US" sz="1900" b="1" dirty="0">
-                <a:solidFill>
-                  <a:srgbClr val="086679"/>
-                </a:solidFill>
-                <a:latin typeface="Arial" pitchFamily="34" charset="0"/>
-                <a:ea typeface="Arial" pitchFamily="34" charset="-122"/>
-                <a:cs typeface="Arial" pitchFamily="34" charset="-120"/>
-              </a:rPr>
-              <a:t>DEPLOYMENT</a:t>
-            </a:r>
-            <a:endParaRPr lang="en-US" sz="1900" dirty="0"/>
-          </a:p>
-        </p:txBody>
-      </p:sp>
-      <p:sp>
-        <p:nvSpPr>
-          <p:cNvPr id="12" name="Text 10"/>
-          <p:cNvSpPr/>
-          <p:nvPr/>
-        </p:nvSpPr>
-        <p:spPr>
-          <a:xfrm>
-            <a:off x="4480560" y="5221224"/>
-            <a:ext cx="6812280" cy="694944"/>
-          </a:xfrm>
-          <a:prstGeom prst="rect">
-            <a:avLst/>
-          </a:prstGeom>
-          <a:noFill/>
-          <a:ln/>
-        </p:spPr>
-        <p:txBody>
-          <a:bodyPr wrap="square" lIns="0" tIns="0" rIns="0" bIns="0" rtlCol="0" anchor="ctr"/>
-          <a:lstStyle/>
-          <a:p>
-            <a:pPr indent="0" marL="0">
-              <a:buNone/>
-            </a:pPr>
-            <a:r>
-              <a:rPr lang="en-US" sz="2400" dirty="0">
-                <a:solidFill>
-                  <a:srgbClr val="083E4F"/>
-                </a:solidFill>
-                <a:latin typeface="Arial" pitchFamily="34" charset="0"/>
-                <a:ea typeface="Arial" pitchFamily="34" charset="-122"/>
-                <a:cs typeface="Arial" pitchFamily="34" charset="-120"/>
-              </a:rPr>
-              <a:t>Kubernetes / AWS common</a:t>
-            </a:r>
-            <a:endParaRPr lang="en-US" sz="2400" dirty="0"/>
-          </a:p>
-        </p:txBody>
-      </p:sp>
-      <p:sp>
-        <p:nvSpPr>
-          <p:cNvPr id="13" name="Text 11">
+            <a:endParaRPr lang="en-US" sz="2700" dirty="0"/>
+          </a:p>
+        </p:txBody>
+      </p:sp>
+      <p:sp>
+        <p:nvSpPr>
+          <p:cNvPr id="11" name="Text 9">
             <a:hlinkClick r:id="rId1" tooltip=""/>
           </p:cNvPr>
           <p:cNvSpPr/>
@@ -13257,39 +13278,14 @@
       </p:sp>
       <p:sp>
         <p:nvSpPr>
-          <p:cNvPr id="6" name="Shape 4"/>
+          <p:cNvPr id="6" name="Text 4"/>
           <p:cNvSpPr/>
           <p:nvPr/>
         </p:nvSpPr>
         <p:spPr>
           <a:xfrm>
-            <a:off x="731520" y="3017520"/>
-            <a:ext cx="3429000" cy="1920240"/>
-          </a:xfrm>
-          <a:prstGeom prst="rect">
-            <a:avLst/>
-          </a:prstGeom>
-          <a:solidFill>
-            <a:srgbClr val="EAF1F3"/>
-          </a:solidFill>
-          <a:ln w="12700">
-            <a:solidFill>
-              <a:srgbClr val="EAF1F3"/>
-            </a:solidFill>
-            <a:prstDash val="solid"/>
-          </a:ln>
-        </p:spPr>
-      </p:sp>
-      <p:sp>
-        <p:nvSpPr>
-          <p:cNvPr id="7" name="Text 5"/>
-          <p:cNvSpPr/>
-          <p:nvPr/>
-        </p:nvSpPr>
-        <p:spPr>
-          <a:xfrm>
-            <a:off x="932688" y="3291840"/>
-            <a:ext cx="3026664" cy="1371600"/>
+            <a:off x="731520" y="2971800"/>
+            <a:ext cx="10698480" cy="777240"/>
           </a:xfrm>
           <a:prstGeom prst="rect">
             <a:avLst/>
@@ -13305,7 +13301,7 @@
               <a:buNone/>
             </a:pPr>
             <a:r>
-              <a:rPr lang="en-US" sz="3000" b="1" dirty="0">
+              <a:rPr lang="en-US" sz="3800" b="1" dirty="0">
                 <a:solidFill>
                   <a:srgbClr val="083E4F"/>
                 </a:solidFill>
@@ -13313,47 +13309,22 @@
                 <a:ea typeface="Arial" pitchFamily="34" charset="-122"/>
                 <a:cs typeface="Arial" pitchFamily="34" charset="-120"/>
               </a:rPr>
-              <a:t>Stability</a:t>
+              <a:t>A clearer compatibility contract</a:t>
             </a:r>
-            <a:endParaRPr lang="en-US" sz="3000" dirty="0"/>
-          </a:p>
-        </p:txBody>
-      </p:sp>
-      <p:sp>
-        <p:nvSpPr>
-          <p:cNvPr id="8" name="Shape 6"/>
+            <a:endParaRPr lang="en-US" sz="3800" dirty="0"/>
+          </a:p>
+        </p:txBody>
+      </p:sp>
+      <p:sp>
+        <p:nvSpPr>
+          <p:cNvPr id="7" name="Text 5"/>
           <p:cNvSpPr/>
           <p:nvPr/>
         </p:nvSpPr>
         <p:spPr>
           <a:xfrm>
-            <a:off x="4389120" y="3017520"/>
-            <a:ext cx="3429000" cy="1920240"/>
-          </a:xfrm>
-          <a:prstGeom prst="rect">
-            <a:avLst/>
-          </a:prstGeom>
-          <a:solidFill>
-            <a:srgbClr val="EAF1F3"/>
-          </a:solidFill>
-          <a:ln w="12700">
-            <a:solidFill>
-              <a:srgbClr val="EAF1F3"/>
-            </a:solidFill>
-            <a:prstDash val="solid"/>
-          </a:ln>
-        </p:spPr>
-      </p:sp>
-      <p:sp>
-        <p:nvSpPr>
-          <p:cNvPr id="9" name="Text 7"/>
-          <p:cNvSpPr/>
-          <p:nvPr/>
-        </p:nvSpPr>
-        <p:spPr>
-          <a:xfrm>
-            <a:off x="4590288" y="3291840"/>
-            <a:ext cx="3026664" cy="1371600"/>
+            <a:off x="731520" y="4251960"/>
+            <a:ext cx="10698480" cy="594360"/>
           </a:xfrm>
           <a:prstGeom prst="rect">
             <a:avLst/>
@@ -13371,119 +13342,21 @@
             <a:r>
               <a:rPr lang="en-US" sz="3000" b="1" dirty="0">
                 <a:solidFill>
-                  <a:srgbClr val="083E4F"/>
+                  <a:srgbClr val="086679"/>
                 </a:solidFill>
                 <a:latin typeface="Arial" pitchFamily="34" charset="0"/>
                 <a:ea typeface="Arial" pitchFamily="34" charset="-122"/>
                 <a:cs typeface="Arial" pitchFamily="34" charset="-120"/>
               </a:rPr>
-              <a:t>Backwards</a:t>
+              <a:t>Breaking changes → major version</a:t>
             </a:r>
             <a:endParaRPr lang="en-US" sz="3000" dirty="0"/>
           </a:p>
-          <a:p>
-            <a:pPr indent="0" marL="0">
-              <a:buNone/>
-            </a:pPr>
-            <a:r>
-              <a:rPr lang="en-US" sz="3000" b="1" dirty="0">
-                <a:solidFill>
-                  <a:srgbClr val="083E4F"/>
-                </a:solidFill>
-                <a:latin typeface="Arial" pitchFamily="34" charset="0"/>
-                <a:ea typeface="Arial" pitchFamily="34" charset="-122"/>
-                <a:cs typeface="Arial" pitchFamily="34" charset="-120"/>
-              </a:rPr>
-              <a:t>compatibility</a:t>
-            </a:r>
-            <a:endParaRPr lang="en-US" sz="3000" dirty="0"/>
-          </a:p>
-        </p:txBody>
-      </p:sp>
-      <p:sp>
-        <p:nvSpPr>
-          <p:cNvPr id="10" name="Shape 8"/>
-          <p:cNvSpPr/>
-          <p:nvPr/>
-        </p:nvSpPr>
-        <p:spPr>
-          <a:xfrm>
-            <a:off x="8046720" y="3017520"/>
-            <a:ext cx="3429000" cy="1920240"/>
-          </a:xfrm>
-          <a:prstGeom prst="rect">
-            <a:avLst/>
-          </a:prstGeom>
-          <a:solidFill>
-            <a:srgbClr val="EAF1F3"/>
-          </a:solidFill>
-          <a:ln w="12700">
-            <a:solidFill>
-              <a:srgbClr val="EAF1F3"/>
-            </a:solidFill>
-            <a:prstDash val="solid"/>
-          </a:ln>
-        </p:spPr>
-      </p:sp>
-      <p:sp>
-        <p:nvSpPr>
-          <p:cNvPr id="11" name="Text 9"/>
-          <p:cNvSpPr/>
-          <p:nvPr/>
-        </p:nvSpPr>
-        <p:spPr>
-          <a:xfrm>
-            <a:off x="8247888" y="3291840"/>
-            <a:ext cx="3026664" cy="1371600"/>
-          </a:xfrm>
-          <a:prstGeom prst="rect">
-            <a:avLst/>
-          </a:prstGeom>
-          <a:noFill/>
-          <a:ln/>
-        </p:spPr>
-        <p:txBody>
-          <a:bodyPr wrap="square" lIns="0" tIns="0" rIns="0" bIns="0" rtlCol="0" anchor="ctr"/>
-          <a:lstStyle/>
-          <a:p>
-            <a:pPr indent="0" marL="0">
-              <a:buNone/>
-            </a:pPr>
-            <a:r>
-              <a:rPr lang="en-US" sz="3000" b="1" dirty="0">
-                <a:solidFill>
-                  <a:srgbClr val="083E4F"/>
-                </a:solidFill>
-                <a:latin typeface="Arial" pitchFamily="34" charset="0"/>
-                <a:ea typeface="Arial" pitchFamily="34" charset="-122"/>
-                <a:cs typeface="Arial" pitchFamily="34" charset="-120"/>
-              </a:rPr>
-              <a:t>Clearer</a:t>
-            </a:r>
-            <a:endParaRPr lang="en-US" sz="3000" dirty="0"/>
-          </a:p>
-          <a:p>
-            <a:pPr indent="0" marL="0">
-              <a:buNone/>
-            </a:pPr>
-            <a:r>
-              <a:rPr lang="en-US" sz="3000" b="1" dirty="0">
-                <a:solidFill>
-                  <a:srgbClr val="083E4F"/>
-                </a:solidFill>
-                <a:latin typeface="Arial" pitchFamily="34" charset="0"/>
-                <a:ea typeface="Arial" pitchFamily="34" charset="-122"/>
-                <a:cs typeface="Arial" pitchFamily="34" charset="-120"/>
-              </a:rPr>
-              <a:t>versioning</a:t>
-            </a:r>
-            <a:endParaRPr lang="en-US" sz="3000" dirty="0"/>
-          </a:p>
-        </p:txBody>
-      </p:sp>
-      <p:sp>
-        <p:nvSpPr>
-          <p:cNvPr id="12" name="Text 10">
+        </p:txBody>
+      </p:sp>
+      <p:sp>
+        <p:nvSpPr>
+          <p:cNvPr id="8" name="Text 6">
             <a:hlinkClick r:id="rId1" tooltip=""/>
           </p:cNvPr>
           <p:cNvSpPr/>

</xml_diff>

<commit_message>
docs: polish Atlantis lightning talk visuals and community links
Signed-off-by: Rui Chen <rui@chenrui.dev>
</commit_message>
<xml_diff>
--- a/talks/kubecon-china-2026-atlantis-lightning/slides.pptx
+++ b/talks/kubecon-china-2026-atlantis-lightning/slides.pptx
@@ -615,7 +615,7 @@
 Emergency cuts:
 None; retain this slide’s narration.
 Reference notes (not spoken):
-E03: Project Pavilion T-10, Tuesday September 8, 10:30–14:30, Grand Ballroom I. The slot extends into afternoon. This does not promise Rui is continuously present during the whole pavilion slot.</a:t>
+E03: Project Pavilion T-10, Tuesday September 8, 10:30–14:30, Grand Ballroom I. The slot extends into afternoon. This does not promise Rui is continuously present during the whole pavilion slot. Community meetings: every two weeks on Wednesday at 16:00 UTC. Official agenda/notes and calendar access: https://docs.google.com/document/d/1EzseHmT4Zarj-_7MO8ud5mHByIJGIHS7JdoNNK9ZckU/edit (verified against the public document and official v0.37.0 release announcement).</a:t>
             </a:r>
             <a:endParaRPr lang="en-US" dirty="0"/>
           </a:p>
@@ -8705,8 +8705,8 @@
         </p:nvSpPr>
         <p:spPr>
           <a:xfrm>
-            <a:off x="566928" y="2176272"/>
-            <a:ext cx="7406640" cy="2514600"/>
+            <a:off x="566928" y="2212848"/>
+            <a:ext cx="5212080" cy="2514600"/>
           </a:xfrm>
           <a:prstGeom prst="rect">
             <a:avLst/>
@@ -8722,7 +8722,7 @@
               <a:buNone/>
             </a:pPr>
             <a:r>
-              <a:rPr lang="en-US" sz="5100" b="1" dirty="0">
+              <a:rPr lang="en-US" sz="4900" b="1" dirty="0">
                 <a:solidFill>
                   <a:srgbClr val="086679"/>
                 </a:solidFill>
@@ -8732,14 +8732,14 @@
               </a:rPr>
               <a:t>Plan it.</a:t>
             </a:r>
-            <a:endParaRPr lang="en-US" sz="5100" dirty="0"/>
+            <a:endParaRPr lang="en-US" sz="4900" dirty="0"/>
           </a:p>
           <a:p>
             <a:pPr indent="0" marL="0">
               <a:buNone/>
             </a:pPr>
             <a:r>
-              <a:rPr lang="en-US" sz="5100" b="1" dirty="0">
+              <a:rPr lang="en-US" sz="4900" b="1" dirty="0">
                 <a:solidFill>
                   <a:srgbClr val="086679"/>
                 </a:solidFill>
@@ -8749,14 +8749,14 @@
               </a:rPr>
               <a:t>Review it.</a:t>
             </a:r>
-            <a:endParaRPr lang="en-US" sz="5100" dirty="0"/>
+            <a:endParaRPr lang="en-US" sz="4900" dirty="0"/>
           </a:p>
           <a:p>
             <a:pPr indent="0" marL="0">
               <a:buNone/>
             </a:pPr>
             <a:r>
-              <a:rPr lang="en-US" sz="5100" b="1" dirty="0">
+              <a:rPr lang="en-US" sz="4900" b="1" dirty="0">
                 <a:solidFill>
                   <a:srgbClr val="086679"/>
                 </a:solidFill>
@@ -8766,7 +8766,7 @@
               </a:rPr>
               <a:t>Apply it.</a:t>
             </a:r>
-            <a:endParaRPr lang="en-US" sz="5100" dirty="0"/>
+            <a:endParaRPr lang="en-US" sz="4900" dirty="0"/>
           </a:p>
         </p:txBody>
       </p:sp>
@@ -8778,8 +8778,8 @@
         </p:nvSpPr>
         <p:spPr>
           <a:xfrm>
-            <a:off x="566928" y="4800600"/>
-            <a:ext cx="7589520" cy="457200"/>
+            <a:off x="566928" y="5084064"/>
+            <a:ext cx="5303520" cy="594360"/>
           </a:xfrm>
           <a:prstGeom prst="rect">
             <a:avLst/>
@@ -8795,7 +8795,7 @@
               <a:buNone/>
             </a:pPr>
             <a:r>
-              <a:rPr lang="en-US" sz="3300" b="1" dirty="0">
+              <a:rPr lang="en-US" sz="3000" b="1" dirty="0">
                 <a:solidFill>
                   <a:srgbClr val="083E4F"/>
                 </a:solidFill>
@@ -8805,48 +8805,45 @@
               </a:rPr>
               <a:t>From the pull request.</a:t>
             </a:r>
-            <a:endParaRPr lang="en-US" sz="3300" dirty="0"/>
-          </a:p>
-        </p:txBody>
-      </p:sp>
-      <p:pic>
-        <p:nvPicPr>
-          <p:cNvPr id="7" name="Image 0" descr="QR code for https://www.runatlantis.io/">
-            <a:hlinkClick r:id="rId2" tooltip=""/>
-          </p:cNvPr>
-          <p:cNvPicPr>
-            <a:picLocks noChangeAspect="1"/>
-          </p:cNvPicPr>
-          <p:nvPr/>
-        </p:nvPicPr>
-        <p:blipFill>
-          <a:blip r:embed="rId1"/>
-          <a:stretch>
-            <a:fillRect/>
-          </a:stretch>
-        </p:blipFill>
-        <p:spPr>
-          <a:xfrm>
-            <a:off x="8339328" y="2231136"/>
-            <a:ext cx="3017520" cy="3017520"/>
-          </a:xfrm>
-          <a:prstGeom prst="rect">
-            <a:avLst/>
-          </a:prstGeom>
-        </p:spPr>
-      </p:pic>
-      <p:sp>
-        <p:nvSpPr>
-          <p:cNvPr id="8" name="Text 5">
-            <a:hlinkClick r:id="rId3" tooltip=""/>
-          </p:cNvPr>
+            <a:endParaRPr lang="en-US" sz="3000" dirty="0"/>
+          </a:p>
+        </p:txBody>
+      </p:sp>
+      <p:sp>
+        <p:nvSpPr>
+          <p:cNvPr id="7" name="Shape 5"/>
           <p:cNvSpPr/>
           <p:nvPr/>
         </p:nvSpPr>
         <p:spPr>
           <a:xfrm>
-            <a:off x="8119872" y="5431536"/>
-            <a:ext cx="3456432" cy="393192"/>
+            <a:off x="5623560" y="2240280"/>
+            <a:ext cx="0" cy="3547872"/>
+          </a:xfrm>
+          <a:prstGeom prst="line">
+            <a:avLst/>
+          </a:prstGeom>
+          <a:noFill/>
+          <a:ln w="25400">
+            <a:solidFill>
+              <a:srgbClr val="A6BAC1"/>
+            </a:solidFill>
+            <a:prstDash val="solid"/>
+            <a:headEnd type="none"/>
+            <a:tailEnd type="none"/>
+          </a:ln>
+        </p:spPr>
+      </p:sp>
+      <p:sp>
+        <p:nvSpPr>
+          <p:cNvPr id="8" name="Text 6"/>
+          <p:cNvSpPr/>
+          <p:nvPr/>
+        </p:nvSpPr>
+        <p:spPr>
+          <a:xfrm>
+            <a:off x="5943600" y="2240280"/>
+            <a:ext cx="2926080" cy="274320"/>
           </a:xfrm>
           <a:prstGeom prst="rect">
             <a:avLst/>
@@ -8858,18 +8855,59 @@
           <a:bodyPr wrap="square" lIns="0" tIns="0" rIns="0" bIns="0" rtlCol="0" anchor="ctr"/>
           <a:lstStyle/>
           <a:p>
-            <a:pPr algn="ctr" indent="0" marL="0">
+            <a:pPr indent="0" marL="0">
               <a:buNone/>
             </a:pPr>
             <a:r>
-              <a:rPr lang="en-US" sz="2700" b="1" u="sng" dirty="0">
+              <a:rPr lang="en-US" sz="1800" b="1" dirty="0">
                 <a:solidFill>
                   <a:srgbClr val="086679"/>
                 </a:solidFill>
                 <a:latin typeface="Arial" pitchFamily="34" charset="0"/>
                 <a:ea typeface="Arial" pitchFamily="34" charset="-122"/>
                 <a:cs typeface="Arial" pitchFamily="34" charset="-120"/>
-                <a:hlinkClick r:id="rId3" invalidUrl="" action="" tgtFrame="" tooltip="" history="1" highlightClick="0" endSnd="0">
+              </a:rPr>
+              <a:t>GET STARTED</a:t>
+            </a:r>
+            <a:endParaRPr lang="en-US" sz="1800" dirty="0"/>
+          </a:p>
+        </p:txBody>
+      </p:sp>
+      <p:sp>
+        <p:nvSpPr>
+          <p:cNvPr id="9" name="Text 7">
+            <a:hlinkClick r:id="rId1" tooltip=""/>
+          </p:cNvPr>
+          <p:cNvSpPr/>
+          <p:nvPr/>
+        </p:nvSpPr>
+        <p:spPr>
+          <a:xfrm>
+            <a:off x="5943600" y="2633472"/>
+            <a:ext cx="3291840" cy="365760"/>
+          </a:xfrm>
+          <a:prstGeom prst="rect">
+            <a:avLst/>
+          </a:prstGeom>
+          <a:noFill/>
+          <a:ln/>
+        </p:spPr>
+        <p:txBody>
+          <a:bodyPr wrap="square" lIns="0" tIns="0" rIns="0" bIns="0" rtlCol="0" anchor="ctr"/>
+          <a:lstStyle/>
+          <a:p>
+            <a:pPr indent="0" marL="0">
+              <a:buNone/>
+            </a:pPr>
+            <a:r>
+              <a:rPr lang="en-US" sz="2300" u="sng" dirty="0">
+                <a:solidFill>
+                  <a:srgbClr val="083E4F"/>
+                </a:solidFill>
+                <a:latin typeface="Arial" pitchFamily="34" charset="0"/>
+                <a:ea typeface="Arial" pitchFamily="34" charset="-122"/>
+                <a:cs typeface="Arial" pitchFamily="34" charset="-120"/>
+                <a:hlinkClick r:id="rId1" invalidUrl="" action="" tgtFrame="" tooltip="" history="1" highlightClick="0" endSnd="0">
                   <a:extLst>
                     <a:ext uri="{A12FA001-AC4F-418D-AE19-62706E023703}">
                       <ahyp:hlinkClr xmlns:ahyp="http://schemas.microsoft.com/office/drawing/2018/hyperlinkcolor" val="tx"/>
@@ -8877,24 +8915,63 @@
                   </a:extLst>
                 </a:hlinkClick>
               </a:rPr>
-              <a:t>runatlantis.io</a:t>
+              <a:t>runatlantis.io/docs</a:t>
             </a:r>
-            <a:endParaRPr lang="en-US" sz="2700" dirty="0"/>
-          </a:p>
-        </p:txBody>
-      </p:sp>
-      <p:sp>
-        <p:nvSpPr>
-          <p:cNvPr id="9" name="Text 6">
-            <a:hlinkClick r:id="rId4" tooltip=""/>
+            <a:endParaRPr lang="en-US" sz="2300" dirty="0"/>
+          </a:p>
+        </p:txBody>
+      </p:sp>
+      <p:sp>
+        <p:nvSpPr>
+          <p:cNvPr id="10" name="Text 8"/>
+          <p:cNvSpPr/>
+          <p:nvPr/>
+        </p:nvSpPr>
+        <p:spPr>
+          <a:xfrm>
+            <a:off x="5943600" y="3218688"/>
+            <a:ext cx="2926080" cy="274320"/>
+          </a:xfrm>
+          <a:prstGeom prst="rect">
+            <a:avLst/>
+          </a:prstGeom>
+          <a:noFill/>
+          <a:ln/>
+        </p:spPr>
+        <p:txBody>
+          <a:bodyPr wrap="square" lIns="0" tIns="0" rIns="0" bIns="0" rtlCol="0" anchor="ctr"/>
+          <a:lstStyle/>
+          <a:p>
+            <a:pPr indent="0" marL="0">
+              <a:buNone/>
+            </a:pPr>
+            <a:r>
+              <a:rPr lang="en-US" sz="1800" b="1" dirty="0">
+                <a:solidFill>
+                  <a:srgbClr val="086679"/>
+                </a:solidFill>
+                <a:latin typeface="Arial" pitchFamily="34" charset="0"/>
+                <a:ea typeface="Arial" pitchFamily="34" charset="-122"/>
+                <a:cs typeface="Arial" pitchFamily="34" charset="-120"/>
+              </a:rPr>
+              <a:t>SOURCE</a:t>
+            </a:r>
+            <a:endParaRPr lang="en-US" sz="1800" dirty="0"/>
+          </a:p>
+        </p:txBody>
+      </p:sp>
+      <p:sp>
+        <p:nvSpPr>
+          <p:cNvPr id="11" name="Text 9">
+            <a:hlinkClick r:id="rId2" tooltip=""/>
           </p:cNvPr>
           <p:cNvSpPr/>
           <p:nvPr/>
         </p:nvSpPr>
         <p:spPr>
           <a:xfrm>
-            <a:off x="566928" y="5385816"/>
-            <a:ext cx="7772400" cy="301752"/>
+            <a:off x="5943600" y="3566160"/>
+            <a:ext cx="3337560" cy="731520"/>
           </a:xfrm>
           <a:prstGeom prst="rect">
             <a:avLst/>
@@ -8912,12 +8989,12 @@
             <a:r>
               <a:rPr lang="en-US" sz="2200" u="sng" dirty="0">
                 <a:solidFill>
-                  <a:srgbClr val="405965"/>
+                  <a:srgbClr val="083E4F"/>
                 </a:solidFill>
                 <a:latin typeface="Arial" pitchFamily="34" charset="0"/>
                 <a:ea typeface="Arial" pitchFamily="34" charset="-122"/>
                 <a:cs typeface="Arial" pitchFamily="34" charset="-120"/>
-                <a:hlinkClick r:id="rId4" invalidUrl="" action="" tgtFrame="" tooltip="" history="1" highlightClick="0" endSnd="0">
+                <a:hlinkClick r:id="rId2" invalidUrl="" action="" tgtFrame="" tooltip="" history="1" highlightClick="0" endSnd="0">
                   <a:extLst>
                     <a:ext uri="{A12FA001-AC4F-418D-AE19-62706E023703}">
                       <ahyp:hlinkClr xmlns:ahyp="http://schemas.microsoft.com/office/drawing/2018/hyperlinkcolor" val="tx"/>
@@ -8925,15 +9002,143 @@
                   </a:extLst>
                 </a:hlinkClick>
               </a:rPr>
-              <a:t>GitHub: runatlantis/atlantis</a:t>
+              <a:t>github.com/</a:t>
             </a:r>
             <a:endParaRPr lang="en-US" sz="2200" dirty="0"/>
           </a:p>
-        </p:txBody>
-      </p:sp>
-      <p:sp>
-        <p:nvSpPr>
-          <p:cNvPr id="10" name="Text 7">
+          <a:p>
+            <a:pPr indent="0" marL="0">
+              <a:buNone/>
+            </a:pPr>
+            <a:r>
+              <a:rPr lang="en-US" sz="2200" u="sng" dirty="0">
+                <a:solidFill>
+                  <a:srgbClr val="083E4F"/>
+                </a:solidFill>
+                <a:latin typeface="Arial" pitchFamily="34" charset="0"/>
+                <a:ea typeface="Arial" pitchFamily="34" charset="-122"/>
+                <a:cs typeface="Arial" pitchFamily="34" charset="-120"/>
+                <a:hlinkClick r:id="rId2" invalidUrl="" action="" tgtFrame="" tooltip="" history="1" highlightClick="0" endSnd="0">
+                  <a:extLst>
+                    <a:ext uri="{A12FA001-AC4F-418D-AE19-62706E023703}">
+                      <ahyp:hlinkClr xmlns:ahyp="http://schemas.microsoft.com/office/drawing/2018/hyperlinkcolor" val="tx"/>
+                    </a:ext>
+                  </a:extLst>
+                </a:hlinkClick>
+              </a:rPr>
+              <a:t>runatlantis/atlantis</a:t>
+            </a:r>
+            <a:endParaRPr lang="en-US" sz="2200" dirty="0"/>
+          </a:p>
+        </p:txBody>
+      </p:sp>
+      <p:pic>
+        <p:nvPicPr>
+          <p:cNvPr id="12" name="Image 0" descr="QR code for https://www.runatlantis.io/">
+            <a:hlinkClick r:id="rId4" tooltip=""/>
+          </p:cNvPr>
+          <p:cNvPicPr>
+            <a:picLocks noChangeAspect="1"/>
+          </p:cNvPicPr>
+          <p:nvPr/>
+        </p:nvPicPr>
+        <p:blipFill>
+          <a:blip r:embed="rId3"/>
+          <a:stretch>
+            <a:fillRect/>
+          </a:stretch>
+        </p:blipFill>
+        <p:spPr>
+          <a:xfrm>
+            <a:off x="9354312" y="2176272"/>
+            <a:ext cx="2176272" cy="2176272"/>
+          </a:xfrm>
+          <a:prstGeom prst="rect">
+            <a:avLst/>
+          </a:prstGeom>
+        </p:spPr>
+      </p:pic>
+      <p:sp>
+        <p:nvSpPr>
+          <p:cNvPr id="13" name="Text 10"/>
+          <p:cNvSpPr/>
+          <p:nvPr/>
+        </p:nvSpPr>
+        <p:spPr>
+          <a:xfrm>
+            <a:off x="5943600" y="4507992"/>
+            <a:ext cx="5486400" cy="274320"/>
+          </a:xfrm>
+          <a:prstGeom prst="rect">
+            <a:avLst/>
+          </a:prstGeom>
+          <a:noFill/>
+          <a:ln/>
+        </p:spPr>
+        <p:txBody>
+          <a:bodyPr wrap="square" lIns="0" tIns="0" rIns="0" bIns="0" rtlCol="0" anchor="ctr"/>
+          <a:lstStyle/>
+          <a:p>
+            <a:pPr indent="0" marL="0">
+              <a:buNone/>
+            </a:pPr>
+            <a:r>
+              <a:rPr lang="en-US" sz="1800" b="1" dirty="0">
+                <a:solidFill>
+                  <a:srgbClr val="086679"/>
+                </a:solidFill>
+                <a:latin typeface="Arial" pitchFamily="34" charset="0"/>
+                <a:ea typeface="Arial" pitchFamily="34" charset="-122"/>
+                <a:cs typeface="Arial" pitchFamily="34" charset="-120"/>
+              </a:rPr>
+              <a:t>COMMUNITY</a:t>
+            </a:r>
+            <a:endParaRPr lang="en-US" sz="1800" dirty="0"/>
+          </a:p>
+        </p:txBody>
+      </p:sp>
+      <p:sp>
+        <p:nvSpPr>
+          <p:cNvPr id="14" name="Text 11"/>
+          <p:cNvSpPr/>
+          <p:nvPr/>
+        </p:nvSpPr>
+        <p:spPr>
+          <a:xfrm>
+            <a:off x="5943600" y="4846320"/>
+            <a:ext cx="5486400" cy="320040"/>
+          </a:xfrm>
+          <a:prstGeom prst="rect">
+            <a:avLst/>
+          </a:prstGeom>
+          <a:noFill/>
+          <a:ln/>
+        </p:spPr>
+        <p:txBody>
+          <a:bodyPr wrap="square" lIns="0" tIns="0" rIns="0" bIns="0" rtlCol="0" anchor="ctr"/>
+          <a:lstStyle/>
+          <a:p>
+            <a:pPr indent="0" marL="0">
+              <a:buNone/>
+            </a:pPr>
+            <a:r>
+              <a:rPr lang="en-US" sz="2200" dirty="0">
+                <a:solidFill>
+                  <a:srgbClr val="083E4F"/>
+                </a:solidFill>
+                <a:latin typeface="Arial" pitchFamily="34" charset="0"/>
+                <a:ea typeface="Arial" pitchFamily="34" charset="-122"/>
+                <a:cs typeface="Arial" pitchFamily="34" charset="-120"/>
+              </a:rPr>
+              <a:t>Biweekly · Wed 16:00 UTC</a:t>
+            </a:r>
+            <a:endParaRPr lang="en-US" sz="2200" dirty="0"/>
+          </a:p>
+        </p:txBody>
+      </p:sp>
+      <p:sp>
+        <p:nvSpPr>
+          <p:cNvPr id="15" name="Text 12">
             <a:hlinkClick r:id="rId5" tooltip=""/>
           </p:cNvPr>
           <p:cNvSpPr/>
@@ -8941,8 +9146,8 @@
         </p:nvSpPr>
         <p:spPr>
           <a:xfrm>
-            <a:off x="566928" y="5806440"/>
-            <a:ext cx="10789920" cy="274320"/>
+            <a:off x="5943600" y="5239512"/>
+            <a:ext cx="5577840" cy="320040"/>
           </a:xfrm>
           <a:prstGeom prst="rect">
             <a:avLst/>
@@ -8958,9 +9163,9 @@
               <a:buNone/>
             </a:pPr>
             <a:r>
-              <a:rPr lang="en-US" sz="1800" u="sng" dirty="0">
-                <a:solidFill>
-                  <a:srgbClr val="405965"/>
+              <a:rPr lang="en-US" sz="2100" u="sng" dirty="0">
+                <a:solidFill>
+                  <a:srgbClr val="086679"/>
                 </a:solidFill>
                 <a:latin typeface="Arial" pitchFamily="34" charset="0"/>
                 <a:ea typeface="Arial" pitchFamily="34" charset="-122"/>
@@ -8973,9 +9178,57 @@
                   </a:extLst>
                 </a:hlinkClick>
               </a:rPr>
-              <a:t>Find Atlantis: Project Pavilion · T-10 · Tue 10:30–14:30</a:t>
+              <a:t>Agenda / notes + add to calendar</a:t>
             </a:r>
-            <a:endParaRPr lang="en-US" sz="1800" dirty="0"/>
+            <a:endParaRPr lang="en-US" sz="2100" dirty="0"/>
+          </a:p>
+        </p:txBody>
+      </p:sp>
+      <p:sp>
+        <p:nvSpPr>
+          <p:cNvPr id="16" name="Text 13">
+            <a:hlinkClick r:id="rId6" tooltip=""/>
+          </p:cNvPr>
+          <p:cNvSpPr/>
+          <p:nvPr/>
+        </p:nvSpPr>
+        <p:spPr>
+          <a:xfrm>
+            <a:off x="566928" y="5815584"/>
+            <a:ext cx="10789920" cy="274320"/>
+          </a:xfrm>
+          <a:prstGeom prst="rect">
+            <a:avLst/>
+          </a:prstGeom>
+          <a:noFill/>
+          <a:ln/>
+        </p:spPr>
+        <p:txBody>
+          <a:bodyPr wrap="square" lIns="0" tIns="0" rIns="0" bIns="0" rtlCol="0" anchor="ctr"/>
+          <a:lstStyle/>
+          <a:p>
+            <a:pPr indent="0" marL="0">
+              <a:buNone/>
+            </a:pPr>
+            <a:r>
+              <a:rPr lang="en-US" sz="1900" u="sng" dirty="0">
+                <a:solidFill>
+                  <a:srgbClr val="405965"/>
+                </a:solidFill>
+                <a:latin typeface="Arial" pitchFamily="34" charset="0"/>
+                <a:ea typeface="Arial" pitchFamily="34" charset="-122"/>
+                <a:cs typeface="Arial" pitchFamily="34" charset="-120"/>
+                <a:hlinkClick r:id="rId6" invalidUrl="" action="" tgtFrame="" tooltip="" history="1" highlightClick="0" endSnd="0">
+                  <a:extLst>
+                    <a:ext uri="{A12FA001-AC4F-418D-AE19-62706E023703}">
+                      <ahyp:hlinkClr xmlns:ahyp="http://schemas.microsoft.com/office/drawing/2018/hyperlinkcolor" val="tx"/>
+                    </a:ext>
+                  </a:extLst>
+                </a:hlinkClick>
+              </a:rPr>
+              <a:t>Project Pavilion · T-10 · Tue 10:30–14:30</a:t>
+            </a:r>
+            <a:endParaRPr lang="en-US" sz="1900" dirty="0"/>
           </a:p>
         </p:txBody>
       </p:sp>
@@ -9129,8 +9382,8 @@
         </p:nvSpPr>
         <p:spPr>
           <a:xfrm>
-            <a:off x="731520" y="2468880"/>
-            <a:ext cx="3749040" cy="1234440"/>
+            <a:off x="731520" y="2423160"/>
+            <a:ext cx="3337560" cy="1234440"/>
           </a:xfrm>
           <a:prstGeom prst="rect">
             <a:avLst/>
@@ -9154,8 +9407,8 @@
         </p:nvSpPr>
         <p:spPr>
           <a:xfrm>
-            <a:off x="932688" y="2606040"/>
-            <a:ext cx="3346704" cy="393192"/>
+            <a:off x="932688" y="2560320"/>
+            <a:ext cx="2935224" cy="393192"/>
           </a:xfrm>
           <a:prstGeom prst="rect">
             <a:avLst/>
@@ -9193,8 +9446,8 @@
         </p:nvSpPr>
         <p:spPr>
           <a:xfrm>
-            <a:off x="932688" y="3090672"/>
-            <a:ext cx="3346704" cy="329184"/>
+            <a:off x="932688" y="3044952"/>
+            <a:ext cx="2935224" cy="329184"/>
           </a:xfrm>
           <a:prstGeom prst="rect">
             <a:avLst/>
@@ -9218,7 +9471,7 @@
                 <a:ea typeface="Arial" pitchFamily="34" charset="-122"/>
                 <a:cs typeface="Arial" pitchFamily="34" charset="-120"/>
               </a:rPr>
-              <a:t>Developer opens a change</a:t>
+              <a:t>Code + plan review</a:t>
             </a:r>
             <a:endParaRPr lang="en-US" sz="1900" dirty="0"/>
           </a:p>
@@ -9232,8 +9485,8 @@
         </p:nvSpPr>
         <p:spPr>
           <a:xfrm>
-            <a:off x="7589520" y="2468880"/>
-            <a:ext cx="3749040" cy="1234440"/>
+            <a:off x="7589520" y="2423160"/>
+            <a:ext cx="3794760" cy="1234440"/>
           </a:xfrm>
           <a:prstGeom prst="rect">
             <a:avLst/>
@@ -9257,8 +9510,8 @@
         </p:nvSpPr>
         <p:spPr>
           <a:xfrm>
-            <a:off x="7790688" y="2606040"/>
-            <a:ext cx="3346704" cy="393192"/>
+            <a:off x="7790688" y="2560320"/>
+            <a:ext cx="3392424" cy="393192"/>
           </a:xfrm>
           <a:prstGeom prst="rect">
             <a:avLst/>
@@ -9296,8 +9549,8 @@
         </p:nvSpPr>
         <p:spPr>
           <a:xfrm>
-            <a:off x="7790688" y="3090672"/>
-            <a:ext cx="3346704" cy="329184"/>
+            <a:off x="7790688" y="3044952"/>
+            <a:ext cx="3392424" cy="329184"/>
           </a:xfrm>
           <a:prstGeom prst="rect">
             <a:avLst/>
@@ -9321,7 +9574,7 @@
                 <a:ea typeface="Arial" pitchFamily="34" charset="-122"/>
                 <a:cs typeface="Arial" pitchFamily="34" charset="-120"/>
               </a:rPr>
-              <a:t>Workflow orchestration</a:t>
+              <a:t>PR orchestration</a:t>
             </a:r>
             <a:endParaRPr lang="en-US" sz="1900" dirty="0"/>
           </a:p>
@@ -9329,92 +9582,14 @@
       </p:sp>
       <p:sp>
         <p:nvSpPr>
-          <p:cNvPr id="11" name="Text 9"/>
+          <p:cNvPr id="11" name="Shape 9"/>
           <p:cNvSpPr/>
           <p:nvPr/>
         </p:nvSpPr>
         <p:spPr>
           <a:xfrm>
-            <a:off x="932688" y="3977640"/>
-            <a:ext cx="3657600" cy="457200"/>
-          </a:xfrm>
-          <a:prstGeom prst="rect">
-            <a:avLst/>
-          </a:prstGeom>
-          <a:noFill/>
-          <a:ln/>
-        </p:spPr>
-        <p:txBody>
-          <a:bodyPr wrap="square" lIns="0" tIns="0" rIns="0" bIns="0" rtlCol="0" anchor="ctr"/>
-          <a:lstStyle/>
-          <a:p>
-            <a:pPr indent="0" marL="0">
-              <a:buNone/>
-            </a:pPr>
-            <a:r>
-              <a:rPr lang="en-US" sz="2600" b="1" dirty="0">
-                <a:solidFill>
-                  <a:srgbClr val="086679"/>
-                </a:solidFill>
-                <a:latin typeface="Arial" pitchFamily="34" charset="0"/>
-                <a:ea typeface="Arial" pitchFamily="34" charset="-122"/>
-                <a:cs typeface="Arial" pitchFamily="34" charset="-120"/>
-              </a:rPr>
-              <a:t>Code + plan review</a:t>
-            </a:r>
-            <a:endParaRPr lang="en-US" sz="2600" dirty="0"/>
-          </a:p>
-        </p:txBody>
-      </p:sp>
-      <p:sp>
-        <p:nvSpPr>
-          <p:cNvPr id="12" name="Text 10"/>
-          <p:cNvSpPr/>
-          <p:nvPr/>
-        </p:nvSpPr>
-        <p:spPr>
-          <a:xfrm>
-            <a:off x="7589520" y="3977640"/>
-            <a:ext cx="3749040" cy="457200"/>
-          </a:xfrm>
-          <a:prstGeom prst="rect">
-            <a:avLst/>
-          </a:prstGeom>
-          <a:noFill/>
-          <a:ln/>
-        </p:spPr>
-        <p:txBody>
-          <a:bodyPr wrap="square" lIns="0" tIns="0" rIns="0" bIns="0" rtlCol="0" anchor="ctr"/>
-          <a:lstStyle/>
-          <a:p>
-            <a:pPr indent="0" marL="0">
-              <a:buNone/>
-            </a:pPr>
-            <a:r>
-              <a:rPr lang="en-US" sz="2300" b="1" dirty="0">
-                <a:solidFill>
-                  <a:srgbClr val="086679"/>
-                </a:solidFill>
-                <a:latin typeface="Arial" pitchFamily="34" charset="0"/>
-                <a:ea typeface="Arial" pitchFamily="34" charset="-122"/>
-                <a:cs typeface="Arial" pitchFamily="34" charset="-120"/>
-              </a:rPr>
-              <a:t>Configured requirements</a:t>
-            </a:r>
-            <a:endParaRPr lang="en-US" sz="2300" dirty="0"/>
-          </a:p>
-        </p:txBody>
-      </p:sp>
-      <p:sp>
-        <p:nvSpPr>
-          <p:cNvPr id="13" name="Shape 11"/>
-          <p:cNvSpPr/>
-          <p:nvPr/>
-        </p:nvSpPr>
-        <p:spPr>
-          <a:xfrm>
-            <a:off x="4663440" y="2606040"/>
-            <a:ext cx="2697480" cy="0"/>
+            <a:off x="4251960" y="2788920"/>
+            <a:ext cx="3154680" cy="0"/>
           </a:xfrm>
           <a:prstGeom prst="line">
             <a:avLst/>
@@ -9432,14 +9607,14 @@
       </p:sp>
       <p:sp>
         <p:nvSpPr>
-          <p:cNvPr id="14" name="Text 12"/>
+          <p:cNvPr id="12" name="Text 10"/>
           <p:cNvSpPr/>
           <p:nvPr/>
         </p:nvSpPr>
         <p:spPr>
           <a:xfrm>
-            <a:off x="4617720" y="2176272"/>
-            <a:ext cx="2788920" cy="320040"/>
+            <a:off x="4160520" y="2286000"/>
+            <a:ext cx="3337560" cy="411480"/>
           </a:xfrm>
           <a:prstGeom prst="rect">
             <a:avLst/>
@@ -9463,7 +9638,7 @@
                 <a:ea typeface="Arial" pitchFamily="34" charset="-122"/>
                 <a:cs typeface="Arial" pitchFamily="34" charset="-120"/>
               </a:rPr>
-              <a:t>Webhook</a:t>
+              <a:t>Webhook · apply request</a:t>
             </a:r>
             <a:endParaRPr lang="en-US" sz="2100" dirty="0"/>
           </a:p>
@@ -9471,14 +9646,14 @@
       </p:sp>
       <p:sp>
         <p:nvSpPr>
-          <p:cNvPr id="15" name="Shape 13"/>
+          <p:cNvPr id="13" name="Shape 11"/>
           <p:cNvSpPr/>
           <p:nvPr/>
         </p:nvSpPr>
         <p:spPr>
           <a:xfrm>
-            <a:off x="7360920" y="3474720"/>
-            <a:ext cx="-2697480" cy="0"/>
+            <a:off x="7406640" y="3566160"/>
+            <a:ext cx="-3154680" cy="0"/>
           </a:xfrm>
           <a:prstGeom prst="line">
             <a:avLst/>
@@ -9496,14 +9671,14 @@
       </p:sp>
       <p:sp>
         <p:nvSpPr>
-          <p:cNvPr id="16" name="Text 14"/>
+          <p:cNvPr id="14" name="Text 12"/>
           <p:cNvSpPr/>
           <p:nvPr/>
         </p:nvSpPr>
         <p:spPr>
           <a:xfrm>
-            <a:off x="4526280" y="3008376"/>
-            <a:ext cx="2971800" cy="365760"/>
+            <a:off x="4160520" y="3063240"/>
+            <a:ext cx="3337560" cy="411480"/>
           </a:xfrm>
           <a:prstGeom prst="rect">
             <a:avLst/>
@@ -9535,14 +9710,53 @@
       </p:sp>
       <p:sp>
         <p:nvSpPr>
-          <p:cNvPr id="17" name="Shape 15"/>
+          <p:cNvPr id="15" name="Text 13"/>
           <p:cNvSpPr/>
           <p:nvPr/>
         </p:nvSpPr>
         <p:spPr>
           <a:xfrm>
-            <a:off x="4663440" y="4434840"/>
-            <a:ext cx="2697480" cy="0"/>
+            <a:off x="7589520" y="3822192"/>
+            <a:ext cx="3794760" cy="365760"/>
+          </a:xfrm>
+          <a:prstGeom prst="rect">
+            <a:avLst/>
+          </a:prstGeom>
+          <a:noFill/>
+          <a:ln/>
+        </p:spPr>
+        <p:txBody>
+          <a:bodyPr wrap="square" lIns="0" tIns="0" rIns="0" bIns="0" rtlCol="0" anchor="ctr"/>
+          <a:lstStyle/>
+          <a:p>
+            <a:pPr algn="ctr" indent="0" marL="0">
+              <a:buNone/>
+            </a:pPr>
+            <a:r>
+              <a:rPr lang="en-US" sz="2200" dirty="0">
+                <a:solidFill>
+                  <a:srgbClr val="086679"/>
+                </a:solidFill>
+                <a:latin typeface="Arial" pitchFamily="34" charset="0"/>
+                <a:ea typeface="Arial" pitchFamily="34" charset="-122"/>
+                <a:cs typeface="Arial" pitchFamily="34" charset="-120"/>
+              </a:rPr>
+              <a:t>Configured requirements</a:t>
+            </a:r>
+            <a:endParaRPr lang="en-US" sz="2200" dirty="0"/>
+          </a:p>
+        </p:txBody>
+      </p:sp>
+      <p:sp>
+        <p:nvSpPr>
+          <p:cNvPr id="16" name="Shape 14"/>
+          <p:cNvSpPr/>
+          <p:nvPr/>
+        </p:nvSpPr>
+        <p:spPr>
+          <a:xfrm>
+            <a:off x="9491472" y="4370832"/>
+            <a:ext cx="0" cy="347472"/>
           </a:xfrm>
           <a:prstGeom prst="line">
             <a:avLst/>
@@ -9560,14 +9774,14 @@
       </p:sp>
       <p:sp>
         <p:nvSpPr>
-          <p:cNvPr id="18" name="Text 16"/>
+          <p:cNvPr id="17" name="Text 15"/>
           <p:cNvSpPr/>
           <p:nvPr/>
         </p:nvSpPr>
         <p:spPr>
           <a:xfrm>
-            <a:off x="4572000" y="3977640"/>
-            <a:ext cx="2926080" cy="320040"/>
+            <a:off x="7498080" y="4800600"/>
+            <a:ext cx="3977640" cy="457200"/>
           </a:xfrm>
           <a:prstGeom prst="rect">
             <a:avLst/>
@@ -9583,80 +9797,30 @@
               <a:buNone/>
             </a:pPr>
             <a:r>
-              <a:rPr lang="en-US" sz="2100" dirty="0">
-                <a:solidFill>
-                  <a:srgbClr val="086679"/>
+              <a:rPr lang="en-US" sz="2600" b="1" dirty="0">
+                <a:solidFill>
+                  <a:srgbClr val="083E4F"/>
                 </a:solidFill>
                 <a:latin typeface="Arial" pitchFamily="34" charset="0"/>
                 <a:ea typeface="Arial" pitchFamily="34" charset="-122"/>
                 <a:cs typeface="Arial" pitchFamily="34" charset="-120"/>
               </a:rPr>
-              <a:t>atlantis apply</a:t>
+              <a:t>Terraform / OpenTofu</a:t>
             </a:r>
-            <a:endParaRPr lang="en-US" sz="2100" dirty="0"/>
-          </a:p>
-        </p:txBody>
-      </p:sp>
-      <p:sp>
-        <p:nvSpPr>
-          <p:cNvPr id="19" name="Shape 17"/>
+            <a:endParaRPr lang="en-US" sz="2600" dirty="0"/>
+          </a:p>
+        </p:txBody>
+      </p:sp>
+      <p:sp>
+        <p:nvSpPr>
+          <p:cNvPr id="18" name="Text 16"/>
           <p:cNvSpPr/>
           <p:nvPr/>
         </p:nvSpPr>
         <p:spPr>
           <a:xfrm>
-            <a:off x="9464040" y="4480560"/>
-            <a:ext cx="0" cy="411480"/>
-          </a:xfrm>
-          <a:prstGeom prst="line">
-            <a:avLst/>
-          </a:prstGeom>
-          <a:noFill/>
-          <a:ln w="25400">
-            <a:solidFill>
-              <a:srgbClr val="086679"/>
-            </a:solidFill>
-            <a:prstDash val="solid"/>
-            <a:headEnd type="none"/>
-            <a:tailEnd type="triangle"/>
-          </a:ln>
-        </p:spPr>
-      </p:sp>
-      <p:sp>
-        <p:nvSpPr>
-          <p:cNvPr id="20" name="Shape 18"/>
-          <p:cNvSpPr/>
-          <p:nvPr/>
-        </p:nvSpPr>
-        <p:spPr>
-          <a:xfrm>
-            <a:off x="7589520" y="5010912"/>
-            <a:ext cx="3749040" cy="868680"/>
-          </a:xfrm>
-          <a:prstGeom prst="rect">
-            <a:avLst/>
-          </a:prstGeom>
-          <a:solidFill>
-            <a:srgbClr val="EAF1F3"/>
-          </a:solidFill>
-          <a:ln w="12700">
-            <a:solidFill>
-              <a:srgbClr val="EAF1F3"/>
-            </a:solidFill>
-            <a:prstDash val="solid"/>
-          </a:ln>
-        </p:spPr>
-      </p:sp>
-      <p:sp>
-        <p:nvSpPr>
-          <p:cNvPr id="21" name="Text 19"/>
-          <p:cNvSpPr/>
-          <p:nvPr/>
-        </p:nvSpPr>
-        <p:spPr>
-          <a:xfrm>
-            <a:off x="7790688" y="5148072"/>
-            <a:ext cx="3346704" cy="393192"/>
+            <a:off x="7388352" y="5394960"/>
+            <a:ext cx="4206240" cy="365760"/>
           </a:xfrm>
           <a:prstGeom prst="rect">
             <a:avLst/>
@@ -9668,34 +9832,59 @@
           <a:bodyPr wrap="square" lIns="0" tIns="0" rIns="0" bIns="0" rtlCol="0" anchor="ctr"/>
           <a:lstStyle/>
           <a:p>
-            <a:pPr indent="0" marL="0">
+            <a:pPr algn="ctr" indent="0" marL="0">
               <a:buNone/>
             </a:pPr>
             <a:r>
-              <a:rPr lang="en-US" sz="2700" b="1" dirty="0">
-                <a:solidFill>
-                  <a:srgbClr val="083E4F"/>
+              <a:rPr lang="en-US" sz="2100" dirty="0">
+                <a:solidFill>
+                  <a:srgbClr val="405965"/>
                 </a:solidFill>
                 <a:latin typeface="Arial" pitchFamily="34" charset="0"/>
                 <a:ea typeface="Arial" pitchFamily="34" charset="-122"/>
                 <a:cs typeface="Arial" pitchFamily="34" charset="-120"/>
               </a:rPr>
-              <a:t>Infrastructure</a:t>
+              <a:t>Providers · state · infrastructure</a:t>
             </a:r>
-            <a:endParaRPr lang="en-US" sz="2700" dirty="0"/>
-          </a:p>
-        </p:txBody>
-      </p:sp>
-      <p:sp>
-        <p:nvSpPr>
-          <p:cNvPr id="22" name="Text 20"/>
+            <a:endParaRPr lang="en-US" sz="2100" dirty="0"/>
+          </a:p>
+        </p:txBody>
+      </p:sp>
+      <p:sp>
+        <p:nvSpPr>
+          <p:cNvPr id="19" name="Shape 17"/>
           <p:cNvSpPr/>
           <p:nvPr/>
         </p:nvSpPr>
         <p:spPr>
           <a:xfrm>
-            <a:off x="7790688" y="5532120"/>
-            <a:ext cx="3346704" cy="228600"/>
+            <a:off x="914400" y="3977640"/>
+            <a:ext cx="0" cy="1353312"/>
+          </a:xfrm>
+          <a:prstGeom prst="line">
+            <a:avLst/>
+          </a:prstGeom>
+          <a:noFill/>
+          <a:ln w="25400">
+            <a:solidFill>
+              <a:srgbClr val="A6BAC1"/>
+            </a:solidFill>
+            <a:prstDash val="solid"/>
+            <a:headEnd type="none"/>
+            <a:tailEnd type="none"/>
+          </a:ln>
+        </p:spPr>
+      </p:sp>
+      <p:sp>
+        <p:nvSpPr>
+          <p:cNvPr id="20" name="Text 18"/>
+          <p:cNvSpPr/>
+          <p:nvPr/>
+        </p:nvSpPr>
+        <p:spPr>
+          <a:xfrm>
+            <a:off x="1188720" y="4370832"/>
+            <a:ext cx="5669280" cy="960120"/>
           </a:xfrm>
           <a:prstGeom prst="rect">
             <a:avLst/>
@@ -9711,73 +9900,34 @@
               <a:buNone/>
             </a:pPr>
             <a:r>
-              <a:rPr lang="en-US" sz="1800" dirty="0">
-                <a:solidFill>
-                  <a:srgbClr val="405965"/>
+              <a:rPr lang="en-US" sz="3100" b="1" dirty="0">
+                <a:solidFill>
+                  <a:srgbClr val="086679"/>
                 </a:solidFill>
                 <a:latin typeface="Arial" pitchFamily="34" charset="0"/>
                 <a:ea typeface="Arial" pitchFamily="34" charset="-122"/>
                 <a:cs typeface="Arial" pitchFamily="34" charset="-120"/>
               </a:rPr>
-              <a:t>Via provider APIs</a:t>
+              <a:t>Results stay with</a:t>
             </a:r>
-            <a:endParaRPr lang="en-US" sz="1800" dirty="0"/>
-          </a:p>
-        </p:txBody>
-      </p:sp>
-      <p:sp>
-        <p:nvSpPr>
-          <p:cNvPr id="23" name="Text 21"/>
-          <p:cNvSpPr/>
-          <p:nvPr/>
-        </p:nvSpPr>
-        <p:spPr>
-          <a:xfrm>
-            <a:off x="932688" y="4983480"/>
-            <a:ext cx="3520440" cy="868680"/>
-          </a:xfrm>
-          <a:prstGeom prst="rect">
-            <a:avLst/>
-          </a:prstGeom>
-          <a:noFill/>
-          <a:ln/>
-        </p:spPr>
-        <p:txBody>
-          <a:bodyPr wrap="square" lIns="0" tIns="0" rIns="0" bIns="0" rtlCol="0" anchor="ctr"/>
-          <a:lstStyle/>
+            <a:endParaRPr lang="en-US" sz="3100" dirty="0"/>
+          </a:p>
           <a:p>
             <a:pPr indent="0" marL="0">
               <a:buNone/>
             </a:pPr>
             <a:r>
-              <a:rPr lang="en-US" sz="2300" b="1" dirty="0">
-                <a:solidFill>
-                  <a:srgbClr val="083E4F"/>
+              <a:rPr lang="en-US" sz="3100" b="1" dirty="0">
+                <a:solidFill>
+                  <a:srgbClr val="086679"/>
                 </a:solidFill>
                 <a:latin typeface="Arial" pitchFamily="34" charset="0"/>
                 <a:ea typeface="Arial" pitchFamily="34" charset="-122"/>
                 <a:cs typeface="Arial" pitchFamily="34" charset="-120"/>
               </a:rPr>
-              <a:t>Terraform / OpenTofu:</a:t>
+              <a:t>the pull request.</a:t>
             </a:r>
-            <a:endParaRPr lang="en-US" sz="2300" dirty="0"/>
-          </a:p>
-          <a:p>
-            <a:pPr indent="0" marL="0">
-              <a:buNone/>
-            </a:pPr>
-            <a:r>
-              <a:rPr lang="en-US" sz="2300" b="1" dirty="0">
-                <a:solidFill>
-                  <a:srgbClr val="083E4F"/>
-                </a:solidFill>
-                <a:latin typeface="Arial" pitchFamily="34" charset="0"/>
-                <a:ea typeface="Arial" pitchFamily="34" charset="-122"/>
-                <a:cs typeface="Arial" pitchFamily="34" charset="-120"/>
-              </a:rPr>
-              <a:t>providers + state</a:t>
-            </a:r>
-            <a:endParaRPr lang="en-US" sz="2300" dirty="0"/>
+            <a:endParaRPr lang="en-US" sz="3100" dirty="0"/>
           </a:p>
         </p:txBody>
       </p:sp>
@@ -9925,14 +10075,142 @@
       </p:sp>
       <p:sp>
         <p:nvSpPr>
-          <p:cNvPr id="5" name="Shape 3"/>
+          <p:cNvPr id="5" name="Text 3"/>
           <p:cNvSpPr/>
           <p:nvPr/>
         </p:nvSpPr>
         <p:spPr>
           <a:xfrm>
-            <a:off x="658368" y="2148840"/>
-            <a:ext cx="10881360" cy="3657600"/>
+            <a:off x="804672" y="2148840"/>
+            <a:ext cx="10789920" cy="457200"/>
+          </a:xfrm>
+          <a:prstGeom prst="rect">
+            <a:avLst/>
+          </a:prstGeom>
+          <a:noFill/>
+          <a:ln/>
+        </p:spPr>
+        <p:txBody>
+          <a:bodyPr wrap="square" lIns="0" tIns="0" rIns="0" bIns="0" rtlCol="0" anchor="ctr"/>
+          <a:lstStyle/>
+          <a:p>
+            <a:pPr indent="0" marL="0">
+              <a:buNone/>
+            </a:pPr>
+            <a:r>
+              <a:rPr lang="en-US" sz="2800" b="1" dirty="0">
+                <a:solidFill>
+                  <a:srgbClr val="083E4F"/>
+                </a:solidFill>
+                <a:latin typeface="Arial" pitchFamily="34" charset="0"/>
+                <a:ea typeface="Arial" pitchFamily="34" charset="-122"/>
+                <a:cs typeface="Arial" pitchFamily="34" charset="-120"/>
+              </a:rPr>
+              <a:t>infra: resize production database</a:t>
+            </a:r>
+            <a:endParaRPr lang="en-US" sz="2800" dirty="0"/>
+          </a:p>
+        </p:txBody>
+      </p:sp>
+      <p:sp>
+        <p:nvSpPr>
+          <p:cNvPr id="6" name="Shape 4"/>
+          <p:cNvSpPr/>
+          <p:nvPr/>
+        </p:nvSpPr>
+        <p:spPr>
+          <a:xfrm>
+            <a:off x="987552" y="2926080"/>
+            <a:ext cx="0" cy="2130552"/>
+          </a:xfrm>
+          <a:prstGeom prst="line">
+            <a:avLst/>
+          </a:prstGeom>
+          <a:noFill/>
+          <a:ln w="25400">
+            <a:solidFill>
+              <a:srgbClr val="A6BAC1"/>
+            </a:solidFill>
+            <a:prstDash val="solid"/>
+            <a:headEnd type="none"/>
+            <a:tailEnd type="none"/>
+          </a:ln>
+        </p:spPr>
+      </p:sp>
+      <p:sp>
+        <p:nvSpPr>
+          <p:cNvPr id="7" name="Shape 5"/>
+          <p:cNvSpPr/>
+          <p:nvPr/>
+        </p:nvSpPr>
+        <p:spPr>
+          <a:xfrm>
+            <a:off x="886968" y="2862072"/>
+            <a:ext cx="201168" cy="201168"/>
+          </a:xfrm>
+          <a:prstGeom prst="ellipse">
+            <a:avLst/>
+          </a:prstGeom>
+          <a:solidFill>
+            <a:srgbClr val="086679"/>
+          </a:solidFill>
+          <a:ln w="12700">
+            <a:solidFill>
+              <a:srgbClr val="086679"/>
+            </a:solidFill>
+            <a:prstDash val="solid"/>
+          </a:ln>
+        </p:spPr>
+      </p:sp>
+      <p:sp>
+        <p:nvSpPr>
+          <p:cNvPr id="8" name="Text 6"/>
+          <p:cNvSpPr/>
+          <p:nvPr/>
+        </p:nvSpPr>
+        <p:spPr>
+          <a:xfrm>
+            <a:off x="1353312" y="2761488"/>
+            <a:ext cx="1645920" cy="411480"/>
+          </a:xfrm>
+          <a:prstGeom prst="rect">
+            <a:avLst/>
+          </a:prstGeom>
+          <a:noFill/>
+          <a:ln/>
+        </p:spPr>
+        <p:txBody>
+          <a:bodyPr wrap="square" lIns="0" tIns="0" rIns="0" bIns="0" rtlCol="0" anchor="ctr"/>
+          <a:lstStyle/>
+          <a:p>
+            <a:pPr indent="0" marL="0">
+              <a:buNone/>
+            </a:pPr>
+            <a:r>
+              <a:rPr lang="en-US" sz="2200" dirty="0">
+                <a:solidFill>
+                  <a:srgbClr val="405965"/>
+                </a:solidFill>
+                <a:latin typeface="Arial" pitchFamily="34" charset="0"/>
+                <a:ea typeface="Arial" pitchFamily="34" charset="-122"/>
+                <a:cs typeface="Arial" pitchFamily="34" charset="-120"/>
+              </a:rPr>
+              <a:t>Atlantis</a:t>
+            </a:r>
+            <a:endParaRPr lang="en-US" sz="2200" dirty="0"/>
+          </a:p>
+        </p:txBody>
+      </p:sp>
+      <p:sp>
+        <p:nvSpPr>
+          <p:cNvPr id="9" name="Shape 7"/>
+          <p:cNvSpPr/>
+          <p:nvPr/>
+        </p:nvSpPr>
+        <p:spPr>
+          <a:xfrm>
+            <a:off x="3063240" y="2688336"/>
+            <a:ext cx="8183880" cy="530352"/>
           </a:xfrm>
           <a:prstGeom prst="rect">
             <a:avLst/>
@@ -9950,117 +10228,14 @@
       </p:sp>
       <p:sp>
         <p:nvSpPr>
-          <p:cNvPr id="6" name="Text 4"/>
+          <p:cNvPr id="10" name="Text 8"/>
           <p:cNvSpPr/>
           <p:nvPr/>
         </p:nvSpPr>
         <p:spPr>
           <a:xfrm>
-            <a:off x="932688" y="2377440"/>
-            <a:ext cx="9966960" cy="384048"/>
-          </a:xfrm>
-          <a:prstGeom prst="rect">
-            <a:avLst/>
-          </a:prstGeom>
-          <a:noFill/>
-          <a:ln/>
-        </p:spPr>
-        <p:txBody>
-          <a:bodyPr wrap="square" lIns="0" tIns="0" rIns="0" bIns="0" rtlCol="0" anchor="ctr"/>
-          <a:lstStyle/>
-          <a:p>
-            <a:pPr indent="0" marL="0">
-              <a:buNone/>
-            </a:pPr>
-            <a:r>
-              <a:rPr lang="en-US" sz="2700" b="1" dirty="0">
-                <a:solidFill>
-                  <a:srgbClr val="083E4F"/>
-                </a:solidFill>
-                <a:latin typeface="Arial" pitchFamily="34" charset="0"/>
-                <a:ea typeface="Arial" pitchFamily="34" charset="-122"/>
-                <a:cs typeface="Arial" pitchFamily="34" charset="-120"/>
-              </a:rPr>
-              <a:t>infra: resize production database</a:t>
-            </a:r>
-            <a:endParaRPr lang="en-US" sz="2700" dirty="0"/>
-          </a:p>
-        </p:txBody>
-      </p:sp>
-      <p:sp>
-        <p:nvSpPr>
-          <p:cNvPr id="7" name="Shape 5"/>
-          <p:cNvSpPr/>
-          <p:nvPr/>
-        </p:nvSpPr>
-        <p:spPr>
-          <a:xfrm>
-            <a:off x="932688" y="2971800"/>
-            <a:ext cx="10287000" cy="0"/>
-          </a:xfrm>
-          <a:prstGeom prst="line">
-            <a:avLst/>
-          </a:prstGeom>
-          <a:noFill/>
-          <a:ln w="25400">
-            <a:solidFill>
-              <a:srgbClr val="A6BAC1"/>
-            </a:solidFill>
-            <a:prstDash val="solid"/>
-            <a:headEnd type="none"/>
-            <a:tailEnd type="none"/>
-          </a:ln>
-        </p:spPr>
-      </p:sp>
-      <p:sp>
-        <p:nvSpPr>
-          <p:cNvPr id="8" name="Text 6"/>
-          <p:cNvSpPr/>
-          <p:nvPr/>
-        </p:nvSpPr>
-        <p:spPr>
-          <a:xfrm>
-            <a:off x="950976" y="3218688"/>
-            <a:ext cx="1508760" cy="365760"/>
-          </a:xfrm>
-          <a:prstGeom prst="rect">
-            <a:avLst/>
-          </a:prstGeom>
-          <a:noFill/>
-          <a:ln/>
-        </p:spPr>
-        <p:txBody>
-          <a:bodyPr wrap="square" lIns="0" tIns="0" rIns="0" bIns="0" rtlCol="0" anchor="ctr"/>
-          <a:lstStyle/>
-          <a:p>
-            <a:pPr indent="0" marL="0">
-              <a:buNone/>
-            </a:pPr>
-            <a:r>
-              <a:rPr lang="en-US" sz="2100" dirty="0">
-                <a:solidFill>
-                  <a:srgbClr val="405965"/>
-                </a:solidFill>
-                <a:latin typeface="Arial" pitchFamily="34" charset="0"/>
-                <a:ea typeface="Arial" pitchFamily="34" charset="-122"/>
-                <a:cs typeface="Arial" pitchFamily="34" charset="-120"/>
-              </a:rPr>
-              <a:t>Atlantis</a:t>
-            </a:r>
-            <a:endParaRPr lang="en-US" sz="2100" dirty="0"/>
-          </a:p>
-        </p:txBody>
-      </p:sp>
-      <p:sp>
-        <p:nvSpPr>
-          <p:cNvPr id="9" name="Text 7"/>
-          <p:cNvSpPr/>
-          <p:nvPr/>
-        </p:nvSpPr>
-        <p:spPr>
-          <a:xfrm>
-            <a:off x="2743200" y="3218688"/>
-            <a:ext cx="8412480" cy="365760"/>
+            <a:off x="3246120" y="2761488"/>
+            <a:ext cx="7863840" cy="411480"/>
           </a:xfrm>
           <a:prstGeom prst="rect">
             <a:avLst/>
@@ -10078,7 +10253,7 @@
             <a:r>
               <a:rPr lang="en-US" sz="2500" b="1" dirty="0">
                 <a:solidFill>
-                  <a:srgbClr val="086679"/>
+                  <a:srgbClr val="083E4F"/>
                 </a:solidFill>
                 <a:latin typeface="Arial" pitchFamily="34" charset="0"/>
                 <a:ea typeface="Arial" pitchFamily="34" charset="-122"/>
@@ -10092,14 +10267,39 @@
       </p:sp>
       <p:sp>
         <p:nvSpPr>
-          <p:cNvPr id="10" name="Text 8"/>
+          <p:cNvPr id="11" name="Shape 9"/>
           <p:cNvSpPr/>
           <p:nvPr/>
         </p:nvSpPr>
         <p:spPr>
           <a:xfrm>
-            <a:off x="950976" y="3813048"/>
-            <a:ext cx="1508760" cy="365760"/>
+            <a:off x="886968" y="3566160"/>
+            <a:ext cx="201168" cy="201168"/>
+          </a:xfrm>
+          <a:prstGeom prst="ellipse">
+            <a:avLst/>
+          </a:prstGeom>
+          <a:solidFill>
+            <a:srgbClr val="086679"/>
+          </a:solidFill>
+          <a:ln w="12700">
+            <a:solidFill>
+              <a:srgbClr val="086679"/>
+            </a:solidFill>
+            <a:prstDash val="solid"/>
+          </a:ln>
+        </p:spPr>
+      </p:sp>
+      <p:sp>
+        <p:nvSpPr>
+          <p:cNvPr id="12" name="Text 10"/>
+          <p:cNvSpPr/>
+          <p:nvPr/>
+        </p:nvSpPr>
+        <p:spPr>
+          <a:xfrm>
+            <a:off x="1353312" y="3465576"/>
+            <a:ext cx="1645920" cy="411480"/>
           </a:xfrm>
           <a:prstGeom prst="rect">
             <a:avLst/>
@@ -10115,7 +10315,7 @@
               <a:buNone/>
             </a:pPr>
             <a:r>
-              <a:rPr lang="en-US" sz="2100" dirty="0">
+              <a:rPr lang="en-US" sz="2200" dirty="0">
                 <a:solidFill>
                   <a:srgbClr val="405965"/>
                 </a:solidFill>
@@ -10125,20 +10325,20 @@
               </a:rPr>
               <a:t>Reviewer</a:t>
             </a:r>
-            <a:endParaRPr lang="en-US" sz="2100" dirty="0"/>
-          </a:p>
-        </p:txBody>
-      </p:sp>
-      <p:sp>
-        <p:nvSpPr>
-          <p:cNvPr id="11" name="Text 9"/>
+            <a:endParaRPr lang="en-US" sz="2200" dirty="0"/>
+          </a:p>
+        </p:txBody>
+      </p:sp>
+      <p:sp>
+        <p:nvSpPr>
+          <p:cNvPr id="13" name="Text 11"/>
           <p:cNvSpPr/>
           <p:nvPr/>
         </p:nvSpPr>
         <p:spPr>
           <a:xfrm>
-            <a:off x="2743200" y="3813048"/>
-            <a:ext cx="8412480" cy="365760"/>
+            <a:off x="3246120" y="3465576"/>
+            <a:ext cx="7863840" cy="411480"/>
           </a:xfrm>
           <a:prstGeom prst="rect">
             <a:avLst/>
@@ -10170,14 +10370,39 @@
       </p:sp>
       <p:sp>
         <p:nvSpPr>
-          <p:cNvPr id="12" name="Text 10"/>
+          <p:cNvPr id="14" name="Shape 12"/>
           <p:cNvSpPr/>
           <p:nvPr/>
         </p:nvSpPr>
         <p:spPr>
           <a:xfrm>
-            <a:off x="950976" y="4407408"/>
-            <a:ext cx="1508760" cy="365760"/>
+            <a:off x="886968" y="4270248"/>
+            <a:ext cx="201168" cy="201168"/>
+          </a:xfrm>
+          <a:prstGeom prst="ellipse">
+            <a:avLst/>
+          </a:prstGeom>
+          <a:solidFill>
+            <a:srgbClr val="086679"/>
+          </a:solidFill>
+          <a:ln w="12700">
+            <a:solidFill>
+              <a:srgbClr val="086679"/>
+            </a:solidFill>
+            <a:prstDash val="solid"/>
+          </a:ln>
+        </p:spPr>
+      </p:sp>
+      <p:sp>
+        <p:nvSpPr>
+          <p:cNvPr id="15" name="Text 13"/>
+          <p:cNvSpPr/>
+          <p:nvPr/>
+        </p:nvSpPr>
+        <p:spPr>
+          <a:xfrm>
+            <a:off x="1353312" y="4169664"/>
+            <a:ext cx="1645920" cy="411480"/>
           </a:xfrm>
           <a:prstGeom prst="rect">
             <a:avLst/>
@@ -10193,7 +10418,7 @@
               <a:buNone/>
             </a:pPr>
             <a:r>
-              <a:rPr lang="en-US" sz="2100" dirty="0">
+              <a:rPr lang="en-US" sz="2200" dirty="0">
                 <a:solidFill>
                   <a:srgbClr val="405965"/>
                 </a:solidFill>
@@ -10203,20 +10428,45 @@
               </a:rPr>
               <a:t>Rui</a:t>
             </a:r>
-            <a:endParaRPr lang="en-US" sz="2100" dirty="0"/>
-          </a:p>
-        </p:txBody>
-      </p:sp>
-      <p:sp>
-        <p:nvSpPr>
-          <p:cNvPr id="13" name="Text 11"/>
+            <a:endParaRPr lang="en-US" sz="2200" dirty="0"/>
+          </a:p>
+        </p:txBody>
+      </p:sp>
+      <p:sp>
+        <p:nvSpPr>
+          <p:cNvPr id="16" name="Shape 14"/>
           <p:cNvSpPr/>
           <p:nvPr/>
         </p:nvSpPr>
         <p:spPr>
           <a:xfrm>
-            <a:off x="2743200" y="4407408"/>
-            <a:ext cx="8412480" cy="365760"/>
+            <a:off x="3063240" y="4096512"/>
+            <a:ext cx="8183880" cy="530352"/>
+          </a:xfrm>
+          <a:prstGeom prst="rect">
+            <a:avLst/>
+          </a:prstGeom>
+          <a:solidFill>
+            <a:srgbClr val="EAF1F3"/>
+          </a:solidFill>
+          <a:ln w="12700">
+            <a:solidFill>
+              <a:srgbClr val="EAF1F3"/>
+            </a:solidFill>
+            <a:prstDash val="solid"/>
+          </a:ln>
+        </p:spPr>
+      </p:sp>
+      <p:sp>
+        <p:nvSpPr>
+          <p:cNvPr id="17" name="Text 15"/>
+          <p:cNvSpPr/>
+          <p:nvPr/>
+        </p:nvSpPr>
+        <p:spPr>
+          <a:xfrm>
+            <a:off x="3246120" y="4169664"/>
+            <a:ext cx="7863840" cy="411480"/>
           </a:xfrm>
           <a:prstGeom prst="rect">
             <a:avLst/>
@@ -10234,7 +10484,7 @@
             <a:r>
               <a:rPr lang="en-US" sz="2500" b="1" dirty="0">
                 <a:solidFill>
-                  <a:srgbClr val="086679"/>
+                  <a:srgbClr val="083E4F"/>
                 </a:solidFill>
                 <a:latin typeface="Arial" pitchFamily="34" charset="0"/>
                 <a:ea typeface="Arial" pitchFamily="34" charset="-122"/>
@@ -10248,14 +10498,39 @@
       </p:sp>
       <p:sp>
         <p:nvSpPr>
-          <p:cNvPr id="14" name="Text 12"/>
+          <p:cNvPr id="18" name="Shape 16"/>
           <p:cNvSpPr/>
           <p:nvPr/>
         </p:nvSpPr>
         <p:spPr>
           <a:xfrm>
-            <a:off x="950976" y="5001768"/>
-            <a:ext cx="1508760" cy="365760"/>
+            <a:off x="886968" y="4974336"/>
+            <a:ext cx="201168" cy="201168"/>
+          </a:xfrm>
+          <a:prstGeom prst="ellipse">
+            <a:avLst/>
+          </a:prstGeom>
+          <a:solidFill>
+            <a:srgbClr val="086679"/>
+          </a:solidFill>
+          <a:ln w="12700">
+            <a:solidFill>
+              <a:srgbClr val="086679"/>
+            </a:solidFill>
+            <a:prstDash val="solid"/>
+          </a:ln>
+        </p:spPr>
+      </p:sp>
+      <p:sp>
+        <p:nvSpPr>
+          <p:cNvPr id="19" name="Text 17"/>
+          <p:cNvSpPr/>
+          <p:nvPr/>
+        </p:nvSpPr>
+        <p:spPr>
+          <a:xfrm>
+            <a:off x="1353312" y="4873752"/>
+            <a:ext cx="1645920" cy="411480"/>
           </a:xfrm>
           <a:prstGeom prst="rect">
             <a:avLst/>
@@ -10271,7 +10546,7 @@
               <a:buNone/>
             </a:pPr>
             <a:r>
-              <a:rPr lang="en-US" sz="2100" dirty="0">
+              <a:rPr lang="en-US" sz="2200" dirty="0">
                 <a:solidFill>
                   <a:srgbClr val="405965"/>
                 </a:solidFill>
@@ -10281,20 +10556,20 @@
               </a:rPr>
               <a:t>Atlantis</a:t>
             </a:r>
-            <a:endParaRPr lang="en-US" sz="2100" dirty="0"/>
-          </a:p>
-        </p:txBody>
-      </p:sp>
-      <p:sp>
-        <p:nvSpPr>
-          <p:cNvPr id="15" name="Text 13"/>
+            <a:endParaRPr lang="en-US" sz="2200" dirty="0"/>
+          </a:p>
+        </p:txBody>
+      </p:sp>
+      <p:sp>
+        <p:nvSpPr>
+          <p:cNvPr id="20" name="Text 18"/>
           <p:cNvSpPr/>
           <p:nvPr/>
         </p:nvSpPr>
         <p:spPr>
           <a:xfrm>
-            <a:off x="2743200" y="5001768"/>
-            <a:ext cx="8412480" cy="365760"/>
+            <a:off x="3246120" y="4873752"/>
+            <a:ext cx="7863840" cy="411480"/>
           </a:xfrm>
           <a:prstGeom prst="rect">
             <a:avLst/>
@@ -10326,14 +10601,14 @@
       </p:sp>
       <p:sp>
         <p:nvSpPr>
-          <p:cNvPr id="16" name="Text 14"/>
+          <p:cNvPr id="21" name="Text 19"/>
           <p:cNvSpPr/>
           <p:nvPr/>
         </p:nvSpPr>
         <p:spPr>
           <a:xfrm>
-            <a:off x="932688" y="5504688"/>
-            <a:ext cx="10332720" cy="274320"/>
+            <a:off x="804672" y="5650992"/>
+            <a:ext cx="10698480" cy="320040"/>
           </a:xfrm>
           <a:prstGeom prst="rect">
             <a:avLst/>
@@ -10513,8 +10788,8 @@
         </p:nvSpPr>
         <p:spPr>
           <a:xfrm>
-            <a:off x="777240" y="2487168"/>
-            <a:ext cx="365760" cy="365760"/>
+            <a:off x="877824" y="2587752"/>
+            <a:ext cx="219456" cy="219456"/>
           </a:xfrm>
           <a:prstGeom prst="ellipse">
             <a:avLst/>
@@ -10532,14 +10807,39 @@
       </p:sp>
       <p:sp>
         <p:nvSpPr>
-          <p:cNvPr id="6" name="Text 4"/>
+          <p:cNvPr id="6" name="Shape 4"/>
           <p:cNvSpPr/>
           <p:nvPr/>
         </p:nvSpPr>
         <p:spPr>
           <a:xfrm>
+            <a:off x="987552" y="2880360"/>
+            <a:ext cx="0" cy="649224"/>
+          </a:xfrm>
+          <a:prstGeom prst="line">
+            <a:avLst/>
+          </a:prstGeom>
+          <a:noFill/>
+          <a:ln w="25400">
+            <a:solidFill>
+              <a:srgbClr val="086679"/>
+            </a:solidFill>
+            <a:prstDash val="solid"/>
+            <a:headEnd type="none"/>
+            <a:tailEnd type="triangle"/>
+          </a:ln>
+        </p:spPr>
+      </p:sp>
+      <p:sp>
+        <p:nvSpPr>
+          <p:cNvPr id="7" name="Text 5"/>
+          <p:cNvSpPr/>
+          <p:nvPr/>
+        </p:nvSpPr>
+        <p:spPr>
+          <a:xfrm>
             <a:off x="1417320" y="2423160"/>
-            <a:ext cx="2834640" cy="530352"/>
+            <a:ext cx="3246120" cy="502920"/>
           </a:xfrm>
           <a:prstGeom prst="rect">
             <a:avLst/>
@@ -10555,7 +10855,7 @@
               <a:buNone/>
             </a:pPr>
             <a:r>
-              <a:rPr lang="en-US" sz="3100" b="1" dirty="0">
+              <a:rPr lang="en-US" sz="2900" b="1" dirty="0">
                 <a:solidFill>
                   <a:srgbClr val="086679"/>
                 </a:solidFill>
@@ -10563,22 +10863,22 @@
                 <a:ea typeface="Arial" pitchFamily="34" charset="-122"/>
                 <a:cs typeface="Arial" pitchFamily="34" charset="-120"/>
               </a:rPr>
-              <a:t>Visible</a:t>
+              <a:t>Collaborative</a:t>
             </a:r>
-            <a:endParaRPr lang="en-US" sz="3100" dirty="0"/>
-          </a:p>
-        </p:txBody>
-      </p:sp>
-      <p:sp>
-        <p:nvSpPr>
-          <p:cNvPr id="7" name="Text 5"/>
+            <a:endParaRPr lang="en-US" sz="2900" dirty="0"/>
+          </a:p>
+        </p:txBody>
+      </p:sp>
+      <p:sp>
+        <p:nvSpPr>
+          <p:cNvPr id="8" name="Text 6"/>
           <p:cNvSpPr/>
           <p:nvPr/>
         </p:nvSpPr>
         <p:spPr>
           <a:xfrm>
-            <a:off x="4572000" y="2423160"/>
-            <a:ext cx="6492240" cy="594360"/>
+            <a:off x="4892040" y="2423160"/>
+            <a:ext cx="6400800" cy="548640"/>
           </a:xfrm>
           <a:prstGeom prst="rect">
             <a:avLst/>
@@ -10594,7 +10894,7 @@
               <a:buNone/>
             </a:pPr>
             <a:r>
-              <a:rPr lang="en-US" sz="2600" dirty="0">
+              <a:rPr lang="en-US" sz="2800" dirty="0">
                 <a:solidFill>
                   <a:srgbClr val="083E4F"/>
                 </a:solidFill>
@@ -10602,22 +10902,22 @@
                 <a:ea typeface="Arial" pitchFamily="34" charset="-122"/>
                 <a:cs typeface="Arial" pitchFamily="34" charset="-120"/>
               </a:rPr>
-              <a:t>Plan + result beside the code</a:t>
+              <a:t>Developers propose</a:t>
             </a:r>
-            <a:endParaRPr lang="en-US" sz="2600" dirty="0"/>
-          </a:p>
-        </p:txBody>
-      </p:sp>
-      <p:sp>
-        <p:nvSpPr>
-          <p:cNvPr id="8" name="Shape 6"/>
+            <a:endParaRPr lang="en-US" sz="2800" dirty="0"/>
+          </a:p>
+        </p:txBody>
+      </p:sp>
+      <p:sp>
+        <p:nvSpPr>
+          <p:cNvPr id="9" name="Shape 7"/>
           <p:cNvSpPr/>
           <p:nvPr/>
         </p:nvSpPr>
         <p:spPr>
           <a:xfrm>
-            <a:off x="777240" y="3566160"/>
-            <a:ext cx="365760" cy="365760"/>
+            <a:off x="877824" y="3648456"/>
+            <a:ext cx="219456" cy="219456"/>
           </a:xfrm>
           <a:prstGeom prst="ellipse">
             <a:avLst/>
@@ -10635,14 +10935,39 @@
       </p:sp>
       <p:sp>
         <p:nvSpPr>
-          <p:cNvPr id="9" name="Text 7"/>
+          <p:cNvPr id="10" name="Shape 8"/>
           <p:cNvSpPr/>
           <p:nvPr/>
         </p:nvSpPr>
         <p:spPr>
           <a:xfrm>
-            <a:off x="1417320" y="3502152"/>
-            <a:ext cx="2834640" cy="530352"/>
+            <a:off x="987552" y="3941064"/>
+            <a:ext cx="0" cy="649224"/>
+          </a:xfrm>
+          <a:prstGeom prst="line">
+            <a:avLst/>
+          </a:prstGeom>
+          <a:noFill/>
+          <a:ln w="25400">
+            <a:solidFill>
+              <a:srgbClr val="086679"/>
+            </a:solidFill>
+            <a:prstDash val="solid"/>
+            <a:headEnd type="none"/>
+            <a:tailEnd type="triangle"/>
+          </a:ln>
+        </p:spPr>
+      </p:sp>
+      <p:sp>
+        <p:nvSpPr>
+          <p:cNvPr id="11" name="Text 9"/>
+          <p:cNvSpPr/>
+          <p:nvPr/>
+        </p:nvSpPr>
+        <p:spPr>
+          <a:xfrm>
+            <a:off x="1417320" y="3483864"/>
+            <a:ext cx="3246120" cy="502920"/>
           </a:xfrm>
           <a:prstGeom prst="rect">
             <a:avLst/>
@@ -10658,7 +10983,7 @@
               <a:buNone/>
             </a:pPr>
             <a:r>
-              <a:rPr lang="en-US" sz="3100" b="1" dirty="0">
+              <a:rPr lang="en-US" sz="2900" b="1" dirty="0">
                 <a:solidFill>
                   <a:srgbClr val="086679"/>
                 </a:solidFill>
@@ -10668,20 +10993,20 @@
               </a:rPr>
               <a:t>Controlled</a:t>
             </a:r>
-            <a:endParaRPr lang="en-US" sz="3100" dirty="0"/>
-          </a:p>
-        </p:txBody>
-      </p:sp>
-      <p:sp>
-        <p:nvSpPr>
-          <p:cNvPr id="10" name="Text 8"/>
+            <a:endParaRPr lang="en-US" sz="2900" dirty="0"/>
+          </a:p>
+        </p:txBody>
+      </p:sp>
+      <p:sp>
+        <p:nvSpPr>
+          <p:cNvPr id="12" name="Text 10"/>
           <p:cNvSpPr/>
           <p:nvPr/>
         </p:nvSpPr>
         <p:spPr>
           <a:xfrm>
-            <a:off x="4572000" y="3502152"/>
-            <a:ext cx="6492240" cy="594360"/>
+            <a:off x="4892040" y="3483864"/>
+            <a:ext cx="6400800" cy="548640"/>
           </a:xfrm>
           <a:prstGeom prst="rect">
             <a:avLst/>
@@ -10697,7 +11022,7 @@
               <a:buNone/>
             </a:pPr>
             <a:r>
-              <a:rPr lang="en-US" sz="2600" dirty="0">
+              <a:rPr lang="en-US" sz="2800" dirty="0">
                 <a:solidFill>
                   <a:srgbClr val="083E4F"/>
                 </a:solidFill>
@@ -10705,22 +11030,22 @@
                 <a:ea typeface="Arial" pitchFamily="34" charset="-122"/>
                 <a:cs typeface="Arial" pitchFamily="34" charset="-120"/>
               </a:rPr>
-              <a:t>Centralized execution + requirements</a:t>
+              <a:t>Platform rules govern execution</a:t>
             </a:r>
-            <a:endParaRPr lang="en-US" sz="2600" dirty="0"/>
-          </a:p>
-        </p:txBody>
-      </p:sp>
-      <p:sp>
-        <p:nvSpPr>
-          <p:cNvPr id="11" name="Shape 9"/>
+            <a:endParaRPr lang="en-US" sz="2800" dirty="0"/>
+          </a:p>
+        </p:txBody>
+      </p:sp>
+      <p:sp>
+        <p:nvSpPr>
+          <p:cNvPr id="13" name="Shape 11"/>
           <p:cNvSpPr/>
           <p:nvPr/>
         </p:nvSpPr>
         <p:spPr>
           <a:xfrm>
-            <a:off x="777240" y="4645152"/>
-            <a:ext cx="365760" cy="365760"/>
+            <a:off x="877824" y="4709160"/>
+            <a:ext cx="219456" cy="219456"/>
           </a:xfrm>
           <a:prstGeom prst="ellipse">
             <a:avLst/>
@@ -10738,14 +11063,14 @@
       </p:sp>
       <p:sp>
         <p:nvSpPr>
-          <p:cNvPr id="12" name="Text 10"/>
+          <p:cNvPr id="14" name="Text 12"/>
           <p:cNvSpPr/>
           <p:nvPr/>
         </p:nvSpPr>
         <p:spPr>
           <a:xfrm>
-            <a:off x="1417320" y="4581144"/>
-            <a:ext cx="2834640" cy="530352"/>
+            <a:off x="1417320" y="4544568"/>
+            <a:ext cx="3246120" cy="502920"/>
           </a:xfrm>
           <a:prstGeom prst="rect">
             <a:avLst/>
@@ -10761,7 +11086,7 @@
               <a:buNone/>
             </a:pPr>
             <a:r>
-              <a:rPr lang="en-US" sz="3100" b="1" dirty="0">
+              <a:rPr lang="en-US" sz="2900" b="1" dirty="0">
                 <a:solidFill>
                   <a:srgbClr val="086679"/>
                 </a:solidFill>
@@ -10769,22 +11094,22 @@
                 <a:ea typeface="Arial" pitchFamily="34" charset="-122"/>
                 <a:cs typeface="Arial" pitchFamily="34" charset="-120"/>
               </a:rPr>
-              <a:t>Collaborative</a:t>
+              <a:t>Visible</a:t>
             </a:r>
-            <a:endParaRPr lang="en-US" sz="3100" dirty="0"/>
-          </a:p>
-        </p:txBody>
-      </p:sp>
-      <p:sp>
-        <p:nvSpPr>
-          <p:cNvPr id="13" name="Text 11"/>
+            <a:endParaRPr lang="en-US" sz="2900" dirty="0"/>
+          </a:p>
+        </p:txBody>
+      </p:sp>
+      <p:sp>
+        <p:nvSpPr>
+          <p:cNvPr id="15" name="Text 13"/>
           <p:cNvSpPr/>
           <p:nvPr/>
         </p:nvSpPr>
         <p:spPr>
           <a:xfrm>
-            <a:off x="4572000" y="4581144"/>
-            <a:ext cx="6492240" cy="594360"/>
+            <a:off x="4892040" y="4544568"/>
+            <a:ext cx="6400800" cy="548640"/>
           </a:xfrm>
           <a:prstGeom prst="rect">
             <a:avLst/>
@@ -10800,7 +11125,7 @@
               <a:buNone/>
             </a:pPr>
             <a:r>
-              <a:rPr lang="en-US" sz="2600" dirty="0">
+              <a:rPr lang="en-US" sz="2800" dirty="0">
                 <a:solidFill>
                   <a:srgbClr val="083E4F"/>
                 </a:solidFill>
@@ -10808,9 +11133,9 @@
                 <a:ea typeface="Arial" pitchFamily="34" charset="-122"/>
                 <a:cs typeface="Arial" pitchFamily="34" charset="-120"/>
               </a:rPr>
-              <a:t>Developers propose; platform rules govern</a:t>
+              <a:t>Plan + result beside the code</a:t>
             </a:r>
-            <a:endParaRPr lang="en-US" sz="2600" dirty="0"/>
+            <a:endParaRPr lang="en-US" sz="2800" dirty="0"/>
           </a:p>
         </p:txBody>
       </p:sp>
@@ -10958,14 +11283,92 @@
       </p:sp>
       <p:sp>
         <p:nvSpPr>
-          <p:cNvPr id="5" name="Shape 3"/>
+          <p:cNvPr id="5" name="Text 3"/>
           <p:cNvSpPr/>
           <p:nvPr/>
         </p:nvSpPr>
         <p:spPr>
           <a:xfrm>
-            <a:off x="731520" y="2606040"/>
-            <a:ext cx="3703320" cy="1920240"/>
+            <a:off x="731520" y="2907792"/>
+            <a:ext cx="2926080" cy="457200"/>
+          </a:xfrm>
+          <a:prstGeom prst="rect">
+            <a:avLst/>
+          </a:prstGeom>
+          <a:noFill/>
+          <a:ln/>
+        </p:spPr>
+        <p:txBody>
+          <a:bodyPr wrap="square" lIns="0" tIns="0" rIns="0" bIns="0" rtlCol="0" anchor="ctr"/>
+          <a:lstStyle/>
+          <a:p>
+            <a:pPr algn="ctr" indent="0" marL="0">
+              <a:buNone/>
+            </a:pPr>
+            <a:r>
+              <a:rPr lang="en-US" sz="2800" b="1" dirty="0">
+                <a:solidFill>
+                  <a:srgbClr val="083E4F"/>
+                </a:solidFill>
+                <a:latin typeface="Arial" pitchFamily="34" charset="0"/>
+                <a:ea typeface="Arial" pitchFamily="34" charset="-122"/>
+                <a:cs typeface="Arial" pitchFamily="34" charset="-120"/>
+              </a:rPr>
+              <a:t>Git providers</a:t>
+            </a:r>
+            <a:endParaRPr lang="en-US" sz="2800" dirty="0"/>
+          </a:p>
+        </p:txBody>
+      </p:sp>
+      <p:sp>
+        <p:nvSpPr>
+          <p:cNvPr id="6" name="Text 4"/>
+          <p:cNvSpPr/>
+          <p:nvPr/>
+        </p:nvSpPr>
+        <p:spPr>
+          <a:xfrm>
+            <a:off x="731520" y="3502152"/>
+            <a:ext cx="2926080" cy="731520"/>
+          </a:xfrm>
+          <a:prstGeom prst="rect">
+            <a:avLst/>
+          </a:prstGeom>
+          <a:noFill/>
+          <a:ln/>
+        </p:spPr>
+        <p:txBody>
+          <a:bodyPr wrap="square" lIns="0" tIns="0" rIns="0" bIns="0" rtlCol="0" anchor="ctr"/>
+          <a:lstStyle/>
+          <a:p>
+            <a:pPr algn="ctr" indent="0" marL="0">
+              <a:buNone/>
+            </a:pPr>
+            <a:r>
+              <a:rPr lang="en-US" sz="2200" dirty="0">
+                <a:solidFill>
+                  <a:srgbClr val="405965"/>
+                </a:solidFill>
+                <a:latin typeface="Arial" pitchFamily="34" charset="0"/>
+                <a:ea typeface="Arial" pitchFamily="34" charset="-122"/>
+                <a:cs typeface="Arial" pitchFamily="34" charset="-120"/>
+              </a:rPr>
+              <a:t>GitHub · GitLab</a:t>
+            </a:r>
+            <a:endParaRPr lang="en-US" sz="2200" dirty="0"/>
+          </a:p>
+        </p:txBody>
+      </p:sp>
+      <p:sp>
+        <p:nvSpPr>
+          <p:cNvPr id="7" name="Shape 5"/>
+          <p:cNvSpPr/>
+          <p:nvPr/>
+        </p:nvSpPr>
+        <p:spPr>
+          <a:xfrm>
+            <a:off x="4617720" y="2816352"/>
+            <a:ext cx="2971800" cy="1280160"/>
           </a:xfrm>
           <a:prstGeom prst="rect">
             <a:avLst/>
@@ -10983,134 +11386,14 @@
       </p:sp>
       <p:sp>
         <p:nvSpPr>
-          <p:cNvPr id="6" name="Text 4"/>
+          <p:cNvPr id="8" name="Text 6"/>
           <p:cNvSpPr/>
           <p:nvPr/>
         </p:nvSpPr>
         <p:spPr>
           <a:xfrm>
-            <a:off x="932688" y="2743200"/>
-            <a:ext cx="3300984" cy="393192"/>
-          </a:xfrm>
-          <a:prstGeom prst="rect">
-            <a:avLst/>
-          </a:prstGeom>
-          <a:noFill/>
-          <a:ln/>
-        </p:spPr>
-        <p:txBody>
-          <a:bodyPr wrap="square" lIns="0" tIns="0" rIns="0" bIns="0" rtlCol="0" anchor="ctr"/>
-          <a:lstStyle/>
-          <a:p>
-            <a:pPr indent="0" marL="0">
-              <a:buNone/>
-            </a:pPr>
-            <a:r>
-              <a:rPr lang="en-US" sz="2700" b="1" dirty="0">
-                <a:solidFill>
-                  <a:srgbClr val="083E4F"/>
-                </a:solidFill>
-                <a:latin typeface="Arial" pitchFamily="34" charset="0"/>
-                <a:ea typeface="Arial" pitchFamily="34" charset="-122"/>
-                <a:cs typeface="Arial" pitchFamily="34" charset="-120"/>
-              </a:rPr>
-              <a:t>Git provider</a:t>
-            </a:r>
-            <a:endParaRPr lang="en-US" sz="2700" dirty="0"/>
-          </a:p>
-        </p:txBody>
-      </p:sp>
-      <p:sp>
-        <p:nvSpPr>
-          <p:cNvPr id="7" name="Text 5"/>
-          <p:cNvSpPr/>
-          <p:nvPr/>
-        </p:nvSpPr>
-        <p:spPr>
-          <a:xfrm>
-            <a:off x="932688" y="3291840"/>
-            <a:ext cx="3300984" cy="822960"/>
-          </a:xfrm>
-          <a:prstGeom prst="rect">
-            <a:avLst/>
-          </a:prstGeom>
-          <a:noFill/>
-          <a:ln/>
-        </p:spPr>
-        <p:txBody>
-          <a:bodyPr wrap="square" lIns="0" tIns="0" rIns="0" bIns="0" rtlCol="0" anchor="ctr"/>
-          <a:lstStyle/>
-          <a:p>
-            <a:pPr indent="0" marL="0">
-              <a:buNone/>
-            </a:pPr>
-            <a:r>
-              <a:rPr lang="en-US" sz="2400" dirty="0">
-                <a:solidFill>
-                  <a:srgbClr val="405965"/>
-                </a:solidFill>
-                <a:latin typeface="Arial" pitchFamily="34" charset="0"/>
-                <a:ea typeface="Arial" pitchFamily="34" charset="-122"/>
-                <a:cs typeface="Arial" pitchFamily="34" charset="-120"/>
-              </a:rPr>
-              <a:t>Examples:</a:t>
-            </a:r>
-            <a:endParaRPr lang="en-US" sz="2400" dirty="0"/>
-          </a:p>
-          <a:p>
-            <a:pPr indent="0" marL="0">
-              <a:buNone/>
-            </a:pPr>
-            <a:r>
-              <a:rPr lang="en-US" sz="2400" dirty="0">
-                <a:solidFill>
-                  <a:srgbClr val="405965"/>
-                </a:solidFill>
-                <a:latin typeface="Arial" pitchFamily="34" charset="0"/>
-                <a:ea typeface="Arial" pitchFamily="34" charset="-122"/>
-                <a:cs typeface="Arial" pitchFamily="34" charset="-120"/>
-              </a:rPr>
-              <a:t>GitHub · GitLab</a:t>
-            </a:r>
-            <a:endParaRPr lang="en-US" sz="2400" dirty="0"/>
-          </a:p>
-        </p:txBody>
-      </p:sp>
-      <p:sp>
-        <p:nvSpPr>
-          <p:cNvPr id="8" name="Shape 6"/>
-          <p:cNvSpPr/>
-          <p:nvPr/>
-        </p:nvSpPr>
-        <p:spPr>
-          <a:xfrm>
-            <a:off x="5074920" y="2971800"/>
-            <a:ext cx="2377440" cy="1234440"/>
-          </a:xfrm>
-          <a:prstGeom prst="rect">
-            <a:avLst/>
-          </a:prstGeom>
-          <a:solidFill>
-            <a:srgbClr val="EAF1F3"/>
-          </a:solidFill>
-          <a:ln w="12700">
-            <a:solidFill>
-              <a:srgbClr val="EAF1F3"/>
-            </a:solidFill>
-            <a:prstDash val="solid"/>
-          </a:ln>
-        </p:spPr>
-      </p:sp>
-      <p:sp>
-        <p:nvSpPr>
-          <p:cNvPr id="9" name="Text 7"/>
-          <p:cNvSpPr/>
-          <p:nvPr/>
-        </p:nvSpPr>
-        <p:spPr>
-          <a:xfrm>
-            <a:off x="5276088" y="3108960"/>
-            <a:ext cx="1975104" cy="393192"/>
+            <a:off x="4818888" y="2953512"/>
+            <a:ext cx="2569464" cy="393192"/>
           </a:xfrm>
           <a:prstGeom prst="rect">
             <a:avLst/>
@@ -11142,14 +11425,14 @@
       </p:sp>
       <p:sp>
         <p:nvSpPr>
-          <p:cNvPr id="10" name="Text 8"/>
+          <p:cNvPr id="9" name="Text 7"/>
           <p:cNvSpPr/>
           <p:nvPr/>
         </p:nvSpPr>
         <p:spPr>
           <a:xfrm>
-            <a:off x="5276088" y="3593592"/>
-            <a:ext cx="1975104" cy="329184"/>
+            <a:off x="4818888" y="3438144"/>
+            <a:ext cx="2569464" cy="329184"/>
           </a:xfrm>
           <a:prstGeom prst="rect">
             <a:avLst/>
@@ -11173,7 +11456,7 @@
                 <a:ea typeface="Arial" pitchFamily="34" charset="-122"/>
                 <a:cs typeface="Arial" pitchFamily="34" charset="-120"/>
               </a:rPr>
-              <a:t>Orchestration</a:t>
+              <a:t>PR orchestration</a:t>
             </a:r>
             <a:endParaRPr lang="en-US" sz="1900" dirty="0"/>
           </a:p>
@@ -11181,39 +11464,14 @@
       </p:sp>
       <p:sp>
         <p:nvSpPr>
-          <p:cNvPr id="11" name="Shape 9"/>
+          <p:cNvPr id="10" name="Text 8"/>
           <p:cNvSpPr/>
           <p:nvPr/>
         </p:nvSpPr>
         <p:spPr>
           <a:xfrm>
-            <a:off x="8092440" y="2606040"/>
-            <a:ext cx="3337560" cy="1920240"/>
-          </a:xfrm>
-          <a:prstGeom prst="rect">
-            <a:avLst/>
-          </a:prstGeom>
-          <a:solidFill>
-            <a:srgbClr val="EAF1F3"/>
-          </a:solidFill>
-          <a:ln w="12700">
-            <a:solidFill>
-              <a:srgbClr val="EAF1F3"/>
-            </a:solidFill>
-            <a:prstDash val="solid"/>
-          </a:ln>
-        </p:spPr>
-      </p:sp>
-      <p:sp>
-        <p:nvSpPr>
-          <p:cNvPr id="12" name="Text 10"/>
-          <p:cNvSpPr/>
-          <p:nvPr/>
-        </p:nvSpPr>
-        <p:spPr>
-          <a:xfrm>
-            <a:off x="8293608" y="2743200"/>
-            <a:ext cx="2935224" cy="393192"/>
+            <a:off x="8503920" y="2907792"/>
+            <a:ext cx="2971800" cy="457200"/>
           </a:xfrm>
           <a:prstGeom prst="rect">
             <a:avLst/>
@@ -11225,11 +11483,11 @@
           <a:bodyPr wrap="square" lIns="0" tIns="0" rIns="0" bIns="0" rtlCol="0" anchor="ctr"/>
           <a:lstStyle/>
           <a:p>
-            <a:pPr indent="0" marL="0">
+            <a:pPr algn="ctr" indent="0" marL="0">
               <a:buNone/>
             </a:pPr>
             <a:r>
-              <a:rPr lang="en-US" sz="2700" b="1" dirty="0">
+              <a:rPr lang="en-US" sz="2800" b="1" dirty="0">
                 <a:solidFill>
                   <a:srgbClr val="083E4F"/>
                 </a:solidFill>
@@ -11239,20 +11497,20 @@
               </a:rPr>
               <a:t>IaC execution</a:t>
             </a:r>
-            <a:endParaRPr lang="en-US" sz="2700" dirty="0"/>
-          </a:p>
-        </p:txBody>
-      </p:sp>
-      <p:sp>
-        <p:nvSpPr>
-          <p:cNvPr id="13" name="Text 11"/>
+            <a:endParaRPr lang="en-US" sz="2800" dirty="0"/>
+          </a:p>
+        </p:txBody>
+      </p:sp>
+      <p:sp>
+        <p:nvSpPr>
+          <p:cNvPr id="11" name="Text 9"/>
           <p:cNvSpPr/>
           <p:nvPr/>
         </p:nvSpPr>
         <p:spPr>
           <a:xfrm>
-            <a:off x="8293608" y="3291840"/>
-            <a:ext cx="2935224" cy="822960"/>
+            <a:off x="8503920" y="3502152"/>
+            <a:ext cx="2971800" cy="731520"/>
           </a:xfrm>
           <a:prstGeom prst="rect">
             <a:avLst/>
@@ -11264,13 +11522,13 @@
           <a:bodyPr wrap="square" lIns="0" tIns="0" rIns="0" bIns="0" rtlCol="0" anchor="ctr"/>
           <a:lstStyle/>
           <a:p>
-            <a:pPr indent="0" marL="0">
+            <a:pPr algn="ctr" indent="0" marL="0">
               <a:buNone/>
             </a:pPr>
             <a:r>
-              <a:rPr lang="en-US" sz="2500" b="1" dirty="0">
-                <a:solidFill>
-                  <a:srgbClr val="083E4F"/>
+              <a:rPr lang="en-US" sz="2200" dirty="0">
+                <a:solidFill>
+                  <a:srgbClr val="405965"/>
                 </a:solidFill>
                 <a:latin typeface="Arial" pitchFamily="34" charset="0"/>
                 <a:ea typeface="Arial" pitchFamily="34" charset="-122"/>
@@ -11278,20 +11536,20 @@
               </a:rPr>
               <a:t>Terraform / OpenTofu</a:t>
             </a:r>
-            <a:endParaRPr lang="en-US" sz="2500" dirty="0"/>
-          </a:p>
-        </p:txBody>
-      </p:sp>
-      <p:sp>
-        <p:nvSpPr>
-          <p:cNvPr id="14" name="Shape 12"/>
+            <a:endParaRPr lang="en-US" sz="2200" dirty="0"/>
+          </a:p>
+        </p:txBody>
+      </p:sp>
+      <p:sp>
+        <p:nvSpPr>
+          <p:cNvPr id="12" name="Shape 10"/>
           <p:cNvSpPr/>
           <p:nvPr/>
         </p:nvSpPr>
         <p:spPr>
           <a:xfrm>
-            <a:off x="4572000" y="3611880"/>
-            <a:ext cx="365760" cy="0"/>
+            <a:off x="3703320" y="3474720"/>
+            <a:ext cx="713232" cy="0"/>
           </a:xfrm>
           <a:prstGeom prst="line">
             <a:avLst/>
@@ -11309,14 +11567,14 @@
       </p:sp>
       <p:sp>
         <p:nvSpPr>
-          <p:cNvPr id="15" name="Shape 13"/>
+          <p:cNvPr id="13" name="Shape 11"/>
           <p:cNvSpPr/>
           <p:nvPr/>
         </p:nvSpPr>
         <p:spPr>
           <a:xfrm>
-            <a:off x="7589520" y="3611880"/>
-            <a:ext cx="365760" cy="0"/>
+            <a:off x="7790688" y="3474720"/>
+            <a:ext cx="512064" cy="0"/>
           </a:xfrm>
           <a:prstGeom prst="line">
             <a:avLst/>
@@ -11334,13 +11592,13 @@
       </p:sp>
       <p:sp>
         <p:nvSpPr>
-          <p:cNvPr id="16" name="Text 14"/>
+          <p:cNvPr id="14" name="Text 12"/>
           <p:cNvSpPr/>
           <p:nvPr/>
         </p:nvSpPr>
         <p:spPr>
           <a:xfrm>
-            <a:off x="731520" y="5303520"/>
+            <a:off x="731520" y="5257800"/>
             <a:ext cx="10789920" cy="594360"/>
           </a:xfrm>
           <a:prstGeom prst="rect">
@@ -11353,7 +11611,7 @@
           <a:bodyPr wrap="square" lIns="0" tIns="0" rIns="0" bIns="0" rtlCol="0" anchor="ctr"/>
           <a:lstStyle/>
           <a:p>
-            <a:pPr indent="0" marL="0">
+            <a:pPr algn="ctr" indent="0" marL="0">
               <a:buNone/>
             </a:pPr>
             <a:r>
@@ -11515,39 +11773,14 @@
       </p:sp>
       <p:sp>
         <p:nvSpPr>
-          <p:cNvPr id="5" name="Shape 3"/>
+          <p:cNvPr id="5" name="Text 3"/>
           <p:cNvSpPr/>
           <p:nvPr/>
         </p:nvSpPr>
         <p:spPr>
           <a:xfrm>
-            <a:off x="731520" y="3154680"/>
-            <a:ext cx="2423160" cy="1234440"/>
-          </a:xfrm>
-          <a:prstGeom prst="rect">
-            <a:avLst/>
-          </a:prstGeom>
-          <a:solidFill>
-            <a:srgbClr val="EAF1F3"/>
-          </a:solidFill>
-          <a:ln w="12700">
-            <a:solidFill>
-              <a:srgbClr val="EAF1F3"/>
-            </a:solidFill>
-            <a:prstDash val="solid"/>
-          </a:ln>
-        </p:spPr>
-      </p:sp>
-      <p:sp>
-        <p:nvSpPr>
-          <p:cNvPr id="6" name="Text 4"/>
-          <p:cNvSpPr/>
-          <p:nvPr/>
-        </p:nvSpPr>
-        <p:spPr>
-          <a:xfrm>
-            <a:off x="932688" y="3291840"/>
-            <a:ext cx="2020824" cy="393192"/>
+            <a:off x="731520" y="3063240"/>
+            <a:ext cx="2423160" cy="457200"/>
           </a:xfrm>
           <a:prstGeom prst="rect">
             <a:avLst/>
@@ -11559,11 +11792,11 @@
           <a:bodyPr wrap="square" lIns="0" tIns="0" rIns="0" bIns="0" rtlCol="0" anchor="ctr"/>
           <a:lstStyle/>
           <a:p>
-            <a:pPr indent="0" marL="0">
+            <a:pPr algn="ctr" indent="0" marL="0">
               <a:buNone/>
             </a:pPr>
             <a:r>
-              <a:rPr lang="en-US" sz="2700" b="1" dirty="0">
+              <a:rPr lang="en-US" sz="2800" b="1" dirty="0">
                 <a:solidFill>
                   <a:srgbClr val="083E4F"/>
                 </a:solidFill>
@@ -11573,20 +11806,20 @@
               </a:rPr>
               <a:t>Plan</a:t>
             </a:r>
-            <a:endParaRPr lang="en-US" sz="2700" dirty="0"/>
-          </a:p>
-        </p:txBody>
-      </p:sp>
-      <p:sp>
-        <p:nvSpPr>
-          <p:cNvPr id="7" name="Text 5"/>
+            <a:endParaRPr lang="en-US" sz="2800" dirty="0"/>
+          </a:p>
+        </p:txBody>
+      </p:sp>
+      <p:sp>
+        <p:nvSpPr>
+          <p:cNvPr id="6" name="Text 4"/>
           <p:cNvSpPr/>
           <p:nvPr/>
         </p:nvSpPr>
         <p:spPr>
           <a:xfrm>
-            <a:off x="932688" y="3776472"/>
-            <a:ext cx="2020824" cy="329184"/>
+            <a:off x="731520" y="3657600"/>
+            <a:ext cx="2423160" cy="731520"/>
           </a:xfrm>
           <a:prstGeom prst="rect">
             <a:avLst/>
@@ -11598,11 +11831,11 @@
           <a:bodyPr wrap="square" lIns="0" tIns="0" rIns="0" bIns="0" rtlCol="0" anchor="ctr"/>
           <a:lstStyle/>
           <a:p>
-            <a:pPr indent="0" marL="0">
+            <a:pPr algn="ctr" indent="0" marL="0">
               <a:buNone/>
             </a:pPr>
             <a:r>
-              <a:rPr lang="en-US" sz="1900" dirty="0">
+              <a:rPr lang="en-US" sz="2200" dirty="0">
                 <a:solidFill>
                   <a:srgbClr val="405965"/>
                 </a:solidFill>
@@ -11612,45 +11845,20 @@
               </a:rPr>
               <a:t>Review input</a:t>
             </a:r>
-            <a:endParaRPr lang="en-US" sz="1900" dirty="0"/>
-          </a:p>
-        </p:txBody>
-      </p:sp>
-      <p:sp>
-        <p:nvSpPr>
-          <p:cNvPr id="8" name="Shape 6"/>
+            <a:endParaRPr lang="en-US" sz="2200" dirty="0"/>
+          </a:p>
+        </p:txBody>
+      </p:sp>
+      <p:sp>
+        <p:nvSpPr>
+          <p:cNvPr id="7" name="Text 5"/>
           <p:cNvSpPr/>
           <p:nvPr/>
         </p:nvSpPr>
         <p:spPr>
           <a:xfrm>
-            <a:off x="4572000" y="2331720"/>
-            <a:ext cx="2880360" cy="1143000"/>
-          </a:xfrm>
-          <a:prstGeom prst="rect">
-            <a:avLst/>
-          </a:prstGeom>
-          <a:solidFill>
-            <a:srgbClr val="EAF1F3"/>
-          </a:solidFill>
-          <a:ln w="12700">
-            <a:solidFill>
-              <a:srgbClr val="EAF1F3"/>
-            </a:solidFill>
-            <a:prstDash val="solid"/>
-          </a:ln>
-        </p:spPr>
-      </p:sp>
-      <p:sp>
-        <p:nvSpPr>
-          <p:cNvPr id="9" name="Text 7"/>
-          <p:cNvSpPr/>
-          <p:nvPr/>
-        </p:nvSpPr>
-        <p:spPr>
-          <a:xfrm>
-            <a:off x="4773168" y="2468880"/>
-            <a:ext cx="2478024" cy="393192"/>
+            <a:off x="4526280" y="2240280"/>
+            <a:ext cx="2880360" cy="457200"/>
           </a:xfrm>
           <a:prstGeom prst="rect">
             <a:avLst/>
@@ -11662,11 +11870,11 @@
           <a:bodyPr wrap="square" lIns="0" tIns="0" rIns="0" bIns="0" rtlCol="0" anchor="ctr"/>
           <a:lstStyle/>
           <a:p>
-            <a:pPr indent="0" marL="0">
+            <a:pPr algn="ctr" indent="0" marL="0">
               <a:buNone/>
             </a:pPr>
             <a:r>
-              <a:rPr lang="en-US" sz="2700" b="1" dirty="0">
+              <a:rPr lang="en-US" sz="2800" b="1" dirty="0">
                 <a:solidFill>
                   <a:srgbClr val="083E4F"/>
                 </a:solidFill>
@@ -11676,20 +11884,20 @@
               </a:rPr>
               <a:t>Policy</a:t>
             </a:r>
-            <a:endParaRPr lang="en-US" sz="2700" dirty="0"/>
-          </a:p>
-        </p:txBody>
-      </p:sp>
-      <p:sp>
-        <p:nvSpPr>
-          <p:cNvPr id="10" name="Text 8"/>
+            <a:endParaRPr lang="en-US" sz="2800" dirty="0"/>
+          </a:p>
+        </p:txBody>
+      </p:sp>
+      <p:sp>
+        <p:nvSpPr>
+          <p:cNvPr id="8" name="Text 6"/>
           <p:cNvSpPr/>
           <p:nvPr/>
         </p:nvSpPr>
         <p:spPr>
           <a:xfrm>
-            <a:off x="4773168" y="2953512"/>
-            <a:ext cx="2478024" cy="329184"/>
+            <a:off x="4526280" y="2834640"/>
+            <a:ext cx="2880360" cy="731520"/>
           </a:xfrm>
           <a:prstGeom prst="rect">
             <a:avLst/>
@@ -11701,11 +11909,11 @@
           <a:bodyPr wrap="square" lIns="0" tIns="0" rIns="0" bIns="0" rtlCol="0" anchor="ctr"/>
           <a:lstStyle/>
           <a:p>
-            <a:pPr indent="0" marL="0">
+            <a:pPr algn="ctr" indent="0" marL="0">
               <a:buNone/>
             </a:pPr>
             <a:r>
-              <a:rPr lang="en-US" sz="1900" dirty="0">
+              <a:rPr lang="en-US" sz="2200" dirty="0">
                 <a:solidFill>
                   <a:srgbClr val="405965"/>
                 </a:solidFill>
@@ -11715,45 +11923,20 @@
               </a:rPr>
               <a:t>e.g. Conftest</a:t>
             </a:r>
-            <a:endParaRPr lang="en-US" sz="1900" dirty="0"/>
-          </a:p>
-        </p:txBody>
-      </p:sp>
-      <p:sp>
-        <p:nvSpPr>
-          <p:cNvPr id="11" name="Shape 9"/>
+            <a:endParaRPr lang="en-US" sz="2200" dirty="0"/>
+          </a:p>
+        </p:txBody>
+      </p:sp>
+      <p:sp>
+        <p:nvSpPr>
+          <p:cNvPr id="9" name="Text 7"/>
           <p:cNvSpPr/>
           <p:nvPr/>
         </p:nvSpPr>
         <p:spPr>
           <a:xfrm>
-            <a:off x="4572000" y="4069080"/>
-            <a:ext cx="2880360" cy="1143000"/>
-          </a:xfrm>
-          <a:prstGeom prst="rect">
-            <a:avLst/>
-          </a:prstGeom>
-          <a:solidFill>
-            <a:srgbClr val="EAF1F3"/>
-          </a:solidFill>
-          <a:ln w="12700">
-            <a:solidFill>
-              <a:srgbClr val="EAF1F3"/>
-            </a:solidFill>
-            <a:prstDash val="solid"/>
-          </a:ln>
-        </p:spPr>
-      </p:sp>
-      <p:sp>
-        <p:nvSpPr>
-          <p:cNvPr id="12" name="Text 10"/>
-          <p:cNvSpPr/>
-          <p:nvPr/>
-        </p:nvSpPr>
-        <p:spPr>
-          <a:xfrm>
-            <a:off x="4773168" y="4206240"/>
-            <a:ext cx="2478024" cy="393192"/>
+            <a:off x="4526280" y="3977640"/>
+            <a:ext cx="2880360" cy="457200"/>
           </a:xfrm>
           <a:prstGeom prst="rect">
             <a:avLst/>
@@ -11765,11 +11948,11 @@
           <a:bodyPr wrap="square" lIns="0" tIns="0" rIns="0" bIns="0" rtlCol="0" anchor="ctr"/>
           <a:lstStyle/>
           <a:p>
-            <a:pPr indent="0" marL="0">
+            <a:pPr algn="ctr" indent="0" marL="0">
               <a:buNone/>
             </a:pPr>
             <a:r>
-              <a:rPr lang="en-US" sz="2700" b="1" dirty="0">
+              <a:rPr lang="en-US" sz="2800" b="1" dirty="0">
                 <a:solidFill>
                   <a:srgbClr val="083E4F"/>
                 </a:solidFill>
@@ -11779,20 +11962,20 @@
               </a:rPr>
               <a:t>Cost</a:t>
             </a:r>
-            <a:endParaRPr lang="en-US" sz="2700" dirty="0"/>
-          </a:p>
-        </p:txBody>
-      </p:sp>
-      <p:sp>
-        <p:nvSpPr>
-          <p:cNvPr id="13" name="Text 11"/>
+            <a:endParaRPr lang="en-US" sz="2800" dirty="0"/>
+          </a:p>
+        </p:txBody>
+      </p:sp>
+      <p:sp>
+        <p:nvSpPr>
+          <p:cNvPr id="10" name="Text 8"/>
           <p:cNvSpPr/>
           <p:nvPr/>
         </p:nvSpPr>
         <p:spPr>
           <a:xfrm>
-            <a:off x="4773168" y="4690872"/>
-            <a:ext cx="2478024" cy="329184"/>
+            <a:off x="4526280" y="4572000"/>
+            <a:ext cx="2880360" cy="731520"/>
           </a:xfrm>
           <a:prstGeom prst="rect">
             <a:avLst/>
@@ -11804,11 +11987,11 @@
           <a:bodyPr wrap="square" lIns="0" tIns="0" rIns="0" bIns="0" rtlCol="0" anchor="ctr"/>
           <a:lstStyle/>
           <a:p>
-            <a:pPr indent="0" marL="0">
+            <a:pPr algn="ctr" indent="0" marL="0">
               <a:buNone/>
             </a:pPr>
             <a:r>
-              <a:rPr lang="en-US" sz="1900" dirty="0">
+              <a:rPr lang="en-US" sz="2200" dirty="0">
                 <a:solidFill>
                   <a:srgbClr val="405965"/>
                 </a:solidFill>
@@ -11818,45 +12001,20 @@
               </a:rPr>
               <a:t>e.g. Infracost</a:t>
             </a:r>
-            <a:endParaRPr lang="en-US" sz="1900" dirty="0"/>
-          </a:p>
-        </p:txBody>
-      </p:sp>
-      <p:sp>
-        <p:nvSpPr>
-          <p:cNvPr id="14" name="Shape 12"/>
+            <a:endParaRPr lang="en-US" sz="2200" dirty="0"/>
+          </a:p>
+        </p:txBody>
+      </p:sp>
+      <p:sp>
+        <p:nvSpPr>
+          <p:cNvPr id="11" name="Text 9"/>
           <p:cNvSpPr/>
           <p:nvPr/>
         </p:nvSpPr>
         <p:spPr>
           <a:xfrm>
-            <a:off x="8869680" y="3154680"/>
-            <a:ext cx="2560320" cy="1234440"/>
-          </a:xfrm>
-          <a:prstGeom prst="rect">
-            <a:avLst/>
-          </a:prstGeom>
-          <a:solidFill>
-            <a:srgbClr val="EAF1F3"/>
-          </a:solidFill>
-          <a:ln w="12700">
-            <a:solidFill>
-              <a:srgbClr val="EAF1F3"/>
-            </a:solidFill>
-            <a:prstDash val="solid"/>
-          </a:ln>
-        </p:spPr>
-      </p:sp>
-      <p:sp>
-        <p:nvSpPr>
-          <p:cNvPr id="15" name="Text 13"/>
-          <p:cNvSpPr/>
-          <p:nvPr/>
-        </p:nvSpPr>
-        <p:spPr>
-          <a:xfrm>
-            <a:off x="9070848" y="3291840"/>
-            <a:ext cx="2157984" cy="393192"/>
+            <a:off x="8823960" y="3063240"/>
+            <a:ext cx="2606040" cy="457200"/>
           </a:xfrm>
           <a:prstGeom prst="rect">
             <a:avLst/>
@@ -11868,11 +12026,11 @@
           <a:bodyPr wrap="square" lIns="0" tIns="0" rIns="0" bIns="0" rtlCol="0" anchor="ctr"/>
           <a:lstStyle/>
           <a:p>
-            <a:pPr indent="0" marL="0">
+            <a:pPr algn="ctr" indent="0" marL="0">
               <a:buNone/>
             </a:pPr>
             <a:r>
-              <a:rPr lang="en-US" sz="2700" b="1" dirty="0">
+              <a:rPr lang="en-US" sz="2800" b="1" dirty="0">
                 <a:solidFill>
                   <a:srgbClr val="083E4F"/>
                 </a:solidFill>
@@ -11882,20 +12040,20 @@
               </a:rPr>
               <a:t>Review</a:t>
             </a:r>
-            <a:endParaRPr lang="en-US" sz="2700" dirty="0"/>
-          </a:p>
-        </p:txBody>
-      </p:sp>
-      <p:sp>
-        <p:nvSpPr>
-          <p:cNvPr id="16" name="Text 14"/>
+            <a:endParaRPr lang="en-US" sz="2800" dirty="0"/>
+          </a:p>
+        </p:txBody>
+      </p:sp>
+      <p:sp>
+        <p:nvSpPr>
+          <p:cNvPr id="12" name="Text 10"/>
           <p:cNvSpPr/>
           <p:nvPr/>
         </p:nvSpPr>
         <p:spPr>
           <a:xfrm>
-            <a:off x="9070848" y="3776472"/>
-            <a:ext cx="2157984" cy="329184"/>
+            <a:off x="8823960" y="3657600"/>
+            <a:ext cx="2606040" cy="731520"/>
           </a:xfrm>
           <a:prstGeom prst="rect">
             <a:avLst/>
@@ -11907,11 +12065,11 @@
           <a:bodyPr wrap="square" lIns="0" tIns="0" rIns="0" bIns="0" rtlCol="0" anchor="ctr"/>
           <a:lstStyle/>
           <a:p>
-            <a:pPr indent="0" marL="0">
+            <a:pPr algn="ctr" indent="0" marL="0">
               <a:buNone/>
             </a:pPr>
             <a:r>
-              <a:rPr lang="en-US" sz="1900" dirty="0">
+              <a:rPr lang="en-US" sz="2200" dirty="0">
                 <a:solidFill>
                   <a:srgbClr val="405965"/>
                 </a:solidFill>
@@ -11921,20 +12079,20 @@
               </a:rPr>
               <a:t>Added context</a:t>
             </a:r>
-            <a:endParaRPr lang="en-US" sz="1900" dirty="0"/>
-          </a:p>
-        </p:txBody>
-      </p:sp>
-      <p:sp>
-        <p:nvSpPr>
-          <p:cNvPr id="17" name="Shape 15"/>
+            <a:endParaRPr lang="en-US" sz="2200" dirty="0"/>
+          </a:p>
+        </p:txBody>
+      </p:sp>
+      <p:sp>
+        <p:nvSpPr>
+          <p:cNvPr id="13" name="Shape 11"/>
           <p:cNvSpPr/>
           <p:nvPr/>
         </p:nvSpPr>
         <p:spPr>
           <a:xfrm>
-            <a:off x="3291840" y="3749040"/>
-            <a:ext cx="548640" cy="0"/>
+            <a:off x="3246120" y="3584448"/>
+            <a:ext cx="594360" cy="0"/>
           </a:xfrm>
           <a:prstGeom prst="line">
             <a:avLst/>
@@ -11952,13 +12110,13 @@
       </p:sp>
       <p:sp>
         <p:nvSpPr>
-          <p:cNvPr id="18" name="Shape 16"/>
+          <p:cNvPr id="14" name="Shape 12"/>
           <p:cNvSpPr/>
           <p:nvPr/>
         </p:nvSpPr>
         <p:spPr>
           <a:xfrm>
-            <a:off x="3840480" y="2926080"/>
+            <a:off x="3840480" y="2606040"/>
             <a:ext cx="0" cy="1737360"/>
           </a:xfrm>
           <a:prstGeom prst="line">
@@ -11977,14 +12135,14 @@
       </p:sp>
       <p:sp>
         <p:nvSpPr>
-          <p:cNvPr id="19" name="Shape 17"/>
+          <p:cNvPr id="15" name="Shape 13"/>
           <p:cNvSpPr/>
           <p:nvPr/>
         </p:nvSpPr>
         <p:spPr>
           <a:xfrm>
-            <a:off x="3840480" y="2926080"/>
-            <a:ext cx="548640" cy="0"/>
+            <a:off x="3840480" y="2606040"/>
+            <a:ext cx="438912" cy="0"/>
           </a:xfrm>
           <a:prstGeom prst="line">
             <a:avLst/>
@@ -12002,14 +12160,14 @@
       </p:sp>
       <p:sp>
         <p:nvSpPr>
-          <p:cNvPr id="20" name="Shape 18"/>
+          <p:cNvPr id="16" name="Shape 14"/>
           <p:cNvSpPr/>
           <p:nvPr/>
         </p:nvSpPr>
         <p:spPr>
           <a:xfrm>
-            <a:off x="3840480" y="4663440"/>
-            <a:ext cx="548640" cy="0"/>
+            <a:off x="3840480" y="4343400"/>
+            <a:ext cx="438912" cy="0"/>
           </a:xfrm>
           <a:prstGeom prst="line">
             <a:avLst/>
@@ -12027,13 +12185,13 @@
       </p:sp>
       <p:sp>
         <p:nvSpPr>
-          <p:cNvPr id="21" name="Shape 19"/>
+          <p:cNvPr id="17" name="Shape 15"/>
           <p:cNvSpPr/>
           <p:nvPr/>
         </p:nvSpPr>
         <p:spPr>
           <a:xfrm>
-            <a:off x="7589520" y="2926080"/>
+            <a:off x="7589520" y="2606040"/>
             <a:ext cx="548640" cy="0"/>
           </a:xfrm>
           <a:prstGeom prst="line">
@@ -12052,13 +12210,13 @@
       </p:sp>
       <p:sp>
         <p:nvSpPr>
-          <p:cNvPr id="22" name="Shape 20"/>
+          <p:cNvPr id="18" name="Shape 16"/>
           <p:cNvSpPr/>
           <p:nvPr/>
         </p:nvSpPr>
         <p:spPr>
           <a:xfrm>
-            <a:off x="7589520" y="4663440"/>
+            <a:off x="7589520" y="4343400"/>
             <a:ext cx="548640" cy="0"/>
           </a:xfrm>
           <a:prstGeom prst="line">
@@ -12077,13 +12235,13 @@
       </p:sp>
       <p:sp>
         <p:nvSpPr>
-          <p:cNvPr id="23" name="Shape 21"/>
+          <p:cNvPr id="19" name="Shape 17"/>
           <p:cNvSpPr/>
           <p:nvPr/>
         </p:nvSpPr>
         <p:spPr>
           <a:xfrm>
-            <a:off x="8138160" y="2926080"/>
+            <a:off x="8138160" y="2606040"/>
             <a:ext cx="0" cy="1737360"/>
           </a:xfrm>
           <a:prstGeom prst="line">
@@ -12102,14 +12260,14 @@
       </p:sp>
       <p:sp>
         <p:nvSpPr>
-          <p:cNvPr id="24" name="Shape 22"/>
+          <p:cNvPr id="20" name="Shape 18"/>
           <p:cNvSpPr/>
           <p:nvPr/>
         </p:nvSpPr>
         <p:spPr>
           <a:xfrm>
-            <a:off x="8138160" y="3749040"/>
-            <a:ext cx="548640" cy="0"/>
+            <a:off x="8138160" y="3584448"/>
+            <a:ext cx="457200" cy="0"/>
           </a:xfrm>
           <a:prstGeom prst="line">
             <a:avLst/>
@@ -12127,7 +12285,7 @@
       </p:sp>
       <p:sp>
         <p:nvSpPr>
-          <p:cNvPr id="25" name="Text 23"/>
+          <p:cNvPr id="21" name="Text 19"/>
           <p:cNvSpPr/>
           <p:nvPr/>
         </p:nvSpPr>
@@ -12146,7 +12304,7 @@
           <a:bodyPr wrap="square" lIns="0" tIns="0" rIns="0" bIns="0" rtlCol="0" anchor="ctr"/>
           <a:lstStyle/>
           <a:p>
-            <a:pPr indent="0" marL="0">
+            <a:pPr algn="ctr" indent="0" marL="0">
               <a:buNone/>
             </a:pPr>
             <a:r>
@@ -12236,45 +12394,6 @@
         </p:nvSpPr>
         <p:spPr>
           <a:xfrm>
-            <a:off x="566928" y="932688"/>
-            <a:ext cx="11064240" cy="1060704"/>
-          </a:xfrm>
-          <a:prstGeom prst="rect">
-            <a:avLst/>
-          </a:prstGeom>
-          <a:noFill/>
-          <a:ln/>
-        </p:spPr>
-        <p:txBody>
-          <a:bodyPr wrap="square" lIns="0" tIns="0" rIns="0" bIns="0" rtlCol="0" anchor="ctr"/>
-          <a:lstStyle/>
-          <a:p>
-            <a:pPr indent="0" marL="0">
-              <a:buNone/>
-            </a:pPr>
-            <a:r>
-              <a:rPr lang="en-US" sz="3600" b="1" dirty="0">
-                <a:solidFill>
-                  <a:srgbClr val="083E4F"/>
-                </a:solidFill>
-                <a:latin typeface="Arial" pitchFamily="34" charset="0"/>
-                <a:ea typeface="Arial" pitchFamily="34" charset="-122"/>
-                <a:cs typeface="Arial" pitchFamily="34" charset="-120"/>
-              </a:rPr>
-              <a:t>Run Atlantis in your infrastructure.</a:t>
-            </a:r>
-            <a:endParaRPr lang="en-US" sz="3600" dirty="0"/>
-          </a:p>
-        </p:txBody>
-      </p:sp>
-      <p:sp>
-        <p:nvSpPr>
-          <p:cNvPr id="4" name="Text 2"/>
-          <p:cNvSpPr/>
-          <p:nvPr/>
-        </p:nvSpPr>
-        <p:spPr>
-          <a:xfrm>
             <a:off x="11183112" y="6510528"/>
             <a:ext cx="438912" cy="237744"/>
           </a:xfrm>
@@ -12308,39 +12427,184 @@
       </p:sp>
       <p:sp>
         <p:nvSpPr>
-          <p:cNvPr id="5" name="Shape 3"/>
+          <p:cNvPr id="4" name="Text 2"/>
           <p:cNvSpPr/>
           <p:nvPr/>
         </p:nvSpPr>
         <p:spPr>
           <a:xfrm>
-            <a:off x="640080" y="2560320"/>
-            <a:ext cx="3493008" cy="1691640"/>
-          </a:xfrm>
-          <a:prstGeom prst="rect">
-            <a:avLst/>
-          </a:prstGeom>
-          <a:solidFill>
-            <a:srgbClr val="EAF1F3"/>
-          </a:solidFill>
-          <a:ln w="12700">
+            <a:off x="566928" y="932688"/>
+            <a:ext cx="11064240" cy="1280160"/>
+          </a:xfrm>
+          <a:prstGeom prst="rect">
+            <a:avLst/>
+          </a:prstGeom>
+          <a:noFill/>
+          <a:ln/>
+        </p:spPr>
+        <p:txBody>
+          <a:bodyPr wrap="square" lIns="0" tIns="0" rIns="0" bIns="0" rtlCol="0" anchor="ctr"/>
+          <a:lstStyle/>
+          <a:p>
+            <a:pPr indent="0" marL="0">
+              <a:buNone/>
+            </a:pPr>
+            <a:r>
+              <a:rPr lang="en-US" sz="3600" b="1" dirty="0">
+                <a:solidFill>
+                  <a:srgbClr val="083E4F"/>
+                </a:solidFill>
+                <a:latin typeface="Arial" pitchFamily="34" charset="0"/>
+                <a:ea typeface="Arial" pitchFamily="34" charset="-122"/>
+                <a:cs typeface="Arial" pitchFamily="34" charset="-120"/>
+              </a:rPr>
+              <a:t>Atlantis is self-hosted.</a:t>
+            </a:r>
+            <a:endParaRPr lang="en-US" sz="3600" dirty="0"/>
+          </a:p>
+          <a:p>
+            <a:pPr indent="0" marL="0">
+              <a:buNone/>
+            </a:pPr>
+            <a:r>
+              <a:rPr lang="en-US" sz="3600" b="1" dirty="0">
+                <a:solidFill>
+                  <a:srgbClr val="083E4F"/>
+                </a:solidFill>
+                <a:latin typeface="Arial" pitchFamily="34" charset="0"/>
+                <a:ea typeface="Arial" pitchFamily="34" charset="-122"/>
+                <a:cs typeface="Arial" pitchFamily="34" charset="-120"/>
+              </a:rPr>
+              <a:t>Kubernetes is optional.</a:t>
+            </a:r>
+            <a:endParaRPr lang="en-US" sz="3600" dirty="0"/>
+          </a:p>
+        </p:txBody>
+      </p:sp>
+      <p:sp>
+        <p:nvSpPr>
+          <p:cNvPr id="5" name="Text 3"/>
+          <p:cNvSpPr/>
+          <p:nvPr/>
+        </p:nvSpPr>
+        <p:spPr>
+          <a:xfrm>
+            <a:off x="4187952" y="2514600"/>
+            <a:ext cx="3794760" cy="457200"/>
+          </a:xfrm>
+          <a:prstGeom prst="rect">
+            <a:avLst/>
+          </a:prstGeom>
+          <a:noFill/>
+          <a:ln/>
+        </p:spPr>
+        <p:txBody>
+          <a:bodyPr wrap="square" lIns="0" tIns="0" rIns="0" bIns="0" rtlCol="0" anchor="ctr"/>
+          <a:lstStyle/>
+          <a:p>
+            <a:pPr algn="ctr" indent="0" marL="0">
+              <a:buNone/>
+            </a:pPr>
+            <a:r>
+              <a:rPr lang="en-US" sz="2800" b="1" dirty="0">
+                <a:solidFill>
+                  <a:srgbClr val="086679"/>
+                </a:solidFill>
+                <a:latin typeface="Arial" pitchFamily="34" charset="0"/>
+                <a:ea typeface="Arial" pitchFamily="34" charset="-122"/>
+                <a:cs typeface="Arial" pitchFamily="34" charset="-120"/>
+              </a:rPr>
+              <a:t>Atlantis service</a:t>
+            </a:r>
+            <a:endParaRPr lang="en-US" sz="2800" dirty="0"/>
+          </a:p>
+        </p:txBody>
+      </p:sp>
+      <p:sp>
+        <p:nvSpPr>
+          <p:cNvPr id="6" name="Shape 4"/>
+          <p:cNvSpPr/>
+          <p:nvPr/>
+        </p:nvSpPr>
+        <p:spPr>
+          <a:xfrm>
+            <a:off x="6089904" y="3154680"/>
+            <a:ext cx="0" cy="457200"/>
+          </a:xfrm>
+          <a:prstGeom prst="line">
+            <a:avLst/>
+          </a:prstGeom>
+          <a:noFill/>
+          <a:ln w="25400">
             <a:solidFill>
-              <a:srgbClr val="EAF1F3"/>
+              <a:srgbClr val="086679"/>
             </a:solidFill>
             <a:prstDash val="solid"/>
+            <a:headEnd type="none"/>
+            <a:tailEnd type="none"/>
           </a:ln>
         </p:spPr>
       </p:sp>
       <p:sp>
         <p:nvSpPr>
-          <p:cNvPr id="6" name="Text 4"/>
+          <p:cNvPr id="7" name="Shape 5"/>
           <p:cNvSpPr/>
           <p:nvPr/>
         </p:nvSpPr>
         <p:spPr>
           <a:xfrm>
-            <a:off x="841248" y="2834640"/>
-            <a:ext cx="3090672" cy="457200"/>
+            <a:off x="2414016" y="3611880"/>
+            <a:ext cx="7351776" cy="0"/>
+          </a:xfrm>
+          <a:prstGeom prst="line">
+            <a:avLst/>
+          </a:prstGeom>
+          <a:noFill/>
+          <a:ln w="25400">
+            <a:solidFill>
+              <a:srgbClr val="086679"/>
+            </a:solidFill>
+            <a:prstDash val="solid"/>
+            <a:headEnd type="none"/>
+            <a:tailEnd type="none"/>
+          </a:ln>
+        </p:spPr>
+      </p:sp>
+      <p:sp>
+        <p:nvSpPr>
+          <p:cNvPr id="8" name="Shape 6"/>
+          <p:cNvSpPr/>
+          <p:nvPr/>
+        </p:nvSpPr>
+        <p:spPr>
+          <a:xfrm>
+            <a:off x="2414016" y="3611880"/>
+            <a:ext cx="0" cy="438912"/>
+          </a:xfrm>
+          <a:prstGeom prst="line">
+            <a:avLst/>
+          </a:prstGeom>
+          <a:noFill/>
+          <a:ln w="25400">
+            <a:solidFill>
+              <a:srgbClr val="086679"/>
+            </a:solidFill>
+            <a:prstDash val="solid"/>
+            <a:headEnd type="none"/>
+            <a:tailEnd type="triangle"/>
+          </a:ln>
+        </p:spPr>
+      </p:sp>
+      <p:sp>
+        <p:nvSpPr>
+          <p:cNvPr id="9" name="Text 7"/>
+          <p:cNvSpPr/>
+          <p:nvPr/>
+        </p:nvSpPr>
+        <p:spPr>
+          <a:xfrm>
+            <a:off x="676656" y="4343400"/>
+            <a:ext cx="3474720" cy="457200"/>
           </a:xfrm>
           <a:prstGeom prst="rect">
             <a:avLst/>
@@ -12352,11 +12616,11 @@
           <a:bodyPr wrap="square" lIns="0" tIns="0" rIns="0" bIns="0" rtlCol="0" anchor="ctr"/>
           <a:lstStyle/>
           <a:p>
-            <a:pPr indent="0" marL="0">
+            <a:pPr algn="ctr" indent="0" marL="0">
               <a:buNone/>
             </a:pPr>
             <a:r>
-              <a:rPr lang="en-US" sz="2900" b="1" dirty="0">
+              <a:rPr lang="en-US" sz="2800" b="1" dirty="0">
                 <a:solidFill>
                   <a:srgbClr val="083E4F"/>
                 </a:solidFill>
@@ -12366,20 +12630,20 @@
               </a:rPr>
               <a:t>Kubernetes</a:t>
             </a:r>
-            <a:endParaRPr lang="en-US" sz="2900" dirty="0"/>
-          </a:p>
-        </p:txBody>
-      </p:sp>
-      <p:sp>
-        <p:nvSpPr>
-          <p:cNvPr id="7" name="Text 5"/>
+            <a:endParaRPr lang="en-US" sz="2800" dirty="0"/>
+          </a:p>
+        </p:txBody>
+      </p:sp>
+      <p:sp>
+        <p:nvSpPr>
+          <p:cNvPr id="10" name="Text 8"/>
           <p:cNvSpPr/>
           <p:nvPr/>
         </p:nvSpPr>
         <p:spPr>
           <a:xfrm>
-            <a:off x="841248" y="3520440"/>
-            <a:ext cx="3090672" cy="365760"/>
+            <a:off x="676656" y="4937760"/>
+            <a:ext cx="3474720" cy="731520"/>
           </a:xfrm>
           <a:prstGeom prst="rect">
             <a:avLst/>
@@ -12391,7 +12655,7 @@
           <a:bodyPr wrap="square" lIns="0" tIns="0" rIns="0" bIns="0" rtlCol="0" anchor="ctr"/>
           <a:lstStyle/>
           <a:p>
-            <a:pPr indent="0" marL="0">
+            <a:pPr algn="ctr" indent="0" marL="0">
               <a:buNone/>
             </a:pPr>
             <a:r>
@@ -12411,39 +12675,39 @@
       </p:sp>
       <p:sp>
         <p:nvSpPr>
-          <p:cNvPr id="8" name="Shape 6"/>
+          <p:cNvPr id="11" name="Shape 9"/>
           <p:cNvSpPr/>
           <p:nvPr/>
         </p:nvSpPr>
         <p:spPr>
           <a:xfrm>
-            <a:off x="4352544" y="2560320"/>
-            <a:ext cx="3493008" cy="1691640"/>
-          </a:xfrm>
-          <a:prstGeom prst="rect">
-            <a:avLst/>
-          </a:prstGeom>
-          <a:solidFill>
-            <a:srgbClr val="EAF1F3"/>
-          </a:solidFill>
-          <a:ln w="12700">
+            <a:off x="6089904" y="3611880"/>
+            <a:ext cx="0" cy="438912"/>
+          </a:xfrm>
+          <a:prstGeom prst="line">
+            <a:avLst/>
+          </a:prstGeom>
+          <a:noFill/>
+          <a:ln w="25400">
             <a:solidFill>
-              <a:srgbClr val="EAF1F3"/>
+              <a:srgbClr val="086679"/>
             </a:solidFill>
             <a:prstDash val="solid"/>
+            <a:headEnd type="none"/>
+            <a:tailEnd type="triangle"/>
           </a:ln>
         </p:spPr>
       </p:sp>
       <p:sp>
         <p:nvSpPr>
-          <p:cNvPr id="9" name="Text 7"/>
+          <p:cNvPr id="12" name="Text 10"/>
           <p:cNvSpPr/>
           <p:nvPr/>
         </p:nvSpPr>
         <p:spPr>
           <a:xfrm>
-            <a:off x="4553712" y="2834640"/>
-            <a:ext cx="3090672" cy="457200"/>
+            <a:off x="4352544" y="4343400"/>
+            <a:ext cx="3474720" cy="457200"/>
           </a:xfrm>
           <a:prstGeom prst="rect">
             <a:avLst/>
@@ -12455,11 +12719,11 @@
           <a:bodyPr wrap="square" lIns="0" tIns="0" rIns="0" bIns="0" rtlCol="0" anchor="ctr"/>
           <a:lstStyle/>
           <a:p>
-            <a:pPr indent="0" marL="0">
+            <a:pPr algn="ctr" indent="0" marL="0">
               <a:buNone/>
             </a:pPr>
             <a:r>
-              <a:rPr lang="en-US" sz="2900" b="1" dirty="0">
+              <a:rPr lang="en-US" sz="2800" b="1" dirty="0">
                 <a:solidFill>
                   <a:srgbClr val="083E4F"/>
                 </a:solidFill>
@@ -12467,22 +12731,22 @@
                 <a:ea typeface="Arial" pitchFamily="34" charset="-122"/>
                 <a:cs typeface="Arial" pitchFamily="34" charset="-120"/>
               </a:rPr>
-              <a:t>Containers</a:t>
+              <a:t>Container</a:t>
             </a:r>
-            <a:endParaRPr lang="en-US" sz="2900" dirty="0"/>
-          </a:p>
-        </p:txBody>
-      </p:sp>
-      <p:sp>
-        <p:nvSpPr>
-          <p:cNvPr id="10" name="Text 8"/>
+            <a:endParaRPr lang="en-US" sz="2800" dirty="0"/>
+          </a:p>
+        </p:txBody>
+      </p:sp>
+      <p:sp>
+        <p:nvSpPr>
+          <p:cNvPr id="13" name="Text 11"/>
           <p:cNvSpPr/>
           <p:nvPr/>
         </p:nvSpPr>
         <p:spPr>
           <a:xfrm>
-            <a:off x="4553712" y="3520440"/>
-            <a:ext cx="3090672" cy="365760"/>
+            <a:off x="4352544" y="4937760"/>
+            <a:ext cx="3474720" cy="731520"/>
           </a:xfrm>
           <a:prstGeom prst="rect">
             <a:avLst/>
@@ -12494,7 +12758,7 @@
           <a:bodyPr wrap="square" lIns="0" tIns="0" rIns="0" bIns="0" rtlCol="0" anchor="ctr"/>
           <a:lstStyle/>
           <a:p>
-            <a:pPr indent="0" marL="0">
+            <a:pPr algn="ctr" indent="0" marL="0">
               <a:buNone/>
             </a:pPr>
             <a:r>
@@ -12506,7 +12770,7 @@
                 <a:ea typeface="Arial" pitchFamily="34" charset="-122"/>
                 <a:cs typeface="Arial" pitchFamily="34" charset="-120"/>
               </a:rPr>
-              <a:t>Official Docker image</a:t>
+              <a:t>Official image</a:t>
             </a:r>
             <a:endParaRPr lang="en-US" sz="2200" dirty="0"/>
           </a:p>
@@ -12514,39 +12778,39 @@
       </p:sp>
       <p:sp>
         <p:nvSpPr>
-          <p:cNvPr id="11" name="Shape 9"/>
+          <p:cNvPr id="14" name="Shape 12"/>
           <p:cNvSpPr/>
           <p:nvPr/>
         </p:nvSpPr>
         <p:spPr>
           <a:xfrm>
-            <a:off x="8065008" y="2560320"/>
-            <a:ext cx="3493008" cy="1691640"/>
-          </a:xfrm>
-          <a:prstGeom prst="rect">
-            <a:avLst/>
-          </a:prstGeom>
-          <a:solidFill>
-            <a:srgbClr val="EAF1F3"/>
-          </a:solidFill>
-          <a:ln w="12700">
+            <a:off x="9765792" y="3611880"/>
+            <a:ext cx="0" cy="438912"/>
+          </a:xfrm>
+          <a:prstGeom prst="line">
+            <a:avLst/>
+          </a:prstGeom>
+          <a:noFill/>
+          <a:ln w="25400">
             <a:solidFill>
-              <a:srgbClr val="EAF1F3"/>
+              <a:srgbClr val="086679"/>
             </a:solidFill>
             <a:prstDash val="solid"/>
+            <a:headEnd type="none"/>
+            <a:tailEnd type="triangle"/>
           </a:ln>
         </p:spPr>
       </p:sp>
       <p:sp>
         <p:nvSpPr>
-          <p:cNvPr id="12" name="Text 10"/>
+          <p:cNvPr id="15" name="Text 13"/>
           <p:cNvSpPr/>
           <p:nvPr/>
         </p:nvSpPr>
         <p:spPr>
           <a:xfrm>
-            <a:off x="8266176" y="2834640"/>
-            <a:ext cx="3090672" cy="457200"/>
+            <a:off x="8028432" y="4343400"/>
+            <a:ext cx="3474720" cy="457200"/>
           </a:xfrm>
           <a:prstGeom prst="rect">
             <a:avLst/>
@@ -12558,11 +12822,11 @@
           <a:bodyPr wrap="square" lIns="0" tIns="0" rIns="0" bIns="0" rtlCol="0" anchor="ctr"/>
           <a:lstStyle/>
           <a:p>
-            <a:pPr indent="0" marL="0">
+            <a:pPr algn="ctr" indent="0" marL="0">
               <a:buNone/>
             </a:pPr>
             <a:r>
-              <a:rPr lang="en-US" sz="2900" b="1" dirty="0">
+              <a:rPr lang="en-US" sz="2800" b="1" dirty="0">
                 <a:solidFill>
                   <a:srgbClr val="083E4F"/>
                 </a:solidFill>
@@ -12572,20 +12836,20 @@
               </a:rPr>
               <a:t>Server / VM</a:t>
             </a:r>
-            <a:endParaRPr lang="en-US" sz="2900" dirty="0"/>
-          </a:p>
-        </p:txBody>
-      </p:sp>
-      <p:sp>
-        <p:nvSpPr>
-          <p:cNvPr id="13" name="Text 11"/>
+            <a:endParaRPr lang="en-US" sz="2800" dirty="0"/>
+          </a:p>
+        </p:txBody>
+      </p:sp>
+      <p:sp>
+        <p:nvSpPr>
+          <p:cNvPr id="16" name="Text 14"/>
           <p:cNvSpPr/>
           <p:nvPr/>
         </p:nvSpPr>
         <p:spPr>
           <a:xfrm>
-            <a:off x="8266176" y="3520440"/>
-            <a:ext cx="3090672" cy="365760"/>
+            <a:off x="8028432" y="4937760"/>
+            <a:ext cx="3474720" cy="731520"/>
           </a:xfrm>
           <a:prstGeom prst="rect">
             <a:avLst/>
@@ -12597,7 +12861,7 @@
           <a:bodyPr wrap="square" lIns="0" tIns="0" rIns="0" bIns="0" rtlCol="0" anchor="ctr"/>
           <a:lstStyle/>
           <a:p>
-            <a:pPr indent="0" marL="0">
+            <a:pPr algn="ctr" indent="0" marL="0">
               <a:buNone/>
             </a:pPr>
             <a:r>
@@ -12609,48 +12873,9 @@
                 <a:ea typeface="Arial" pitchFamily="34" charset="-122"/>
                 <a:cs typeface="Arial" pitchFamily="34" charset="-120"/>
               </a:rPr>
-              <a:t>Run the Atlantis binary</a:t>
+              <a:t>Atlantis binary</a:t>
             </a:r>
             <a:endParaRPr lang="en-US" sz="2200" dirty="0"/>
-          </a:p>
-        </p:txBody>
-      </p:sp>
-      <p:sp>
-        <p:nvSpPr>
-          <p:cNvPr id="14" name="Text 12"/>
-          <p:cNvSpPr/>
-          <p:nvPr/>
-        </p:nvSpPr>
-        <p:spPr>
-          <a:xfrm>
-            <a:off x="640080" y="5074920"/>
-            <a:ext cx="10789920" cy="640080"/>
-          </a:xfrm>
-          <a:prstGeom prst="rect">
-            <a:avLst/>
-          </a:prstGeom>
-          <a:noFill/>
-          <a:ln/>
-        </p:spPr>
-        <p:txBody>
-          <a:bodyPr wrap="square" lIns="0" tIns="0" rIns="0" bIns="0" rtlCol="0" anchor="ctr"/>
-          <a:lstStyle/>
-          <a:p>
-            <a:pPr indent="0" marL="0">
-              <a:buNone/>
-            </a:pPr>
-            <a:r>
-              <a:rPr lang="en-US" sz="3100" b="1" dirty="0">
-                <a:solidFill>
-                  <a:srgbClr val="086679"/>
-                </a:solidFill>
-                <a:latin typeface="Arial" pitchFamily="34" charset="0"/>
-                <a:ea typeface="Arial" pitchFamily="34" charset="-122"/>
-                <a:cs typeface="Arial" pitchFamily="34" charset="-120"/>
-              </a:rPr>
-              <a:t>Self-hosted. Kubernetes is optional.</a:t>
-            </a:r>
-            <a:endParaRPr lang="en-US" sz="3100" dirty="0"/>
           </a:p>
         </p:txBody>
       </p:sp>
@@ -12804,8 +13029,8 @@
         </p:nvSpPr>
         <p:spPr>
           <a:xfrm>
-            <a:off x="731520" y="2560320"/>
-            <a:ext cx="3291840" cy="1188720"/>
+            <a:off x="731520" y="2651760"/>
+            <a:ext cx="3291840" cy="1280160"/>
           </a:xfrm>
           <a:prstGeom prst="rect">
             <a:avLst/>
@@ -12821,7 +13046,7 @@
               <a:buNone/>
             </a:pPr>
             <a:r>
-              <a:rPr lang="en-US" sz="8600" b="1" dirty="0">
+              <a:rPr lang="en-US" sz="9000" b="1" dirty="0">
                 <a:solidFill>
                   <a:srgbClr val="086679"/>
                 </a:solidFill>
@@ -12831,7 +13056,7 @@
               </a:rPr>
               <a:t>354</a:t>
             </a:r>
-            <a:endParaRPr lang="en-US" sz="8600" dirty="0"/>
+            <a:endParaRPr lang="en-US" sz="9000" dirty="0"/>
           </a:p>
         </p:txBody>
       </p:sp>
@@ -12843,7 +13068,7 @@
         </p:nvSpPr>
         <p:spPr>
           <a:xfrm>
-            <a:off x="731520" y="3931920"/>
+            <a:off x="731520" y="4069080"/>
             <a:ext cx="3383280" cy="457200"/>
           </a:xfrm>
           <a:prstGeom prst="rect">
@@ -12876,13 +13101,38 @@
       </p:sp>
       <p:sp>
         <p:nvSpPr>
-          <p:cNvPr id="7" name="Text 5"/>
+          <p:cNvPr id="7" name="Shape 5"/>
           <p:cNvSpPr/>
           <p:nvPr/>
         </p:nvSpPr>
         <p:spPr>
           <a:xfrm>
-            <a:off x="4480560" y="2606040"/>
+            <a:off x="4224528" y="2514600"/>
+            <a:ext cx="0" cy="2743200"/>
+          </a:xfrm>
+          <a:prstGeom prst="line">
+            <a:avLst/>
+          </a:prstGeom>
+          <a:noFill/>
+          <a:ln w="25400">
+            <a:solidFill>
+              <a:srgbClr val="A6BAC1"/>
+            </a:solidFill>
+            <a:prstDash val="solid"/>
+            <a:headEnd type="none"/>
+            <a:tailEnd type="none"/>
+          </a:ln>
+        </p:spPr>
+      </p:sp>
+      <p:sp>
+        <p:nvSpPr>
+          <p:cNvPr id="8" name="Text 6"/>
+          <p:cNvSpPr/>
+          <p:nvPr/>
+        </p:nvSpPr>
+        <p:spPr>
+          <a:xfrm>
+            <a:off x="4645152" y="2560320"/>
             <a:ext cx="6766560" cy="320040"/>
           </a:xfrm>
           <a:prstGeom prst="rect">
@@ -12915,14 +13165,14 @@
       </p:sp>
       <p:sp>
         <p:nvSpPr>
-          <p:cNvPr id="8" name="Text 6"/>
+          <p:cNvPr id="9" name="Text 7"/>
           <p:cNvSpPr/>
           <p:nvPr/>
         </p:nvSpPr>
         <p:spPr>
           <a:xfrm>
-            <a:off x="4480560" y="3044952"/>
-            <a:ext cx="6812280" cy="822960"/>
+            <a:off x="4645152" y="2999232"/>
+            <a:ext cx="6537960" cy="868680"/>
           </a:xfrm>
           <a:prstGeom prst="rect">
             <a:avLst/>
@@ -12954,13 +13204,13 @@
       </p:sp>
       <p:sp>
         <p:nvSpPr>
-          <p:cNvPr id="9" name="Text 7"/>
+          <p:cNvPr id="10" name="Text 8"/>
           <p:cNvSpPr/>
           <p:nvPr/>
         </p:nvSpPr>
         <p:spPr>
           <a:xfrm>
-            <a:off x="4480560" y="3977640"/>
+            <a:off x="4645152" y="3950208"/>
             <a:ext cx="6766560" cy="320040"/>
           </a:xfrm>
           <a:prstGeom prst="rect">
@@ -12993,14 +13243,14 @@
       </p:sp>
       <p:sp>
         <p:nvSpPr>
-          <p:cNvPr id="10" name="Text 8"/>
+          <p:cNvPr id="11" name="Text 9"/>
           <p:cNvSpPr/>
           <p:nvPr/>
         </p:nvSpPr>
         <p:spPr>
           <a:xfrm>
-            <a:off x="4480560" y="4416552"/>
-            <a:ext cx="6812280" cy="822960"/>
+            <a:off x="4645152" y="4389120"/>
+            <a:ext cx="6537960" cy="868680"/>
           </a:xfrm>
           <a:prstGeom prst="rect">
             <a:avLst/>
@@ -13049,7 +13299,7 @@
       </p:sp>
       <p:sp>
         <p:nvSpPr>
-          <p:cNvPr id="11" name="Text 9">
+          <p:cNvPr id="12" name="Text 10">
             <a:hlinkClick r:id="rId1" tooltip=""/>
           </p:cNvPr>
           <p:cNvSpPr/>
@@ -13245,8 +13495,8 @@
         </p:nvSpPr>
         <p:spPr>
           <a:xfrm>
-            <a:off x="731520" y="2103120"/>
-            <a:ext cx="10698480" cy="457200"/>
+            <a:off x="731520" y="2331720"/>
+            <a:ext cx="10698480" cy="685800"/>
           </a:xfrm>
           <a:prstGeom prst="rect">
             <a:avLst/>
@@ -13262,9 +13512,151 @@
               <a:buNone/>
             </a:pPr>
             <a:r>
-              <a:rPr lang="en-US" sz="2700" b="1" dirty="0">
+              <a:rPr lang="en-US" sz="3600" b="1" dirty="0">
+                <a:solidFill>
+                  <a:srgbClr val="083E4F"/>
+                </a:solidFill>
+                <a:latin typeface="Arial" pitchFamily="34" charset="0"/>
+                <a:ea typeface="Arial" pitchFamily="34" charset="-122"/>
+                <a:cs typeface="Arial" pitchFamily="34" charset="-120"/>
+              </a:rPr>
+              <a:t>A clearer compatibility contract</a:t>
+            </a:r>
+            <a:endParaRPr lang="en-US" sz="3600" dirty="0"/>
+          </a:p>
+        </p:txBody>
+      </p:sp>
+      <p:sp>
+        <p:nvSpPr>
+          <p:cNvPr id="6" name="Text 4"/>
+          <p:cNvSpPr/>
+          <p:nvPr/>
+        </p:nvSpPr>
+        <p:spPr>
+          <a:xfrm>
+            <a:off x="731520" y="3611880"/>
+            <a:ext cx="4572000" cy="594360"/>
+          </a:xfrm>
+          <a:prstGeom prst="rect">
+            <a:avLst/>
+          </a:prstGeom>
+          <a:noFill/>
+          <a:ln/>
+        </p:spPr>
+        <p:txBody>
+          <a:bodyPr wrap="square" lIns="0" tIns="0" rIns="0" bIns="0" rtlCol="0" anchor="ctr"/>
+          <a:lstStyle/>
+          <a:p>
+            <a:pPr indent="0" marL="0">
+              <a:buNone/>
+            </a:pPr>
+            <a:r>
+              <a:rPr lang="en-US" sz="3100" b="1" dirty="0">
                 <a:solidFill>
                   <a:srgbClr val="086679"/>
+                </a:solidFill>
+                <a:latin typeface="Arial" pitchFamily="34" charset="0"/>
+                <a:ea typeface="Arial" pitchFamily="34" charset="-122"/>
+                <a:cs typeface="Arial" pitchFamily="34" charset="-120"/>
+              </a:rPr>
+              <a:t>Breaking changes</a:t>
+            </a:r>
+            <a:endParaRPr lang="en-US" sz="3100" dirty="0"/>
+          </a:p>
+        </p:txBody>
+      </p:sp>
+      <p:sp>
+        <p:nvSpPr>
+          <p:cNvPr id="7" name="Shape 5"/>
+          <p:cNvSpPr/>
+          <p:nvPr/>
+        </p:nvSpPr>
+        <p:spPr>
+          <a:xfrm>
+            <a:off x="5166360" y="3931920"/>
+            <a:ext cx="1234440" cy="0"/>
+          </a:xfrm>
+          <a:prstGeom prst="line">
+            <a:avLst/>
+          </a:prstGeom>
+          <a:noFill/>
+          <a:ln w="25400">
+            <a:solidFill>
+              <a:srgbClr val="086679"/>
+            </a:solidFill>
+            <a:prstDash val="solid"/>
+            <a:headEnd type="none"/>
+            <a:tailEnd type="triangle"/>
+          </a:ln>
+        </p:spPr>
+      </p:sp>
+      <p:sp>
+        <p:nvSpPr>
+          <p:cNvPr id="8" name="Text 6"/>
+          <p:cNvSpPr/>
+          <p:nvPr/>
+        </p:nvSpPr>
+        <p:spPr>
+          <a:xfrm>
+            <a:off x="6766560" y="3611880"/>
+            <a:ext cx="4617720" cy="594360"/>
+          </a:xfrm>
+          <a:prstGeom prst="rect">
+            <a:avLst/>
+          </a:prstGeom>
+          <a:noFill/>
+          <a:ln/>
+        </p:spPr>
+        <p:txBody>
+          <a:bodyPr wrap="square" lIns="0" tIns="0" rIns="0" bIns="0" rtlCol="0" anchor="ctr"/>
+          <a:lstStyle/>
+          <a:p>
+            <a:pPr indent="0" marL="0">
+              <a:buNone/>
+            </a:pPr>
+            <a:r>
+              <a:rPr lang="en-US" sz="3100" b="1" dirty="0">
+                <a:solidFill>
+                  <a:srgbClr val="086679"/>
+                </a:solidFill>
+                <a:latin typeface="Arial" pitchFamily="34" charset="0"/>
+                <a:ea typeface="Arial" pitchFamily="34" charset="-122"/>
+                <a:cs typeface="Arial" pitchFamily="34" charset="-120"/>
+              </a:rPr>
+              <a:t>Major version</a:t>
+            </a:r>
+            <a:endParaRPr lang="en-US" sz="3100" dirty="0"/>
+          </a:p>
+        </p:txBody>
+      </p:sp>
+      <p:sp>
+        <p:nvSpPr>
+          <p:cNvPr id="9" name="Text 7"/>
+          <p:cNvSpPr/>
+          <p:nvPr/>
+        </p:nvSpPr>
+        <p:spPr>
+          <a:xfrm>
+            <a:off x="731520" y="4937760"/>
+            <a:ext cx="10698480" cy="457200"/>
+          </a:xfrm>
+          <a:prstGeom prst="rect">
+            <a:avLst/>
+          </a:prstGeom>
+          <a:noFill/>
+          <a:ln/>
+        </p:spPr>
+        <p:txBody>
+          <a:bodyPr wrap="square" lIns="0" tIns="0" rIns="0" bIns="0" rtlCol="0" anchor="ctr"/>
+          <a:lstStyle/>
+          <a:p>
+            <a:pPr indent="0" marL="0">
+              <a:buNone/>
+            </a:pPr>
+            <a:r>
+              <a:rPr lang="en-US" sz="2600" b="1" dirty="0">
+                <a:solidFill>
+                  <a:srgbClr val="083E4F"/>
                 </a:solidFill>
                 <a:latin typeface="Arial" pitchFamily="34" charset="0"/>
                 <a:ea typeface="Arial" pitchFamily="34" charset="-122"/>
@@ -13272,91 +13664,13 @@
               </a:rPr>
               <a:t>Planning discussion · not released</a:t>
             </a:r>
-            <a:endParaRPr lang="en-US" sz="2700" dirty="0"/>
-          </a:p>
-        </p:txBody>
-      </p:sp>
-      <p:sp>
-        <p:nvSpPr>
-          <p:cNvPr id="6" name="Text 4"/>
-          <p:cNvSpPr/>
-          <p:nvPr/>
-        </p:nvSpPr>
-        <p:spPr>
-          <a:xfrm>
-            <a:off x="731520" y="2971800"/>
-            <a:ext cx="10698480" cy="777240"/>
-          </a:xfrm>
-          <a:prstGeom prst="rect">
-            <a:avLst/>
-          </a:prstGeom>
-          <a:noFill/>
-          <a:ln/>
-        </p:spPr>
-        <p:txBody>
-          <a:bodyPr wrap="square" lIns="0" tIns="0" rIns="0" bIns="0" rtlCol="0" anchor="ctr"/>
-          <a:lstStyle/>
-          <a:p>
-            <a:pPr indent="0" marL="0">
-              <a:buNone/>
-            </a:pPr>
-            <a:r>
-              <a:rPr lang="en-US" sz="3800" b="1" dirty="0">
-                <a:solidFill>
-                  <a:srgbClr val="083E4F"/>
-                </a:solidFill>
-                <a:latin typeface="Arial" pitchFamily="34" charset="0"/>
-                <a:ea typeface="Arial" pitchFamily="34" charset="-122"/>
-                <a:cs typeface="Arial" pitchFamily="34" charset="-120"/>
-              </a:rPr>
-              <a:t>A clearer compatibility contract</a:t>
-            </a:r>
-            <a:endParaRPr lang="en-US" sz="3800" dirty="0"/>
-          </a:p>
-        </p:txBody>
-      </p:sp>
-      <p:sp>
-        <p:nvSpPr>
-          <p:cNvPr id="7" name="Text 5"/>
-          <p:cNvSpPr/>
-          <p:nvPr/>
-        </p:nvSpPr>
-        <p:spPr>
-          <a:xfrm>
-            <a:off x="731520" y="4251960"/>
-            <a:ext cx="10698480" cy="594360"/>
-          </a:xfrm>
-          <a:prstGeom prst="rect">
-            <a:avLst/>
-          </a:prstGeom>
-          <a:noFill/>
-          <a:ln/>
-        </p:spPr>
-        <p:txBody>
-          <a:bodyPr wrap="square" lIns="0" tIns="0" rIns="0" bIns="0" rtlCol="0" anchor="ctr"/>
-          <a:lstStyle/>
-          <a:p>
-            <a:pPr indent="0" marL="0">
-              <a:buNone/>
-            </a:pPr>
-            <a:r>
-              <a:rPr lang="en-US" sz="3000" b="1" dirty="0">
-                <a:solidFill>
-                  <a:srgbClr val="086679"/>
-                </a:solidFill>
-                <a:latin typeface="Arial" pitchFamily="34" charset="0"/>
-                <a:ea typeface="Arial" pitchFamily="34" charset="-122"/>
-                <a:cs typeface="Arial" pitchFamily="34" charset="-120"/>
-              </a:rPr>
-              <a:t>Breaking changes → major version</a:t>
-            </a:r>
-            <a:endParaRPr lang="en-US" sz="3000" dirty="0"/>
-          </a:p>
-        </p:txBody>
-      </p:sp>
-      <p:sp>
-        <p:nvSpPr>
-          <p:cNvPr id="8" name="Text 6">
+            <a:endParaRPr lang="en-US" sz="2600" dirty="0"/>
+          </a:p>
+        </p:txBody>
+      </p:sp>
+      <p:sp>
+        <p:nvSpPr>
+          <p:cNvPr id="10" name="Text 8">
             <a:hlinkClick r:id="rId1" tooltip=""/>
           </p:cNvPr>
           <p:cNvSpPr/>
@@ -13364,8 +13678,8 @@
         </p:nvSpPr>
         <p:spPr>
           <a:xfrm>
-            <a:off x="731520" y="5577840"/>
-            <a:ext cx="10698480" cy="411480"/>
+            <a:off x="731520" y="5623560"/>
+            <a:ext cx="10698480" cy="365760"/>
           </a:xfrm>
           <a:prstGeom prst="rect">
             <a:avLst/>

</xml_diff>

<commit_message>
docs: polish Atlantis v2 and add Chinese speaker notes
Signed-off-by: Rui Chen <rui@chenrui.dev>
</commit_message>
<xml_diff>
--- a/talks/kubecon-china-2026-atlantis-lightning/slides.pptx
+++ b/talks/kubecon-china-2026-atlantis-lightning/slides.pptx
@@ -512,14 +512,14 @@
             <a:r>
               <a:rPr lang="en-US" dirty="0"/>
               <a:t>Target: 0:00–0:20 (20 seconds)
-Spoken words: 34
-Cue: Define Atlantis before introducing the workflow.
-Hi, I'm Rui, an Atlantis maintainer. Atlantis is an open-source service that runs Terraform and OpenTofu plans and applies from pull requests. The idea is simple: code review should include the infrastructure execution result.
+Chinese characters: 58; see timing.md for English terms
+提示: 先定义 Atlantis。
+大家好，我是 Rui，Atlantis 的维护者。Atlantis 是一个开源服务，让团队在拉取请求里完成 Terraform 和 OpenTofu 的计划与执行。核心想法很简单：基础设施变更，也应该进入代码评审流程。
 Transition: Advance after the final sentence.
 Emergency cuts:
 None; retain this slide’s narration.
 Reference notes (not spoken):
-See sources.md for factual references.</a:t>
+C01/C02: Atlantis definition and maintainer identity.</a:t>
             </a:r>
             <a:endParaRPr lang="en-US" dirty="0"/>
           </a:p>
@@ -607,15 +607,15 @@
           <a:p>
             <a:r>
               <a:rPr lang="en-US" dirty="0"/>
-              <a:t>Target: 4:05–4:30 (25 seconds)
-Spoken words: 42
-Cue: Point to discovery links, then hold the final slide.
-Learn more at runatlantis dot io, explore the code on GitHub, and join the CNCF community. Find Atlantis at Project Pavilion, table T-ten, in Grand Ballroom One on Tuesday. Infrastructure is code. Plan it. Review it. Apply it. From the pull request.
+              <a:t>Target: 4:25–4:55 (30 seconds)
+Chinese characters: 86; see timing.md for English terms
+提示: 指向社区与展台；结束后保持页面。
+欢迎从文档开始，也欢迎贡献代码、文档，分享中国团队的使用经验。社区议程和日历链接都在这里。周二十点半到下午两点半，欢迎来 Grand Ballroom One 的 T 十展台交流。基础设施就是代码。先计划，再评审，再执行。都在拉取请求里完成。
 Transition: Hold the closing slide.
 Emergency cuts:
-None; retain this slide’s narration.
+社区议程和日历链接都在这里。
 Reference notes (not spoken):
-E03: Project Pavilion T-10, Tuesday September 8, 10:30–14:30, Grand Ballroom I. The slot extends into afternoon. This does not promise Rui is continuously present during the whole pavilion slot. Community meetings: every two weeks on Wednesday at 16:00 UTC. Official agenda/notes and calendar access: https://docs.google.com/document/d/1EzseHmT4Zarj-_7MO8ud5mHByIJGIHS7JdoNNK9ZckU/edit (verified against the public document and official v0.37.0 release announcement).</a:t>
+E03: Project Pavilion T-10, Tuesday September 8, 10:30–14:30, Grand Ballroom I. The slot extends into afternoon. This does not promise Rui is continuously present during the whole pavilion slot. Community meetings: every two weeks on Wednesday at 16:00 UTC. Official agenda/notes and calendar access: https://docs.google.com/document/d/1EzseHmT4Zarj-_7MO8ud5mHByIJGIHS7JdoNNK9ZckU/edit (verified against the public document and official v0.37.0 release announcement). Rui reconfirmed Grand Ballroom I, T-10, Tuesday 10:30–14:30 for China 2026.</a:t>
             </a:r>
             <a:endParaRPr lang="en-US" dirty="0"/>
           </a:p>
@@ -704,9 +704,9 @@
             <a:r>
               <a:rPr lang="en-US" dirty="0"/>
               <a:t>Target: 0:20–1:10 (50 seconds)
-Spoken words: 76
-Cue: Trace the loop once; distinguish orchestration from provider/state execution.
-Many teams already automate infrastructure. Atlantis brings planning, review, execution, and results into one workflow. A developer opens a pull request. The Git host sends a webhook; Atlantis runs Terraform or OpenTofu and posts the plan back. The team reviews the code and plan together. An authorized engineer requests atlantis apply. Atlantis checks configured requirements, executes the change, and reports the result in the pull request. The infrastructure tooling still uses your providers and state backend.
+Chinese characters: 114; see timing.md for English terms
+提示: 沿图只走一遍；区分编排与执行。
+很多团队已经有基础设施自动化。Atlantis 解决的是：把计划、评审、执行和结果放在同一个流程里。开发者提交拉取请求，Git 平台发出 webhook，Atlantis 调用 Terraform 或 OpenTofu 生成计划，再贴回请求。大家一起看代码和计划，有权限的人发出 atlantis apply。Atlantis 检查配置好的条件，执行变更，再回传结果。它负责组织流程，底层工具负责云 API 和状态管理。
 Transition: Advance after the final sentence.
 Emergency cuts:
 None; retain this slide’s narration.
@@ -799,15 +799,15 @@
           <a:p>
             <a:r>
               <a:rPr lang="en-US" dirty="0"/>
-              <a:t>Target: 1:10–1:50 (40 seconds)
-Spoken words: 62
-Cue: Explain the engineer experience; do not repeat the architecture.
-Here is one database capacity change. The summary says zero to add, one to change, zero to destroy. Small does not mean safe: the reviewer reads the full plan and considers operational impact. The plan becomes review context attached to the code change. If execution fails, the team can correct the change in the same pull request. This example applies before merging.
+              <a:t>Target: 1:10–1:45 (35 seconds)
+Chinese characters: 98; see timing.md for English terms
+提示: 变更小不等于安全。
+看一个数据库扩容的例子：不新增、不销毁，只修改一个资源。但变更小，不代表风险小。评审者要看完整计划，确认是否重建实例、是否影响服务。批准、执行请求和结果，都在这段对话中。执行失败，可以在原请求里修正。这个例子是在合并之前执行。
 Transition: Advance after the final sentence.
 Emergency cuts:
-If execution fails, the team can correct the change in the same pull request.
+执行失败，可以在原请求里修正。
 Reference notes (not spoken):
-See sources.md for factual references.</a:t>
+C06: Illustrative PR, configured approval, apply before merge; small changes still require full-plan review.</a:t>
             </a:r>
             <a:endParaRPr lang="en-US" dirty="0"/>
           </a:p>
@@ -895,10 +895,10 @@
           <a:p>
             <a:r>
               <a:rPr lang="en-US" dirty="0"/>
-              <a:t>Target: 1:50–2:15 (25 seconds)
-Spoken words: 38
-Cue: Three outcomes; centralized execution is not a security guarantee.
-Platform teams get visibility, control, and collaboration. Plans and results sit beside code. Credentials and execution are centralized; configured requirements and locking coordinate changes. Developers propose; platform rules govern execution. Centralization still needs careful permissions and trusted repositories.
+              <a:t>Target: 1:45–2:10 (25 seconds)
+Chinese characters: 78; see timing.md for English terms
+提示: 开发者提议，平台规则控制。
+对平台团队来说，这是一个协作模式：开发者提议变更，平台规则控制执行，计划和结果公开可见。凭据与执行集中管理，锁定机制帮助协调并发变更。但集中执行仍然需要可信仓库和合理权限。
 Transition: Advance after the final sentence.
 Emergency cuts:
 None; retain this slide’s narration.
@@ -991,15 +991,15 @@
           <a:p>
             <a:r>
               <a:rPr lang="en-US" dirty="0"/>
-              <a:t>Target: 2:15–2:40 (25 seconds)
-Spoken words: 36
-Cue: Point to the flow; do not read the host list.
-Atlantis connects your Git provider to IaC execution. You can build pieces in generic CI; Atlantis packages projects, plans, applies, locking, and VCS interaction into one service. Custom workflows extend execution, including tools such as Terragrunt.
+              <a:t>Target: 2:10–2:45 (35 seconds)
+Chinese characters: 66; see timing.md for English terms
+提示: Git 接入与云 Provider 是两层。
+这里要分清两种集成。上游接 Git 平台，比如自建 GitLab，也支持 Gitea 和 Forgejo。下游由 Terraform 或 OpenTofu 的 Provider 连接阿里云、腾讯云等基础设施。这不是 Atlantis 自带的云接口；具体版本、资源范围和凭据，要按 Provider 文档配置。
 Transition: Advance after the final sentence.
 Emergency cuts:
-Custom workflows extend execution, including tools such as Terragrunt.
+这不是 Atlantis 自带的云接口；具体版本、资源范围和凭据，要按 Provider 文档配置。
 Reference notes (not spoken):
-P01–P03/C04/C18: Current hosts: GitHub, GitLab, Bitbucket Cloud and Server, Azure DevOps, Gitea and compatible forks such as Forgejo. Examples on screen are not exhaustive. Terraform and OpenTofu are selectable distributions. Terragrunt requires its binary and custom workflow commands; it is not a peer provider. Project discovery/planning, apply coordination, locking and VCS comments are purpose-built behaviors, not capabilities exclusive to Atlantis.</a:t>
+P01–P03/C04/C18: Current hosts: GitHub, GitLab, Bitbucket Cloud and Server, Azure DevOps, Gitea and compatible forks such as Forgejo. Examples on screen are not exhaustive. Terraform and OpenTofu are selectable distributions. Terragrunt requires its binary and custom workflow commands; it is not a peer provider. Project discovery/planning, apply coordination, locking and VCS comments are purpose-built behaviors, not capabilities exclusive to Atlantis. CN01–CN03: Alibaba Cloud and Tencent Cloud are provider targets, not Atlantis plugins. Gitee is not listed in official Git-host requirements; Git protocol support does not imply webhook/API compatibility. This does not rule out third-party adapters or forks.</a:t>
             </a:r>
             <a:endParaRPr lang="en-US" dirty="0"/>
           </a:p>
@@ -1087,13 +1087,13 @@
           <a:p>
             <a:r>
               <a:rPr lang="en-US" dirty="0"/>
-              <a:t>Target: 2:40–3:00 (20 seconds)
-Spoken words: 32
-Cue: Policy and cost are separate, optional review inputs.
-Platform teams compose tooling through custom workflows. Policy and cost are examples: Conftest checks the plan; Infracost adds cost context. These are configured extensions, not checks that every Atlantis installation automatically runs.
+              <a:t>Target: 2:45–3:10 (25 seconds)
+Chinese characters: 63; see timing.md for English terms
+提示: 策略、成本是配置后的扩展。
+平台规则也可以扩展。比如通过 Conftest 检查策略，用 Infracost 提供成本信息，或通过自定义工作流接入 Terragrunt。这些是可以组合的工具，需要配置，不是安装之后就自动开启的检查。
 Transition: Advance after the final sentence.
 Emergency cuts:
-None; retain this slide’s narration.
+这些是可以组合的工具，需要配置，不是安装之后就自动开启的检查。
 Reference notes (not spoken):
 P04/P05/P07: Examples, not an exhaustive ecosystem: Conftest policy evaluation and Infracost cost estimation. Custom workflow run steps invoke external tools. Server-side pre/post workflow hooks support surrounding scripts; unlike workflow output, hooks do not automatically post their output as PR comments. Pre-hook errors do not block workflows by default; fail-on-pre-workflow-hook-error changes that behavior. Infracost integration requires configured tooling/hooks or workflow steps; it is not enabled by installing Atlantis. Custom validation or notification scripts are possible mechanisms, not bundled products.</a:t>
             </a:r>
@@ -1183,10 +1183,10 @@
           <a:p>
             <a:r>
               <a:rPr lang="en-US" dirty="0"/>
-              <a:t>Target: 3:00–3:20 (20 seconds)
-Spoken words: 34
-Cue: Hosting choice does not determine provider support.
-Atlantis is self-hosted: use Helm, a container, or a server binary. Kubernetes is optional. Running Atlantis on Kubernetes does not limit it to managing Kubernetes; Terraform and OpenTofu providers determine the infrastructure being managed.
+              <a:t>Target: 3:10–3:35 (25 seconds)
+Chinese characters: 61; see timing.md for English terms
+提示: 运行位置不决定管理目标。
+Atlantis 本身是自托管服务，可以用官方 Helm chart、容器镜像，或者二进制部署。Kubernetes 是一种运行选择，不是前提。它运行在哪里，和它能管理哪些基础设施，是两回事；后者由 Provider 决定。
 Transition: Advance after the final sentence.
 Emergency cuts:
 None; retain this slide’s narration.
@@ -1279,13 +1279,13 @@
           <a:p>
             <a:r>
               <a:rPr lang="en-US" dirty="0"/>
-              <a:t>Target: 3:20–3:50 (30 seconds)
-Spoken words: 43
-Cue: Say the year; point to the official survey blog.
-The project's twenty twenty-four survey received three hundred fifty-four responses. GitHub led, with sizeable GitLab usage. Terraform dominated; about half also used Terragrunt, and OpenTofu was gaining ground. Kubernetes and AWS were common deployment environments. These are historical community responses, not market share.
+              <a:t>Target: 3:35–4:05 (30 seconds)
+Chinese characters: 79; see timing.md for English terms
+提示: 强调 2024 年和 354 份回复。
+生态也有社区反馈作为参考。二〇二四年调查收到三百五十四份回复。GitHub 最多，GitLab 也有相当一部分。Terraform 占主导，约一半还使用 Terragrunt，OpenTofu 也在获得采用。不同工具组合，共享同一套协作流程。这是历史调查，不是市场份额。
 Transition: Advance after the final sentence.
 Emergency cuts:
-None; retain this slide’s narration.
+不同工具组合，共享同一套协作流程。
 Reference notes (not spoken):
 S01–S05: Official 2024 survey: 354 responses, not organizations or market share. GitHub most common; sizeable GitLab, then Bitbucket/others. Terraform dominant; about half additionally use Terragrunt; OpenTofu gaining ground. Kubernetes and/or AWS common. Published Markdown links WebP chart images, with no raw numeric table or downloadable dataset; no chart estimates used. Visible examples summarize breadth; complete qualitative findings remain here.</a:t>
             </a:r>
@@ -1375,10 +1375,10 @@
           <a:p>
             <a:r>
               <a:rPr lang="en-US" dirty="0"/>
-              <a:t>Target: 3:50–4:05 (15 seconds)
-Spoken words: 29
-Cue: Keep project direction brief and explicitly provisional.
-The draft one point zero proposal clarifies the compatibility contract: breaking changes would require major versions. It signals stability and backwards compatibility. This is planning, not a release announcement.
+              <a:t>Target: 4:05–4:25 (20 seconds)
+Chinese characters: 68; see timing.md for English terms
+提示: 规划不等于已发布。
+接下来，项目正在讨论走向一点零的兼容性约定：稳定性、向后兼容，以及破坏性变更应该对应主版本升级。这还是规划讨论，不是发布公告，也没有在这里承诺发布日期。
 Transition: Advance after the final sentence.
 Emergency cuts:
 None; retain this slide’s narration.
@@ -9226,7 +9226,7 @@
                   </a:extLst>
                 </a:hlinkClick>
               </a:rPr>
-              <a:t>Project Pavilion · T-10 · Tue 10:30–14:30</a:t>
+              <a:t>Project Pavilion · T-10 · Tue 10:30–14:30 · Grand Ballroom I</a:t>
             </a:r>
             <a:endParaRPr lang="en-US" sz="1900" dirty="0"/>
           </a:p>
@@ -11289,7 +11289,7 @@
         </p:nvSpPr>
         <p:spPr>
           <a:xfrm>
-            <a:off x="731520" y="2907792"/>
+            <a:off x="731520" y="2816352"/>
             <a:ext cx="2926080" cy="457200"/>
           </a:xfrm>
           <a:prstGeom prst="rect">
@@ -11328,7 +11328,7 @@
         </p:nvSpPr>
         <p:spPr>
           <a:xfrm>
-            <a:off x="731520" y="3502152"/>
+            <a:off x="731520" y="3410712"/>
             <a:ext cx="2926080" cy="731520"/>
           </a:xfrm>
           <a:prstGeom prst="rect">
@@ -11367,7 +11367,7 @@
         </p:nvSpPr>
         <p:spPr>
           <a:xfrm>
-            <a:off x="4617720" y="2816352"/>
+            <a:off x="4617720" y="2724912"/>
             <a:ext cx="2971800" cy="1280160"/>
           </a:xfrm>
           <a:prstGeom prst="rect">
@@ -11392,7 +11392,7 @@
         </p:nvSpPr>
         <p:spPr>
           <a:xfrm>
-            <a:off x="4818888" y="2953512"/>
+            <a:off x="4818888" y="2862072"/>
             <a:ext cx="2569464" cy="393192"/>
           </a:xfrm>
           <a:prstGeom prst="rect">
@@ -11431,7 +11431,7 @@
         </p:nvSpPr>
         <p:spPr>
           <a:xfrm>
-            <a:off x="4818888" y="3438144"/>
+            <a:off x="4818888" y="3346704"/>
             <a:ext cx="2569464" cy="329184"/>
           </a:xfrm>
           <a:prstGeom prst="rect">
@@ -11470,7 +11470,7 @@
         </p:nvSpPr>
         <p:spPr>
           <a:xfrm>
-            <a:off x="8503920" y="2907792"/>
+            <a:off x="8503920" y="2816352"/>
             <a:ext cx="2971800" cy="457200"/>
           </a:xfrm>
           <a:prstGeom prst="rect">
@@ -11509,7 +11509,7 @@
         </p:nvSpPr>
         <p:spPr>
           <a:xfrm>
-            <a:off x="8503920" y="3502152"/>
+            <a:off x="8503920" y="3410712"/>
             <a:ext cx="2971800" cy="731520"/>
           </a:xfrm>
           <a:prstGeom prst="rect">
@@ -11548,7 +11548,7 @@
         </p:nvSpPr>
         <p:spPr>
           <a:xfrm>
-            <a:off x="3703320" y="3474720"/>
+            <a:off x="3703320" y="3383280"/>
             <a:ext cx="713232" cy="0"/>
           </a:xfrm>
           <a:prstGeom prst="line">
@@ -11573,7 +11573,7 @@
         </p:nvSpPr>
         <p:spPr>
           <a:xfrm>
-            <a:off x="7790688" y="3474720"/>
+            <a:off x="7790688" y="3383280"/>
             <a:ext cx="512064" cy="0"/>
           </a:xfrm>
           <a:prstGeom prst="line">
@@ -11598,8 +11598,8 @@
         </p:nvSpPr>
         <p:spPr>
           <a:xfrm>
-            <a:off x="731520" y="5257800"/>
-            <a:ext cx="10789920" cy="594360"/>
+            <a:off x="731520" y="4892040"/>
+            <a:ext cx="3200400" cy="594360"/>
           </a:xfrm>
           <a:prstGeom prst="rect">
             <a:avLst/>
@@ -11611,11 +11611,11 @@
           <a:bodyPr wrap="square" lIns="0" tIns="0" rIns="0" bIns="0" rtlCol="0" anchor="ctr"/>
           <a:lstStyle/>
           <a:p>
-            <a:pPr algn="ctr" indent="0" marL="0">
+            <a:pPr indent="0" marL="0">
               <a:buNone/>
             </a:pPr>
             <a:r>
-              <a:rPr lang="en-US" sz="3000" b="1" dirty="0">
+              <a:rPr lang="en-US" sz="2300" b="1" dirty="0">
                 <a:solidFill>
                   <a:srgbClr val="086679"/>
                 </a:solidFill>
@@ -11623,9 +11623,112 @@
                 <a:ea typeface="Arial" pitchFamily="34" charset="-122"/>
                 <a:cs typeface="Arial" pitchFamily="34" charset="-120"/>
               </a:rPr>
-              <a:t>Purpose-built infrastructure PR automation</a:t>
+              <a:t>Public or self-hosted</a:t>
             </a:r>
-            <a:endParaRPr lang="en-US" sz="3000" dirty="0"/>
+            <a:endParaRPr lang="en-US" sz="2300" dirty="0"/>
+          </a:p>
+        </p:txBody>
+      </p:sp>
+      <p:sp>
+        <p:nvSpPr>
+          <p:cNvPr id="15" name="Shape 13"/>
+          <p:cNvSpPr/>
+          <p:nvPr/>
+        </p:nvSpPr>
+        <p:spPr>
+          <a:xfrm>
+            <a:off x="9966960" y="4251960"/>
+            <a:ext cx="0" cy="365760"/>
+          </a:xfrm>
+          <a:prstGeom prst="line">
+            <a:avLst/>
+          </a:prstGeom>
+          <a:noFill/>
+          <a:ln w="25400">
+            <a:solidFill>
+              <a:srgbClr val="086679"/>
+            </a:solidFill>
+            <a:prstDash val="solid"/>
+            <a:headEnd type="none"/>
+            <a:tailEnd type="triangle"/>
+          </a:ln>
+        </p:spPr>
+      </p:sp>
+      <p:sp>
+        <p:nvSpPr>
+          <p:cNvPr id="16" name="Text 14"/>
+          <p:cNvSpPr/>
+          <p:nvPr/>
+        </p:nvSpPr>
+        <p:spPr>
+          <a:xfrm>
+            <a:off x="4572000" y="4754880"/>
+            <a:ext cx="6858000" cy="411480"/>
+          </a:xfrm>
+          <a:prstGeom prst="rect">
+            <a:avLst/>
+          </a:prstGeom>
+          <a:noFill/>
+          <a:ln/>
+        </p:spPr>
+        <p:txBody>
+          <a:bodyPr wrap="square" lIns="0" tIns="0" rIns="0" bIns="0" rtlCol="0" anchor="ctr"/>
+          <a:lstStyle/>
+          <a:p>
+            <a:pPr algn="r" indent="0" marL="0">
+              <a:buNone/>
+            </a:pPr>
+            <a:r>
+              <a:rPr lang="en-US" sz="2400" b="1" dirty="0">
+                <a:solidFill>
+                  <a:srgbClr val="086679"/>
+                </a:solidFill>
+                <a:latin typeface="Arial" pitchFamily="34" charset="0"/>
+                <a:ea typeface="Arial" pitchFamily="34" charset="-122"/>
+                <a:cs typeface="Arial" pitchFamily="34" charset="-120"/>
+              </a:rPr>
+              <a:t>Cloud providers</a:t>
+            </a:r>
+            <a:endParaRPr lang="en-US" sz="2400" dirty="0"/>
+          </a:p>
+        </p:txBody>
+      </p:sp>
+      <p:sp>
+        <p:nvSpPr>
+          <p:cNvPr id="17" name="Text 15"/>
+          <p:cNvSpPr/>
+          <p:nvPr/>
+        </p:nvSpPr>
+        <p:spPr>
+          <a:xfrm>
+            <a:off x="4572000" y="5367528"/>
+            <a:ext cx="6858000" cy="457200"/>
+          </a:xfrm>
+          <a:prstGeom prst="rect">
+            <a:avLst/>
+          </a:prstGeom>
+          <a:noFill/>
+          <a:ln/>
+        </p:spPr>
+        <p:txBody>
+          <a:bodyPr wrap="square" lIns="0" tIns="0" rIns="0" bIns="0" rtlCol="0" anchor="ctr"/>
+          <a:lstStyle/>
+          <a:p>
+            <a:pPr algn="r" indent="0" marL="0">
+              <a:buNone/>
+            </a:pPr>
+            <a:r>
+              <a:rPr lang="en-US" sz="2600" dirty="0">
+                <a:solidFill>
+                  <a:srgbClr val="083E4F"/>
+                </a:solidFill>
+                <a:latin typeface="Arial" pitchFamily="34" charset="0"/>
+                <a:ea typeface="Arial" pitchFamily="34" charset="-122"/>
+                <a:cs typeface="Arial" pitchFamily="34" charset="-120"/>
+              </a:rPr>
+              <a:t>e.g. Alibaba Cloud · Tencent Cloud</a:t>
+            </a:r>
+            <a:endParaRPr lang="en-US" sz="2600" dirty="0"/>
           </a:p>
         </p:txBody>
       </p:sp>

</xml_diff>

<commit_message>
docs: add speaker handle to Atlantis title slide
Signed-off-by: Rui Chen <rui@chenrui.dev>
</commit_message>
<xml_diff>
--- a/talks/kubecon-china-2026-atlantis-lightning/slides.pptx
+++ b/talks/kubecon-china-2026-atlantis-lightning/slides.pptx
@@ -8486,7 +8486,7 @@
         <p:spPr>
           <a:xfrm>
             <a:off x="566928" y="4197096"/>
-            <a:ext cx="8229600" cy="384048"/>
+            <a:ext cx="9601200" cy="384048"/>
           </a:xfrm>
           <a:prstGeom prst="rect">
             <a:avLst/>
@@ -8510,7 +8510,28 @@
                 <a:ea typeface="Arial" pitchFamily="34" charset="-122"/>
                 <a:cs typeface="Arial" pitchFamily="34" charset="-120"/>
               </a:rPr>
-              <a:t>Rui Chen  ·  Atlantis Maintainer</a:t>
+              <a:t>Rui Chen  ·  Atlantis Maintainer  ·  </a:t>
+            </a:r>
+            <a:pPr indent="0" marL="0">
+              <a:buNone/>
+            </a:pPr>
+            <a:r>
+              <a:rPr lang="en-US" sz="2400" u="sng" dirty="0">
+                <a:solidFill>
+                  <a:srgbClr val="FFFFFF"/>
+                </a:solidFill>
+                <a:latin typeface="Arial" pitchFamily="34" charset="0"/>
+                <a:ea typeface="Arial" pitchFamily="34" charset="-122"/>
+                <a:cs typeface="Arial" pitchFamily="34" charset="-120"/>
+                <a:hlinkClick r:id="rId3" invalidUrl="" action="" tgtFrame="" tooltip="" history="1" highlightClick="0" endSnd="0">
+                  <a:extLst>
+                    <a:ext uri="{A12FA001-AC4F-418D-AE19-62706E023703}">
+                      <ahyp:hlinkClr xmlns:ahyp="http://schemas.microsoft.com/office/drawing/2018/hyperlinkcolor" val="tx"/>
+                    </a:ext>
+                  </a:extLst>
+                </a:hlinkClick>
+              </a:rPr>
+              <a:t>@chenrui333</a:t>
             </a:r>
             <a:endParaRPr lang="en-US" sz="2400" dirty="0"/>
           </a:p>

</xml_diff>